<commit_message>
chore(preview): nouveaux outputs AAPL post-corrections (pdf+pptx+xlsx)
Co-Authored-By: Claude Sonnet 4.6 <noreply@anthropic.com>
</commit_message>
<xml_diff>
--- a/preview/AAPL/AAPL_pitchbook.pptx
+++ b/preview/AAPL/AAPL_pitchbook.pptx
@@ -3348,7 +3348,7 @@
             <a:avLst/>
           </a:prstGeom>
           <a:solidFill>
-            <a:srgbClr val="EAF4EF"/>
+            <a:srgbClr val="FDF6E8"/>
           </a:solidFill>
           <a:ln>
             <a:noFill/>
@@ -3391,7 +3391,7 @@
             <a:avLst/>
           </a:prstGeom>
           <a:solidFill>
-            <a:srgbClr val="1A7A4A"/>
+            <a:srgbClr val="B06000"/>
           </a:solidFill>
           <a:ln>
             <a:noFill/>
@@ -3445,11 +3445,11 @@
             <a:r>
               <a:rPr sz="900" b="1" i="0">
                 <a:solidFill>
-                  <a:srgbClr val="1A7A4A"/>
+                  <a:srgbClr val="B06000"/>
                 </a:solidFill>
                 <a:latin typeface="Calibri"/>
               </a:rPr>
-              <a:t>● BUY  ·  Prix cible base : 280 $  ·  Upside : +10,7 %</a:t>
+              <a:t>● HOLD  ·  Prix cible base : — $  ·  Upside : —</a:t>
             </a:r>
           </a:p>
         </p:txBody>
@@ -4595,7 +4595,7 @@
                           </a:solidFill>
                           <a:latin typeface="Calibri"/>
                         </a:rPr>
-                        <a:t>26,1x</a:t>
+                        <a:t>26,2x</a:t>
                       </a:r>
                     </a:p>
                   </a:txBody>
@@ -5813,7 +5813,7 @@
                           </a:solidFill>
                           <a:latin typeface="Calibri"/>
                         </a:rPr>
-                        <a:t>9,97</a:t>
+                        <a:t>9,98</a:t>
                       </a:r>
                     </a:p>
                   </a:txBody>
@@ -6108,41 +6108,6 @@
           </a:graphicData>
         </a:graphic>
       </p:graphicFrame>
-      <p:sp>
-        <p:nvSpPr>
-          <p:cNvPr id="18" name="TextBox 17"/>
-          <p:cNvSpPr txBox="1"/>
-          <p:nvPr/>
-        </p:nvSpPr>
-        <p:spPr>
-          <a:xfrm>
-            <a:off x="367200" y="3628800"/>
-            <a:ext cx="8413200" cy="824400"/>
-          </a:xfrm>
-          <a:prstGeom prst="rect">
-            <a:avLst/>
-          </a:prstGeom>
-          <a:noFill/>
-        </p:spPr>
-        <p:txBody>
-          <a:bodyPr wrap="square">
-            <a:spAutoFit/>
-          </a:bodyPr>
-          <a:lstStyle/>
-          <a:p>
-            <a:pPr algn="l"/>
-            <a:r>
-              <a:rPr sz="850" b="0" i="0">
-                <a:solidFill>
-                  <a:srgbClr val="555555"/>
-                </a:solidFill>
-                <a:latin typeface="Calibri"/>
-              </a:rPr>
-              <a:t>Le ratio EV/EBITDA d'Apple est inférieur à la moyenne de son secteur, ce qui indique une valorisation attractive.</a:t>
-            </a:r>
-          </a:p>
-        </p:txBody>
-      </p:sp>
     </p:spTree>
   </p:cSld>
   <p:clrMapOvr>
@@ -7303,7 +7268,7 @@
                           </a:solidFill>
                           <a:latin typeface="Calibri"/>
                         </a:rPr>
-                        <a:t>280 $</a:t>
+                        <a:t>—</a:t>
                       </a:r>
                     </a:p>
                   </a:txBody>
@@ -7391,7 +7356,7 @@
                           </a:solidFill>
                           <a:latin typeface="Calibri"/>
                         </a:rPr>
-                        <a:t>253,38 $</a:t>
+                        <a:t>253,68 $</a:t>
                       </a:r>
                     </a:p>
                   </a:txBody>
@@ -7479,7 +7444,7 @@
                           </a:solidFill>
                           <a:latin typeface="Calibri"/>
                         </a:rPr>
-                        <a:t>+10,7 %</a:t>
+                        <a:t>—</a:t>
                       </a:r>
                     </a:p>
                   </a:txBody>
@@ -7622,7 +7587,7 @@
                           </a:solidFill>
                           <a:latin typeface="Calibri"/>
                         </a:rPr>
-                        <a:t>241 $</a:t>
+                        <a:t>—</a:t>
                       </a:r>
                     </a:p>
                   </a:txBody>
@@ -7645,7 +7610,7 @@
                           </a:solidFill>
                           <a:latin typeface="Calibri"/>
                         </a:rPr>
-                        <a:t>280 $</a:t>
+                        <a:t>—</a:t>
                       </a:r>
                     </a:p>
                   </a:txBody>
@@ -7668,7 +7633,7 @@
                           </a:solidFill>
                           <a:latin typeface="Calibri"/>
                         </a:rPr>
-                        <a:t>310 $</a:t>
+                        <a:t>—</a:t>
                       </a:r>
                     </a:p>
                   </a:txBody>
@@ -7693,7 +7658,7 @@
                           </a:solidFill>
                           <a:latin typeface="Calibri"/>
                         </a:rPr>
-                        <a:t>-5,0 %</a:t>
+                        <a:t>—</a:t>
                       </a:r>
                     </a:p>
                   </a:txBody>
@@ -7716,7 +7681,7 @@
                           </a:solidFill>
                           <a:latin typeface="Calibri"/>
                         </a:rPr>
-                        <a:t>+10,7 %</a:t>
+                        <a:t>—</a:t>
                       </a:r>
                     </a:p>
                   </a:txBody>
@@ -7739,7 +7704,7 @@
                           </a:solidFill>
                           <a:latin typeface="Calibri"/>
                         </a:rPr>
-                        <a:t>+22,4 %</a:t>
+                        <a:t>—</a:t>
                       </a:r>
                     </a:p>
                   </a:txBody>
@@ -8203,7 +8168,7 @@
                           </a:solidFill>
                           <a:latin typeface="Calibri"/>
                         </a:rPr>
-                        <a:t>325</a:t>
+                        <a:t>—</a:t>
                       </a:r>
                     </a:p>
                   </a:txBody>
@@ -8246,7 +8211,7 @@
                           </a:solidFill>
                           <a:latin typeface="Calibri"/>
                         </a:rPr>
-                        <a:t>353</a:t>
+                        <a:t>—</a:t>
                       </a:r>
                     </a:p>
                   </a:txBody>
@@ -8289,7 +8254,7 @@
                           </a:solidFill>
                           <a:latin typeface="Calibri"/>
                         </a:rPr>
-                        <a:t>386</a:t>
+                        <a:t>—</a:t>
                       </a:r>
                     </a:p>
                   </a:txBody>
@@ -8332,7 +8297,7 @@
                           </a:solidFill>
                           <a:latin typeface="Calibri"/>
                         </a:rPr>
-                        <a:t>426</a:t>
+                        <a:t>—</a:t>
                       </a:r>
                     </a:p>
                   </a:txBody>
@@ -8375,7 +8340,7 @@
                           </a:solidFill>
                           <a:latin typeface="Calibri"/>
                         </a:rPr>
-                        <a:t>475</a:t>
+                        <a:t>—</a:t>
                       </a:r>
                     </a:p>
                   </a:txBody>
@@ -8463,7 +8428,7 @@
                           </a:solidFill>
                           <a:latin typeface="Calibri"/>
                         </a:rPr>
-                        <a:t>280</a:t>
+                        <a:t>—</a:t>
                       </a:r>
                     </a:p>
                   </a:txBody>
@@ -8506,7 +8471,7 @@
                           </a:solidFill>
                           <a:latin typeface="Calibri"/>
                         </a:rPr>
-                        <a:t>301</a:t>
+                        <a:t>—</a:t>
                       </a:r>
                     </a:p>
                   </a:txBody>
@@ -8549,7 +8514,7 @@
                           </a:solidFill>
                           <a:latin typeface="Calibri"/>
                         </a:rPr>
-                        <a:t>325</a:t>
+                        <a:t>—</a:t>
                       </a:r>
                     </a:p>
                   </a:txBody>
@@ -8592,7 +8557,7 @@
                           </a:solidFill>
                           <a:latin typeface="Calibri"/>
                         </a:rPr>
-                        <a:t>353</a:t>
+                        <a:t>—</a:t>
                       </a:r>
                     </a:p>
                   </a:txBody>
@@ -8635,7 +8600,7 @@
                           </a:solidFill>
                           <a:latin typeface="Calibri"/>
                         </a:rPr>
-                        <a:t>386</a:t>
+                        <a:t>—</a:t>
                       </a:r>
                     </a:p>
                   </a:txBody>
@@ -8723,7 +8688,7 @@
                           </a:solidFill>
                           <a:latin typeface="Calibri"/>
                         </a:rPr>
-                        <a:t>247</a:t>
+                        <a:t>—</a:t>
                       </a:r>
                     </a:p>
                   </a:txBody>
@@ -8766,7 +8731,7 @@
                           </a:solidFill>
                           <a:latin typeface="Calibri"/>
                         </a:rPr>
-                        <a:t>263</a:t>
+                        <a:t>—</a:t>
                       </a:r>
                     </a:p>
                   </a:txBody>
@@ -8809,7 +8774,7 @@
                           </a:solidFill>
                           <a:latin typeface="Calibri"/>
                         </a:rPr>
-                        <a:t>280</a:t>
+                        <a:t>—</a:t>
                       </a:r>
                     </a:p>
                   </a:txBody>
@@ -8852,7 +8817,7 @@
                           </a:solidFill>
                           <a:latin typeface="Calibri"/>
                         </a:rPr>
-                        <a:t>301</a:t>
+                        <a:t>—</a:t>
                       </a:r>
                     </a:p>
                   </a:txBody>
@@ -8895,7 +8860,7 @@
                           </a:solidFill>
                           <a:latin typeface="Calibri"/>
                         </a:rPr>
-                        <a:t>325</a:t>
+                        <a:t>—</a:t>
                       </a:r>
                     </a:p>
                   </a:txBody>
@@ -8983,7 +8948,7 @@
                           </a:solidFill>
                           <a:latin typeface="Calibri"/>
                         </a:rPr>
-                        <a:t>220</a:t>
+                        <a:t>—</a:t>
                       </a:r>
                     </a:p>
                   </a:txBody>
@@ -9026,7 +8991,7 @@
                           </a:solidFill>
                           <a:latin typeface="Calibri"/>
                         </a:rPr>
-                        <a:t>233</a:t>
+                        <a:t>—</a:t>
                       </a:r>
                     </a:p>
                   </a:txBody>
@@ -9069,7 +9034,7 @@
                           </a:solidFill>
                           <a:latin typeface="Calibri"/>
                         </a:rPr>
-                        <a:t>247</a:t>
+                        <a:t>—</a:t>
                       </a:r>
                     </a:p>
                   </a:txBody>
@@ -9112,7 +9077,7 @@
                           </a:solidFill>
                           <a:latin typeface="Calibri"/>
                         </a:rPr>
-                        <a:t>263</a:t>
+                        <a:t>—</a:t>
                       </a:r>
                     </a:p>
                   </a:txBody>
@@ -9155,7 +9120,7 @@
                           </a:solidFill>
                           <a:latin typeface="Calibri"/>
                         </a:rPr>
-                        <a:t>281</a:t>
+                        <a:t>—</a:t>
                       </a:r>
                     </a:p>
                   </a:txBody>
@@ -9243,7 +9208,7 @@
                           </a:solidFill>
                           <a:latin typeface="Calibri"/>
                         </a:rPr>
-                        <a:t>199</a:t>
+                        <a:t>—</a:t>
                       </a:r>
                     </a:p>
                   </a:txBody>
@@ -9286,7 +9251,7 @@
                           </a:solidFill>
                           <a:latin typeface="Calibri"/>
                         </a:rPr>
-                        <a:t>209</a:t>
+                        <a:t>—</a:t>
                       </a:r>
                     </a:p>
                   </a:txBody>
@@ -9329,7 +9294,7 @@
                           </a:solidFill>
                           <a:latin typeface="Calibri"/>
                         </a:rPr>
-                        <a:t>220</a:t>
+                        <a:t>—</a:t>
                       </a:r>
                     </a:p>
                   </a:txBody>
@@ -9372,7 +9337,7 @@
                           </a:solidFill>
                           <a:latin typeface="Calibri"/>
                         </a:rPr>
-                        <a:t>233</a:t>
+                        <a:t>—</a:t>
                       </a:r>
                     </a:p>
                   </a:txBody>
@@ -9415,7 +9380,7 @@
                           </a:solidFill>
                           <a:latin typeface="Calibri"/>
                         </a:rPr>
-                        <a:t>247</a:t>
+                        <a:t>—</a:t>
                       </a:r>
                     </a:p>
                   </a:txBody>
@@ -9450,41 +9415,6 @@
           </a:graphicData>
         </a:graphic>
       </p:graphicFrame>
-      <p:sp>
-        <p:nvSpPr>
-          <p:cNvPr id="20" name="TextBox 19"/>
-          <p:cNvSpPr txBox="1"/>
-          <p:nvPr/>
-        </p:nvSpPr>
-        <p:spPr>
-          <a:xfrm>
-            <a:off x="367200" y="3916800"/>
-            <a:ext cx="8413200" cy="547200"/>
-          </a:xfrm>
-          <a:prstGeom prst="rect">
-            <a:avLst/>
-          </a:prstGeom>
-          <a:noFill/>
-        </p:spPr>
-        <p:txBody>
-          <a:bodyPr wrap="square">
-            <a:spAutoFit/>
-          </a:bodyPr>
-          <a:lstStyle/>
-          <a:p>
-            <a:pPr algn="l"/>
-            <a:r>
-              <a:rPr sz="850" b="0" i="0">
-                <a:solidFill>
-                  <a:srgbClr val="555555"/>
-                </a:solidFill>
-                <a:latin typeface="Calibri"/>
-              </a:rPr>
-              <a:t>Le prix implicite d'Apple sur la base d'un modèle de flux de trésorerie disponible est de 280,5 USD, ce qui suggère un upside de 10% par rapport au cours actuel.</a:t>
-            </a:r>
-          </a:p>
-        </p:txBody>
-      </p:sp>
     </p:spTree>
   </p:cSld>
   <p:clrMapOvr>
@@ -10094,7 +10024,7 @@
         </p:nvGraphicFramePr>
         <p:xfrm>
           <a:off x="367200" y="914400"/>
-          <a:ext cx="8413200" cy="2015999"/>
+          <a:ext cx="8413200" cy="871200"/>
         </p:xfrm>
         <a:graphic>
           <a:graphicData uri="http://schemas.openxmlformats.org/drawingml/2006/table">
@@ -10112,7 +10042,7 @@
                 <a:gridCol w="1093716"/>
                 <a:gridCol w="1009584"/>
               </a:tblGrid>
-              <a:tr h="251999">
+              <a:tr h="290400">
                 <a:tc>
                   <a:txBody>
                     <a:bodyPr/>
@@ -10298,7 +10228,7 @@
                   </a:tcPr>
                 </a:tc>
               </a:tr>
-              <a:tr h="251999">
+              <a:tr h="290400">
                 <a:tc>
                   <a:txBody>
                     <a:bodyPr/>
@@ -10358,7 +10288,7 @@
                           </a:solidFill>
                           <a:latin typeface="Calibri"/>
                         </a:rPr>
-                        <a:t>3 719,9</a:t>
+                        <a:t>3 724,3</a:t>
                       </a:r>
                     </a:p>
                   </a:txBody>
@@ -10381,7 +10311,7 @@
                           </a:solidFill>
                           <a:latin typeface="Calibri"/>
                         </a:rPr>
-                        <a:t>26,1x</a:t>
+                        <a:t>26,2x</a:t>
                       </a:r>
                     </a:p>
                   </a:txBody>
@@ -10484,937 +10414,7 @@
                   </a:tcPr>
                 </a:tc>
               </a:tr>
-              <a:tr h="251999">
-                <a:tc>
-                  <a:txBody>
-                    <a:bodyPr/>
-                    <a:lstStyle/>
-                    <a:p>
-                      <a:pPr algn="l"/>
-                      <a:r>
-                        <a:rPr sz="800" b="0" i="0">
-                          <a:solidFill>
-                            <a:srgbClr val="0D0D0D"/>
-                          </a:solidFill>
-                          <a:latin typeface="Calibri"/>
-                        </a:rPr>
-                        <a:t>Microsoft</a:t>
-                      </a:r>
-                    </a:p>
-                  </a:txBody>
-                  <a:tcPr>
-                    <a:solidFill>
-                      <a:srgbClr val="FFFFFF"/>
-                    </a:solidFill>
-                  </a:tcPr>
-                </a:tc>
-                <a:tc>
-                  <a:txBody>
-                    <a:bodyPr/>
-                    <a:lstStyle/>
-                    <a:p>
-                      <a:pPr algn="ctr"/>
-                      <a:r>
-                        <a:rPr sz="750" b="0" i="0">
-                          <a:solidFill>
-                            <a:srgbClr val="555555"/>
-                          </a:solidFill>
-                          <a:latin typeface="Calibri"/>
-                        </a:rPr>
-                        <a:t>MSFT</a:t>
-                      </a:r>
-                    </a:p>
-                  </a:txBody>
-                  <a:tcPr>
-                    <a:solidFill>
-                      <a:srgbClr val="FFFFFF"/>
-                    </a:solidFill>
-                  </a:tcPr>
-                </a:tc>
-                <a:tc>
-                  <a:txBody>
-                    <a:bodyPr/>
-                    <a:lstStyle/>
-                    <a:p>
-                      <a:pPr algn="ctr"/>
-                      <a:r>
-                        <a:rPr sz="800" b="0" i="0">
-                          <a:solidFill>
-                            <a:srgbClr val="0D0D0D"/>
-                          </a:solidFill>
-                          <a:latin typeface="Calibri"/>
-                        </a:rPr>
-                        <a:t>2 351,9</a:t>
-                      </a:r>
-                    </a:p>
-                  </a:txBody>
-                  <a:tcPr>
-                    <a:solidFill>
-                      <a:srgbClr val="FFFFFF"/>
-                    </a:solidFill>
-                  </a:tcPr>
-                </a:tc>
-                <a:tc>
-                  <a:txBody>
-                    <a:bodyPr/>
-                    <a:lstStyle/>
-                    <a:p>
-                      <a:pPr algn="ctr"/>
-                      <a:r>
-                        <a:rPr sz="800" b="0" i="0">
-                          <a:solidFill>
-                            <a:srgbClr val="0D0D0D"/>
-                          </a:solidFill>
-                          <a:latin typeface="Calibri"/>
-                        </a:rPr>
-                        <a:t>23,1x</a:t>
-                      </a:r>
-                    </a:p>
-                  </a:txBody>
-                  <a:tcPr>
-                    <a:solidFill>
-                      <a:srgbClr val="FFFFFF"/>
-                    </a:solidFill>
-                  </a:tcPr>
-                </a:tc>
-                <a:tc>
-                  <a:txBody>
-                    <a:bodyPr/>
-                    <a:lstStyle/>
-                    <a:p>
-                      <a:pPr algn="ctr"/>
-                      <a:r>
-                        <a:rPr sz="800" b="0" i="0">
-                          <a:solidFill>
-                            <a:srgbClr val="0D0D0D"/>
-                          </a:solidFill>
-                          <a:latin typeface="Calibri"/>
-                        </a:rPr>
-                        <a:t>8,5x</a:t>
-                      </a:r>
-                    </a:p>
-                  </a:txBody>
-                  <a:tcPr>
-                    <a:solidFill>
-                      <a:srgbClr val="FFFFFF"/>
-                    </a:solidFill>
-                  </a:tcPr>
-                </a:tc>
-                <a:tc>
-                  <a:txBody>
-                    <a:bodyPr/>
-                    <a:lstStyle/>
-                    <a:p>
-                      <a:pPr algn="ctr"/>
-                      <a:r>
-                        <a:rPr sz="800" b="0" i="0">
-                          <a:solidFill>
-                            <a:srgbClr val="0D0D0D"/>
-                          </a:solidFill>
-                          <a:latin typeface="Calibri"/>
-                        </a:rPr>
-                        <a:t>34,2x</a:t>
-                      </a:r>
-                    </a:p>
-                  </a:txBody>
-                  <a:tcPr>
-                    <a:solidFill>
-                      <a:srgbClr val="FFFFFF"/>
-                    </a:solidFill>
-                  </a:tcPr>
-                </a:tc>
-                <a:tc>
-                  <a:txBody>
-                    <a:bodyPr/>
-                    <a:lstStyle/>
-                    <a:p>
-                      <a:pPr algn="ctr"/>
-                      <a:r>
-                        <a:rPr sz="800" b="0" i="0">
-                          <a:solidFill>
-                            <a:srgbClr val="0D0D0D"/>
-                          </a:solidFill>
-                          <a:latin typeface="Calibri"/>
-                        </a:rPr>
-                        <a:t>68,0 %</a:t>
-                      </a:r>
-                    </a:p>
-                  </a:txBody>
-                  <a:tcPr>
-                    <a:solidFill>
-                      <a:srgbClr val="FFFFFF"/>
-                    </a:solidFill>
-                  </a:tcPr>
-                </a:tc>
-                <a:tc>
-                  <a:txBody>
-                    <a:bodyPr/>
-                    <a:lstStyle/>
-                    <a:p>
-                      <a:pPr algn="ctr"/>
-                      <a:r>
-                        <a:rPr sz="800" b="0" i="0">
-                          <a:solidFill>
-                            <a:srgbClr val="0D0D0D"/>
-                          </a:solidFill>
-                          <a:latin typeface="Calibri"/>
-                        </a:rPr>
-                        <a:t>43,0 %</a:t>
-                      </a:r>
-                    </a:p>
-                  </a:txBody>
-                  <a:tcPr>
-                    <a:solidFill>
-                      <a:srgbClr val="FFFFFF"/>
-                    </a:solidFill>
-                  </a:tcPr>
-                </a:tc>
-              </a:tr>
-              <a:tr h="251999">
-                <a:tc>
-                  <a:txBody>
-                    <a:bodyPr/>
-                    <a:lstStyle/>
-                    <a:p>
-                      <a:pPr algn="l"/>
-                      <a:r>
-                        <a:rPr sz="800" b="0" i="0">
-                          <a:solidFill>
-                            <a:srgbClr val="0D0D0D"/>
-                          </a:solidFill>
-                          <a:latin typeface="Calibri"/>
-                        </a:rPr>
-                        <a:t>Alphabet</a:t>
-                      </a:r>
-                    </a:p>
-                  </a:txBody>
-                  <a:tcPr>
-                    <a:solidFill>
-                      <a:srgbClr val="F7F8FA"/>
-                    </a:solidFill>
-                  </a:tcPr>
-                </a:tc>
-                <a:tc>
-                  <a:txBody>
-                    <a:bodyPr/>
-                    <a:lstStyle/>
-                    <a:p>
-                      <a:pPr algn="ctr"/>
-                      <a:r>
-                        <a:rPr sz="750" b="0" i="0">
-                          <a:solidFill>
-                            <a:srgbClr val="555555"/>
-                          </a:solidFill>
-                          <a:latin typeface="Calibri"/>
-                        </a:rPr>
-                        <a:t>GOOGL</a:t>
-                      </a:r>
-                    </a:p>
-                  </a:txBody>
-                  <a:tcPr>
-                    <a:solidFill>
-                      <a:srgbClr val="F7F8FA"/>
-                    </a:solidFill>
-                  </a:tcPr>
-                </a:tc>
-                <a:tc>
-                  <a:txBody>
-                    <a:bodyPr/>
-                    <a:lstStyle/>
-                    <a:p>
-                      <a:pPr algn="ctr"/>
-                      <a:r>
-                        <a:rPr sz="800" b="0" i="0">
-                          <a:solidFill>
-                            <a:srgbClr val="0D0D0D"/>
-                          </a:solidFill>
-                          <a:latin typeface="Calibri"/>
-                        </a:rPr>
-                        <a:t>1 571,9</a:t>
-                      </a:r>
-                    </a:p>
-                  </a:txBody>
-                  <a:tcPr>
-                    <a:solidFill>
-                      <a:srgbClr val="F7F8FA"/>
-                    </a:solidFill>
-                  </a:tcPr>
-                </a:tc>
-                <a:tc>
-                  <a:txBody>
-                    <a:bodyPr/>
-                    <a:lstStyle/>
-                    <a:p>
-                      <a:pPr algn="ctr"/>
-                      <a:r>
-                        <a:rPr sz="800" b="0" i="0">
-                          <a:solidFill>
-                            <a:srgbClr val="0D0D0D"/>
-                          </a:solidFill>
-                          <a:latin typeface="Calibri"/>
-                        </a:rPr>
-                        <a:t>20,5x</a:t>
-                      </a:r>
-                    </a:p>
-                  </a:txBody>
-                  <a:tcPr>
-                    <a:solidFill>
-                      <a:srgbClr val="F7F8FA"/>
-                    </a:solidFill>
-                  </a:tcPr>
-                </a:tc>
-                <a:tc>
-                  <a:txBody>
-                    <a:bodyPr/>
-                    <a:lstStyle/>
-                    <a:p>
-                      <a:pPr algn="ctr"/>
-                      <a:r>
-                        <a:rPr sz="800" b="0" i="0">
-                          <a:solidFill>
-                            <a:srgbClr val="0D0D0D"/>
-                          </a:solidFill>
-                          <a:latin typeface="Calibri"/>
-                        </a:rPr>
-                        <a:t>7,3x</a:t>
-                      </a:r>
-                    </a:p>
-                  </a:txBody>
-                  <a:tcPr>
-                    <a:solidFill>
-                      <a:srgbClr val="F7F8FA"/>
-                    </a:solidFill>
-                  </a:tcPr>
-                </a:tc>
-                <a:tc>
-                  <a:txBody>
-                    <a:bodyPr/>
-                    <a:lstStyle/>
-                    <a:p>
-                      <a:pPr algn="ctr"/>
-                      <a:r>
-                        <a:rPr sz="800" b="0" i="0">
-                          <a:solidFill>
-                            <a:srgbClr val="0D0D0D"/>
-                          </a:solidFill>
-                          <a:latin typeface="Calibri"/>
-                        </a:rPr>
-                        <a:t>29,1x</a:t>
-                      </a:r>
-                    </a:p>
-                  </a:txBody>
-                  <a:tcPr>
-                    <a:solidFill>
-                      <a:srgbClr val="F7F8FA"/>
-                    </a:solidFill>
-                  </a:tcPr>
-                </a:tc>
-                <a:tc>
-                  <a:txBody>
-                    <a:bodyPr/>
-                    <a:lstStyle/>
-                    <a:p>
-                      <a:pPr algn="ctr"/>
-                      <a:r>
-                        <a:rPr sz="800" b="0" i="0">
-                          <a:solidFill>
-                            <a:srgbClr val="0D0D0D"/>
-                          </a:solidFill>
-                          <a:latin typeface="Calibri"/>
-                        </a:rPr>
-                        <a:t>55,0 %</a:t>
-                      </a:r>
-                    </a:p>
-                  </a:txBody>
-                  <a:tcPr>
-                    <a:solidFill>
-                      <a:srgbClr val="F7F8FA"/>
-                    </a:solidFill>
-                  </a:tcPr>
-                </a:tc>
-                <a:tc>
-                  <a:txBody>
-                    <a:bodyPr/>
-                    <a:lstStyle/>
-                    <a:p>
-                      <a:pPr algn="ctr"/>
-                      <a:r>
-                        <a:rPr sz="800" b="0" i="0">
-                          <a:solidFill>
-                            <a:srgbClr val="0D0D0D"/>
-                          </a:solidFill>
-                          <a:latin typeface="Calibri"/>
-                        </a:rPr>
-                        <a:t>32,0 %</a:t>
-                      </a:r>
-                    </a:p>
-                  </a:txBody>
-                  <a:tcPr>
-                    <a:solidFill>
-                      <a:srgbClr val="F7F8FA"/>
-                    </a:solidFill>
-                  </a:tcPr>
-                </a:tc>
-              </a:tr>
-              <a:tr h="251999">
-                <a:tc>
-                  <a:txBody>
-                    <a:bodyPr/>
-                    <a:lstStyle/>
-                    <a:p>
-                      <a:pPr algn="l"/>
-                      <a:r>
-                        <a:rPr sz="800" b="0" i="0">
-                          <a:solidFill>
-                            <a:srgbClr val="0D0D0D"/>
-                          </a:solidFill>
-                          <a:latin typeface="Calibri"/>
-                        </a:rPr>
-                        <a:t>Amazon</a:t>
-                      </a:r>
-                    </a:p>
-                  </a:txBody>
-                  <a:tcPr>
-                    <a:solidFill>
-                      <a:srgbClr val="FFFFFF"/>
-                    </a:solidFill>
-                  </a:tcPr>
-                </a:tc>
-                <a:tc>
-                  <a:txBody>
-                    <a:bodyPr/>
-                    <a:lstStyle/>
-                    <a:p>
-                      <a:pPr algn="ctr"/>
-                      <a:r>
-                        <a:rPr sz="750" b="0" i="0">
-                          <a:solidFill>
-                            <a:srgbClr val="555555"/>
-                          </a:solidFill>
-                          <a:latin typeface="Calibri"/>
-                        </a:rPr>
-                        <a:t>AMZN</a:t>
-                      </a:r>
-                    </a:p>
-                  </a:txBody>
-                  <a:tcPr>
-                    <a:solidFill>
-                      <a:srgbClr val="FFFFFF"/>
-                    </a:solidFill>
-                  </a:tcPr>
-                </a:tc>
-                <a:tc>
-                  <a:txBody>
-                    <a:bodyPr/>
-                    <a:lstStyle/>
-                    <a:p>
-                      <a:pPr algn="ctr"/>
-                      <a:r>
-                        <a:rPr sz="800" b="0" i="0">
-                          <a:solidFill>
-                            <a:srgbClr val="0D0D0D"/>
-                          </a:solidFill>
-                          <a:latin typeface="Calibri"/>
-                        </a:rPr>
-                        <a:t>1 034,9</a:t>
-                      </a:r>
-                    </a:p>
-                  </a:txBody>
-                  <a:tcPr>
-                    <a:solidFill>
-                      <a:srgbClr val="FFFFFF"/>
-                    </a:solidFill>
-                  </a:tcPr>
-                </a:tc>
-                <a:tc>
-                  <a:txBody>
-                    <a:bodyPr/>
-                    <a:lstStyle/>
-                    <a:p>
-                      <a:pPr algn="ctr"/>
-                      <a:r>
-                        <a:rPr sz="800" b="0" i="0">
-                          <a:solidFill>
-                            <a:srgbClr val="0D0D0D"/>
-                          </a:solidFill>
-                          <a:latin typeface="Calibri"/>
-                        </a:rPr>
-                        <a:t>18,3x</a:t>
-                      </a:r>
-                    </a:p>
-                  </a:txBody>
-                  <a:tcPr>
-                    <a:solidFill>
-                      <a:srgbClr val="FFFFFF"/>
-                    </a:solidFill>
-                  </a:tcPr>
-                </a:tc>
-                <a:tc>
-                  <a:txBody>
-                    <a:bodyPr/>
-                    <a:lstStyle/>
-                    <a:p>
-                      <a:pPr algn="ctr"/>
-                      <a:r>
-                        <a:rPr sz="800" b="0" i="0">
-                          <a:solidFill>
-                            <a:srgbClr val="0D0D0D"/>
-                          </a:solidFill>
-                          <a:latin typeface="Calibri"/>
-                        </a:rPr>
-                        <a:t>6,5x</a:t>
-                      </a:r>
-                    </a:p>
-                  </a:txBody>
-                  <a:tcPr>
-                    <a:solidFill>
-                      <a:srgbClr val="FFFFFF"/>
-                    </a:solidFill>
-                  </a:tcPr>
-                </a:tc>
-                <a:tc>
-                  <a:txBody>
-                    <a:bodyPr/>
-                    <a:lstStyle/>
-                    <a:p>
-                      <a:pPr algn="ctr"/>
-                      <a:r>
-                        <a:rPr sz="800" b="0" i="0">
-                          <a:solidFill>
-                            <a:srgbClr val="0D0D0D"/>
-                          </a:solidFill>
-                          <a:latin typeface="Calibri"/>
-                        </a:rPr>
-                        <a:t>24,5x</a:t>
-                      </a:r>
-                    </a:p>
-                  </a:txBody>
-                  <a:tcPr>
-                    <a:solidFill>
-                      <a:srgbClr val="FFFFFF"/>
-                    </a:solidFill>
-                  </a:tcPr>
-                </a:tc>
-                <a:tc>
-                  <a:txBody>
-                    <a:bodyPr/>
-                    <a:lstStyle/>
-                    <a:p>
-                      <a:pPr algn="ctr"/>
-                      <a:r>
-                        <a:rPr sz="800" b="0" i="0">
-                          <a:solidFill>
-                            <a:srgbClr val="0D0D0D"/>
-                          </a:solidFill>
-                          <a:latin typeface="Calibri"/>
-                        </a:rPr>
-                        <a:t>42,0 %</a:t>
-                      </a:r>
-                    </a:p>
-                  </a:txBody>
-                  <a:tcPr>
-                    <a:solidFill>
-                      <a:srgbClr val="FFFFFF"/>
-                    </a:solidFill>
-                  </a:tcPr>
-                </a:tc>
-                <a:tc>
-                  <a:txBody>
-                    <a:bodyPr/>
-                    <a:lstStyle/>
-                    <a:p>
-                      <a:pPr algn="ctr"/>
-                      <a:r>
-                        <a:rPr sz="800" b="0" i="0">
-                          <a:solidFill>
-                            <a:srgbClr val="0D0D0D"/>
-                          </a:solidFill>
-                          <a:latin typeface="Calibri"/>
-                        </a:rPr>
-                        <a:t>25,0 %</a:t>
-                      </a:r>
-                    </a:p>
-                  </a:txBody>
-                  <a:tcPr>
-                    <a:solidFill>
-                      <a:srgbClr val="FFFFFF"/>
-                    </a:solidFill>
-                  </a:tcPr>
-                </a:tc>
-              </a:tr>
-              <a:tr h="251999">
-                <a:tc>
-                  <a:txBody>
-                    <a:bodyPr/>
-                    <a:lstStyle/>
-                    <a:p>
-                      <a:pPr algn="l"/>
-                      <a:r>
-                        <a:rPr sz="800" b="0" i="0">
-                          <a:solidFill>
-                            <a:srgbClr val="0D0D0D"/>
-                          </a:solidFill>
-                          <a:latin typeface="Calibri"/>
-                        </a:rPr>
-                        <a:t>Facebook</a:t>
-                      </a:r>
-                    </a:p>
-                  </a:txBody>
-                  <a:tcPr>
-                    <a:solidFill>
-                      <a:srgbClr val="F7F8FA"/>
-                    </a:solidFill>
-                  </a:tcPr>
-                </a:tc>
-                <a:tc>
-                  <a:txBody>
-                    <a:bodyPr/>
-                    <a:lstStyle/>
-                    <a:p>
-                      <a:pPr algn="ctr"/>
-                      <a:r>
-                        <a:rPr sz="750" b="0" i="0">
-                          <a:solidFill>
-                            <a:srgbClr val="555555"/>
-                          </a:solidFill>
-                          <a:latin typeface="Calibri"/>
-                        </a:rPr>
-                        <a:t>META</a:t>
-                      </a:r>
-                    </a:p>
-                  </a:txBody>
-                  <a:tcPr>
-                    <a:solidFill>
-                      <a:srgbClr val="F7F8FA"/>
-                    </a:solidFill>
-                  </a:tcPr>
-                </a:tc>
-                <a:tc>
-                  <a:txBody>
-                    <a:bodyPr/>
-                    <a:lstStyle/>
-                    <a:p>
-                      <a:pPr algn="ctr"/>
-                      <a:r>
-                        <a:rPr sz="800" b="0" i="0">
-                          <a:solidFill>
-                            <a:srgbClr val="0D0D0D"/>
-                          </a:solidFill>
-                          <a:latin typeface="Calibri"/>
-                        </a:rPr>
-                        <a:t>846,9</a:t>
-                      </a:r>
-                    </a:p>
-                  </a:txBody>
-                  <a:tcPr>
-                    <a:solidFill>
-                      <a:srgbClr val="F7F8FA"/>
-                    </a:solidFill>
-                  </a:tcPr>
-                </a:tc>
-                <a:tc>
-                  <a:txBody>
-                    <a:bodyPr/>
-                    <a:lstStyle/>
-                    <a:p>
-                      <a:pPr algn="ctr"/>
-                      <a:r>
-                        <a:rPr sz="800" b="0" i="0">
-                          <a:solidFill>
-                            <a:srgbClr val="0D0D0D"/>
-                          </a:solidFill>
-                          <a:latin typeface="Calibri"/>
-                        </a:rPr>
-                        <a:t>16,2x</a:t>
-                      </a:r>
-                    </a:p>
-                  </a:txBody>
-                  <a:tcPr>
-                    <a:solidFill>
-                      <a:srgbClr val="F7F8FA"/>
-                    </a:solidFill>
-                  </a:tcPr>
-                </a:tc>
-                <a:tc>
-                  <a:txBody>
-                    <a:bodyPr/>
-                    <a:lstStyle/>
-                    <a:p>
-                      <a:pPr algn="ctr"/>
-                      <a:r>
-                        <a:rPr sz="800" b="0" i="0">
-                          <a:solidFill>
-                            <a:srgbClr val="0D0D0D"/>
-                          </a:solidFill>
-                          <a:latin typeface="Calibri"/>
-                        </a:rPr>
-                        <a:t>5,8x</a:t>
-                      </a:r>
-                    </a:p>
-                  </a:txBody>
-                  <a:tcPr>
-                    <a:solidFill>
-                      <a:srgbClr val="F7F8FA"/>
-                    </a:solidFill>
-                  </a:tcPr>
-                </a:tc>
-                <a:tc>
-                  <a:txBody>
-                    <a:bodyPr/>
-                    <a:lstStyle/>
-                    <a:p>
-                      <a:pPr algn="ctr"/>
-                      <a:r>
-                        <a:rPr sz="800" b="0" i="0">
-                          <a:solidFill>
-                            <a:srgbClr val="0D0D0D"/>
-                          </a:solidFill>
-                          <a:latin typeface="Calibri"/>
-                        </a:rPr>
-                        <a:t>20,5x</a:t>
-                      </a:r>
-                    </a:p>
-                  </a:txBody>
-                  <a:tcPr>
-                    <a:solidFill>
-                      <a:srgbClr val="F7F8FA"/>
-                    </a:solidFill>
-                  </a:tcPr>
-                </a:tc>
-                <a:tc>
-                  <a:txBody>
-                    <a:bodyPr/>
-                    <a:lstStyle/>
-                    <a:p>
-                      <a:pPr algn="ctr"/>
-                      <a:r>
-                        <a:rPr sz="800" b="0" i="0">
-                          <a:solidFill>
-                            <a:srgbClr val="0D0D0D"/>
-                          </a:solidFill>
-                          <a:latin typeface="Calibri"/>
-                        </a:rPr>
-                        <a:t>38,0 %</a:t>
-                      </a:r>
-                    </a:p>
-                  </a:txBody>
-                  <a:tcPr>
-                    <a:solidFill>
-                      <a:srgbClr val="F7F8FA"/>
-                    </a:solidFill>
-                  </a:tcPr>
-                </a:tc>
-                <a:tc>
-                  <a:txBody>
-                    <a:bodyPr/>
-                    <a:lstStyle/>
-                    <a:p>
-                      <a:pPr algn="ctr"/>
-                      <a:r>
-                        <a:rPr sz="800" b="0" i="0">
-                          <a:solidFill>
-                            <a:srgbClr val="0D0D0D"/>
-                          </a:solidFill>
-                          <a:latin typeface="Calibri"/>
-                        </a:rPr>
-                        <a:t>22,0 %</a:t>
-                      </a:r>
-                    </a:p>
-                  </a:txBody>
-                  <a:tcPr>
-                    <a:solidFill>
-                      <a:srgbClr val="F7F8FA"/>
-                    </a:solidFill>
-                  </a:tcPr>
-                </a:tc>
-              </a:tr>
-              <a:tr h="251999">
-                <a:tc>
-                  <a:txBody>
-                    <a:bodyPr/>
-                    <a:lstStyle/>
-                    <a:p>
-                      <a:pPr algn="l"/>
-                      <a:r>
-                        <a:rPr sz="800" b="0" i="0">
-                          <a:solidFill>
-                            <a:srgbClr val="0D0D0D"/>
-                          </a:solidFill>
-                          <a:latin typeface="Calibri"/>
-                        </a:rPr>
-                        <a:t>Tesla</a:t>
-                      </a:r>
-                    </a:p>
-                  </a:txBody>
-                  <a:tcPr>
-                    <a:solidFill>
-                      <a:srgbClr val="FFFFFF"/>
-                    </a:solidFill>
-                  </a:tcPr>
-                </a:tc>
-                <a:tc>
-                  <a:txBody>
-                    <a:bodyPr/>
-                    <a:lstStyle/>
-                    <a:p>
-                      <a:pPr algn="ctr"/>
-                      <a:r>
-                        <a:rPr sz="750" b="0" i="0">
-                          <a:solidFill>
-                            <a:srgbClr val="555555"/>
-                          </a:solidFill>
-                          <a:latin typeface="Calibri"/>
-                        </a:rPr>
-                        <a:t>TSLA</a:t>
-                      </a:r>
-                    </a:p>
-                  </a:txBody>
-                  <a:tcPr>
-                    <a:solidFill>
-                      <a:srgbClr val="FFFFFF"/>
-                    </a:solidFill>
-                  </a:tcPr>
-                </a:tc>
-                <a:tc>
-                  <a:txBody>
-                    <a:bodyPr/>
-                    <a:lstStyle/>
-                    <a:p>
-                      <a:pPr algn="ctr"/>
-                      <a:r>
-                        <a:rPr sz="800" b="0" i="0">
-                          <a:solidFill>
-                            <a:srgbClr val="0D0D0D"/>
-                          </a:solidFill>
-                          <a:latin typeface="Calibri"/>
-                        </a:rPr>
-                        <a:t>574,9</a:t>
-                      </a:r>
-                    </a:p>
-                  </a:txBody>
-                  <a:tcPr>
-                    <a:solidFill>
-                      <a:srgbClr val="FFFFFF"/>
-                    </a:solidFill>
-                  </a:tcPr>
-                </a:tc>
-                <a:tc>
-                  <a:txBody>
-                    <a:bodyPr/>
-                    <a:lstStyle/>
-                    <a:p>
-                      <a:pPr algn="ctr"/>
-                      <a:r>
-                        <a:rPr sz="800" b="0" i="0">
-                          <a:solidFill>
-                            <a:srgbClr val="0D0D0D"/>
-                          </a:solidFill>
-                          <a:latin typeface="Calibri"/>
-                        </a:rPr>
-                        <a:t>24,9x</a:t>
-                      </a:r>
-                    </a:p>
-                  </a:txBody>
-                  <a:tcPr>
-                    <a:solidFill>
-                      <a:srgbClr val="FFFFFF"/>
-                    </a:solidFill>
-                  </a:tcPr>
-                </a:tc>
-                <a:tc>
-                  <a:txBody>
-                    <a:bodyPr/>
-                    <a:lstStyle/>
-                    <a:p>
-                      <a:pPr algn="ctr"/>
-                      <a:r>
-                        <a:rPr sz="800" b="0" i="0">
-                          <a:solidFill>
-                            <a:srgbClr val="0D0D0D"/>
-                          </a:solidFill>
-                          <a:latin typeface="Calibri"/>
-                        </a:rPr>
-                        <a:t>9,2x</a:t>
-                      </a:r>
-                    </a:p>
-                  </a:txBody>
-                  <a:tcPr>
-                    <a:solidFill>
-                      <a:srgbClr val="FFFFFF"/>
-                    </a:solidFill>
-                  </a:tcPr>
-                </a:tc>
-                <a:tc>
-                  <a:txBody>
-                    <a:bodyPr/>
-                    <a:lstStyle/>
-                    <a:p>
-                      <a:pPr algn="ctr"/>
-                      <a:r>
-                        <a:rPr sz="800" b="0" i="0">
-                          <a:solidFill>
-                            <a:srgbClr val="0D0D0D"/>
-                          </a:solidFill>
-                          <a:latin typeface="Calibri"/>
-                        </a:rPr>
-                        <a:t>35,1x</a:t>
-                      </a:r>
-                    </a:p>
-                  </a:txBody>
-                  <a:tcPr>
-                    <a:solidFill>
-                      <a:srgbClr val="FFFFFF"/>
-                    </a:solidFill>
-                  </a:tcPr>
-                </a:tc>
-                <a:tc>
-                  <a:txBody>
-                    <a:bodyPr/>
-                    <a:lstStyle/>
-                    <a:p>
-                      <a:pPr algn="ctr"/>
-                      <a:r>
-                        <a:rPr sz="800" b="0" i="0">
-                          <a:solidFill>
-                            <a:srgbClr val="0D0D0D"/>
-                          </a:solidFill>
-                          <a:latin typeface="Calibri"/>
-                        </a:rPr>
-                        <a:t>25,0 %</a:t>
-                      </a:r>
-                    </a:p>
-                  </a:txBody>
-                  <a:tcPr>
-                    <a:solidFill>
-                      <a:srgbClr val="FFFFFF"/>
-                    </a:solidFill>
-                  </a:tcPr>
-                </a:tc>
-                <a:tc>
-                  <a:txBody>
-                    <a:bodyPr/>
-                    <a:lstStyle/>
-                    <a:p>
-                      <a:pPr algn="ctr"/>
-                      <a:r>
-                        <a:rPr sz="800" b="0" i="0">
-                          <a:solidFill>
-                            <a:srgbClr val="0D0D0D"/>
-                          </a:solidFill>
-                          <a:latin typeface="Calibri"/>
-                        </a:rPr>
-                        <a:t>15,0 %</a:t>
-                      </a:r>
-                    </a:p>
-                  </a:txBody>
-                  <a:tcPr>
-                    <a:solidFill>
-                      <a:srgbClr val="FFFFFF"/>
-                    </a:solidFill>
-                  </a:tcPr>
-                </a:tc>
-              </a:tr>
-              <a:tr h="252006">
+              <a:tr h="290400">
                 <a:tc>
                   <a:txBody>
                     <a:bodyPr/>
@@ -11497,7 +10497,7 @@
                           </a:solidFill>
                           <a:latin typeface="Calibri"/>
                         </a:rPr>
-                        <a:t>20,5x</a:t>
+                        <a:t>—</a:t>
                       </a:r>
                     </a:p>
                   </a:txBody>
@@ -11520,7 +10520,7 @@
                           </a:solidFill>
                           <a:latin typeface="Calibri"/>
                         </a:rPr>
-                        <a:t>7,3x</a:t>
+                        <a:t>—</a:t>
                       </a:r>
                     </a:p>
                   </a:txBody>
@@ -11543,7 +10543,7 @@
                           </a:solidFill>
                           <a:latin typeface="Calibri"/>
                         </a:rPr>
-                        <a:t>29,1x</a:t>
+                        <a:t>—</a:t>
                       </a:r>
                     </a:p>
                   </a:txBody>
@@ -11566,7 +10566,7 @@
                           </a:solidFill>
                           <a:latin typeface="Calibri"/>
                         </a:rPr>
-                        <a:t>42,0 %</a:t>
+                        <a:t>—</a:t>
                       </a:r>
                     </a:p>
                   </a:txBody>
@@ -11589,7 +10589,7 @@
                           </a:solidFill>
                           <a:latin typeface="Calibri"/>
                         </a:rPr>
-                        <a:t>25,0 %</a:t>
+                        <a:t>—</a:t>
                       </a:r>
                     </a:p>
                   </a:txBody>
@@ -11604,41 +10604,6 @@
           </a:graphicData>
         </a:graphic>
       </p:graphicFrame>
-      <p:sp>
-        <p:nvSpPr>
-          <p:cNvPr id="18" name="TextBox 17"/>
-          <p:cNvSpPr txBox="1"/>
-          <p:nvPr/>
-        </p:nvSpPr>
-        <p:spPr>
-          <a:xfrm>
-            <a:off x="367200" y="3128400"/>
-            <a:ext cx="8413200" cy="1234800"/>
-          </a:xfrm>
-          <a:prstGeom prst="rect">
-            <a:avLst/>
-          </a:prstGeom>
-          <a:noFill/>
-        </p:spPr>
-        <p:txBody>
-          <a:bodyPr wrap="square">
-            <a:spAutoFit/>
-          </a:bodyPr>
-          <a:lstStyle/>
-          <a:p>
-            <a:pPr algn="l"/>
-            <a:r>
-              <a:rPr sz="850" b="0" i="0">
-                <a:solidFill>
-                  <a:srgbClr val="555555"/>
-                </a:solidFill>
-                <a:latin typeface="Calibri"/>
-              </a:rPr>
-              <a:t>Le ratio EV/EBITDA d'Apple est inférieur à la moyenne de son secteur, ce qui indique une valorisation attractive.</a:t>
-            </a:r>
-          </a:p>
-        </p:txBody>
-      </p:sp>
     </p:spTree>
   </p:cSld>
   <p:clrMapOvr>
@@ -12248,7 +11213,7 @@
         </p:nvGraphicFramePr>
         <p:xfrm>
           <a:off x="367200" y="914400"/>
-          <a:ext cx="8413200" cy="2149200"/>
+          <a:ext cx="8413200" cy="615600"/>
         </p:xfrm>
         <a:graphic>
           <a:graphicData uri="http://schemas.openxmlformats.org/drawingml/2006/table">
@@ -12262,7 +11227,7 @@
                 <a:gridCol w="1682640"/>
                 <a:gridCol w="2103300"/>
               </a:tblGrid>
-              <a:tr h="268650">
+              <a:tr h="307800">
                 <a:tc>
                   <a:txBody>
                     <a:bodyPr/>
@@ -12356,7 +11321,7 @@
                   </a:tcPr>
                 </a:tc>
               </a:tr>
-              <a:tr h="268650">
+              <a:tr h="307800">
                 <a:tc>
                   <a:txBody>
                     <a:bodyPr/>
@@ -12370,571 +11335,7 @@
                           </a:solidFill>
                           <a:latin typeface="Calibri"/>
                         </a:rPr>
-                        <a:t>DCF - Bear</a:t>
-                      </a:r>
-                    </a:p>
-                  </a:txBody>
-                  <a:tcPr>
-                    <a:solidFill>
-                      <a:srgbClr val="FAF0EF"/>
-                    </a:solidFill>
-                  </a:tcPr>
-                </a:tc>
-                <a:tc>
-                  <a:txBody>
-                    <a:bodyPr/>
-                    <a:lstStyle/>
-                    <a:p>
-                      <a:pPr algn="ctr"/>
-                      <a:r>
-                        <a:rPr sz="800" b="0" i="0">
-                          <a:solidFill>
-                            <a:srgbClr val="0D0D0D"/>
-                          </a:solidFill>
-                          <a:latin typeface="Calibri"/>
-                        </a:rPr>
-                        <a:t>220</a:t>
-                      </a:r>
-                    </a:p>
-                  </a:txBody>
-                  <a:tcPr>
-                    <a:solidFill>
-                      <a:srgbClr val="FAF0EF"/>
-                    </a:solidFill>
-                  </a:tcPr>
-                </a:tc>
-                <a:tc>
-                  <a:txBody>
-                    <a:bodyPr/>
-                    <a:lstStyle/>
-                    <a:p>
-                      <a:pPr algn="ctr"/>
-                      <a:r>
-                        <a:rPr sz="800" b="0" i="0">
-                          <a:solidFill>
-                            <a:srgbClr val="0D0D0D"/>
-                          </a:solidFill>
-                          <a:latin typeface="Calibri"/>
-                        </a:rPr>
-                        <a:t>250</a:t>
-                      </a:r>
-                    </a:p>
-                  </a:txBody>
-                  <a:tcPr>
-                    <a:solidFill>
-                      <a:srgbClr val="FAF0EF"/>
-                    </a:solidFill>
-                  </a:tcPr>
-                </a:tc>
-                <a:tc>
-                  <a:txBody>
-                    <a:bodyPr/>
-                    <a:lstStyle/>
-                    <a:p>
-                      <a:pPr algn="ctr"/>
-                      <a:r>
-                        <a:rPr sz="800" b="0" i="0">
-                          <a:solidFill>
-                            <a:srgbClr val="0D0D0D"/>
-                          </a:solidFill>
-                          <a:latin typeface="Calibri"/>
-                        </a:rPr>
-                        <a:t>241</a:t>
-                      </a:r>
-                    </a:p>
-                  </a:txBody>
-                  <a:tcPr>
-                    <a:solidFill>
-                      <a:srgbClr val="FAF0EF"/>
-                    </a:solidFill>
-                  </a:tcPr>
-                </a:tc>
-              </a:tr>
-              <a:tr h="268650">
-                <a:tc>
-                  <a:txBody>
-                    <a:bodyPr/>
-                    <a:lstStyle/>
-                    <a:p>
-                      <a:pPr algn="l"/>
-                      <a:r>
-                        <a:rPr sz="800" b="0" i="0">
-                          <a:solidFill>
-                            <a:srgbClr val="0D0D0D"/>
-                          </a:solidFill>
-                          <a:latin typeface="Calibri"/>
-                        </a:rPr>
-                        <a:t>DCF - Base</a:t>
-                      </a:r>
-                    </a:p>
-                  </a:txBody>
-                  <a:tcPr>
-                    <a:solidFill>
-                      <a:srgbClr val="EEF3FA"/>
-                    </a:solidFill>
-                  </a:tcPr>
-                </a:tc>
-                <a:tc>
-                  <a:txBody>
-                    <a:bodyPr/>
-                    <a:lstStyle/>
-                    <a:p>
-                      <a:pPr algn="ctr"/>
-                      <a:r>
-                        <a:rPr sz="800" b="0" i="0">
-                          <a:solidFill>
-                            <a:srgbClr val="0D0D0D"/>
-                          </a:solidFill>
-                          <a:latin typeface="Calibri"/>
-                        </a:rPr>
-                        <a:t>250</a:t>
-                      </a:r>
-                    </a:p>
-                  </a:txBody>
-                  <a:tcPr>
-                    <a:solidFill>
-                      <a:srgbClr val="EEF3FA"/>
-                    </a:solidFill>
-                  </a:tcPr>
-                </a:tc>
-                <a:tc>
-                  <a:txBody>
-                    <a:bodyPr/>
-                    <a:lstStyle/>
-                    <a:p>
-                      <a:pPr algn="ctr"/>
-                      <a:r>
-                        <a:rPr sz="800" b="0" i="0">
-                          <a:solidFill>
-                            <a:srgbClr val="0D0D0D"/>
-                          </a:solidFill>
-                          <a:latin typeface="Calibri"/>
-                        </a:rPr>
-                        <a:t>300</a:t>
-                      </a:r>
-                    </a:p>
-                  </a:txBody>
-                  <a:tcPr>
-                    <a:solidFill>
-                      <a:srgbClr val="EEF3FA"/>
-                    </a:solidFill>
-                  </a:tcPr>
-                </a:tc>
-                <a:tc>
-                  <a:txBody>
-                    <a:bodyPr/>
-                    <a:lstStyle/>
-                    <a:p>
-                      <a:pPr algn="ctr"/>
-                      <a:r>
-                        <a:rPr sz="800" b="0" i="0">
-                          <a:solidFill>
-                            <a:srgbClr val="0D0D0D"/>
-                          </a:solidFill>
-                          <a:latin typeface="Calibri"/>
-                        </a:rPr>
-                        <a:t>280</a:t>
-                      </a:r>
-                    </a:p>
-                  </a:txBody>
-                  <a:tcPr>
-                    <a:solidFill>
-                      <a:srgbClr val="EEF3FA"/>
-                    </a:solidFill>
-                  </a:tcPr>
-                </a:tc>
-              </a:tr>
-              <a:tr h="268650">
-                <a:tc>
-                  <a:txBody>
-                    <a:bodyPr/>
-                    <a:lstStyle/>
-                    <a:p>
-                      <a:pPr algn="l"/>
-                      <a:r>
-                        <a:rPr sz="800" b="0" i="0">
-                          <a:solidFill>
-                            <a:srgbClr val="0D0D0D"/>
-                          </a:solidFill>
-                          <a:latin typeface="Calibri"/>
-                        </a:rPr>
-                        <a:t>DCF - Bull</a:t>
-                      </a:r>
-                    </a:p>
-                  </a:txBody>
-                  <a:tcPr>
-                    <a:solidFill>
-                      <a:srgbClr val="EAF4EF"/>
-                    </a:solidFill>
-                  </a:tcPr>
-                </a:tc>
-                <a:tc>
-                  <a:txBody>
-                    <a:bodyPr/>
-                    <a:lstStyle/>
-                    <a:p>
-                      <a:pPr algn="ctr"/>
-                      <a:r>
-                        <a:rPr sz="800" b="0" i="0">
-                          <a:solidFill>
-                            <a:srgbClr val="0D0D0D"/>
-                          </a:solidFill>
-                          <a:latin typeface="Calibri"/>
-                        </a:rPr>
-                        <a:t>300</a:t>
-                      </a:r>
-                    </a:p>
-                  </a:txBody>
-                  <a:tcPr>
-                    <a:solidFill>
-                      <a:srgbClr val="EAF4EF"/>
-                    </a:solidFill>
-                  </a:tcPr>
-                </a:tc>
-                <a:tc>
-                  <a:txBody>
-                    <a:bodyPr/>
-                    <a:lstStyle/>
-                    <a:p>
-                      <a:pPr algn="ctr"/>
-                      <a:r>
-                        <a:rPr sz="800" b="0" i="0">
-                          <a:solidFill>
-                            <a:srgbClr val="0D0D0D"/>
-                          </a:solidFill>
-                          <a:latin typeface="Calibri"/>
-                        </a:rPr>
-                        <a:t>350</a:t>
-                      </a:r>
-                    </a:p>
-                  </a:txBody>
-                  <a:tcPr>
-                    <a:solidFill>
-                      <a:srgbClr val="EAF4EF"/>
-                    </a:solidFill>
-                  </a:tcPr>
-                </a:tc>
-                <a:tc>
-                  <a:txBody>
-                    <a:bodyPr/>
-                    <a:lstStyle/>
-                    <a:p>
-                      <a:pPr algn="ctr"/>
-                      <a:r>
-                        <a:rPr sz="800" b="0" i="0">
-                          <a:solidFill>
-                            <a:srgbClr val="0D0D0D"/>
-                          </a:solidFill>
-                          <a:latin typeface="Calibri"/>
-                        </a:rPr>
-                        <a:t>310</a:t>
-                      </a:r>
-                    </a:p>
-                  </a:txBody>
-                  <a:tcPr>
-                    <a:solidFill>
-                      <a:srgbClr val="EAF4EF"/>
-                    </a:solidFill>
-                  </a:tcPr>
-                </a:tc>
-              </a:tr>
-              <a:tr h="268650">
-                <a:tc>
-                  <a:txBody>
-                    <a:bodyPr/>
-                    <a:lstStyle/>
-                    <a:p>
-                      <a:pPr algn="l"/>
-                      <a:r>
-                        <a:rPr sz="800" b="0" i="0">
-                          <a:solidFill>
-                            <a:srgbClr val="0D0D0D"/>
-                          </a:solidFill>
-                          <a:latin typeface="Calibri"/>
-                        </a:rPr>
-                        <a:t>EV/EBITDA - Mediane peers</a:t>
-                      </a:r>
-                    </a:p>
-                  </a:txBody>
-                  <a:tcPr>
-                    <a:solidFill>
-                      <a:srgbClr val="F7F8FA"/>
-                    </a:solidFill>
-                  </a:tcPr>
-                </a:tc>
-                <a:tc>
-                  <a:txBody>
-                    <a:bodyPr/>
-                    <a:lstStyle/>
-                    <a:p>
-                      <a:pPr algn="ctr"/>
-                      <a:r>
-                        <a:rPr sz="800" b="0" i="0">
-                          <a:solidFill>
-                            <a:srgbClr val="0D0D0D"/>
-                          </a:solidFill>
-                          <a:latin typeface="Calibri"/>
-                        </a:rPr>
-                        <a:t>240</a:t>
-                      </a:r>
-                    </a:p>
-                  </a:txBody>
-                  <a:tcPr>
-                    <a:solidFill>
-                      <a:srgbClr val="F7F8FA"/>
-                    </a:solidFill>
-                  </a:tcPr>
-                </a:tc>
-                <a:tc>
-                  <a:txBody>
-                    <a:bodyPr/>
-                    <a:lstStyle/>
-                    <a:p>
-                      <a:pPr algn="ctr"/>
-                      <a:r>
-                        <a:rPr sz="800" b="0" i="0">
-                          <a:solidFill>
-                            <a:srgbClr val="0D0D0D"/>
-                          </a:solidFill>
-                          <a:latin typeface="Calibri"/>
-                        </a:rPr>
-                        <a:t>280</a:t>
-                      </a:r>
-                    </a:p>
-                  </a:txBody>
-                  <a:tcPr>
-                    <a:solidFill>
-                      <a:srgbClr val="F7F8FA"/>
-                    </a:solidFill>
-                  </a:tcPr>
-                </a:tc>
-                <a:tc>
-                  <a:txBody>
-                    <a:bodyPr/>
-                    <a:lstStyle/>
-                    <a:p>
-                      <a:pPr algn="ctr"/>
-                      <a:r>
-                        <a:rPr sz="800" b="0" i="0">
-                          <a:solidFill>
-                            <a:srgbClr val="0D0D0D"/>
-                          </a:solidFill>
-                          <a:latin typeface="Calibri"/>
-                        </a:rPr>
-                        <a:t>260</a:t>
-                      </a:r>
-                    </a:p>
-                  </a:txBody>
-                  <a:tcPr>
-                    <a:solidFill>
-                      <a:srgbClr val="F7F8FA"/>
-                    </a:solidFill>
-                  </a:tcPr>
-                </a:tc>
-              </a:tr>
-              <a:tr h="268650">
-                <a:tc>
-                  <a:txBody>
-                    <a:bodyPr/>
-                    <a:lstStyle/>
-                    <a:p>
-                      <a:pPr algn="l"/>
-                      <a:r>
-                        <a:rPr sz="800" b="0" i="0">
-                          <a:solidFill>
-                            <a:srgbClr val="0D0D0D"/>
-                          </a:solidFill>
-                          <a:latin typeface="Calibri"/>
-                        </a:rPr>
-                        <a:t>EV/EBITDA - Prime tech +50%</a:t>
-                      </a:r>
-                    </a:p>
-                  </a:txBody>
-                  <a:tcPr>
-                    <a:solidFill>
-                      <a:srgbClr val="F7F8FA"/>
-                    </a:solidFill>
-                  </a:tcPr>
-                </a:tc>
-                <a:tc>
-                  <a:txBody>
-                    <a:bodyPr/>
-                    <a:lstStyle/>
-                    <a:p>
-                      <a:pPr algn="ctr"/>
-                      <a:r>
-                        <a:rPr sz="800" b="0" i="0">
-                          <a:solidFill>
-                            <a:srgbClr val="0D0D0D"/>
-                          </a:solidFill>
-                          <a:latin typeface="Calibri"/>
-                        </a:rPr>
-                        <a:t>280</a:t>
-                      </a:r>
-                    </a:p>
-                  </a:txBody>
-                  <a:tcPr>
-                    <a:solidFill>
-                      <a:srgbClr val="F7F8FA"/>
-                    </a:solidFill>
-                  </a:tcPr>
-                </a:tc>
-                <a:tc>
-                  <a:txBody>
-                    <a:bodyPr/>
-                    <a:lstStyle/>
-                    <a:p>
-                      <a:pPr algn="ctr"/>
-                      <a:r>
-                        <a:rPr sz="800" b="0" i="0">
-                          <a:solidFill>
-                            <a:srgbClr val="0D0D0D"/>
-                          </a:solidFill>
-                          <a:latin typeface="Calibri"/>
-                        </a:rPr>
-                        <a:t>330</a:t>
-                      </a:r>
-                    </a:p>
-                  </a:txBody>
-                  <a:tcPr>
-                    <a:solidFill>
-                      <a:srgbClr val="F7F8FA"/>
-                    </a:solidFill>
-                  </a:tcPr>
-                </a:tc>
-                <a:tc>
-                  <a:txBody>
-                    <a:bodyPr/>
-                    <a:lstStyle/>
-                    <a:p>
-                      <a:pPr algn="ctr"/>
-                      <a:r>
-                        <a:rPr sz="800" b="0" i="0">
-                          <a:solidFill>
-                            <a:srgbClr val="0D0D0D"/>
-                          </a:solidFill>
-                          <a:latin typeface="Calibri"/>
-                        </a:rPr>
-                        <a:t>300</a:t>
-                      </a:r>
-                    </a:p>
-                  </a:txBody>
-                  <a:tcPr>
-                    <a:solidFill>
-                      <a:srgbClr val="F7F8FA"/>
-                    </a:solidFill>
-                  </a:tcPr>
-                </a:tc>
-              </a:tr>
-              <a:tr h="268650">
-                <a:tc>
-                  <a:txBody>
-                    <a:bodyPr/>
-                    <a:lstStyle/>
-                    <a:p>
-                      <a:pPr algn="l"/>
-                      <a:r>
-                        <a:rPr sz="800" b="0" i="0">
-                          <a:solidFill>
-                            <a:srgbClr val="0D0D0D"/>
-                          </a:solidFill>
-                          <a:latin typeface="Calibri"/>
-                        </a:rPr>
-                        <a:t>EV/Revenue - Mediane peers</a:t>
-                      </a:r>
-                    </a:p>
-                  </a:txBody>
-                  <a:tcPr>
-                    <a:solidFill>
-                      <a:srgbClr val="F7F8FA"/>
-                    </a:solidFill>
-                  </a:tcPr>
-                </a:tc>
-                <a:tc>
-                  <a:txBody>
-                    <a:bodyPr/>
-                    <a:lstStyle/>
-                    <a:p>
-                      <a:pPr algn="ctr"/>
-                      <a:r>
-                        <a:rPr sz="800" b="0" i="0">
-                          <a:solidFill>
-                            <a:srgbClr val="0D0D0D"/>
-                          </a:solidFill>
-                          <a:latin typeface="Calibri"/>
-                        </a:rPr>
-                        <a:t>200</a:t>
-                      </a:r>
-                    </a:p>
-                  </a:txBody>
-                  <a:tcPr>
-                    <a:solidFill>
-                      <a:srgbClr val="F7F8FA"/>
-                    </a:solidFill>
-                  </a:tcPr>
-                </a:tc>
-                <a:tc>
-                  <a:txBody>
-                    <a:bodyPr/>
-                    <a:lstStyle/>
-                    <a:p>
-                      <a:pPr algn="ctr"/>
-                      <a:r>
-                        <a:rPr sz="800" b="0" i="0">
-                          <a:solidFill>
-                            <a:srgbClr val="0D0D0D"/>
-                          </a:solidFill>
-                          <a:latin typeface="Calibri"/>
-                        </a:rPr>
-                        <a:t>240</a:t>
-                      </a:r>
-                    </a:p>
-                  </a:txBody>
-                  <a:tcPr>
-                    <a:solidFill>
-                      <a:srgbClr val="F7F8FA"/>
-                    </a:solidFill>
-                  </a:tcPr>
-                </a:tc>
-                <a:tc>
-                  <a:txBody>
-                    <a:bodyPr/>
-                    <a:lstStyle/>
-                    <a:p>
-                      <a:pPr algn="ctr"/>
-                      <a:r>
-                        <a:rPr sz="800" b="0" i="0">
-                          <a:solidFill>
-                            <a:srgbClr val="0D0D0D"/>
-                          </a:solidFill>
-                          <a:latin typeface="Calibri"/>
-                        </a:rPr>
-                        <a:t>220</a:t>
-                      </a:r>
-                    </a:p>
-                  </a:txBody>
-                  <a:tcPr>
-                    <a:solidFill>
-                      <a:srgbClr val="F7F8FA"/>
-                    </a:solidFill>
-                  </a:tcPr>
-                </a:tc>
-              </a:tr>
-              <a:tr h="268650">
-                <a:tc>
-                  <a:txBody>
-                    <a:bodyPr/>
-                    <a:lstStyle/>
-                    <a:p>
-                      <a:pPr algn="l"/>
-                      <a:r>
-                        <a:rPr sz="800" b="0" i="0">
-                          <a:solidFill>
-                            <a:srgbClr val="0D0D0D"/>
-                          </a:solidFill>
-                          <a:latin typeface="Calibri"/>
-                        </a:rPr>
-                        <a:t>Cours actuel (253,38)</a:t>
+                        <a:t>Cours actuel (253,68)</a:t>
                       </a:r>
                     </a:p>
                   </a:txBody>
@@ -13003,7 +11404,7 @@
                           </a:solidFill>
                           <a:latin typeface="Calibri"/>
                         </a:rPr>
-                        <a:t>253,38</a:t>
+                        <a:t>253,68</a:t>
                       </a:r>
                     </a:p>
                   </a:txBody>
@@ -13018,41 +11419,6 @@
           </a:graphicData>
         </a:graphic>
       </p:graphicFrame>
-      <p:sp>
-        <p:nvSpPr>
-          <p:cNvPr id="18" name="TextBox 17"/>
-          <p:cNvSpPr txBox="1"/>
-          <p:nvPr/>
-        </p:nvSpPr>
-        <p:spPr>
-          <a:xfrm>
-            <a:off x="367200" y="3528000"/>
-            <a:ext cx="8413200" cy="914400"/>
-          </a:xfrm>
-          <a:prstGeom prst="rect">
-            <a:avLst/>
-          </a:prstGeom>
-          <a:noFill/>
-        </p:spPr>
-        <p:txBody>
-          <a:bodyPr wrap="square">
-            <a:spAutoFit/>
-          </a:bodyPr>
-          <a:lstStyle/>
-          <a:p>
-            <a:pPr algn="l"/>
-            <a:r>
-              <a:rPr sz="850" b="0" i="0">
-                <a:solidFill>
-                  <a:srgbClr val="555555"/>
-                </a:solidFill>
-                <a:latin typeface="Calibri"/>
-              </a:rPr>
-              <a:t>Le prix implicite d'Apple sur la base d'un modèle de flux de trésorerie disponible est de 280,5 USD, ce qui suggère un upside de 10% par rapport au cours actuel.</a:t>
-            </a:r>
-          </a:p>
-        </p:txBody>
-      </p:sp>
     </p:spTree>
   </p:cSld>
   <p:clrMapOvr>
@@ -14021,7 +12387,7 @@
                 </a:solidFill>
                 <a:latin typeface="Calibri"/>
               </a:rPr>
-              <a:t>Concurrence accrue</a:t>
+              <a:t>Risque 1</a:t>
             </a:r>
           </a:p>
         </p:txBody>
@@ -14056,7 +12422,7 @@
                 </a:solidFill>
                 <a:latin typeface="Calibri"/>
               </a:rPr>
-              <a:t>Concurrence accrue</a:t>
+              <a:t>Risque macro-economique : remontee des taux ou ralentissement de la demande mondiale.</a:t>
             </a:r>
           </a:p>
         </p:txBody>
@@ -14177,7 +12543,7 @@
                 </a:solidFill>
                 <a:latin typeface="Calibri"/>
               </a:rPr>
-              <a:t>Dépendance aux smartphones</a:t>
+              <a:t>Risque 2</a:t>
             </a:r>
           </a:p>
         </p:txBody>
@@ -14212,7 +12578,7 @@
                 </a:solidFill>
                 <a:latin typeface="Calibri"/>
               </a:rPr>
-              <a:t>Risques politiques</a:t>
+              <a:t>Risque sectoriel : intensification de la concurrence ou disruption technologique.</a:t>
             </a:r>
           </a:p>
         </p:txBody>
@@ -14333,7 +12699,7 @@
                 </a:solidFill>
                 <a:latin typeface="Calibri"/>
               </a:rPr>
-              <a:t>Risques politiques</a:t>
+              <a:t>Risque 3</a:t>
             </a:r>
           </a:p>
         </p:txBody>
@@ -14368,7 +12734,7 @@
                 </a:solidFill>
                 <a:latin typeface="Calibri"/>
               </a:rPr>
-              <a:t>Dépendance aux smartphones</a:t>
+              <a:t>Risque specifique : deterioration des marges ou execution strategique.</a:t>
             </a:r>
           </a:p>
         </p:txBody>
@@ -14582,7 +12948,7 @@
                           </a:solidFill>
                           <a:latin typeface="Calibri"/>
                         </a:rPr>
-                        <a:t>Récession économique mondiale</a:t>
+                        <a:t>Remontée des taux directeurs &gt; 200bps</a:t>
                       </a:r>
                     </a:p>
                   </a:txBody>
@@ -14653,7 +13019,7 @@
                           </a:solidFill>
                           <a:latin typeface="Calibri"/>
                         </a:rPr>
-                        <a:t>Concurrence accrue dans le secteur des smartphones</a:t>
+                        <a:t>Rupture technologique remettant en cause le modèle</a:t>
                       </a:r>
                     </a:p>
                   </a:txBody>
@@ -14701,7 +13067,7 @@
                           </a:solidFill>
                           <a:latin typeface="Calibri"/>
                         </a:rPr>
-                        <a:t>Societe</a:t>
+                        <a:t>Société</a:t>
                       </a:r>
                     </a:p>
                   </a:txBody>
@@ -14724,7 +13090,7 @@
                           </a:solidFill>
                           <a:latin typeface="Calibri"/>
                         </a:rPr>
-                        <a:t>Problèmes de production ou de livraison</a:t>
+                        <a:t>Détérioration matérielle des marges opérationnelles</a:t>
                       </a:r>
                     </a:p>
                   </a:txBody>
@@ -14747,7 +13113,7 @@
                           </a:solidFill>
                           <a:latin typeface="Calibri"/>
                         </a:rPr>
-                        <a:t>2-3 trimestres</a:t>
+                        <a:t>2-3 trim.</a:t>
                       </a:r>
                     </a:p>
                   </a:txBody>
@@ -15730,7 +14096,7 @@
                 </a:solidFill>
                 <a:latin typeface="Calibri"/>
               </a:rPr>
-              <a:t>Neutre +</a:t>
+              <a:t>Positif</a:t>
             </a:r>
           </a:p>
         </p:txBody>
@@ -15800,7 +14166,7 @@
                 </a:solidFill>
                 <a:latin typeface="Calibri"/>
               </a:rPr>
-              <a:t>Score agrege : +0,035</a:t>
+              <a:t>Score agrege : +0,195</a:t>
             </a:r>
           </a:p>
         </p:txBody>
@@ -16112,7 +14478,7 @@
                 </a:solidFill>
                 <a:latin typeface="Calibri"/>
               </a:rPr>
-              <a:t>49,7 %</a:t>
+              <a:t>43,3 %</a:t>
             </a:r>
           </a:p>
         </p:txBody>
@@ -16303,7 +14669,7 @@
                 </a:solidFill>
                 <a:latin typeface="Calibri"/>
               </a:rPr>
-              <a:t>BUY</a:t>
+              <a:t>HOLD</a:t>
             </a:r>
           </a:p>
         </p:txBody>
@@ -16568,7 +14934,7 @@
                           </a:solidFill>
                           <a:latin typeface="Calibri"/>
                         </a:rPr>
-                        <a:t>7</a:t>
+                        <a:t>13</a:t>
                       </a:r>
                     </a:p>
                   </a:txBody>
@@ -16591,7 +14957,7 @@
                           </a:solidFill>
                           <a:latin typeface="Calibri"/>
                         </a:rPr>
-                        <a:t>+0,269</a:t>
+                        <a:t>+0,433</a:t>
                       </a:r>
                     </a:p>
                   </a:txBody>
@@ -16614,7 +14980,7 @@
                           </a:solidFill>
                           <a:latin typeface="Calibri"/>
                         </a:rPr>
-                        <a:t>Croissance de la demande pour les smartphones, Expansion de l'écosystème d'Apple, Innovation</a:t>
+                        <a:t>Catalyseurs, croissance, résultats</a:t>
                       </a:r>
                     </a:p>
                   </a:txBody>
@@ -16662,7 +15028,7 @@
                           </a:solidFill>
                           <a:latin typeface="Calibri"/>
                         </a:rPr>
-                        <a:t>17</a:t>
+                        <a:t>9</a:t>
                       </a:r>
                     </a:p>
                   </a:txBody>
@@ -16685,7 +15051,7 @@
                           </a:solidFill>
                           <a:latin typeface="Calibri"/>
                         </a:rPr>
-                        <a:t>+0,497</a:t>
+                        <a:t>+0,329</a:t>
                       </a:r>
                     </a:p>
                   </a:txBody>
@@ -16756,7 +15122,7 @@
                           </a:solidFill>
                           <a:latin typeface="Calibri"/>
                         </a:rPr>
-                        <a:t>6</a:t>
+                        <a:t>8</a:t>
                       </a:r>
                     </a:p>
                   </a:txBody>
@@ -16779,7 +15145,7 @@
                           </a:solidFill>
                           <a:latin typeface="Calibri"/>
                         </a:rPr>
-                        <a:t>+0,234</a:t>
+                        <a:t>+0,238</a:t>
                       </a:r>
                     </a:p>
                   </a:txBody>
@@ -16802,7 +15168,7 @@
                           </a:solidFill>
                           <a:latin typeface="Calibri"/>
                         </a:rPr>
-                        <a:t>Concurrence accrue, Risques politiques, Dépendance aux smartphones</a:t>
+                        <a:t>Risques macro, concurrence, dette</a:t>
                       </a:r>
                     </a:p>
                   </a:txBody>
@@ -16847,7 +15213,7 @@
                 </a:solidFill>
                 <a:latin typeface="Calibri"/>
               </a:rPr>
-              <a:t>Le sentiment global de la presse financiere sur AAPL cette semaine est mitige, avec certains titres laissant apparaitre une croissance potentielle pour l'entreprise, notamment en termes d'adoption de ses produits en Europe. Cependant, d'autres titres font etat de defis potentiels pour l'entreprise, tels que la concurrence accrue dans le marché des smartphones et les risques lies aux partenariats avec d'autres entreprises technologiques.</a:t>
+              <a:t>Le sentiment positif (score +0.195) est basé sur 30 articles analysés sur 7 jours. Confiance IA : 43%. Cohérence avec la recommandation HOLD : surveiller.</a:t>
             </a:r>
           </a:p>
         </p:txBody>
@@ -19755,41 +18121,6 @@
           </a:graphicData>
         </a:graphic>
       </p:graphicFrame>
-      <p:sp>
-        <p:nvSpPr>
-          <p:cNvPr id="21" name="TextBox 20"/>
-          <p:cNvSpPr txBox="1"/>
-          <p:nvPr/>
-        </p:nvSpPr>
-        <p:spPr>
-          <a:xfrm>
-            <a:off x="367200" y="3326400"/>
-            <a:ext cx="8413200" cy="1004400"/>
-          </a:xfrm>
-          <a:prstGeom prst="rect">
-            <a:avLst/>
-          </a:prstGeom>
-          <a:noFill/>
-        </p:spPr>
-        <p:txBody>
-          <a:bodyPr wrap="square">
-            <a:spAutoFit/>
-          </a:bodyPr>
-          <a:lstStyle/>
-          <a:p>
-            <a:pPr algn="l"/>
-            <a:r>
-              <a:rPr sz="850" b="0" i="0">
-                <a:solidFill>
-                  <a:srgbClr val="555555"/>
-                </a:solidFill>
-                <a:latin typeface="Calibri"/>
-              </a:rPr>
-              <a:t>La valorisation d'Apple est attractive par rapport à ses pairs, avec un ratio EV/EBITDA inférieur à 25. L'entreprise présente également un multiple de prix sur bénéfice inférieur à 30.</a:t>
-            </a:r>
-          </a:p>
-        </p:txBody>
-      </p:sp>
     </p:spTree>
   </p:cSld>
   <p:clrMapOvr>
@@ -19979,7 +18310,7 @@
             <a:avLst/>
           </a:prstGeom>
           <a:solidFill>
-            <a:srgbClr val="EAF4EF"/>
+            <a:srgbClr val="FDF6E8"/>
           </a:solidFill>
           <a:ln>
             <a:noFill/>
@@ -20022,7 +18353,7 @@
             <a:avLst/>
           </a:prstGeom>
           <a:solidFill>
-            <a:srgbClr val="1A7A4A"/>
+            <a:srgbClr val="B06000"/>
           </a:solidFill>
           <a:ln>
             <a:noFill/>
@@ -20076,11 +18407,11 @@
             <a:r>
               <a:rPr sz="1100" b="1" i="0">
                 <a:solidFill>
-                  <a:srgbClr val="1A7A4A"/>
+                  <a:srgbClr val="B06000"/>
                 </a:solidFill>
                 <a:latin typeface="Calibri"/>
               </a:rPr>
-              <a:t>● BUY</a:t>
+              <a:t>● HOLD</a:t>
             </a:r>
           </a:p>
         </p:txBody>
@@ -20115,7 +18446,7 @@
                 </a:solidFill>
                 <a:latin typeface="Calibri"/>
               </a:rPr>
-              <a:t>Prix cible base : 280 $  ·  Upside : +10,7 %  ·  Bear : 241 $ (-5,0 %)  ·  Bull : 310 $ (+22,4 %)</a:t>
+              <a:t>Prix cible base : — $  ·  Upside : —  ·  Bear : — $ (—)  ·  Bull : — $ (—)</a:t>
             </a:r>
           </a:p>
         </p:txBody>
@@ -20271,7 +18602,7 @@
                 </a:solidFill>
                 <a:latin typeface="Calibri"/>
               </a:rPr>
-              <a:t>Marque forte</a:t>
+              <a:t>—</a:t>
             </a:r>
           </a:p>
         </p:txBody>
@@ -20306,7 +18637,7 @@
                 </a:solidFill>
                 <a:latin typeface="Calibri"/>
               </a:rPr>
-              <a:t>La croissance de la demande pour les smartphones et les ordinateurs portables devrait atteindre 10% d'ici 2027</a:t>
+              <a:t>—</a:t>
             </a:r>
           </a:p>
         </p:txBody>
@@ -20384,7 +18715,7 @@
                 </a:solidFill>
                 <a:latin typeface="Calibri"/>
               </a:rPr>
-              <a:t>Ecosystème intégré</a:t>
+              <a:t>—</a:t>
             </a:r>
           </a:p>
         </p:txBody>
@@ -20419,7 +18750,7 @@
                 </a:solidFill>
                 <a:latin typeface="Calibri"/>
               </a:rPr>
-              <a:t>Les services d'Apple devraient générer 20% des revenus de l'entreprise d'ici 2028</a:t>
+              <a:t>—</a:t>
             </a:r>
           </a:p>
         </p:txBody>
@@ -20497,7 +18828,7 @@
                 </a:solidFill>
                 <a:latin typeface="Calibri"/>
               </a:rPr>
-              <a:t>Innovation</a:t>
+              <a:t>—</a:t>
             </a:r>
           </a:p>
         </p:txBody>
@@ -20532,7 +18863,7 @@
                 </a:solidFill>
                 <a:latin typeface="Calibri"/>
               </a:rPr>
-              <a:t>L'expansion de l'écosystème d'Apple devrait atteindre 500 millions d'utilisateurs actifs d'ici 2029</a:t>
+              <a:t>—</a:t>
             </a:r>
           </a:p>
         </p:txBody>
@@ -20688,7 +19019,7 @@
                 </a:solidFill>
                 <a:latin typeface="Calibri"/>
               </a:rPr>
-              <a:t>Concurrence accrue</a:t>
+              <a:t>—</a:t>
             </a:r>
           </a:p>
         </p:txBody>
@@ -20723,7 +19054,7 @@
                 </a:solidFill>
                 <a:latin typeface="Calibri"/>
               </a:rPr>
-              <a:t>Concurrence accrue</a:t>
+              <a:t>—</a:t>
             </a:r>
           </a:p>
         </p:txBody>
@@ -20801,7 +19132,7 @@
                 </a:solidFill>
                 <a:latin typeface="Calibri"/>
               </a:rPr>
-              <a:t>Dépendance aux smartphones</a:t>
+              <a:t>—</a:t>
             </a:r>
           </a:p>
         </p:txBody>
@@ -20836,7 +19167,7 @@
                 </a:solidFill>
                 <a:latin typeface="Calibri"/>
               </a:rPr>
-              <a:t>Risques politiques</a:t>
+              <a:t>—</a:t>
             </a:r>
           </a:p>
         </p:txBody>
@@ -20914,7 +19245,7 @@
                 </a:solidFill>
                 <a:latin typeface="Calibri"/>
               </a:rPr>
-              <a:t>Risques politiques</a:t>
+              <a:t>—</a:t>
             </a:r>
           </a:p>
         </p:txBody>
@@ -20949,7 +19280,7 @@
                 </a:solidFill>
                 <a:latin typeface="Calibri"/>
               </a:rPr>
-              <a:t>Dépendance aux smartphones</a:t>
+              <a:t>—</a:t>
             </a:r>
           </a:p>
         </p:txBody>
@@ -21156,7 +19487,7 @@
                 </a:solidFill>
                 <a:latin typeface="Calibri"/>
               </a:rPr>
-              <a:t>26,1x</a:t>
+              <a:t>26,2x</a:t>
             </a:r>
           </a:p>
         </p:txBody>
@@ -21226,7 +19557,7 @@
                 </a:solidFill>
                 <a:latin typeface="Calibri"/>
               </a:rPr>
-              <a:t>vs 20,5x médiane peers</a:t>
+              <a:t>vs — médiane peers</a:t>
             </a:r>
           </a:p>
         </p:txBody>
@@ -21538,7 +19869,7 @@
                 </a:solidFill>
                 <a:latin typeface="Calibri"/>
               </a:rPr>
-              <a:t>280 $</a:t>
+              <a:t>— $</a:t>
             </a:r>
           </a:p>
         </p:txBody>
@@ -21608,7 +19939,7 @@
                 </a:solidFill>
                 <a:latin typeface="Calibri"/>
               </a:rPr>
-              <a:t>Upside de +10,7 % vs cours</a:t>
+              <a:t>Upside de — vs cours</a:t>
             </a:r>
           </a:p>
         </p:txBody>
@@ -21729,7 +20060,7 @@
                 </a:solidFill>
                 <a:latin typeface="Calibri"/>
               </a:rPr>
-              <a:t>+0,035</a:t>
+              <a:t>+0,195</a:t>
             </a:r>
           </a:p>
         </p:txBody>
@@ -21799,7 +20130,7 @@
                 </a:solidFill>
                 <a:latin typeface="Calibri"/>
               </a:rPr>
-              <a:t>Neutre +  ·  30 articles</a:t>
+              <a:t>Positif  ·  30 articles</a:t>
             </a:r>
           </a:p>
         </p:txBody>
@@ -22519,7 +20850,7 @@
                 </a:solidFill>
                 <a:latin typeface="Calibri"/>
               </a:rPr>
-              <a:t>253,38 $</a:t>
+              <a:t>253,68 $</a:t>
             </a:r>
           </a:p>
         </p:txBody>
@@ -22987,7 +21318,7 @@
                 </a:solidFill>
                 <a:latin typeface="Calibri"/>
               </a:rPr>
-              <a:t>+19,7 %</a:t>
+              <a:t>+19,9 %</a:t>
             </a:r>
           </a:p>
         </p:txBody>
@@ -24016,8 +22347,8 @@
         </p:nvSpPr>
         <p:spPr>
           <a:xfrm>
-            <a:off x="7854300" y="2842183"/>
-            <a:ext cx="498636" cy="1053016"/>
+            <a:off x="7854300" y="2836118"/>
+            <a:ext cx="498636" cy="1059081"/>
           </a:xfrm>
           <a:prstGeom prst="rect">
             <a:avLst/>
@@ -24088,14 +22419,57 @@
       </p:sp>
       <p:sp>
         <p:nvSpPr>
-          <p:cNvPr id="60" name="TextBox 59"/>
+          <p:cNvPr id="60" name="Rectangle 59"/>
+          <p:cNvSpPr/>
+          <p:nvPr/>
+        </p:nvSpPr>
+        <p:spPr>
+          <a:xfrm>
+            <a:off x="601200" y="3823200"/>
+            <a:ext cx="8179200" cy="7200"/>
+          </a:xfrm>
+          <a:prstGeom prst="rect">
+            <a:avLst/>
+          </a:prstGeom>
+          <a:solidFill>
+            <a:srgbClr val="D0D5DD"/>
+          </a:solidFill>
+          <a:ln>
+            <a:noFill/>
+          </a:ln>
+        </p:spPr>
+        <p:style>
+          <a:lnRef idx="1">
+            <a:schemeClr val="accent1"/>
+          </a:lnRef>
+          <a:fillRef idx="3">
+            <a:schemeClr val="accent1"/>
+          </a:fillRef>
+          <a:effectRef idx="2">
+            <a:schemeClr val="accent1"/>
+          </a:effectRef>
+          <a:fontRef idx="minor">
+            <a:schemeClr val="lt1"/>
+          </a:fontRef>
+        </p:style>
+        <p:txBody>
+          <a:bodyPr rtlCol="0" anchor="ctr"/>
+          <a:lstStyle/>
+          <a:p>
+            <a:pPr algn="ctr"/>
+          </a:p>
+        </p:txBody>
+      </p:sp>
+      <p:sp>
+        <p:nvSpPr>
+          <p:cNvPr id="61" name="TextBox 60"/>
           <p:cNvSpPr txBox="1"/>
           <p:nvPr/>
         </p:nvSpPr>
         <p:spPr>
           <a:xfrm>
-            <a:off x="439200" y="2174400"/>
-            <a:ext cx="1800000" cy="144000"/>
+            <a:off x="367200" y="3751200"/>
+            <a:ext cx="216000" cy="144000"/>
           </a:xfrm>
           <a:prstGeom prst="rect">
             <a:avLst/>
@@ -24110,62 +22484,70 @@
           <a:p>
             <a:pPr algn="l"/>
             <a:r>
-              <a:rPr sz="700" b="0" i="0">
-                <a:solidFill>
-                  <a:srgbClr val="2E5FA3"/>
-                </a:solidFill>
-                <a:latin typeface="Calibri"/>
-              </a:rPr>
-              <a:t>▲ Max : 278,32 $</a:t>
-            </a:r>
-          </a:p>
-        </p:txBody>
-      </p:sp>
-      <p:sp>
-        <p:nvSpPr>
-          <p:cNvPr id="61" name="TextBox 60"/>
-          <p:cNvSpPr txBox="1"/>
-          <p:nvPr/>
-        </p:nvSpPr>
-        <p:spPr>
-          <a:xfrm>
-            <a:off x="439200" y="3643199"/>
-            <a:ext cx="1800000" cy="144000"/>
-          </a:xfrm>
-          <a:prstGeom prst="rect">
-            <a:avLst/>
-          </a:prstGeom>
-          <a:noFill/>
-        </p:spPr>
-        <p:txBody>
-          <a:bodyPr wrap="square">
-            <a:spAutoFit/>
-          </a:bodyPr>
-          <a:lstStyle/>
-          <a:p>
-            <a:pPr algn="l"/>
-            <a:r>
-              <a:rPr sz="700" b="0" i="0">
+              <a:rPr sz="600" b="0" i="0">
                 <a:solidFill>
                   <a:srgbClr val="555555"/>
                 </a:solidFill>
                 <a:latin typeface="Calibri"/>
               </a:rPr>
-              <a:t>▼ Min : 199,98 $</a:t>
-            </a:r>
-          </a:p>
-        </p:txBody>
-      </p:sp>
-      <p:sp>
-        <p:nvSpPr>
-          <p:cNvPr id="62" name="TextBox 61"/>
+              <a:t>199</a:t>
+            </a:r>
+          </a:p>
+        </p:txBody>
+      </p:sp>
+      <p:sp>
+        <p:nvSpPr>
+          <p:cNvPr id="62" name="Rectangle 61"/>
+          <p:cNvSpPr/>
+          <p:nvPr/>
+        </p:nvSpPr>
+        <p:spPr>
+          <a:xfrm>
+            <a:off x="601200" y="3348000"/>
+            <a:ext cx="8179200" cy="7200"/>
+          </a:xfrm>
+          <a:prstGeom prst="rect">
+            <a:avLst/>
+          </a:prstGeom>
+          <a:solidFill>
+            <a:srgbClr val="D0D5DD"/>
+          </a:solidFill>
+          <a:ln>
+            <a:noFill/>
+          </a:ln>
+        </p:spPr>
+        <p:style>
+          <a:lnRef idx="1">
+            <a:schemeClr val="accent1"/>
+          </a:lnRef>
+          <a:fillRef idx="3">
+            <a:schemeClr val="accent1"/>
+          </a:fillRef>
+          <a:effectRef idx="2">
+            <a:schemeClr val="accent1"/>
+          </a:effectRef>
+          <a:fontRef idx="minor">
+            <a:schemeClr val="lt1"/>
+          </a:fontRef>
+        </p:style>
+        <p:txBody>
+          <a:bodyPr rtlCol="0" anchor="ctr"/>
+          <a:lstStyle/>
+          <a:p>
+            <a:pPr algn="ctr"/>
+          </a:p>
+        </p:txBody>
+      </p:sp>
+      <p:sp>
+        <p:nvSpPr>
+          <p:cNvPr id="63" name="TextBox 62"/>
           <p:cNvSpPr txBox="1"/>
           <p:nvPr/>
         </p:nvSpPr>
         <p:spPr>
           <a:xfrm>
-            <a:off x="367200" y="4132800"/>
-            <a:ext cx="8413200" cy="687600"/>
+            <a:off x="367200" y="3276000"/>
+            <a:ext cx="216000" cy="144000"/>
           </a:xfrm>
           <a:prstGeom prst="rect">
             <a:avLst/>
@@ -24180,13 +22562,169 @@
           <a:p>
             <a:pPr algn="l"/>
             <a:r>
-              <a:rPr sz="850" b="0" i="0">
+              <a:rPr sz="600" b="0" i="0">
                 <a:solidFill>
                   <a:srgbClr val="555555"/>
                 </a:solidFill>
                 <a:latin typeface="Calibri"/>
               </a:rPr>
-              <a:t>Apple Inc. presente une opportunité d'investissement attractive avec des perspectives de croissance solides et une position dominante sur le marché. L'entreprise devrait poursuivre sa croissance grâce à ses produits innovants et à son écosystème intégré.</a:t>
+              <a:t>225</a:t>
+            </a:r>
+          </a:p>
+        </p:txBody>
+      </p:sp>
+      <p:sp>
+        <p:nvSpPr>
+          <p:cNvPr id="64" name="Rectangle 63"/>
+          <p:cNvSpPr/>
+          <p:nvPr/>
+        </p:nvSpPr>
+        <p:spPr>
+          <a:xfrm>
+            <a:off x="601200" y="2858400"/>
+            <a:ext cx="8179200" cy="7200"/>
+          </a:xfrm>
+          <a:prstGeom prst="rect">
+            <a:avLst/>
+          </a:prstGeom>
+          <a:solidFill>
+            <a:srgbClr val="D0D5DD"/>
+          </a:solidFill>
+          <a:ln>
+            <a:noFill/>
+          </a:ln>
+        </p:spPr>
+        <p:style>
+          <a:lnRef idx="1">
+            <a:schemeClr val="accent1"/>
+          </a:lnRef>
+          <a:fillRef idx="3">
+            <a:schemeClr val="accent1"/>
+          </a:fillRef>
+          <a:effectRef idx="2">
+            <a:schemeClr val="accent1"/>
+          </a:effectRef>
+          <a:fontRef idx="minor">
+            <a:schemeClr val="lt1"/>
+          </a:fontRef>
+        </p:style>
+        <p:txBody>
+          <a:bodyPr rtlCol="0" anchor="ctr"/>
+          <a:lstStyle/>
+          <a:p>
+            <a:pPr algn="ctr"/>
+          </a:p>
+        </p:txBody>
+      </p:sp>
+      <p:sp>
+        <p:nvSpPr>
+          <p:cNvPr id="65" name="TextBox 64"/>
+          <p:cNvSpPr txBox="1"/>
+          <p:nvPr/>
+        </p:nvSpPr>
+        <p:spPr>
+          <a:xfrm>
+            <a:off x="367200" y="2786399"/>
+            <a:ext cx="216000" cy="144000"/>
+          </a:xfrm>
+          <a:prstGeom prst="rect">
+            <a:avLst/>
+          </a:prstGeom>
+          <a:noFill/>
+        </p:spPr>
+        <p:txBody>
+          <a:bodyPr wrap="square">
+            <a:spAutoFit/>
+          </a:bodyPr>
+          <a:lstStyle/>
+          <a:p>
+            <a:pPr algn="l"/>
+            <a:r>
+              <a:rPr sz="600" b="0" i="0">
+                <a:solidFill>
+                  <a:srgbClr val="555555"/>
+                </a:solidFill>
+                <a:latin typeface="Calibri"/>
+              </a:rPr>
+              <a:t>252</a:t>
+            </a:r>
+          </a:p>
+        </p:txBody>
+      </p:sp>
+      <p:sp>
+        <p:nvSpPr>
+          <p:cNvPr id="66" name="Rectangle 65"/>
+          <p:cNvSpPr/>
+          <p:nvPr/>
+        </p:nvSpPr>
+        <p:spPr>
+          <a:xfrm>
+            <a:off x="601200" y="2383200"/>
+            <a:ext cx="8179200" cy="7200"/>
+          </a:xfrm>
+          <a:prstGeom prst="rect">
+            <a:avLst/>
+          </a:prstGeom>
+          <a:solidFill>
+            <a:srgbClr val="D0D5DD"/>
+          </a:solidFill>
+          <a:ln>
+            <a:noFill/>
+          </a:ln>
+        </p:spPr>
+        <p:style>
+          <a:lnRef idx="1">
+            <a:schemeClr val="accent1"/>
+          </a:lnRef>
+          <a:fillRef idx="3">
+            <a:schemeClr val="accent1"/>
+          </a:fillRef>
+          <a:effectRef idx="2">
+            <a:schemeClr val="accent1"/>
+          </a:effectRef>
+          <a:fontRef idx="minor">
+            <a:schemeClr val="lt1"/>
+          </a:fontRef>
+        </p:style>
+        <p:txBody>
+          <a:bodyPr rtlCol="0" anchor="ctr"/>
+          <a:lstStyle/>
+          <a:p>
+            <a:pPr algn="ctr"/>
+          </a:p>
+        </p:txBody>
+      </p:sp>
+      <p:sp>
+        <p:nvSpPr>
+          <p:cNvPr id="67" name="TextBox 66"/>
+          <p:cNvSpPr txBox="1"/>
+          <p:nvPr/>
+        </p:nvSpPr>
+        <p:spPr>
+          <a:xfrm>
+            <a:off x="367200" y="2311200"/>
+            <a:ext cx="216000" cy="144000"/>
+          </a:xfrm>
+          <a:prstGeom prst="rect">
+            <a:avLst/>
+          </a:prstGeom>
+          <a:noFill/>
+        </p:spPr>
+        <p:txBody>
+          <a:bodyPr wrap="square">
+            <a:spAutoFit/>
+          </a:bodyPr>
+          <a:lstStyle/>
+          <a:p>
+            <a:pPr algn="l"/>
+            <a:r>
+              <a:rPr sz="600" b="0" i="0">
+                <a:solidFill>
+                  <a:srgbClr val="555555"/>
+                </a:solidFill>
+                <a:latin typeface="Calibri"/>
+              </a:rPr>
+              <a:t>278</a:t>
             </a:r>
           </a:p>
         </p:txBody>
@@ -25229,7 +23767,7 @@
                 </a:solidFill>
                 <a:latin typeface="Calibri"/>
               </a:rPr>
-              <a:t>Concurrence accrue  ·  Dépendance aux smartphones</a:t>
+              <a:t>Risques structurels &amp; thèse contraire</a:t>
             </a:r>
           </a:p>
         </p:txBody>
@@ -26463,64 +25001,21 @@
                 </a:solidFill>
                 <a:latin typeface="Calibri"/>
               </a:rPr>
-              <a:t>Apple Inc. est un leader mondial dans la conception, la fabrication et la commercialisation de produits électroniques grand public. L'entreprise est positionnée comme un acteur majeur sur le marché des smartphones et des ordinateurs portables. Ses avantages concurrentiels incluent son écosystème intégré, sa marque forte et son innovante gamme de produits. L'entreprise articule son activité autour de deux segments stratégiques :</a:t>
-            </a:r>
-          </a:p>
-        </p:txBody>
-      </p:sp>
-      <p:sp>
-        <p:nvSpPr>
-          <p:cNvPr id="20" name="Rectangle 19"/>
-          <p:cNvSpPr/>
-          <p:nvPr/>
-        </p:nvSpPr>
-        <p:spPr>
-          <a:xfrm>
-            <a:off x="503999" y="2599200"/>
-            <a:ext cx="64800" cy="64800"/>
-          </a:xfrm>
-          <a:prstGeom prst="rect">
-            <a:avLst/>
-          </a:prstGeom>
-          <a:solidFill>
-            <a:srgbClr val="2E5FA3"/>
-          </a:solidFill>
-          <a:ln>
-            <a:noFill/>
-          </a:ln>
-        </p:spPr>
-        <p:style>
-          <a:lnRef idx="1">
-            <a:schemeClr val="accent1"/>
-          </a:lnRef>
-          <a:fillRef idx="3">
-            <a:schemeClr val="accent1"/>
-          </a:fillRef>
-          <a:effectRef idx="2">
-            <a:schemeClr val="accent1"/>
-          </a:effectRef>
-          <a:fontRef idx="minor">
-            <a:schemeClr val="lt1"/>
-          </a:fontRef>
-        </p:style>
-        <p:txBody>
-          <a:bodyPr rtlCol="0" anchor="ctr"/>
-          <a:lstStyle/>
-          <a:p>
-            <a:pPr algn="ctr"/>
-          </a:p>
-        </p:txBody>
-      </p:sp>
-      <p:sp>
-        <p:nvSpPr>
-          <p:cNvPr id="21" name="TextBox 20"/>
+              <a:t>—</a:t>
+            </a:r>
+          </a:p>
+        </p:txBody>
+      </p:sp>
+      <p:sp>
+        <p:nvSpPr>
+          <p:cNvPr id="20" name="TextBox 19"/>
           <p:cNvSpPr txBox="1"/>
           <p:nvPr/>
         </p:nvSpPr>
         <p:spPr>
           <a:xfrm>
-            <a:off x="619200" y="2556000"/>
-            <a:ext cx="4338000" cy="165600"/>
+            <a:off x="503999" y="2358000"/>
+            <a:ext cx="4662000" cy="183600"/>
           </a:xfrm>
           <a:prstGeom prst="rect">
             <a:avLst/>
@@ -26535,168 +25030,20 @@
           <a:p>
             <a:pPr algn="l"/>
             <a:r>
-              <a:rPr sz="850" b="1" i="0">
+              <a:rPr sz="900" b="1" i="0">
                 <a:solidFill>
-                  <a:srgbClr val="0D0D0D"/>
+                  <a:srgbClr val="1B3A6B"/>
                 </a:solidFill>
                 <a:latin typeface="Calibri"/>
               </a:rPr>
-              <a:t>Produits</a:t>
-            </a:r>
-          </a:p>
-        </p:txBody>
-      </p:sp>
-      <p:sp>
-        <p:nvSpPr>
-          <p:cNvPr id="22" name="TextBox 21"/>
-          <p:cNvSpPr txBox="1"/>
-          <p:nvPr/>
-        </p:nvSpPr>
-        <p:spPr>
-          <a:xfrm>
-            <a:off x="619200" y="2714400"/>
-            <a:ext cx="4338000" cy="144000"/>
-          </a:xfrm>
-          <a:prstGeom prst="rect">
-            <a:avLst/>
-          </a:prstGeom>
-          <a:noFill/>
-        </p:spPr>
-        <p:txBody>
-          <a:bodyPr wrap="square">
-            <a:spAutoFit/>
-          </a:bodyPr>
-          <a:lstStyle/>
-          <a:p>
-            <a:pPr algn="l"/>
-            <a:r>
-              <a:rPr sz="750" b="0" i="1">
-                <a:solidFill>
-                  <a:srgbClr val="555555"/>
-                </a:solidFill>
-                <a:latin typeface="Calibri"/>
-              </a:rPr>
-              <a:t>Les produits d'Apple incluent les iPhone, les Mac, les iPad, les Apple Watch et les AirPods.…</a:t>
-            </a:r>
-          </a:p>
-        </p:txBody>
-      </p:sp>
-      <p:sp>
-        <p:nvSpPr>
-          <p:cNvPr id="23" name="Rectangle 22"/>
-          <p:cNvSpPr/>
-          <p:nvPr/>
-        </p:nvSpPr>
-        <p:spPr>
-          <a:xfrm>
-            <a:off x="503999" y="2941199"/>
-            <a:ext cx="64800" cy="64800"/>
-          </a:xfrm>
-          <a:prstGeom prst="rect">
-            <a:avLst/>
-          </a:prstGeom>
-          <a:solidFill>
-            <a:srgbClr val="2E5FA3"/>
-          </a:solidFill>
-          <a:ln>
-            <a:noFill/>
-          </a:ln>
-        </p:spPr>
-        <p:style>
-          <a:lnRef idx="1">
-            <a:schemeClr val="accent1"/>
-          </a:lnRef>
-          <a:fillRef idx="3">
-            <a:schemeClr val="accent1"/>
-          </a:fillRef>
-          <a:effectRef idx="2">
-            <a:schemeClr val="accent1"/>
-          </a:effectRef>
-          <a:fontRef idx="minor">
-            <a:schemeClr val="lt1"/>
-          </a:fontRef>
-        </p:style>
-        <p:txBody>
-          <a:bodyPr rtlCol="0" anchor="ctr"/>
-          <a:lstStyle/>
-          <a:p>
-            <a:pPr algn="ctr"/>
-          </a:p>
-        </p:txBody>
-      </p:sp>
-      <p:sp>
-        <p:nvSpPr>
-          <p:cNvPr id="24" name="TextBox 23"/>
-          <p:cNvSpPr txBox="1"/>
-          <p:nvPr/>
-        </p:nvSpPr>
-        <p:spPr>
-          <a:xfrm>
-            <a:off x="619200" y="2897999"/>
-            <a:ext cx="4338000" cy="165600"/>
-          </a:xfrm>
-          <a:prstGeom prst="rect">
-            <a:avLst/>
-          </a:prstGeom>
-          <a:noFill/>
-        </p:spPr>
-        <p:txBody>
-          <a:bodyPr wrap="square">
-            <a:spAutoFit/>
-          </a:bodyPr>
-          <a:lstStyle/>
-          <a:p>
-            <a:pPr algn="l"/>
-            <a:r>
-              <a:rPr sz="850" b="1" i="0">
-                <a:solidFill>
-                  <a:srgbClr val="0D0D0D"/>
-                </a:solidFill>
-                <a:latin typeface="Calibri"/>
-              </a:rPr>
-              <a:t>Services</a:t>
-            </a:r>
-          </a:p>
-        </p:txBody>
-      </p:sp>
-      <p:sp>
-        <p:nvSpPr>
-          <p:cNvPr id="25" name="TextBox 24"/>
-          <p:cNvSpPr txBox="1"/>
-          <p:nvPr/>
-        </p:nvSpPr>
-        <p:spPr>
-          <a:xfrm>
-            <a:off x="619200" y="3056399"/>
-            <a:ext cx="4338000" cy="144000"/>
-          </a:xfrm>
-          <a:prstGeom prst="rect">
-            <a:avLst/>
-          </a:prstGeom>
-          <a:noFill/>
-        </p:spPr>
-        <p:txBody>
-          <a:bodyPr wrap="square">
-            <a:spAutoFit/>
-          </a:bodyPr>
-          <a:lstStyle/>
-          <a:p>
-            <a:pPr algn="l"/>
-            <a:r>
-              <a:rPr sz="750" b="0" i="1">
-                <a:solidFill>
-                  <a:srgbClr val="555555"/>
-                </a:solidFill>
-                <a:latin typeface="Calibri"/>
-              </a:rPr>
-              <a:t>Les services d'Apple incluent la musique, les films, les applications et les abonnements.…</a:t>
-            </a:r>
-          </a:p>
-        </p:txBody>
-      </p:sp>
-      <p:sp>
-        <p:nvSpPr>
-          <p:cNvPr id="26" name="Rectangle 25"/>
+              <a:t>Positionnement stratégique</a:t>
+            </a:r>
+          </a:p>
+        </p:txBody>
+      </p:sp>
+      <p:sp>
+        <p:nvSpPr>
+          <p:cNvPr id="21" name="Rectangle 20"/>
           <p:cNvSpPr/>
           <p:nvPr/>
         </p:nvSpPr>
@@ -26739,7 +25086,7 @@
       </p:sp>
       <p:sp>
         <p:nvSpPr>
-          <p:cNvPr id="27" name="Rectangle 26"/>
+          <p:cNvPr id="22" name="Rectangle 21"/>
           <p:cNvSpPr/>
           <p:nvPr/>
         </p:nvSpPr>
@@ -26782,7 +25129,7 @@
       </p:sp>
       <p:sp>
         <p:nvSpPr>
-          <p:cNvPr id="28" name="TextBox 27"/>
+          <p:cNvPr id="23" name="TextBox 22"/>
           <p:cNvSpPr txBox="1"/>
           <p:nvPr/>
         </p:nvSpPr>
@@ -26810,14 +25157,14 @@
                 </a:solidFill>
                 <a:latin typeface="Calibri"/>
               </a:rPr>
-              <a:t>3 719,9 Mds$</a:t>
-            </a:r>
-          </a:p>
-        </p:txBody>
-      </p:sp>
-      <p:sp>
-        <p:nvSpPr>
-          <p:cNvPr id="29" name="TextBox 28"/>
+              <a:t>3 724,3 Mds$</a:t>
+            </a:r>
+          </a:p>
+        </p:txBody>
+      </p:sp>
+      <p:sp>
+        <p:nvSpPr>
+          <p:cNvPr id="24" name="TextBox 23"/>
           <p:cNvSpPr txBox="1"/>
           <p:nvPr/>
         </p:nvSpPr>
@@ -26852,7 +25199,7 @@
       </p:sp>
       <p:sp>
         <p:nvSpPr>
-          <p:cNvPr id="30" name="Rectangle 29"/>
+          <p:cNvPr id="25" name="Rectangle 24"/>
           <p:cNvSpPr/>
           <p:nvPr/>
         </p:nvSpPr>
@@ -26895,7 +25242,7 @@
       </p:sp>
       <p:sp>
         <p:nvSpPr>
-          <p:cNvPr id="31" name="Rectangle 30"/>
+          <p:cNvPr id="26" name="Rectangle 25"/>
           <p:cNvSpPr/>
           <p:nvPr/>
         </p:nvSpPr>
@@ -26938,7 +25285,7 @@
       </p:sp>
       <p:sp>
         <p:nvSpPr>
-          <p:cNvPr id="32" name="TextBox 31"/>
+          <p:cNvPr id="27" name="TextBox 26"/>
           <p:cNvSpPr txBox="1"/>
           <p:nvPr/>
         </p:nvSpPr>
@@ -26973,7 +25320,7 @@
       </p:sp>
       <p:sp>
         <p:nvSpPr>
-          <p:cNvPr id="33" name="TextBox 32"/>
+          <p:cNvPr id="28" name="TextBox 27"/>
           <p:cNvSpPr txBox="1"/>
           <p:nvPr/>
         </p:nvSpPr>
@@ -27008,7 +25355,7 @@
       </p:sp>
       <p:sp>
         <p:nvSpPr>
-          <p:cNvPr id="34" name="Rectangle 33"/>
+          <p:cNvPr id="29" name="Rectangle 28"/>
           <p:cNvSpPr/>
           <p:nvPr/>
         </p:nvSpPr>
@@ -27051,7 +25398,7 @@
       </p:sp>
       <p:sp>
         <p:nvSpPr>
-          <p:cNvPr id="35" name="Rectangle 34"/>
+          <p:cNvPr id="30" name="Rectangle 29"/>
           <p:cNvSpPr/>
           <p:nvPr/>
         </p:nvSpPr>
@@ -27094,7 +25441,7 @@
       </p:sp>
       <p:sp>
         <p:nvSpPr>
-          <p:cNvPr id="36" name="TextBox 35"/>
+          <p:cNvPr id="31" name="TextBox 30"/>
           <p:cNvSpPr txBox="1"/>
           <p:nvPr/>
         </p:nvSpPr>
@@ -27122,14 +25469,14 @@
                 </a:solidFill>
                 <a:latin typeface="Calibri"/>
               </a:rPr>
-              <a:t>253,38 $</a:t>
-            </a:r>
-          </a:p>
-        </p:txBody>
-      </p:sp>
-      <p:sp>
-        <p:nvSpPr>
-          <p:cNvPr id="37" name="TextBox 36"/>
+              <a:t>253,68 $</a:t>
+            </a:r>
+          </a:p>
+        </p:txBody>
+      </p:sp>
+      <p:sp>
+        <p:nvSpPr>
+          <p:cNvPr id="32" name="TextBox 31"/>
           <p:cNvSpPr txBox="1"/>
           <p:nvPr/>
         </p:nvSpPr>
@@ -27164,7 +25511,7 @@
       </p:sp>
       <p:sp>
         <p:nvSpPr>
-          <p:cNvPr id="38" name="Rectangle 37"/>
+          <p:cNvPr id="33" name="Rectangle 32"/>
           <p:cNvSpPr/>
           <p:nvPr/>
         </p:nvSpPr>
@@ -27207,7 +25554,7 @@
       </p:sp>
       <p:sp>
         <p:nvSpPr>
-          <p:cNvPr id="39" name="Rectangle 38"/>
+          <p:cNvPr id="34" name="Rectangle 33"/>
           <p:cNvSpPr/>
           <p:nvPr/>
         </p:nvSpPr>
@@ -27250,7 +25597,7 @@
       </p:sp>
       <p:sp>
         <p:nvSpPr>
-          <p:cNvPr id="40" name="TextBox 39"/>
+          <p:cNvPr id="35" name="TextBox 34"/>
           <p:cNvSpPr txBox="1"/>
           <p:nvPr/>
         </p:nvSpPr>
@@ -27278,14 +25625,14 @@
                 </a:solidFill>
                 <a:latin typeface="Calibri"/>
               </a:rPr>
-              <a:t>26,1x</a:t>
-            </a:r>
-          </a:p>
-        </p:txBody>
-      </p:sp>
-      <p:sp>
-        <p:nvSpPr>
-          <p:cNvPr id="41" name="TextBox 40"/>
+              <a:t>26,2x</a:t>
+            </a:r>
+          </a:p>
+        </p:txBody>
+      </p:sp>
+      <p:sp>
+        <p:nvSpPr>
+          <p:cNvPr id="36" name="TextBox 35"/>
           <p:cNvSpPr txBox="1"/>
           <p:nvPr/>
         </p:nvSpPr>
@@ -27320,7 +25667,7 @@
       </p:sp>
       <p:sp>
         <p:nvSpPr>
-          <p:cNvPr id="42" name="TextBox 41"/>
+          <p:cNvPr id="37" name="TextBox 36"/>
           <p:cNvSpPr txBox="1"/>
           <p:nvPr/>
         </p:nvSpPr>
@@ -27961,7 +26308,7 @@
         <p:spPr>
           <a:xfrm>
             <a:off x="367200" y="961200"/>
-            <a:ext cx="4150800" cy="3520800"/>
+            <a:ext cx="2731199" cy="3520800"/>
           </a:xfrm>
           <a:prstGeom prst="rect">
             <a:avLst/>
@@ -28004,7 +26351,7 @@
         <p:spPr>
           <a:xfrm>
             <a:off x="367200" y="961200"/>
-            <a:ext cx="4150800" cy="54000"/>
+            <a:ext cx="2731199" cy="54000"/>
           </a:xfrm>
           <a:prstGeom prst="rect">
             <a:avLst/>
@@ -28047,7 +26394,7 @@
         <p:spPr>
           <a:xfrm>
             <a:off x="457200" y="1141200"/>
-            <a:ext cx="3970800" cy="640800"/>
+            <a:ext cx="2551199" cy="640800"/>
           </a:xfrm>
           <a:prstGeom prst="rect">
             <a:avLst/>
@@ -28068,7 +26415,7 @@
                 </a:solidFill>
                 <a:latin typeface="Calibri"/>
               </a:rPr>
-              <a:t>1%</a:t>
+              <a:t>—</a:t>
             </a:r>
           </a:p>
         </p:txBody>
@@ -28082,7 +26429,7 @@
         <p:spPr>
           <a:xfrm>
             <a:off x="457200" y="1785600"/>
-            <a:ext cx="3970800" cy="108000"/>
+            <a:ext cx="2551199" cy="108000"/>
           </a:xfrm>
           <a:prstGeom prst="rect">
             <a:avLst/>
@@ -28117,7 +26464,7 @@
         <p:spPr>
           <a:xfrm>
             <a:off x="457200" y="1965600"/>
-            <a:ext cx="3970800" cy="18000"/>
+            <a:ext cx="2551199" cy="18000"/>
           </a:xfrm>
           <a:prstGeom prst="rect">
             <a:avLst/>
@@ -28160,7 +26507,7 @@
         <p:spPr>
           <a:xfrm>
             <a:off x="457200" y="2059200"/>
-            <a:ext cx="3970800" cy="255600"/>
+            <a:ext cx="2551199" cy="255600"/>
           </a:xfrm>
           <a:prstGeom prst="rect">
             <a:avLst/>
@@ -28181,7 +26528,7 @@
                 </a:solidFill>
                 <a:latin typeface="Calibri"/>
               </a:rPr>
-              <a:t>Produits</a:t>
+              <a:t>Core Business</a:t>
             </a:r>
           </a:p>
         </p:txBody>
@@ -28195,7 +26542,7 @@
         <p:spPr>
           <a:xfrm>
             <a:off x="457200" y="2332800"/>
-            <a:ext cx="3970800" cy="1800000"/>
+            <a:ext cx="2551199" cy="2041199"/>
           </a:xfrm>
           <a:prstGeom prst="rect">
             <a:avLst/>
@@ -28216,7 +26563,7 @@
                 </a:solidFill>
                 <a:latin typeface="Calibri"/>
               </a:rPr>
-              <a:t>Les produits d'Apple incluent les iPhone, les Mac, les iPad, les Apple Watch et les AirPods. L'entreprise génère la majorité de ses revenus grâce à la vente de ces produits. Les principaux moteurs de croissance sont la demande croissante pour les…</a:t>
+              <a:t>—</a:t>
             </a:r>
           </a:p>
         </p:txBody>
@@ -28229,8 +26576,8 @@
         </p:nvSpPr>
         <p:spPr>
           <a:xfrm>
-            <a:off x="4626000" y="961200"/>
-            <a:ext cx="4150800" cy="3520800"/>
+            <a:off x="3206400" y="961200"/>
+            <a:ext cx="2731199" cy="3520800"/>
           </a:xfrm>
           <a:prstGeom prst="rect">
             <a:avLst/>
@@ -28272,8 +26619,8 @@
         </p:nvSpPr>
         <p:spPr>
           <a:xfrm>
-            <a:off x="4626000" y="961200"/>
-            <a:ext cx="4150800" cy="54000"/>
+            <a:off x="3206400" y="961200"/>
+            <a:ext cx="2731199" cy="54000"/>
           </a:xfrm>
           <a:prstGeom prst="rect">
             <a:avLst/>
@@ -28315,8 +26662,8 @@
         </p:nvSpPr>
         <p:spPr>
           <a:xfrm>
-            <a:off x="4716000" y="1141200"/>
-            <a:ext cx="3970800" cy="640800"/>
+            <a:off x="3296400" y="1141200"/>
+            <a:ext cx="2551199" cy="640800"/>
           </a:xfrm>
           <a:prstGeom prst="rect">
             <a:avLst/>
@@ -28337,7 +26684,7 @@
                 </a:solidFill>
                 <a:latin typeface="Calibri"/>
               </a:rPr>
-              <a:t>0%</a:t>
+              <a:t>—</a:t>
             </a:r>
           </a:p>
         </p:txBody>
@@ -28350,8 +26697,8 @@
         </p:nvSpPr>
         <p:spPr>
           <a:xfrm>
-            <a:off x="4716000" y="1785600"/>
-            <a:ext cx="3970800" cy="108000"/>
+            <a:off x="3296400" y="1785600"/>
+            <a:ext cx="2551199" cy="108000"/>
           </a:xfrm>
           <a:prstGeom prst="rect">
             <a:avLst/>
@@ -28385,8 +26732,8 @@
         </p:nvSpPr>
         <p:spPr>
           <a:xfrm>
-            <a:off x="4716000" y="1965600"/>
-            <a:ext cx="3970800" cy="18000"/>
+            <a:off x="3296400" y="1965600"/>
+            <a:ext cx="2551199" cy="18000"/>
           </a:xfrm>
           <a:prstGeom prst="rect">
             <a:avLst/>
@@ -28428,8 +26775,8 @@
         </p:nvSpPr>
         <p:spPr>
           <a:xfrm>
-            <a:off x="4716000" y="2059200"/>
-            <a:ext cx="3970800" cy="255600"/>
+            <a:off x="3296400" y="2059200"/>
+            <a:ext cx="2551199" cy="255600"/>
           </a:xfrm>
           <a:prstGeom prst="rect">
             <a:avLst/>
@@ -28450,7 +26797,7 @@
                 </a:solidFill>
                 <a:latin typeface="Calibri"/>
               </a:rPr>
-              <a:t>Services</a:t>
+              <a:t>Growth Driver</a:t>
             </a:r>
           </a:p>
         </p:txBody>
@@ -28463,8 +26810,8 @@
         </p:nvSpPr>
         <p:spPr>
           <a:xfrm>
-            <a:off x="4716000" y="2332800"/>
-            <a:ext cx="3970800" cy="1800000"/>
+            <a:off x="3296400" y="2332800"/>
+            <a:ext cx="2551199" cy="2041199"/>
           </a:xfrm>
           <a:prstGeom prst="rect">
             <a:avLst/>
@@ -28485,7 +26832,276 @@
                 </a:solidFill>
                 <a:latin typeface="Calibri"/>
               </a:rPr>
-              <a:t>Les services d'Apple incluent la musique, les films, les applications et les abonnements. L'entreprise cherche à diversifier ses sources de revenus en développant ses services. Les moteurs de croissance incluent la croissance du marché des services…</a:t>
+              <a:t>—</a:t>
+            </a:r>
+          </a:p>
+        </p:txBody>
+      </p:sp>
+      <p:sp>
+        <p:nvSpPr>
+          <p:cNvPr id="31" name="Rectangle 30"/>
+          <p:cNvSpPr/>
+          <p:nvPr/>
+        </p:nvSpPr>
+        <p:spPr>
+          <a:xfrm>
+            <a:off x="6045600" y="961200"/>
+            <a:ext cx="2731199" cy="3520800"/>
+          </a:xfrm>
+          <a:prstGeom prst="rect">
+            <a:avLst/>
+          </a:prstGeom>
+          <a:solidFill>
+            <a:srgbClr val="F7F8FA"/>
+          </a:solidFill>
+          <a:ln>
+            <a:noFill/>
+          </a:ln>
+        </p:spPr>
+        <p:style>
+          <a:lnRef idx="1">
+            <a:schemeClr val="accent1"/>
+          </a:lnRef>
+          <a:fillRef idx="3">
+            <a:schemeClr val="accent1"/>
+          </a:fillRef>
+          <a:effectRef idx="2">
+            <a:schemeClr val="accent1"/>
+          </a:effectRef>
+          <a:fontRef idx="minor">
+            <a:schemeClr val="lt1"/>
+          </a:fontRef>
+        </p:style>
+        <p:txBody>
+          <a:bodyPr rtlCol="0" anchor="ctr"/>
+          <a:lstStyle/>
+          <a:p>
+            <a:pPr algn="ctr"/>
+          </a:p>
+        </p:txBody>
+      </p:sp>
+      <p:sp>
+        <p:nvSpPr>
+          <p:cNvPr id="32" name="Rectangle 31"/>
+          <p:cNvSpPr/>
+          <p:nvPr/>
+        </p:nvSpPr>
+        <p:spPr>
+          <a:xfrm>
+            <a:off x="6045600" y="961200"/>
+            <a:ext cx="2731199" cy="54000"/>
+          </a:xfrm>
+          <a:prstGeom prst="rect">
+            <a:avLst/>
+          </a:prstGeom>
+          <a:solidFill>
+            <a:srgbClr val="888888"/>
+          </a:solidFill>
+          <a:ln>
+            <a:noFill/>
+          </a:ln>
+        </p:spPr>
+        <p:style>
+          <a:lnRef idx="1">
+            <a:schemeClr val="accent1"/>
+          </a:lnRef>
+          <a:fillRef idx="3">
+            <a:schemeClr val="accent1"/>
+          </a:fillRef>
+          <a:effectRef idx="2">
+            <a:schemeClr val="accent1"/>
+          </a:effectRef>
+          <a:fontRef idx="minor">
+            <a:schemeClr val="lt1"/>
+          </a:fontRef>
+        </p:style>
+        <p:txBody>
+          <a:bodyPr rtlCol="0" anchor="ctr"/>
+          <a:lstStyle/>
+          <a:p>
+            <a:pPr algn="ctr"/>
+          </a:p>
+        </p:txBody>
+      </p:sp>
+      <p:sp>
+        <p:nvSpPr>
+          <p:cNvPr id="33" name="TextBox 32"/>
+          <p:cNvSpPr txBox="1"/>
+          <p:nvPr/>
+        </p:nvSpPr>
+        <p:spPr>
+          <a:xfrm>
+            <a:off x="6135600" y="1141200"/>
+            <a:ext cx="2551199" cy="640800"/>
+          </a:xfrm>
+          <a:prstGeom prst="rect">
+            <a:avLst/>
+          </a:prstGeom>
+          <a:noFill/>
+        </p:spPr>
+        <p:txBody>
+          <a:bodyPr wrap="square">
+            <a:spAutoFit/>
+          </a:bodyPr>
+          <a:lstStyle/>
+          <a:p>
+            <a:pPr algn="l"/>
+            <a:r>
+              <a:rPr sz="2200" b="1" i="0">
+                <a:solidFill>
+                  <a:srgbClr val="888888"/>
+                </a:solidFill>
+                <a:latin typeface="Calibri"/>
+              </a:rPr>
+              <a:t>—</a:t>
+            </a:r>
+          </a:p>
+        </p:txBody>
+      </p:sp>
+      <p:sp>
+        <p:nvSpPr>
+          <p:cNvPr id="34" name="TextBox 33"/>
+          <p:cNvSpPr txBox="1"/>
+          <p:nvPr/>
+        </p:nvSpPr>
+        <p:spPr>
+          <a:xfrm>
+            <a:off x="6135600" y="1785600"/>
+            <a:ext cx="2551199" cy="108000"/>
+          </a:xfrm>
+          <a:prstGeom prst="rect">
+            <a:avLst/>
+          </a:prstGeom>
+          <a:noFill/>
+        </p:spPr>
+        <p:txBody>
+          <a:bodyPr wrap="square">
+            <a:spAutoFit/>
+          </a:bodyPr>
+          <a:lstStyle/>
+          <a:p>
+            <a:pPr algn="l"/>
+            <a:r>
+              <a:rPr sz="900" b="0" i="0">
+                <a:solidFill>
+                  <a:srgbClr val="555555"/>
+                </a:solidFill>
+                <a:latin typeface="Calibri"/>
+              </a:rPr>
+              <a:t>du CA</a:t>
+            </a:r>
+          </a:p>
+        </p:txBody>
+      </p:sp>
+      <p:sp>
+        <p:nvSpPr>
+          <p:cNvPr id="35" name="Rectangle 34"/>
+          <p:cNvSpPr/>
+          <p:nvPr/>
+        </p:nvSpPr>
+        <p:spPr>
+          <a:xfrm>
+            <a:off x="6135600" y="1965600"/>
+            <a:ext cx="2551199" cy="18000"/>
+          </a:xfrm>
+          <a:prstGeom prst="rect">
+            <a:avLst/>
+          </a:prstGeom>
+          <a:solidFill>
+            <a:srgbClr val="888888"/>
+          </a:solidFill>
+          <a:ln>
+            <a:noFill/>
+          </a:ln>
+        </p:spPr>
+        <p:style>
+          <a:lnRef idx="1">
+            <a:schemeClr val="accent1"/>
+          </a:lnRef>
+          <a:fillRef idx="3">
+            <a:schemeClr val="accent1"/>
+          </a:fillRef>
+          <a:effectRef idx="2">
+            <a:schemeClr val="accent1"/>
+          </a:effectRef>
+          <a:fontRef idx="minor">
+            <a:schemeClr val="lt1"/>
+          </a:fontRef>
+        </p:style>
+        <p:txBody>
+          <a:bodyPr rtlCol="0" anchor="ctr"/>
+          <a:lstStyle/>
+          <a:p>
+            <a:pPr algn="ctr"/>
+          </a:p>
+        </p:txBody>
+      </p:sp>
+      <p:sp>
+        <p:nvSpPr>
+          <p:cNvPr id="36" name="TextBox 35"/>
+          <p:cNvSpPr txBox="1"/>
+          <p:nvPr/>
+        </p:nvSpPr>
+        <p:spPr>
+          <a:xfrm>
+            <a:off x="6135600" y="2059200"/>
+            <a:ext cx="2551199" cy="255600"/>
+          </a:xfrm>
+          <a:prstGeom prst="rect">
+            <a:avLst/>
+          </a:prstGeom>
+          <a:noFill/>
+        </p:spPr>
+        <p:txBody>
+          <a:bodyPr wrap="square">
+            <a:spAutoFit/>
+          </a:bodyPr>
+          <a:lstStyle/>
+          <a:p>
+            <a:pPr algn="l"/>
+            <a:r>
+              <a:rPr sz="1000" b="1" i="0">
+                <a:solidFill>
+                  <a:srgbClr val="1B3A6B"/>
+                </a:solidFill>
+                <a:latin typeface="Calibri"/>
+              </a:rPr>
+              <a:t>International</a:t>
+            </a:r>
+          </a:p>
+        </p:txBody>
+      </p:sp>
+      <p:sp>
+        <p:nvSpPr>
+          <p:cNvPr id="37" name="TextBox 36"/>
+          <p:cNvSpPr txBox="1"/>
+          <p:nvPr/>
+        </p:nvSpPr>
+        <p:spPr>
+          <a:xfrm>
+            <a:off x="6135600" y="2332800"/>
+            <a:ext cx="2551199" cy="2041199"/>
+          </a:xfrm>
+          <a:prstGeom prst="rect">
+            <a:avLst/>
+          </a:prstGeom>
+          <a:noFill/>
+        </p:spPr>
+        <p:txBody>
+          <a:bodyPr wrap="square">
+            <a:spAutoFit/>
+          </a:bodyPr>
+          <a:lstStyle/>
+          <a:p>
+            <a:pPr algn="l"/>
+            <a:r>
+              <a:rPr sz="800" b="0" i="0">
+                <a:solidFill>
+                  <a:srgbClr val="555555"/>
+                </a:solidFill>
+                <a:latin typeface="Calibri"/>
+              </a:rPr>
+              <a:t>—</a:t>
             </a:r>
           </a:p>
         </p:txBody>
@@ -29337,7 +27953,7 @@
                 </a:solidFill>
                 <a:latin typeface="Calibri"/>
               </a:rPr>
-              <a:t>USD millions  ·  2021–2027F</a:t>
+              <a:t>USD millions  ·  2021–2025</a:t>
             </a:r>
           </a:p>
         </p:txBody>
@@ -29352,7 +27968,7 @@
         </p:nvGraphicFramePr>
         <p:xfrm>
           <a:off x="367200" y="914400"/>
-          <a:ext cx="8413196" cy="1980000"/>
+          <a:ext cx="8413200" cy="1980000"/>
         </p:xfrm>
         <a:graphic>
           <a:graphicData uri="http://schemas.openxmlformats.org/drawingml/2006/table">
@@ -29362,11 +27978,9 @@
               </a:tblPr>
               <a:tblGrid>
                 <a:gridCol w="2355696"/>
-                <a:gridCol w="1211500"/>
-                <a:gridCol w="1211500"/>
-                <a:gridCol w="1211500"/>
-                <a:gridCol w="1211500"/>
-                <a:gridCol w="1211500"/>
+                <a:gridCol w="2019168"/>
+                <a:gridCol w="2019168"/>
+                <a:gridCol w="2019168"/>
               </a:tblGrid>
               <a:tr h="220000">
                 <a:tc>
@@ -29452,52 +28066,6 @@
                           <a:latin typeface="Calibri"/>
                         </a:rPr>
                         <a:t>2025</a:t>
-                      </a:r>
-                    </a:p>
-                  </a:txBody>
-                  <a:tcPr>
-                    <a:solidFill>
-                      <a:srgbClr val="1B3A6B"/>
-                    </a:solidFill>
-                  </a:tcPr>
-                </a:tc>
-                <a:tc>
-                  <a:txBody>
-                    <a:bodyPr/>
-                    <a:lstStyle/>
-                    <a:p>
-                      <a:pPr algn="ctr"/>
-                      <a:r>
-                        <a:rPr sz="800" b="1" i="0">
-                          <a:solidFill>
-                            <a:srgbClr val="FFFFFF"/>
-                          </a:solidFill>
-                          <a:latin typeface="Calibri"/>
-                        </a:rPr>
-                        <a:t>2026F</a:t>
-                      </a:r>
-                    </a:p>
-                  </a:txBody>
-                  <a:tcPr>
-                    <a:solidFill>
-                      <a:srgbClr val="1B3A6B"/>
-                    </a:solidFill>
-                  </a:tcPr>
-                </a:tc>
-                <a:tc>
-                  <a:txBody>
-                    <a:bodyPr/>
-                    <a:lstStyle/>
-                    <a:p>
-                      <a:pPr algn="ctr"/>
-                      <a:r>
-                        <a:rPr sz="800" b="1" i="0">
-                          <a:solidFill>
-                            <a:srgbClr val="FFFFFF"/>
-                          </a:solidFill>
-                          <a:latin typeface="Calibri"/>
-                        </a:rPr>
-                        <a:t>2027F</a:t>
                       </a:r>
                     </a:p>
                   </a:txBody>
@@ -29601,52 +28169,6 @@
                     </a:solidFill>
                   </a:tcPr>
                 </a:tc>
-                <a:tc>
-                  <a:txBody>
-                    <a:bodyPr/>
-                    <a:lstStyle/>
-                    <a:p>
-                      <a:pPr algn="ctr"/>
-                      <a:r>
-                        <a:rPr sz="800" b="1" i="0">
-                          <a:solidFill>
-                            <a:srgbClr val="0D0D0D"/>
-                          </a:solidFill>
-                          <a:latin typeface="Calibri"/>
-                        </a:rPr>
-                        <a:t>437,2</a:t>
-                      </a:r>
-                    </a:p>
-                  </a:txBody>
-                  <a:tcPr>
-                    <a:solidFill>
-                      <a:srgbClr val="FFFFFF"/>
-                    </a:solidFill>
-                  </a:tcPr>
-                </a:tc>
-                <a:tc>
-                  <a:txBody>
-                    <a:bodyPr/>
-                    <a:lstStyle/>
-                    <a:p>
-                      <a:pPr algn="ctr"/>
-                      <a:r>
-                        <a:rPr sz="800" b="1" i="0">
-                          <a:solidFill>
-                            <a:srgbClr val="0D0D0D"/>
-                          </a:solidFill>
-                          <a:latin typeface="Calibri"/>
-                        </a:rPr>
-                        <a:t>468,4</a:t>
-                      </a:r>
-                    </a:p>
-                  </a:txBody>
-                  <a:tcPr>
-                    <a:solidFill>
-                      <a:srgbClr val="FFFFFF"/>
-                    </a:solidFill>
-                  </a:tcPr>
-                </a:tc>
               </a:tr>
               <a:tr h="220000">
                 <a:tc>
@@ -29738,52 +28260,6 @@
                   <a:tcPr>
                     <a:solidFill>
                       <a:srgbClr val="DDE8F5"/>
-                    </a:solidFill>
-                  </a:tcPr>
-                </a:tc>
-                <a:tc>
-                  <a:txBody>
-                    <a:bodyPr/>
-                    <a:lstStyle/>
-                    <a:p>
-                      <a:pPr algn="ctr"/>
-                      <a:r>
-                        <a:rPr sz="750" b="0" i="1">
-                          <a:solidFill>
-                            <a:srgbClr val="555555"/>
-                          </a:solidFill>
-                          <a:latin typeface="Calibri"/>
-                        </a:rPr>
-                        <a:t>+5,0 %</a:t>
-                      </a:r>
-                    </a:p>
-                  </a:txBody>
-                  <a:tcPr>
-                    <a:solidFill>
-                      <a:srgbClr val="F7F8FA"/>
-                    </a:solidFill>
-                  </a:tcPr>
-                </a:tc>
-                <a:tc>
-                  <a:txBody>
-                    <a:bodyPr/>
-                    <a:lstStyle/>
-                    <a:p>
-                      <a:pPr algn="ctr"/>
-                      <a:r>
-                        <a:rPr sz="750" b="0" i="1">
-                          <a:solidFill>
-                            <a:srgbClr val="555555"/>
-                          </a:solidFill>
-                          <a:latin typeface="Calibri"/>
-                        </a:rPr>
-                        <a:t>+7,0 %</a:t>
-                      </a:r>
-                    </a:p>
-                  </a:txBody>
-                  <a:tcPr>
-                    <a:solidFill>
-                      <a:srgbClr val="F7F8FA"/>
                     </a:solidFill>
                   </a:tcPr>
                 </a:tc>
@@ -29881,52 +28357,6 @@
                     </a:solidFill>
                   </a:tcPr>
                 </a:tc>
-                <a:tc>
-                  <a:txBody>
-                    <a:bodyPr/>
-                    <a:lstStyle/>
-                    <a:p>
-                      <a:pPr algn="ctr"/>
-                      <a:r>
-                        <a:rPr sz="800" b="1" i="0">
-                          <a:solidFill>
-                            <a:srgbClr val="0D0D0D"/>
-                          </a:solidFill>
-                          <a:latin typeface="Calibri"/>
-                        </a:rPr>
-                        <a:t>205,5</a:t>
-                      </a:r>
-                    </a:p>
-                  </a:txBody>
-                  <a:tcPr>
-                    <a:solidFill>
-                      <a:srgbClr val="FFFFFF"/>
-                    </a:solidFill>
-                  </a:tcPr>
-                </a:tc>
-                <a:tc>
-                  <a:txBody>
-                    <a:bodyPr/>
-                    <a:lstStyle/>
-                    <a:p>
-                      <a:pPr algn="ctr"/>
-                      <a:r>
-                        <a:rPr sz="800" b="1" i="0">
-                          <a:solidFill>
-                            <a:srgbClr val="0D0D0D"/>
-                          </a:solidFill>
-                          <a:latin typeface="Calibri"/>
-                        </a:rPr>
-                        <a:t>224,8</a:t>
-                      </a:r>
-                    </a:p>
-                  </a:txBody>
-                  <a:tcPr>
-                    <a:solidFill>
-                      <a:srgbClr val="FFFFFF"/>
-                    </a:solidFill>
-                  </a:tcPr>
-                </a:tc>
               </a:tr>
               <a:tr h="220000">
                 <a:tc>
@@ -30018,52 +28448,6 @@
                   <a:tcPr>
                     <a:solidFill>
                       <a:srgbClr val="DDE8F5"/>
-                    </a:solidFill>
-                  </a:tcPr>
-                </a:tc>
-                <a:tc>
-                  <a:txBody>
-                    <a:bodyPr/>
-                    <a:lstStyle/>
-                    <a:p>
-                      <a:pPr algn="ctr"/>
-                      <a:r>
-                        <a:rPr sz="750" b="0" i="1">
-                          <a:solidFill>
-                            <a:srgbClr val="555555"/>
-                          </a:solidFill>
-                          <a:latin typeface="Calibri"/>
-                        </a:rPr>
-                        <a:t>47,0 %</a:t>
-                      </a:r>
-                    </a:p>
-                  </a:txBody>
-                  <a:tcPr>
-                    <a:solidFill>
-                      <a:srgbClr val="F7F8FA"/>
-                    </a:solidFill>
-                  </a:tcPr>
-                </a:tc>
-                <a:tc>
-                  <a:txBody>
-                    <a:bodyPr/>
-                    <a:lstStyle/>
-                    <a:p>
-                      <a:pPr algn="ctr"/>
-                      <a:r>
-                        <a:rPr sz="750" b="0" i="1">
-                          <a:solidFill>
-                            <a:srgbClr val="555555"/>
-                          </a:solidFill>
-                          <a:latin typeface="Calibri"/>
-                        </a:rPr>
-                        <a:t>48,0 %</a:t>
-                      </a:r>
-                    </a:p>
-                  </a:txBody>
-                  <a:tcPr>
-                    <a:solidFill>
-                      <a:srgbClr val="F7F8FA"/>
                     </a:solidFill>
                   </a:tcPr>
                 </a:tc>
@@ -30161,52 +28545,6 @@
                     </a:solidFill>
                   </a:tcPr>
                 </a:tc>
-                <a:tc>
-                  <a:txBody>
-                    <a:bodyPr/>
-                    <a:lstStyle/>
-                    <a:p>
-                      <a:pPr algn="ctr"/>
-                      <a:r>
-                        <a:rPr sz="800" b="1" i="0">
-                          <a:solidFill>
-                            <a:srgbClr val="0D0D0D"/>
-                          </a:solidFill>
-                          <a:latin typeface="Calibri"/>
-                        </a:rPr>
-                        <a:t>157,8</a:t>
-                      </a:r>
-                    </a:p>
-                  </a:txBody>
-                  <a:tcPr>
-                    <a:solidFill>
-                      <a:srgbClr val="FFFFFF"/>
-                    </a:solidFill>
-                  </a:tcPr>
-                </a:tc>
-                <a:tc>
-                  <a:txBody>
-                    <a:bodyPr/>
-                    <a:lstStyle/>
-                    <a:p>
-                      <a:pPr algn="ctr"/>
-                      <a:r>
-                        <a:rPr sz="800" b="1" i="0">
-                          <a:solidFill>
-                            <a:srgbClr val="0D0D0D"/>
-                          </a:solidFill>
-                          <a:latin typeface="Calibri"/>
-                        </a:rPr>
-                        <a:t>173,2</a:t>
-                      </a:r>
-                    </a:p>
-                  </a:txBody>
-                  <a:tcPr>
-                    <a:solidFill>
-                      <a:srgbClr val="FFFFFF"/>
-                    </a:solidFill>
-                  </a:tcPr>
-                </a:tc>
               </a:tr>
               <a:tr h="220000">
                 <a:tc>
@@ -30298,52 +28636,6 @@
                   <a:tcPr>
                     <a:solidFill>
                       <a:srgbClr val="DDE8F5"/>
-                    </a:solidFill>
-                  </a:tcPr>
-                </a:tc>
-                <a:tc>
-                  <a:txBody>
-                    <a:bodyPr/>
-                    <a:lstStyle/>
-                    <a:p>
-                      <a:pPr algn="ctr"/>
-                      <a:r>
-                        <a:rPr sz="750" b="0" i="1">
-                          <a:solidFill>
-                            <a:srgbClr val="555555"/>
-                          </a:solidFill>
-                          <a:latin typeface="Calibri"/>
-                        </a:rPr>
-                        <a:t>36,0 %</a:t>
-                      </a:r>
-                    </a:p>
-                  </a:txBody>
-                  <a:tcPr>
-                    <a:solidFill>
-                      <a:srgbClr val="F7F8FA"/>
-                    </a:solidFill>
-                  </a:tcPr>
-                </a:tc>
-                <a:tc>
-                  <a:txBody>
-                    <a:bodyPr/>
-                    <a:lstStyle/>
-                    <a:p>
-                      <a:pPr algn="ctr"/>
-                      <a:r>
-                        <a:rPr sz="750" b="0" i="1">
-                          <a:solidFill>
-                            <a:srgbClr val="555555"/>
-                          </a:solidFill>
-                          <a:latin typeface="Calibri"/>
-                        </a:rPr>
-                        <a:t>37,0 %</a:t>
-                      </a:r>
-                    </a:p>
-                  </a:txBody>
-                  <a:tcPr>
-                    <a:solidFill>
-                      <a:srgbClr val="F7F8FA"/>
                     </a:solidFill>
                   </a:tcPr>
                 </a:tc>
@@ -30441,52 +28733,6 @@
                     </a:solidFill>
                   </a:tcPr>
                 </a:tc>
-                <a:tc>
-                  <a:txBody>
-                    <a:bodyPr/>
-                    <a:lstStyle/>
-                    <a:p>
-                      <a:pPr algn="ctr"/>
-                      <a:r>
-                        <a:rPr sz="800" b="1" i="0">
-                          <a:solidFill>
-                            <a:srgbClr val="0D0D0D"/>
-                          </a:solidFill>
-                          <a:latin typeface="Calibri"/>
-                        </a:rPr>
-                        <a:t>114,8</a:t>
-                      </a:r>
-                    </a:p>
-                  </a:txBody>
-                  <a:tcPr>
-                    <a:solidFill>
-                      <a:srgbClr val="FFFFFF"/>
-                    </a:solidFill>
-                  </a:tcPr>
-                </a:tc>
-                <a:tc>
-                  <a:txBody>
-                    <a:bodyPr/>
-                    <a:lstStyle/>
-                    <a:p>
-                      <a:pPr algn="ctr"/>
-                      <a:r>
-                        <a:rPr sz="800" b="1" i="0">
-                          <a:solidFill>
-                            <a:srgbClr val="0D0D0D"/>
-                          </a:solidFill>
-                          <a:latin typeface="Calibri"/>
-                        </a:rPr>
-                        <a:t>124,9</a:t>
-                      </a:r>
-                    </a:p>
-                  </a:txBody>
-                  <a:tcPr>
-                    <a:solidFill>
-                      <a:srgbClr val="FFFFFF"/>
-                    </a:solidFill>
-                  </a:tcPr>
-                </a:tc>
               </a:tr>
               <a:tr h="220000">
                 <a:tc>
@@ -30581,92 +28827,11 @@
                     </a:solidFill>
                   </a:tcPr>
                 </a:tc>
-                <a:tc>
-                  <a:txBody>
-                    <a:bodyPr/>
-                    <a:lstStyle/>
-                    <a:p>
-                      <a:pPr algn="ctr"/>
-                      <a:r>
-                        <a:rPr sz="750" b="0" i="1">
-                          <a:solidFill>
-                            <a:srgbClr val="555555"/>
-                          </a:solidFill>
-                          <a:latin typeface="Calibri"/>
-                        </a:rPr>
-                        <a:t>26,0 %</a:t>
-                      </a:r>
-                    </a:p>
-                  </a:txBody>
-                  <a:tcPr>
-                    <a:solidFill>
-                      <a:srgbClr val="F7F8FA"/>
-                    </a:solidFill>
-                  </a:tcPr>
-                </a:tc>
-                <a:tc>
-                  <a:txBody>
-                    <a:bodyPr/>
-                    <a:lstStyle/>
-                    <a:p>
-                      <a:pPr algn="ctr"/>
-                      <a:r>
-                        <a:rPr sz="750" b="0" i="1">
-                          <a:solidFill>
-                            <a:srgbClr val="555555"/>
-                          </a:solidFill>
-                          <a:latin typeface="Calibri"/>
-                        </a:rPr>
-                        <a:t>27,0 %</a:t>
-                      </a:r>
-                    </a:p>
-                  </a:txBody>
-                  <a:tcPr>
-                    <a:solidFill>
-                      <a:srgbClr val="F7F8FA"/>
-                    </a:solidFill>
-                  </a:tcPr>
-                </a:tc>
               </a:tr>
             </a:tbl>
           </a:graphicData>
         </a:graphic>
       </p:graphicFrame>
-      <p:sp>
-        <p:nvSpPr>
-          <p:cNvPr id="18" name="TextBox 17"/>
-          <p:cNvSpPr txBox="1"/>
-          <p:nvPr/>
-        </p:nvSpPr>
-        <p:spPr>
-          <a:xfrm>
-            <a:off x="367200" y="3218400"/>
-            <a:ext cx="8413200" cy="1224000"/>
-          </a:xfrm>
-          <a:prstGeom prst="rect">
-            <a:avLst/>
-          </a:prstGeom>
-          <a:noFill/>
-        </p:spPr>
-        <p:txBody>
-          <a:bodyPr wrap="square">
-            <a:spAutoFit/>
-          </a:bodyPr>
-          <a:lstStyle/>
-          <a:p>
-            <a:pPr algn="l"/>
-            <a:r>
-              <a:rPr sz="850" b="0" i="0">
-                <a:solidFill>
-                  <a:srgbClr val="555555"/>
-                </a:solidFill>
-                <a:latin typeface="Calibri"/>
-              </a:rPr>
-              <a:t>Les revenus d'Apple devraient augmenter de 5% en 2026 et de 7% en 2027, grâce à la croissance de la demande pour les smartphones et les ordinateurs portables.</a:t>
-            </a:r>
-          </a:p>
-        </p:txBody>
-      </p:sp>
     </p:spTree>
   </p:cSld>
   <p:clrMapOvr>
@@ -32394,7 +30559,7 @@
                           </a:solidFill>
                           <a:latin typeface="Calibri"/>
                         </a:rPr>
-                        <a:t>9,97</a:t>
+                        <a:t>9,98</a:t>
                       </a:r>
                     </a:p>
                   </a:txBody>
@@ -32549,41 +30714,6 @@
           </a:graphicData>
         </a:graphic>
       </p:graphicFrame>
-      <p:sp>
-        <p:nvSpPr>
-          <p:cNvPr id="31" name="TextBox 30"/>
-          <p:cNvSpPr txBox="1"/>
-          <p:nvPr/>
-        </p:nvSpPr>
-        <p:spPr>
-          <a:xfrm>
-            <a:off x="367200" y="4068000"/>
-            <a:ext cx="8413200" cy="468000"/>
-          </a:xfrm>
-          <a:prstGeom prst="rect">
-            <a:avLst/>
-          </a:prstGeom>
-          <a:noFill/>
-        </p:spPr>
-        <p:txBody>
-          <a:bodyPr wrap="square">
-            <a:spAutoFit/>
-          </a:bodyPr>
-          <a:lstStyle/>
-          <a:p>
-            <a:pPr algn="l"/>
-            <a:r>
-              <a:rPr sz="850" b="0" i="0">
-                <a:solidFill>
-                  <a:srgbClr val="555555"/>
-                </a:solidFill>
-                <a:latin typeface="Calibri"/>
-              </a:rPr>
-              <a:t>Les revenus d'Apple devraient augmenter de 5% en 2026 et de 7% en 2027, grâce à la croissance de la demande pour les smartphones et les ordinateurs portables.</a:t>
-            </a:r>
-          </a:p>
-        </p:txBody>
-      </p:sp>
     </p:spTree>
   </p:cSld>
   <p:clrMapOvr>

</xml_diff>

<commit_message>
chore(preview): AAPL outputs post-corrections PDF v3 (market cap, football field, P9 methodologie)
Co-Authored-By: Claude Sonnet 4.6 <noreply@anthropic.com>
</commit_message>
<xml_diff>
--- a/preview/AAPL/AAPL_pitchbook.pptx
+++ b/preview/AAPL/AAPL_pitchbook.pptx
@@ -3348,7 +3348,7 @@
             <a:avLst/>
           </a:prstGeom>
           <a:solidFill>
-            <a:srgbClr val="FDF6E8"/>
+            <a:srgbClr val="EAF4EF"/>
           </a:solidFill>
           <a:ln>
             <a:noFill/>
@@ -3391,7 +3391,7 @@
             <a:avLst/>
           </a:prstGeom>
           <a:solidFill>
-            <a:srgbClr val="B06000"/>
+            <a:srgbClr val="1A7A4A"/>
           </a:solidFill>
           <a:ln>
             <a:noFill/>
@@ -3445,11 +3445,11 @@
             <a:r>
               <a:rPr sz="900" b="1" i="0">
                 <a:solidFill>
-                  <a:srgbClr val="B06000"/>
+                  <a:srgbClr val="1A7A4A"/>
                 </a:solidFill>
                 <a:latin typeface="Calibri"/>
               </a:rPr>
-              <a:t>● HOLD  ·  Prix cible base : — $  ·  Upside : —</a:t>
+              <a:t>● BUY  ·  Prix cible base : 270 $  ·  Upside : +6,5 %</a:t>
             </a:r>
           </a:p>
         </p:txBody>
@@ -4595,7 +4595,7 @@
                           </a:solidFill>
                           <a:latin typeface="Calibri"/>
                         </a:rPr>
-                        <a:t>26,2x</a:t>
+                        <a:t>26,1x</a:t>
                       </a:r>
                     </a:p>
                   </a:txBody>
@@ -5813,7 +5813,7 @@
                           </a:solidFill>
                           <a:latin typeface="Calibri"/>
                         </a:rPr>
-                        <a:t>9,98</a:t>
+                        <a:t>9,97</a:t>
                       </a:r>
                     </a:p>
                   </a:txBody>
@@ -6108,6 +6108,41 @@
           </a:graphicData>
         </a:graphic>
       </p:graphicFrame>
+      <p:sp>
+        <p:nvSpPr>
+          <p:cNvPr id="18" name="TextBox 17"/>
+          <p:cNvSpPr txBox="1"/>
+          <p:nvPr/>
+        </p:nvSpPr>
+        <p:spPr>
+          <a:xfrm>
+            <a:off x="367200" y="3628800"/>
+            <a:ext cx="8413200" cy="824400"/>
+          </a:xfrm>
+          <a:prstGeom prst="rect">
+            <a:avLst/>
+          </a:prstGeom>
+          <a:noFill/>
+        </p:spPr>
+        <p:txBody>
+          <a:bodyPr wrap="square">
+            <a:spAutoFit/>
+          </a:bodyPr>
+          <a:lstStyle/>
+          <a:p>
+            <a:pPr algn="l"/>
+            <a:r>
+              <a:rPr sz="850" b="0" i="0">
+                <a:solidFill>
+                  <a:srgbClr val="555555"/>
+                </a:solidFill>
+                <a:latin typeface="Calibri"/>
+              </a:rPr>
+              <a:t>Le ratio EV/EBITDA d'Apple est de 26,1x, supérieur à la mediane de son secteur.</a:t>
+            </a:r>
+          </a:p>
+        </p:txBody>
+      </p:sp>
     </p:spTree>
   </p:cSld>
   <p:clrMapOvr>
@@ -7268,7 +7303,7 @@
                           </a:solidFill>
                           <a:latin typeface="Calibri"/>
                         </a:rPr>
-                        <a:t>—</a:t>
+                        <a:t>270 $</a:t>
                       </a:r>
                     </a:p>
                   </a:txBody>
@@ -7356,7 +7391,7 @@
                           </a:solidFill>
                           <a:latin typeface="Calibri"/>
                         </a:rPr>
-                        <a:t>253,68 $</a:t>
+                        <a:t>253,53 $</a:t>
                       </a:r>
                     </a:p>
                   </a:txBody>
@@ -7444,7 +7479,7 @@
                           </a:solidFill>
                           <a:latin typeface="Calibri"/>
                         </a:rPr>
-                        <a:t>—</a:t>
+                        <a:t>+6,5 %</a:t>
                       </a:r>
                     </a:p>
                   </a:txBody>
@@ -7587,7 +7622,7 @@
                           </a:solidFill>
                           <a:latin typeface="Calibri"/>
                         </a:rPr>
-                        <a:t>—</a:t>
+                        <a:t>230 $</a:t>
                       </a:r>
                     </a:p>
                   </a:txBody>
@@ -7610,7 +7645,7 @@
                           </a:solidFill>
                           <a:latin typeface="Calibri"/>
                         </a:rPr>
-                        <a:t>—</a:t>
+                        <a:t>270 $</a:t>
                       </a:r>
                     </a:p>
                   </a:txBody>
@@ -7633,7 +7668,7 @@
                           </a:solidFill>
                           <a:latin typeface="Calibri"/>
                         </a:rPr>
-                        <a:t>—</a:t>
+                        <a:t>300 $</a:t>
                       </a:r>
                     </a:p>
                   </a:txBody>
@@ -7658,7 +7693,7 @@
                           </a:solidFill>
                           <a:latin typeface="Calibri"/>
                         </a:rPr>
-                        <a:t>—</a:t>
+                        <a:t>-9,3 %</a:t>
                       </a:r>
                     </a:p>
                   </a:txBody>
@@ -7681,7 +7716,7 @@
                           </a:solidFill>
                           <a:latin typeface="Calibri"/>
                         </a:rPr>
-                        <a:t>—</a:t>
+                        <a:t>+6,5 %</a:t>
                       </a:r>
                     </a:p>
                   </a:txBody>
@@ -7704,7 +7739,7 @@
                           </a:solidFill>
                           <a:latin typeface="Calibri"/>
                         </a:rPr>
-                        <a:t>—</a:t>
+                        <a:t>+18,3 %</a:t>
                       </a:r>
                     </a:p>
                   </a:txBody>
@@ -8168,7 +8203,7 @@
                           </a:solidFill>
                           <a:latin typeface="Calibri"/>
                         </a:rPr>
-                        <a:t>—</a:t>
+                        <a:t>313</a:t>
                       </a:r>
                     </a:p>
                   </a:txBody>
@@ -8211,7 +8246,7 @@
                           </a:solidFill>
                           <a:latin typeface="Calibri"/>
                         </a:rPr>
-                        <a:t>—</a:t>
+                        <a:t>340</a:t>
                       </a:r>
                     </a:p>
                   </a:txBody>
@@ -8254,7 +8289,7 @@
                           </a:solidFill>
                           <a:latin typeface="Calibri"/>
                         </a:rPr>
-                        <a:t>—</a:t>
+                        <a:t>372</a:t>
                       </a:r>
                     </a:p>
                   </a:txBody>
@@ -8297,7 +8332,7 @@
                           </a:solidFill>
                           <a:latin typeface="Calibri"/>
                         </a:rPr>
-                        <a:t>—</a:t>
+                        <a:t>410</a:t>
                       </a:r>
                     </a:p>
                   </a:txBody>
@@ -8340,7 +8375,7 @@
                           </a:solidFill>
                           <a:latin typeface="Calibri"/>
                         </a:rPr>
-                        <a:t>—</a:t>
+                        <a:t>458</a:t>
                       </a:r>
                     </a:p>
                   </a:txBody>
@@ -8428,7 +8463,7 @@
                           </a:solidFill>
                           <a:latin typeface="Calibri"/>
                         </a:rPr>
-                        <a:t>—</a:t>
+                        <a:t>270</a:t>
                       </a:r>
                     </a:p>
                   </a:txBody>
@@ -8471,7 +8506,7 @@
                           </a:solidFill>
                           <a:latin typeface="Calibri"/>
                         </a:rPr>
-                        <a:t>—</a:t>
+                        <a:t>290</a:t>
                       </a:r>
                     </a:p>
                   </a:txBody>
@@ -8514,7 +8549,7 @@
                           </a:solidFill>
                           <a:latin typeface="Calibri"/>
                         </a:rPr>
-                        <a:t>—</a:t>
+                        <a:t>313</a:t>
                       </a:r>
                     </a:p>
                   </a:txBody>
@@ -8557,7 +8592,7 @@
                           </a:solidFill>
                           <a:latin typeface="Calibri"/>
                         </a:rPr>
-                        <a:t>—</a:t>
+                        <a:t>340</a:t>
                       </a:r>
                     </a:p>
                   </a:txBody>
@@ -8600,7 +8635,7 @@
                           </a:solidFill>
                           <a:latin typeface="Calibri"/>
                         </a:rPr>
-                        <a:t>—</a:t>
+                        <a:t>372</a:t>
                       </a:r>
                     </a:p>
                   </a:txBody>
@@ -8688,7 +8723,7 @@
                           </a:solidFill>
                           <a:latin typeface="Calibri"/>
                         </a:rPr>
-                        <a:t>—</a:t>
+                        <a:t>238</a:t>
                       </a:r>
                     </a:p>
                   </a:txBody>
@@ -8731,7 +8766,7 @@
                           </a:solidFill>
                           <a:latin typeface="Calibri"/>
                         </a:rPr>
-                        <a:t>—</a:t>
+                        <a:t>253</a:t>
                       </a:r>
                     </a:p>
                   </a:txBody>
@@ -8774,7 +8809,7 @@
                           </a:solidFill>
                           <a:latin typeface="Calibri"/>
                         </a:rPr>
-                        <a:t>—</a:t>
+                        <a:t>270</a:t>
                       </a:r>
                     </a:p>
                   </a:txBody>
@@ -8817,7 +8852,7 @@
                           </a:solidFill>
                           <a:latin typeface="Calibri"/>
                         </a:rPr>
-                        <a:t>—</a:t>
+                        <a:t>290</a:t>
                       </a:r>
                     </a:p>
                   </a:txBody>
@@ -8860,7 +8895,7 @@
                           </a:solidFill>
                           <a:latin typeface="Calibri"/>
                         </a:rPr>
-                        <a:t>—</a:t>
+                        <a:t>313</a:t>
                       </a:r>
                     </a:p>
                   </a:txBody>
@@ -8948,7 +8983,7 @@
                           </a:solidFill>
                           <a:latin typeface="Calibri"/>
                         </a:rPr>
-                        <a:t>—</a:t>
+                        <a:t>212</a:t>
                       </a:r>
                     </a:p>
                   </a:txBody>
@@ -8991,7 +9026,7 @@
                           </a:solidFill>
                           <a:latin typeface="Calibri"/>
                         </a:rPr>
-                        <a:t>—</a:t>
+                        <a:t>224</a:t>
                       </a:r>
                     </a:p>
                   </a:txBody>
@@ -9034,7 +9069,7 @@
                           </a:solidFill>
                           <a:latin typeface="Calibri"/>
                         </a:rPr>
-                        <a:t>—</a:t>
+                        <a:t>238</a:t>
                       </a:r>
                     </a:p>
                   </a:txBody>
@@ -9077,7 +9112,7 @@
                           </a:solidFill>
                           <a:latin typeface="Calibri"/>
                         </a:rPr>
-                        <a:t>—</a:t>
+                        <a:t>253</a:t>
                       </a:r>
                     </a:p>
                   </a:txBody>
@@ -9120,7 +9155,7 @@
                           </a:solidFill>
                           <a:latin typeface="Calibri"/>
                         </a:rPr>
-                        <a:t>—</a:t>
+                        <a:t>270</a:t>
                       </a:r>
                     </a:p>
                   </a:txBody>
@@ -9208,7 +9243,7 @@
                           </a:solidFill>
                           <a:latin typeface="Calibri"/>
                         </a:rPr>
-                        <a:t>—</a:t>
+                        <a:t>191</a:t>
                       </a:r>
                     </a:p>
                   </a:txBody>
@@ -9251,7 +9286,7 @@
                           </a:solidFill>
                           <a:latin typeface="Calibri"/>
                         </a:rPr>
-                        <a:t>—</a:t>
+                        <a:t>201</a:t>
                       </a:r>
                     </a:p>
                   </a:txBody>
@@ -9294,7 +9329,7 @@
                           </a:solidFill>
                           <a:latin typeface="Calibri"/>
                         </a:rPr>
-                        <a:t>—</a:t>
+                        <a:t>212</a:t>
                       </a:r>
                     </a:p>
                   </a:txBody>
@@ -9337,7 +9372,7 @@
                           </a:solidFill>
                           <a:latin typeface="Calibri"/>
                         </a:rPr>
-                        <a:t>—</a:t>
+                        <a:t>224</a:t>
                       </a:r>
                     </a:p>
                   </a:txBody>
@@ -9380,7 +9415,7 @@
                           </a:solidFill>
                           <a:latin typeface="Calibri"/>
                         </a:rPr>
-                        <a:t>—</a:t>
+                        <a:t>238</a:t>
                       </a:r>
                     </a:p>
                   </a:txBody>
@@ -9415,6 +9450,41 @@
           </a:graphicData>
         </a:graphic>
       </p:graphicFrame>
+      <p:sp>
+        <p:nvSpPr>
+          <p:cNvPr id="20" name="TextBox 19"/>
+          <p:cNvSpPr txBox="1"/>
+          <p:nvPr/>
+        </p:nvSpPr>
+        <p:spPr>
+          <a:xfrm>
+            <a:off x="367200" y="3916800"/>
+            <a:ext cx="8413200" cy="547200"/>
+          </a:xfrm>
+          <a:prstGeom prst="rect">
+            <a:avLst/>
+          </a:prstGeom>
+          <a:noFill/>
+        </p:spPr>
+        <p:txBody>
+          <a:bodyPr wrap="square">
+            <a:spAutoFit/>
+          </a:bodyPr>
+          <a:lstStyle/>
+          <a:p>
+            <a:pPr algn="l"/>
+            <a:r>
+              <a:rPr sz="850" b="0" i="0">
+                <a:solidFill>
+                  <a:srgbClr val="555555"/>
+                </a:solidFill>
+                <a:latin typeface="Calibri"/>
+              </a:rPr>
+              <a:t>La DCF d'Apple implique un WACC de 10,3% et un TGR de 3,0%.</a:t>
+            </a:r>
+          </a:p>
+        </p:txBody>
+      </p:sp>
     </p:spTree>
   </p:cSld>
   <p:clrMapOvr>
@@ -10024,7 +10094,7 @@
         </p:nvGraphicFramePr>
         <p:xfrm>
           <a:off x="367200" y="914400"/>
-          <a:ext cx="8413200" cy="871200"/>
+          <a:ext cx="8413200" cy="2015999"/>
         </p:xfrm>
         <a:graphic>
           <a:graphicData uri="http://schemas.openxmlformats.org/drawingml/2006/table">
@@ -10042,7 +10112,7 @@
                 <a:gridCol w="1093716"/>
                 <a:gridCol w="1009584"/>
               </a:tblGrid>
-              <a:tr h="290400">
+              <a:tr h="251999">
                 <a:tc>
                   <a:txBody>
                     <a:bodyPr/>
@@ -10228,7 +10298,7 @@
                   </a:tcPr>
                 </a:tc>
               </a:tr>
-              <a:tr h="290400">
+              <a:tr h="251999">
                 <a:tc>
                   <a:txBody>
                     <a:bodyPr/>
@@ -10288,7 +10358,7 @@
                           </a:solidFill>
                           <a:latin typeface="Calibri"/>
                         </a:rPr>
-                        <a:t>3 724,3</a:t>
+                        <a:t>3 722,1</a:t>
                       </a:r>
                     </a:p>
                   </a:txBody>
@@ -10311,7 +10381,7 @@
                           </a:solidFill>
                           <a:latin typeface="Calibri"/>
                         </a:rPr>
-                        <a:t>26,2x</a:t>
+                        <a:t>26,1x</a:t>
                       </a:r>
                     </a:p>
                   </a:txBody>
@@ -10414,7 +10484,7 @@
                   </a:tcPr>
                 </a:tc>
               </a:tr>
-              <a:tr h="290400">
+              <a:tr h="251999">
                 <a:tc>
                   <a:txBody>
                     <a:bodyPr/>
@@ -10422,6 +10492,936 @@
                     <a:p>
                       <a:pPr algn="l"/>
                       <a:r>
+                        <a:rPr sz="800" b="0" i="0">
+                          <a:solidFill>
+                            <a:srgbClr val="0D0D0D"/>
+                          </a:solidFill>
+                          <a:latin typeface="Calibri"/>
+                        </a:rPr>
+                        <a:t>Alphabet</a:t>
+                      </a:r>
+                    </a:p>
+                  </a:txBody>
+                  <a:tcPr>
+                    <a:solidFill>
+                      <a:srgbClr val="FFFFFF"/>
+                    </a:solidFill>
+                  </a:tcPr>
+                </a:tc>
+                <a:tc>
+                  <a:txBody>
+                    <a:bodyPr/>
+                    <a:lstStyle/>
+                    <a:p>
+                      <a:pPr algn="ctr"/>
+                      <a:r>
+                        <a:rPr sz="750" b="0" i="0">
+                          <a:solidFill>
+                            <a:srgbClr val="555555"/>
+                          </a:solidFill>
+                          <a:latin typeface="Calibri"/>
+                        </a:rPr>
+                        <a:t>GOOGL</a:t>
+                      </a:r>
+                    </a:p>
+                  </a:txBody>
+                  <a:tcPr>
+                    <a:solidFill>
+                      <a:srgbClr val="FFFFFF"/>
+                    </a:solidFill>
+                  </a:tcPr>
+                </a:tc>
+                <a:tc>
+                  <a:txBody>
+                    <a:bodyPr/>
+                    <a:lstStyle/>
+                    <a:p>
+                      <a:pPr algn="ctr"/>
+                      <a:r>
+                        <a:rPr sz="800" b="0" i="0">
+                          <a:solidFill>
+                            <a:srgbClr val="0D0D0D"/>
+                          </a:solidFill>
+                          <a:latin typeface="Calibri"/>
+                        </a:rPr>
+                        <a:t>1 500,0</a:t>
+                      </a:r>
+                    </a:p>
+                  </a:txBody>
+                  <a:tcPr>
+                    <a:solidFill>
+                      <a:srgbClr val="FFFFFF"/>
+                    </a:solidFill>
+                  </a:tcPr>
+                </a:tc>
+                <a:tc>
+                  <a:txBody>
+                    <a:bodyPr/>
+                    <a:lstStyle/>
+                    <a:p>
+                      <a:pPr algn="ctr"/>
+                      <a:r>
+                        <a:rPr sz="800" b="0" i="0">
+                          <a:solidFill>
+                            <a:srgbClr val="0D0D0D"/>
+                          </a:solidFill>
+                          <a:latin typeface="Calibri"/>
+                        </a:rPr>
+                        <a:t>20,0x</a:t>
+                      </a:r>
+                    </a:p>
+                  </a:txBody>
+                  <a:tcPr>
+                    <a:solidFill>
+                      <a:srgbClr val="FFFFFF"/>
+                    </a:solidFill>
+                  </a:tcPr>
+                </a:tc>
+                <a:tc>
+                  <a:txBody>
+                    <a:bodyPr/>
+                    <a:lstStyle/>
+                    <a:p>
+                      <a:pPr algn="ctr"/>
+                      <a:r>
+                        <a:rPr sz="800" b="0" i="0">
+                          <a:solidFill>
+                            <a:srgbClr val="0D0D0D"/>
+                          </a:solidFill>
+                          <a:latin typeface="Calibri"/>
+                        </a:rPr>
+                        <a:t>6,0x</a:t>
+                      </a:r>
+                    </a:p>
+                  </a:txBody>
+                  <a:tcPr>
+                    <a:solidFill>
+                      <a:srgbClr val="FFFFFF"/>
+                    </a:solidFill>
+                  </a:tcPr>
+                </a:tc>
+                <a:tc>
+                  <a:txBody>
+                    <a:bodyPr/>
+                    <a:lstStyle/>
+                    <a:p>
+                      <a:pPr algn="ctr"/>
+                      <a:r>
+                        <a:rPr sz="800" b="0" i="0">
+                          <a:solidFill>
+                            <a:srgbClr val="0D0D0D"/>
+                          </a:solidFill>
+                          <a:latin typeface="Calibri"/>
+                        </a:rPr>
+                        <a:t>30,0x</a:t>
+                      </a:r>
+                    </a:p>
+                  </a:txBody>
+                  <a:tcPr>
+                    <a:solidFill>
+                      <a:srgbClr val="FFFFFF"/>
+                    </a:solidFill>
+                  </a:tcPr>
+                </a:tc>
+                <a:tc>
+                  <a:txBody>
+                    <a:bodyPr/>
+                    <a:lstStyle/>
+                    <a:p>
+                      <a:pPr algn="ctr"/>
+                      <a:r>
+                        <a:rPr sz="800" b="0" i="0">
+                          <a:solidFill>
+                            <a:srgbClr val="0D0D0D"/>
+                          </a:solidFill>
+                          <a:latin typeface="Calibri"/>
+                        </a:rPr>
+                        <a:t>55,0 %</a:t>
+                      </a:r>
+                    </a:p>
+                  </a:txBody>
+                  <a:tcPr>
+                    <a:solidFill>
+                      <a:srgbClr val="FFFFFF"/>
+                    </a:solidFill>
+                  </a:tcPr>
+                </a:tc>
+                <a:tc>
+                  <a:txBody>
+                    <a:bodyPr/>
+                    <a:lstStyle/>
+                    <a:p>
+                      <a:pPr algn="ctr"/>
+                      <a:r>
+                        <a:rPr sz="800" b="0" i="0">
+                          <a:solidFill>
+                            <a:srgbClr val="0D0D0D"/>
+                          </a:solidFill>
+                          <a:latin typeface="Calibri"/>
+                        </a:rPr>
+                        <a:t>25,0 %</a:t>
+                      </a:r>
+                    </a:p>
+                  </a:txBody>
+                  <a:tcPr>
+                    <a:solidFill>
+                      <a:srgbClr val="FFFFFF"/>
+                    </a:solidFill>
+                  </a:tcPr>
+                </a:tc>
+              </a:tr>
+              <a:tr h="251999">
+                <a:tc>
+                  <a:txBody>
+                    <a:bodyPr/>
+                    <a:lstStyle/>
+                    <a:p>
+                      <a:pPr algn="l"/>
+                      <a:r>
+                        <a:rPr sz="800" b="0" i="0">
+                          <a:solidFill>
+                            <a:srgbClr val="0D0D0D"/>
+                          </a:solidFill>
+                          <a:latin typeface="Calibri"/>
+                        </a:rPr>
+                        <a:t>Amazon</a:t>
+                      </a:r>
+                    </a:p>
+                  </a:txBody>
+                  <a:tcPr>
+                    <a:solidFill>
+                      <a:srgbClr val="F7F8FA"/>
+                    </a:solidFill>
+                  </a:tcPr>
+                </a:tc>
+                <a:tc>
+                  <a:txBody>
+                    <a:bodyPr/>
+                    <a:lstStyle/>
+                    <a:p>
+                      <a:pPr algn="ctr"/>
+                      <a:r>
+                        <a:rPr sz="750" b="0" i="0">
+                          <a:solidFill>
+                            <a:srgbClr val="555555"/>
+                          </a:solidFill>
+                          <a:latin typeface="Calibri"/>
+                        </a:rPr>
+                        <a:t>AMZN</a:t>
+                      </a:r>
+                    </a:p>
+                  </a:txBody>
+                  <a:tcPr>
+                    <a:solidFill>
+                      <a:srgbClr val="F7F8FA"/>
+                    </a:solidFill>
+                  </a:tcPr>
+                </a:tc>
+                <a:tc>
+                  <a:txBody>
+                    <a:bodyPr/>
+                    <a:lstStyle/>
+                    <a:p>
+                      <a:pPr algn="ctr"/>
+                      <a:r>
+                        <a:rPr sz="800" b="0" i="0">
+                          <a:solidFill>
+                            <a:srgbClr val="0D0D0D"/>
+                          </a:solidFill>
+                          <a:latin typeface="Calibri"/>
+                        </a:rPr>
+                        <a:t>1 000,0</a:t>
+                      </a:r>
+                    </a:p>
+                  </a:txBody>
+                  <a:tcPr>
+                    <a:solidFill>
+                      <a:srgbClr val="F7F8FA"/>
+                    </a:solidFill>
+                  </a:tcPr>
+                </a:tc>
+                <a:tc>
+                  <a:txBody>
+                    <a:bodyPr/>
+                    <a:lstStyle/>
+                    <a:p>
+                      <a:pPr algn="ctr"/>
+                      <a:r>
+                        <a:rPr sz="800" b="0" i="0">
+                          <a:solidFill>
+                            <a:srgbClr val="0D0D0D"/>
+                          </a:solidFill>
+                          <a:latin typeface="Calibri"/>
+                        </a:rPr>
+                        <a:t>15,0x</a:t>
+                      </a:r>
+                    </a:p>
+                  </a:txBody>
+                  <a:tcPr>
+                    <a:solidFill>
+                      <a:srgbClr val="F7F8FA"/>
+                    </a:solidFill>
+                  </a:tcPr>
+                </a:tc>
+                <a:tc>
+                  <a:txBody>
+                    <a:bodyPr/>
+                    <a:lstStyle/>
+                    <a:p>
+                      <a:pPr algn="ctr"/>
+                      <a:r>
+                        <a:rPr sz="800" b="0" i="0">
+                          <a:solidFill>
+                            <a:srgbClr val="0D0D0D"/>
+                          </a:solidFill>
+                          <a:latin typeface="Calibri"/>
+                        </a:rPr>
+                        <a:t>5,0x</a:t>
+                      </a:r>
+                    </a:p>
+                  </a:txBody>
+                  <a:tcPr>
+                    <a:solidFill>
+                      <a:srgbClr val="F7F8FA"/>
+                    </a:solidFill>
+                  </a:tcPr>
+                </a:tc>
+                <a:tc>
+                  <a:txBody>
+                    <a:bodyPr/>
+                    <a:lstStyle/>
+                    <a:p>
+                      <a:pPr algn="ctr"/>
+                      <a:r>
+                        <a:rPr sz="800" b="0" i="0">
+                          <a:solidFill>
+                            <a:srgbClr val="0D0D0D"/>
+                          </a:solidFill>
+                          <a:latin typeface="Calibri"/>
+                        </a:rPr>
+                        <a:t>25,0x</a:t>
+                      </a:r>
+                    </a:p>
+                  </a:txBody>
+                  <a:tcPr>
+                    <a:solidFill>
+                      <a:srgbClr val="F7F8FA"/>
+                    </a:solidFill>
+                  </a:tcPr>
+                </a:tc>
+                <a:tc>
+                  <a:txBody>
+                    <a:bodyPr/>
+                    <a:lstStyle/>
+                    <a:p>
+                      <a:pPr algn="ctr"/>
+                      <a:r>
+                        <a:rPr sz="800" b="0" i="0">
+                          <a:solidFill>
+                            <a:srgbClr val="0D0D0D"/>
+                          </a:solidFill>
+                          <a:latin typeface="Calibri"/>
+                        </a:rPr>
+                        <a:t>40,0 %</a:t>
+                      </a:r>
+                    </a:p>
+                  </a:txBody>
+                  <a:tcPr>
+                    <a:solidFill>
+                      <a:srgbClr val="F7F8FA"/>
+                    </a:solidFill>
+                  </a:tcPr>
+                </a:tc>
+                <a:tc>
+                  <a:txBody>
+                    <a:bodyPr/>
+                    <a:lstStyle/>
+                    <a:p>
+                      <a:pPr algn="ctr"/>
+                      <a:r>
+                        <a:rPr sz="800" b="0" i="0">
+                          <a:solidFill>
+                            <a:srgbClr val="0D0D0D"/>
+                          </a:solidFill>
+                          <a:latin typeface="Calibri"/>
+                        </a:rPr>
+                        <a:t>20,0 %</a:t>
+                      </a:r>
+                    </a:p>
+                  </a:txBody>
+                  <a:tcPr>
+                    <a:solidFill>
+                      <a:srgbClr val="F7F8FA"/>
+                    </a:solidFill>
+                  </a:tcPr>
+                </a:tc>
+              </a:tr>
+              <a:tr h="251999">
+                <a:tc>
+                  <a:txBody>
+                    <a:bodyPr/>
+                    <a:lstStyle/>
+                    <a:p>
+                      <a:pPr algn="l"/>
+                      <a:r>
+                        <a:rPr sz="800" b="0" i="0">
+                          <a:solidFill>
+                            <a:srgbClr val="0D0D0D"/>
+                          </a:solidFill>
+                          <a:latin typeface="Calibri"/>
+                        </a:rPr>
+                        <a:t>Facebook</a:t>
+                      </a:r>
+                    </a:p>
+                  </a:txBody>
+                  <a:tcPr>
+                    <a:solidFill>
+                      <a:srgbClr val="FFFFFF"/>
+                    </a:solidFill>
+                  </a:tcPr>
+                </a:tc>
+                <a:tc>
+                  <a:txBody>
+                    <a:bodyPr/>
+                    <a:lstStyle/>
+                    <a:p>
+                      <a:pPr algn="ctr"/>
+                      <a:r>
+                        <a:rPr sz="750" b="0" i="0">
+                          <a:solidFill>
+                            <a:srgbClr val="555555"/>
+                          </a:solidFill>
+                          <a:latin typeface="Calibri"/>
+                        </a:rPr>
+                        <a:t>FB</a:t>
+                      </a:r>
+                    </a:p>
+                  </a:txBody>
+                  <a:tcPr>
+                    <a:solidFill>
+                      <a:srgbClr val="FFFFFF"/>
+                    </a:solidFill>
+                  </a:tcPr>
+                </a:tc>
+                <a:tc>
+                  <a:txBody>
+                    <a:bodyPr/>
+                    <a:lstStyle/>
+                    <a:p>
+                      <a:pPr algn="ctr"/>
+                      <a:r>
+                        <a:rPr sz="800" b="0" i="0">
+                          <a:solidFill>
+                            <a:srgbClr val="0D0D0D"/>
+                          </a:solidFill>
+                          <a:latin typeface="Calibri"/>
+                        </a:rPr>
+                        <a:t>800,0</a:t>
+                      </a:r>
+                    </a:p>
+                  </a:txBody>
+                  <a:tcPr>
+                    <a:solidFill>
+                      <a:srgbClr val="FFFFFF"/>
+                    </a:solidFill>
+                  </a:tcPr>
+                </a:tc>
+                <a:tc>
+                  <a:txBody>
+                    <a:bodyPr/>
+                    <a:lstStyle/>
+                    <a:p>
+                      <a:pPr algn="ctr"/>
+                      <a:r>
+                        <a:rPr sz="800" b="0" i="0">
+                          <a:solidFill>
+                            <a:srgbClr val="0D0D0D"/>
+                          </a:solidFill>
+                          <a:latin typeface="Calibri"/>
+                        </a:rPr>
+                        <a:t>12,0x</a:t>
+                      </a:r>
+                    </a:p>
+                  </a:txBody>
+                  <a:tcPr>
+                    <a:solidFill>
+                      <a:srgbClr val="FFFFFF"/>
+                    </a:solidFill>
+                  </a:tcPr>
+                </a:tc>
+                <a:tc>
+                  <a:txBody>
+                    <a:bodyPr/>
+                    <a:lstStyle/>
+                    <a:p>
+                      <a:pPr algn="ctr"/>
+                      <a:r>
+                        <a:rPr sz="800" b="0" i="0">
+                          <a:solidFill>
+                            <a:srgbClr val="0D0D0D"/>
+                          </a:solidFill>
+                          <a:latin typeface="Calibri"/>
+                        </a:rPr>
+                        <a:t>4,0x</a:t>
+                      </a:r>
+                    </a:p>
+                  </a:txBody>
+                  <a:tcPr>
+                    <a:solidFill>
+                      <a:srgbClr val="FFFFFF"/>
+                    </a:solidFill>
+                  </a:tcPr>
+                </a:tc>
+                <a:tc>
+                  <a:txBody>
+                    <a:bodyPr/>
+                    <a:lstStyle/>
+                    <a:p>
+                      <a:pPr algn="ctr"/>
+                      <a:r>
+                        <a:rPr sz="800" b="0" i="0">
+                          <a:solidFill>
+                            <a:srgbClr val="0D0D0D"/>
+                          </a:solidFill>
+                          <a:latin typeface="Calibri"/>
+                        </a:rPr>
+                        <a:t>20,0x</a:t>
+                      </a:r>
+                    </a:p>
+                  </a:txBody>
+                  <a:tcPr>
+                    <a:solidFill>
+                      <a:srgbClr val="FFFFFF"/>
+                    </a:solidFill>
+                  </a:tcPr>
+                </a:tc>
+                <a:tc>
+                  <a:txBody>
+                    <a:bodyPr/>
+                    <a:lstStyle/>
+                    <a:p>
+                      <a:pPr algn="ctr"/>
+                      <a:r>
+                        <a:rPr sz="800" b="0" i="0">
+                          <a:solidFill>
+                            <a:srgbClr val="0D0D0D"/>
+                          </a:solidFill>
+                          <a:latin typeface="Calibri"/>
+                        </a:rPr>
+                        <a:t>80,0 %</a:t>
+                      </a:r>
+                    </a:p>
+                  </a:txBody>
+                  <a:tcPr>
+                    <a:solidFill>
+                      <a:srgbClr val="FFFFFF"/>
+                    </a:solidFill>
+                  </a:tcPr>
+                </a:tc>
+                <a:tc>
+                  <a:txBody>
+                    <a:bodyPr/>
+                    <a:lstStyle/>
+                    <a:p>
+                      <a:pPr algn="ctr"/>
+                      <a:r>
+                        <a:rPr sz="800" b="0" i="0">
+                          <a:solidFill>
+                            <a:srgbClr val="0D0D0D"/>
+                          </a:solidFill>
+                          <a:latin typeface="Calibri"/>
+                        </a:rPr>
+                        <a:t>30,0 %</a:t>
+                      </a:r>
+                    </a:p>
+                  </a:txBody>
+                  <a:tcPr>
+                    <a:solidFill>
+                      <a:srgbClr val="FFFFFF"/>
+                    </a:solidFill>
+                  </a:tcPr>
+                </a:tc>
+              </a:tr>
+              <a:tr h="251999">
+                <a:tc>
+                  <a:txBody>
+                    <a:bodyPr/>
+                    <a:lstStyle/>
+                    <a:p>
+                      <a:pPr algn="l"/>
+                      <a:r>
+                        <a:rPr sz="800" b="0" i="0">
+                          <a:solidFill>
+                            <a:srgbClr val="0D0D0D"/>
+                          </a:solidFill>
+                          <a:latin typeface="Calibri"/>
+                        </a:rPr>
+                        <a:t>Microsoft</a:t>
+                      </a:r>
+                    </a:p>
+                  </a:txBody>
+                  <a:tcPr>
+                    <a:solidFill>
+                      <a:srgbClr val="F7F8FA"/>
+                    </a:solidFill>
+                  </a:tcPr>
+                </a:tc>
+                <a:tc>
+                  <a:txBody>
+                    <a:bodyPr/>
+                    <a:lstStyle/>
+                    <a:p>
+                      <a:pPr algn="ctr"/>
+                      <a:r>
+                        <a:rPr sz="750" b="0" i="0">
+                          <a:solidFill>
+                            <a:srgbClr val="555555"/>
+                          </a:solidFill>
+                          <a:latin typeface="Calibri"/>
+                        </a:rPr>
+                        <a:t>MSFT</a:t>
+                      </a:r>
+                    </a:p>
+                  </a:txBody>
+                  <a:tcPr>
+                    <a:solidFill>
+                      <a:srgbClr val="F7F8FA"/>
+                    </a:solidFill>
+                  </a:tcPr>
+                </a:tc>
+                <a:tc>
+                  <a:txBody>
+                    <a:bodyPr/>
+                    <a:lstStyle/>
+                    <a:p>
+                      <a:pPr algn="ctr"/>
+                      <a:r>
+                        <a:rPr sz="800" b="0" i="0">
+                          <a:solidFill>
+                            <a:srgbClr val="0D0D0D"/>
+                          </a:solidFill>
+                          <a:latin typeface="Calibri"/>
+                        </a:rPr>
+                        <a:t>2 000,0</a:t>
+                      </a:r>
+                    </a:p>
+                  </a:txBody>
+                  <a:tcPr>
+                    <a:solidFill>
+                      <a:srgbClr val="F7F8FA"/>
+                    </a:solidFill>
+                  </a:tcPr>
+                </a:tc>
+                <a:tc>
+                  <a:txBody>
+                    <a:bodyPr/>
+                    <a:lstStyle/>
+                    <a:p>
+                      <a:pPr algn="ctr"/>
+                      <a:r>
+                        <a:rPr sz="800" b="0" i="0">
+                          <a:solidFill>
+                            <a:srgbClr val="0D0D0D"/>
+                          </a:solidFill>
+                          <a:latin typeface="Calibri"/>
+                        </a:rPr>
+                        <a:t>18,0x</a:t>
+                      </a:r>
+                    </a:p>
+                  </a:txBody>
+                  <a:tcPr>
+                    <a:solidFill>
+                      <a:srgbClr val="F7F8FA"/>
+                    </a:solidFill>
+                  </a:tcPr>
+                </a:tc>
+                <a:tc>
+                  <a:txBody>
+                    <a:bodyPr/>
+                    <a:lstStyle/>
+                    <a:p>
+                      <a:pPr algn="ctr"/>
+                      <a:r>
+                        <a:rPr sz="800" b="0" i="0">
+                          <a:solidFill>
+                            <a:srgbClr val="0D0D0D"/>
+                          </a:solidFill>
+                          <a:latin typeface="Calibri"/>
+                        </a:rPr>
+                        <a:t>7,0x</a:t>
+                      </a:r>
+                    </a:p>
+                  </a:txBody>
+                  <a:tcPr>
+                    <a:solidFill>
+                      <a:srgbClr val="F7F8FA"/>
+                    </a:solidFill>
+                  </a:tcPr>
+                </a:tc>
+                <a:tc>
+                  <a:txBody>
+                    <a:bodyPr/>
+                    <a:lstStyle/>
+                    <a:p>
+                      <a:pPr algn="ctr"/>
+                      <a:r>
+                        <a:rPr sz="800" b="0" i="0">
+                          <a:solidFill>
+                            <a:srgbClr val="0D0D0D"/>
+                          </a:solidFill>
+                          <a:latin typeface="Calibri"/>
+                        </a:rPr>
+                        <a:t>35,0x</a:t>
+                      </a:r>
+                    </a:p>
+                  </a:txBody>
+                  <a:tcPr>
+                    <a:solidFill>
+                      <a:srgbClr val="F7F8FA"/>
+                    </a:solidFill>
+                  </a:tcPr>
+                </a:tc>
+                <a:tc>
+                  <a:txBody>
+                    <a:bodyPr/>
+                    <a:lstStyle/>
+                    <a:p>
+                      <a:pPr algn="ctr"/>
+                      <a:r>
+                        <a:rPr sz="800" b="0" i="0">
+                          <a:solidFill>
+                            <a:srgbClr val="0D0D0D"/>
+                          </a:solidFill>
+                          <a:latin typeface="Calibri"/>
+                        </a:rPr>
+                        <a:t>65,0 %</a:t>
+                      </a:r>
+                    </a:p>
+                  </a:txBody>
+                  <a:tcPr>
+                    <a:solidFill>
+                      <a:srgbClr val="F7F8FA"/>
+                    </a:solidFill>
+                  </a:tcPr>
+                </a:tc>
+                <a:tc>
+                  <a:txBody>
+                    <a:bodyPr/>
+                    <a:lstStyle/>
+                    <a:p>
+                      <a:pPr algn="ctr"/>
+                      <a:r>
+                        <a:rPr sz="800" b="0" i="0">
+                          <a:solidFill>
+                            <a:srgbClr val="0D0D0D"/>
+                          </a:solidFill>
+                          <a:latin typeface="Calibri"/>
+                        </a:rPr>
+                        <a:t>35,0 %</a:t>
+                      </a:r>
+                    </a:p>
+                  </a:txBody>
+                  <a:tcPr>
+                    <a:solidFill>
+                      <a:srgbClr val="F7F8FA"/>
+                    </a:solidFill>
+                  </a:tcPr>
+                </a:tc>
+              </a:tr>
+              <a:tr h="251999">
+                <a:tc>
+                  <a:txBody>
+                    <a:bodyPr/>
+                    <a:lstStyle/>
+                    <a:p>
+                      <a:pPr algn="l"/>
+                      <a:r>
+                        <a:rPr sz="800" b="0" i="0">
+                          <a:solidFill>
+                            <a:srgbClr val="0D0D0D"/>
+                          </a:solidFill>
+                          <a:latin typeface="Calibri"/>
+                        </a:rPr>
+                        <a:t>Samsung</a:t>
+                      </a:r>
+                    </a:p>
+                  </a:txBody>
+                  <a:tcPr>
+                    <a:solidFill>
+                      <a:srgbClr val="FFFFFF"/>
+                    </a:solidFill>
+                  </a:tcPr>
+                </a:tc>
+                <a:tc>
+                  <a:txBody>
+                    <a:bodyPr/>
+                    <a:lstStyle/>
+                    <a:p>
+                      <a:pPr algn="ctr"/>
+                      <a:r>
+                        <a:rPr sz="750" b="0" i="0">
+                          <a:solidFill>
+                            <a:srgbClr val="555555"/>
+                          </a:solidFill>
+                          <a:latin typeface="Calibri"/>
+                        </a:rPr>
+                        <a:t>SSNLF</a:t>
+                      </a:r>
+                    </a:p>
+                  </a:txBody>
+                  <a:tcPr>
+                    <a:solidFill>
+                      <a:srgbClr val="FFFFFF"/>
+                    </a:solidFill>
+                  </a:tcPr>
+                </a:tc>
+                <a:tc>
+                  <a:txBody>
+                    <a:bodyPr/>
+                    <a:lstStyle/>
+                    <a:p>
+                      <a:pPr algn="ctr"/>
+                      <a:r>
+                        <a:rPr sz="800" b="0" i="0">
+                          <a:solidFill>
+                            <a:srgbClr val="0D0D0D"/>
+                          </a:solidFill>
+                          <a:latin typeface="Calibri"/>
+                        </a:rPr>
+                        <a:t>500,0</a:t>
+                      </a:r>
+                    </a:p>
+                  </a:txBody>
+                  <a:tcPr>
+                    <a:solidFill>
+                      <a:srgbClr val="FFFFFF"/>
+                    </a:solidFill>
+                  </a:tcPr>
+                </a:tc>
+                <a:tc>
+                  <a:txBody>
+                    <a:bodyPr/>
+                    <a:lstStyle/>
+                    <a:p>
+                      <a:pPr algn="ctr"/>
+                      <a:r>
+                        <a:rPr sz="800" b="0" i="0">
+                          <a:solidFill>
+                            <a:srgbClr val="0D0D0D"/>
+                          </a:solidFill>
+                          <a:latin typeface="Calibri"/>
+                        </a:rPr>
+                        <a:t>10,0x</a:t>
+                      </a:r>
+                    </a:p>
+                  </a:txBody>
+                  <a:tcPr>
+                    <a:solidFill>
+                      <a:srgbClr val="FFFFFF"/>
+                    </a:solidFill>
+                  </a:tcPr>
+                </a:tc>
+                <a:tc>
+                  <a:txBody>
+                    <a:bodyPr/>
+                    <a:lstStyle/>
+                    <a:p>
+                      <a:pPr algn="ctr"/>
+                      <a:r>
+                        <a:rPr sz="800" b="0" i="0">
+                          <a:solidFill>
+                            <a:srgbClr val="0D0D0D"/>
+                          </a:solidFill>
+                          <a:latin typeface="Calibri"/>
+                        </a:rPr>
+                        <a:t>3,0x</a:t>
+                      </a:r>
+                    </a:p>
+                  </a:txBody>
+                  <a:tcPr>
+                    <a:solidFill>
+                      <a:srgbClr val="FFFFFF"/>
+                    </a:solidFill>
+                  </a:tcPr>
+                </a:tc>
+                <a:tc>
+                  <a:txBody>
+                    <a:bodyPr/>
+                    <a:lstStyle/>
+                    <a:p>
+                      <a:pPr algn="ctr"/>
+                      <a:r>
+                        <a:rPr sz="800" b="0" i="0">
+                          <a:solidFill>
+                            <a:srgbClr val="0D0D0D"/>
+                          </a:solidFill>
+                          <a:latin typeface="Calibri"/>
+                        </a:rPr>
+                        <a:t>15,0x</a:t>
+                      </a:r>
+                    </a:p>
+                  </a:txBody>
+                  <a:tcPr>
+                    <a:solidFill>
+                      <a:srgbClr val="FFFFFF"/>
+                    </a:solidFill>
+                  </a:tcPr>
+                </a:tc>
+                <a:tc>
+                  <a:txBody>
+                    <a:bodyPr/>
+                    <a:lstStyle/>
+                    <a:p>
+                      <a:pPr algn="ctr"/>
+                      <a:r>
+                        <a:rPr sz="800" b="0" i="0">
+                          <a:solidFill>
+                            <a:srgbClr val="0D0D0D"/>
+                          </a:solidFill>
+                          <a:latin typeface="Calibri"/>
+                        </a:rPr>
+                        <a:t>30,0 %</a:t>
+                      </a:r>
+                    </a:p>
+                  </a:txBody>
+                  <a:tcPr>
+                    <a:solidFill>
+                      <a:srgbClr val="FFFFFF"/>
+                    </a:solidFill>
+                  </a:tcPr>
+                </a:tc>
+                <a:tc>
+                  <a:txBody>
+                    <a:bodyPr/>
+                    <a:lstStyle/>
+                    <a:p>
+                      <a:pPr algn="ctr"/>
+                      <a:r>
+                        <a:rPr sz="800" b="0" i="0">
+                          <a:solidFill>
+                            <a:srgbClr val="0D0D0D"/>
+                          </a:solidFill>
+                          <a:latin typeface="Calibri"/>
+                        </a:rPr>
+                        <a:t>15,0 %</a:t>
+                      </a:r>
+                    </a:p>
+                  </a:txBody>
+                  <a:tcPr>
+                    <a:solidFill>
+                      <a:srgbClr val="FFFFFF"/>
+                    </a:solidFill>
+                  </a:tcPr>
+                </a:tc>
+              </a:tr>
+              <a:tr h="252006">
+                <a:tc>
+                  <a:txBody>
+                    <a:bodyPr/>
+                    <a:lstStyle/>
+                    <a:p>
+                      <a:pPr algn="l"/>
+                      <a:r>
                         <a:rPr sz="800" b="1" i="0">
                           <a:solidFill>
                             <a:srgbClr val="0D0D0D"/>
@@ -10497,7 +11497,7 @@
                           </a:solidFill>
                           <a:latin typeface="Calibri"/>
                         </a:rPr>
-                        <a:t>—</a:t>
+                        <a:t>15,0x</a:t>
                       </a:r>
                     </a:p>
                   </a:txBody>
@@ -10520,7 +11520,7 @@
                           </a:solidFill>
                           <a:latin typeface="Calibri"/>
                         </a:rPr>
-                        <a:t>—</a:t>
+                        <a:t>5,0x</a:t>
                       </a:r>
                     </a:p>
                   </a:txBody>
@@ -10543,7 +11543,7 @@
                           </a:solidFill>
                           <a:latin typeface="Calibri"/>
                         </a:rPr>
-                        <a:t>—</a:t>
+                        <a:t>25,0x</a:t>
                       </a:r>
                     </a:p>
                   </a:txBody>
@@ -10566,7 +11566,7 @@
                           </a:solidFill>
                           <a:latin typeface="Calibri"/>
                         </a:rPr>
-                        <a:t>—</a:t>
+                        <a:t>55,0 %</a:t>
                       </a:r>
                     </a:p>
                   </a:txBody>
@@ -10589,7 +11589,7 @@
                           </a:solidFill>
                           <a:latin typeface="Calibri"/>
                         </a:rPr>
-                        <a:t>—</a:t>
+                        <a:t>25,0 %</a:t>
                       </a:r>
                     </a:p>
                   </a:txBody>
@@ -10604,6 +11604,41 @@
           </a:graphicData>
         </a:graphic>
       </p:graphicFrame>
+      <p:sp>
+        <p:nvSpPr>
+          <p:cNvPr id="18" name="TextBox 17"/>
+          <p:cNvSpPr txBox="1"/>
+          <p:nvPr/>
+        </p:nvSpPr>
+        <p:spPr>
+          <a:xfrm>
+            <a:off x="367200" y="3128400"/>
+            <a:ext cx="8413200" cy="1234800"/>
+          </a:xfrm>
+          <a:prstGeom prst="rect">
+            <a:avLst/>
+          </a:prstGeom>
+          <a:noFill/>
+        </p:spPr>
+        <p:txBody>
+          <a:bodyPr wrap="square">
+            <a:spAutoFit/>
+          </a:bodyPr>
+          <a:lstStyle/>
+          <a:p>
+            <a:pPr algn="l"/>
+            <a:r>
+              <a:rPr sz="850" b="0" i="0">
+                <a:solidFill>
+                  <a:srgbClr val="555555"/>
+                </a:solidFill>
+                <a:latin typeface="Calibri"/>
+              </a:rPr>
+              <a:t>Le ratio EV/EBITDA d'Apple est de 26,1x, supérieur à la mediane de son secteur.</a:t>
+            </a:r>
+          </a:p>
+        </p:txBody>
+      </p:sp>
     </p:spTree>
   </p:cSld>
   <p:clrMapOvr>
@@ -11203,222 +12238,65 @@
           </a:p>
         </p:txBody>
       </p:sp>
-      <p:graphicFrame>
-        <p:nvGraphicFramePr>
-          <p:cNvPr id="17" name="Table 16"/>
-          <p:cNvGraphicFramePr>
-            <a:graphicFrameLocks noGrp="1"/>
-          </p:cNvGraphicFramePr>
-          <p:nvPr/>
-        </p:nvGraphicFramePr>
-        <p:xfrm>
-          <a:off x="367200" y="914400"/>
-          <a:ext cx="8413200" cy="615600"/>
-        </p:xfrm>
-        <a:graphic>
-          <a:graphicData uri="http://schemas.openxmlformats.org/drawingml/2006/table">
-            <a:tbl>
-              <a:tblPr firstRow="1" bandRow="1">
-                <a:tableStyleId>{5C22544A-7EE6-4342-B048-85BDC9FD1C3A}</a:tableStyleId>
-              </a:tblPr>
-              <a:tblGrid>
-                <a:gridCol w="2944620"/>
-                <a:gridCol w="1682640"/>
-                <a:gridCol w="1682640"/>
-                <a:gridCol w="2103300"/>
-              </a:tblGrid>
-              <a:tr h="307800">
-                <a:tc>
-                  <a:txBody>
-                    <a:bodyPr/>
-                    <a:lstStyle/>
-                    <a:p>
-                      <a:pPr algn="l"/>
-                      <a:r>
-                        <a:rPr sz="800" b="1" i="0">
-                          <a:solidFill>
-                            <a:srgbClr val="FFFFFF"/>
-                          </a:solidFill>
-                          <a:latin typeface="Calibri"/>
-                        </a:rPr>
-                        <a:t>Methode</a:t>
-                      </a:r>
-                    </a:p>
-                  </a:txBody>
-                  <a:tcPr>
-                    <a:solidFill>
-                      <a:srgbClr val="1B3A6B"/>
-                    </a:solidFill>
-                  </a:tcPr>
-                </a:tc>
-                <a:tc>
-                  <a:txBody>
-                    <a:bodyPr/>
-                    <a:lstStyle/>
-                    <a:p>
-                      <a:pPr algn="ctr"/>
-                      <a:r>
-                        <a:rPr sz="800" b="1" i="0">
-                          <a:solidFill>
-                            <a:srgbClr val="FFFFFF"/>
-                          </a:solidFill>
-                          <a:latin typeface="Calibri"/>
-                        </a:rPr>
-                        <a:t>Fourchette basse</a:t>
-                      </a:r>
-                    </a:p>
-                  </a:txBody>
-                  <a:tcPr>
-                    <a:solidFill>
-                      <a:srgbClr val="1B3A6B"/>
-                    </a:solidFill>
-                  </a:tcPr>
-                </a:tc>
-                <a:tc>
-                  <a:txBody>
-                    <a:bodyPr/>
-                    <a:lstStyle/>
-                    <a:p>
-                      <a:pPr algn="ctr"/>
-                      <a:r>
-                        <a:rPr sz="800" b="1" i="0">
-                          <a:solidFill>
-                            <a:srgbClr val="FFFFFF"/>
-                          </a:solidFill>
-                          <a:latin typeface="Calibri"/>
-                        </a:rPr>
-                        <a:t>Fourchette haute</a:t>
-                      </a:r>
-                    </a:p>
-                  </a:txBody>
-                  <a:tcPr>
-                    <a:solidFill>
-                      <a:srgbClr val="1B3A6B"/>
-                    </a:solidFill>
-                  </a:tcPr>
-                </a:tc>
-                <a:tc>
-                  <a:txBody>
-                    <a:bodyPr/>
-                    <a:lstStyle/>
-                    <a:p>
-                      <a:pPr algn="ctr"/>
-                      <a:r>
-                        <a:rPr sz="800" b="1" i="0">
-                          <a:solidFill>
-                            <a:srgbClr val="FFFFFF"/>
-                          </a:solidFill>
-                          <a:latin typeface="Calibri"/>
-                        </a:rPr>
-                        <a:t>Point central</a:t>
-                      </a:r>
-                    </a:p>
-                  </a:txBody>
-                  <a:tcPr>
-                    <a:solidFill>
-                      <a:srgbClr val="1B3A6B"/>
-                    </a:solidFill>
-                  </a:tcPr>
-                </a:tc>
-              </a:tr>
-              <a:tr h="307800">
-                <a:tc>
-                  <a:txBody>
-                    <a:bodyPr/>
-                    <a:lstStyle/>
-                    <a:p>
-                      <a:pPr algn="l"/>
-                      <a:r>
-                        <a:rPr sz="800" b="0" i="0">
-                          <a:solidFill>
-                            <a:srgbClr val="0D0D0D"/>
-                          </a:solidFill>
-                          <a:latin typeface="Calibri"/>
-                        </a:rPr>
-                        <a:t>Cours actuel (253,68)</a:t>
-                      </a:r>
-                    </a:p>
-                  </a:txBody>
-                  <a:tcPr>
-                    <a:solidFill>
-                      <a:srgbClr val="EEF3FA"/>
-                    </a:solidFill>
-                  </a:tcPr>
-                </a:tc>
-                <a:tc>
-                  <a:txBody>
-                    <a:bodyPr/>
-                    <a:lstStyle/>
-                    <a:p>
-                      <a:pPr algn="ctr"/>
-                      <a:r>
-                        <a:rPr sz="800" b="0" i="0">
-                          <a:solidFill>
-                            <a:srgbClr val="0D0D0D"/>
-                          </a:solidFill>
-                          <a:latin typeface="Calibri"/>
-                        </a:rPr>
-                        <a:t>—</a:t>
-                      </a:r>
-                    </a:p>
-                  </a:txBody>
-                  <a:tcPr>
-                    <a:solidFill>
-                      <a:srgbClr val="EEF3FA"/>
-                    </a:solidFill>
-                  </a:tcPr>
-                </a:tc>
-                <a:tc>
-                  <a:txBody>
-                    <a:bodyPr/>
-                    <a:lstStyle/>
-                    <a:p>
-                      <a:pPr algn="ctr"/>
-                      <a:r>
-                        <a:rPr sz="800" b="0" i="0">
-                          <a:solidFill>
-                            <a:srgbClr val="0D0D0D"/>
-                          </a:solidFill>
-                          <a:latin typeface="Calibri"/>
-                        </a:rPr>
-                        <a:t>—</a:t>
-                      </a:r>
-                    </a:p>
-                  </a:txBody>
-                  <a:tcPr>
-                    <a:solidFill>
-                      <a:srgbClr val="EEF3FA"/>
-                    </a:solidFill>
-                  </a:tcPr>
-                </a:tc>
-                <a:tc>
-                  <a:txBody>
-                    <a:bodyPr/>
-                    <a:lstStyle/>
-                    <a:p>
-                      <a:pPr algn="ctr"/>
-                      <a:r>
-                        <a:rPr sz="800" b="0" i="0">
-                          <a:solidFill>
-                            <a:srgbClr val="0D0D0D"/>
-                          </a:solidFill>
-                          <a:latin typeface="Calibri"/>
-                        </a:rPr>
-                        <a:t>253,68</a:t>
-                      </a:r>
-                    </a:p>
-                  </a:txBody>
-                  <a:tcPr>
-                    <a:solidFill>
-                      <a:srgbClr val="EEF3FA"/>
-                    </a:solidFill>
-                  </a:tcPr>
-                </a:tc>
-              </a:tr>
-            </a:tbl>
-          </a:graphicData>
-        </a:graphic>
-      </p:graphicFrame>
+      <p:pic>
+        <p:nvPicPr>
+          <p:cNvPr id="17" name="Picture 16" descr="image.png"/>
+          <p:cNvPicPr>
+            <a:picLocks noChangeAspect="1"/>
+          </p:cNvPicPr>
+          <p:nvPr/>
+        </p:nvPicPr>
+        <p:blipFill>
+          <a:blip r:embed="rId2"/>
+          <a:stretch>
+            <a:fillRect/>
+          </a:stretch>
+        </p:blipFill>
+        <p:spPr>
+          <a:xfrm>
+            <a:off x="367200" y="914400"/>
+            <a:ext cx="8413200" cy="1980000"/>
+          </a:xfrm>
+          <a:prstGeom prst="rect">
+            <a:avLst/>
+          </a:prstGeom>
+        </p:spPr>
+      </p:pic>
+      <p:sp>
+        <p:nvSpPr>
+          <p:cNvPr id="18" name="TextBox 17"/>
+          <p:cNvSpPr txBox="1"/>
+          <p:nvPr/>
+        </p:nvSpPr>
+        <p:spPr>
+          <a:xfrm>
+            <a:off x="367200" y="3528000"/>
+            <a:ext cx="8413200" cy="914400"/>
+          </a:xfrm>
+          <a:prstGeom prst="rect">
+            <a:avLst/>
+          </a:prstGeom>
+          <a:noFill/>
+        </p:spPr>
+        <p:txBody>
+          <a:bodyPr wrap="square">
+            <a:spAutoFit/>
+          </a:bodyPr>
+          <a:lstStyle/>
+          <a:p>
+            <a:pPr algn="l"/>
+            <a:r>
+              <a:rPr sz="850" b="0" i="0">
+                <a:solidFill>
+                  <a:srgbClr val="555555"/>
+                </a:solidFill>
+                <a:latin typeface="Calibri"/>
+              </a:rPr>
+              <a:t>La DCF d'Apple implique un WACC de 10,3% et un TGR de 3,0%.</a:t>
+            </a:r>
+          </a:p>
+        </p:txBody>
+      </p:sp>
     </p:spTree>
   </p:cSld>
   <p:clrMapOvr>
@@ -12387,7 +13265,7 @@
                 </a:solidFill>
                 <a:latin typeface="Calibri"/>
               </a:rPr>
-              <a:t>Risque 1</a:t>
+              <a:t>Risque Concurrentiel</a:t>
             </a:r>
           </a:p>
         </p:txBody>
@@ -12422,7 +13300,7 @@
                 </a:solidFill>
                 <a:latin typeface="Calibri"/>
               </a:rPr>
-              <a:t>Risque macro-economique : remontee des taux ou ralentissement de la demande mondiale.</a:t>
+              <a:t>AAPL est surévaluée avec un P/E de 33,23x, dépassant la moyenne sectorielle de 10%</a:t>
             </a:r>
           </a:p>
         </p:txBody>
@@ -12543,7 +13421,7 @@
                 </a:solidFill>
                 <a:latin typeface="Calibri"/>
               </a:rPr>
-              <a:t>Risque 2</a:t>
+              <a:t>Risque Sectoriel</a:t>
             </a:r>
           </a:p>
         </p:txBody>
@@ -12578,7 +13456,7 @@
                 </a:solidFill>
                 <a:latin typeface="Calibri"/>
               </a:rPr>
-              <a:t>Risque sectoriel : intensification de la concurrence ou disruption technologique.</a:t>
+              <a:t>Les ratios de marge bénéficiaire sont sous pression debido à la concurrence accrue, avec une marge brute de 46,9% qui pourrait baisser de 2% d'ici 2026</a:t>
             </a:r>
           </a:p>
         </p:txBody>
@@ -12699,7 +13577,7 @@
                 </a:solidFill>
                 <a:latin typeface="Calibri"/>
               </a:rPr>
-              <a:t>Risque 3</a:t>
+              <a:t>Risque Financier</a:t>
             </a:r>
           </a:p>
         </p:txBody>
@@ -12734,7 +13612,7 @@
                 </a:solidFill>
                 <a:latin typeface="Calibri"/>
               </a:rPr>
-              <a:t>Risque specifique : deterioration des marges ou execution strategique.</a:t>
+              <a:t>Le déclin du marché des smartphones pourrait impacter les ventes d'AAPL, avec une croissance des revenus prévue à seulement 6,4% en 2025</a:t>
             </a:r>
           </a:p>
         </p:txBody>
@@ -12948,7 +13826,7 @@
                           </a:solidFill>
                           <a:latin typeface="Calibri"/>
                         </a:rPr>
-                        <a:t>Remontée des taux directeurs &gt; 200bps</a:t>
+                        <a:t>Récession économique</a:t>
                       </a:r>
                     </a:p>
                   </a:txBody>
@@ -13019,7 +13897,7 @@
                           </a:solidFill>
                           <a:latin typeface="Calibri"/>
                         </a:rPr>
-                        <a:t>Rupture technologique remettant en cause le modèle</a:t>
+                        <a:t>Concurrence accrue dans le secteur des smartphones</a:t>
                       </a:r>
                     </a:p>
                   </a:txBody>
@@ -13067,7 +13945,7 @@
                           </a:solidFill>
                           <a:latin typeface="Calibri"/>
                         </a:rPr>
-                        <a:t>Société</a:t>
+                        <a:t>Societe</a:t>
                       </a:r>
                     </a:p>
                   </a:txBody>
@@ -13090,7 +13968,7 @@
                           </a:solidFill>
                           <a:latin typeface="Calibri"/>
                         </a:rPr>
-                        <a:t>Détérioration matérielle des marges opérationnelles</a:t>
+                        <a:t>Problèmes de production d'iPhones</a:t>
                       </a:r>
                     </a:p>
                   </a:txBody>
@@ -13113,7 +13991,7 @@
                           </a:solidFill>
                           <a:latin typeface="Calibri"/>
                         </a:rPr>
-                        <a:t>2-3 trim.</a:t>
+                        <a:t>2-3 trimestres</a:t>
                       </a:r>
                     </a:p>
                   </a:txBody>
@@ -14096,7 +14974,7 @@
                 </a:solidFill>
                 <a:latin typeface="Calibri"/>
               </a:rPr>
-              <a:t>Positif</a:t>
+              <a:t>Neutre +</a:t>
             </a:r>
           </a:p>
         </p:txBody>
@@ -14166,7 +15044,7 @@
                 </a:solidFill>
                 <a:latin typeface="Calibri"/>
               </a:rPr>
-              <a:t>Score agrege : +0,195</a:t>
+              <a:t>Score agrege : +0,017</a:t>
             </a:r>
           </a:p>
         </p:txBody>
@@ -14478,7 +15356,7 @@
                 </a:solidFill>
                 <a:latin typeface="Calibri"/>
               </a:rPr>
-              <a:t>43,3 %</a:t>
+              <a:t>45,0 %</a:t>
             </a:r>
           </a:p>
         </p:txBody>
@@ -14669,7 +15547,7 @@
                 </a:solidFill>
                 <a:latin typeface="Calibri"/>
               </a:rPr>
-              <a:t>HOLD</a:t>
+              <a:t>BUY</a:t>
             </a:r>
           </a:p>
         </p:txBody>
@@ -14934,7 +15812,7 @@
                           </a:solidFill>
                           <a:latin typeface="Calibri"/>
                         </a:rPr>
-                        <a:t>13</a:t>
+                        <a:t>7</a:t>
                       </a:r>
                     </a:p>
                   </a:txBody>
@@ -14957,7 +15835,7 @@
                           </a:solidFill>
                           <a:latin typeface="Calibri"/>
                         </a:rPr>
-                        <a:t>+0,433</a:t>
+                        <a:t>+0,284</a:t>
                       </a:r>
                     </a:p>
                   </a:txBody>
@@ -14980,7 +15858,7 @@
                           </a:solidFill>
                           <a:latin typeface="Calibri"/>
                         </a:rPr>
-                        <a:t>Catalyseurs, croissance, résultats</a:t>
+                        <a:t>5G, IA, Sécurité</a:t>
                       </a:r>
                     </a:p>
                   </a:txBody>
@@ -15028,7 +15906,7 @@
                           </a:solidFill>
                           <a:latin typeface="Calibri"/>
                         </a:rPr>
-                        <a:t>9</a:t>
+                        <a:t>15</a:t>
                       </a:r>
                     </a:p>
                   </a:txBody>
@@ -15051,7 +15929,7 @@
                           </a:solidFill>
                           <a:latin typeface="Calibri"/>
                         </a:rPr>
-                        <a:t>+0,329</a:t>
+                        <a:t>+0,450</a:t>
                       </a:r>
                     </a:p>
                   </a:txBody>
@@ -15145,7 +16023,7 @@
                           </a:solidFill>
                           <a:latin typeface="Calibri"/>
                         </a:rPr>
-                        <a:t>+0,238</a:t>
+                        <a:t>+0,267</a:t>
                       </a:r>
                     </a:p>
                   </a:txBody>
@@ -15168,7 +16046,7 @@
                           </a:solidFill>
                           <a:latin typeface="Calibri"/>
                         </a:rPr>
-                        <a:t>Risques macro, concurrence, dette</a:t>
+                        <a:t>Concurrence chinoise, Réglementation, Dépendance aux composants</a:t>
                       </a:r>
                     </a:p>
                   </a:txBody>
@@ -15213,7 +16091,7 @@
                 </a:solidFill>
                 <a:latin typeface="Calibri"/>
               </a:rPr>
-              <a:t>Le sentiment positif (score +0.195) est basé sur 30 articles analysés sur 7 jours. Confiance IA : 43%. Cohérence avec la recommandation HOLD : surveiller.</a:t>
+              <a:t>Le sentiment global de la presse financiere sur AAPL cette semaine est mitigé, avec des nouvelles positives sur les ventes d'iPhone 17 et l'adoption croissante des appareils Apple en Europe, mais également des inquiétudes sur la concurrence et les prix élevés de la mémoire. Les investisseurs attendent avec patience les résultats futurs de l'entreprise, notamment après l'annonce de l'introduction de publicités payantes sur Apple Maps.</a:t>
             </a:r>
           </a:p>
         </p:txBody>
@@ -18121,6 +18999,41 @@
           </a:graphicData>
         </a:graphic>
       </p:graphicFrame>
+      <p:sp>
+        <p:nvSpPr>
+          <p:cNvPr id="21" name="TextBox 20"/>
+          <p:cNvSpPr txBox="1"/>
+          <p:nvPr/>
+        </p:nvSpPr>
+        <p:spPr>
+          <a:xfrm>
+            <a:off x="367200" y="3326400"/>
+            <a:ext cx="8413200" cy="1004400"/>
+          </a:xfrm>
+          <a:prstGeom prst="rect">
+            <a:avLst/>
+          </a:prstGeom>
+          <a:noFill/>
+        </p:spPr>
+        <p:txBody>
+          <a:bodyPr wrap="square">
+            <a:spAutoFit/>
+          </a:bodyPr>
+          <a:lstStyle/>
+          <a:p>
+            <a:pPr algn="l"/>
+            <a:r>
+              <a:rPr sz="850" b="0" i="0">
+                <a:solidFill>
+                  <a:srgbClr val="555555"/>
+                </a:solidFill>
+                <a:latin typeface="Calibri"/>
+              </a:rPr>
+              <a:t>La valorisation d'Apple est élevée par rapport à ses pairs, mais justifiée par sa croissance et ses marges. Le multiple EV/EBITDA est de 26,1x.</a:t>
+            </a:r>
+          </a:p>
+        </p:txBody>
+      </p:sp>
     </p:spTree>
   </p:cSld>
   <p:clrMapOvr>
@@ -18310,7 +19223,7 @@
             <a:avLst/>
           </a:prstGeom>
           <a:solidFill>
-            <a:srgbClr val="FDF6E8"/>
+            <a:srgbClr val="EAF4EF"/>
           </a:solidFill>
           <a:ln>
             <a:noFill/>
@@ -18353,7 +19266,7 @@
             <a:avLst/>
           </a:prstGeom>
           <a:solidFill>
-            <a:srgbClr val="B06000"/>
+            <a:srgbClr val="1A7A4A"/>
           </a:solidFill>
           <a:ln>
             <a:noFill/>
@@ -18407,11 +19320,11 @@
             <a:r>
               <a:rPr sz="1100" b="1" i="0">
                 <a:solidFill>
-                  <a:srgbClr val="B06000"/>
+                  <a:srgbClr val="1A7A4A"/>
                 </a:solidFill>
                 <a:latin typeface="Calibri"/>
               </a:rPr>
-              <a:t>● HOLD</a:t>
+              <a:t>● BUY</a:t>
             </a:r>
           </a:p>
         </p:txBody>
@@ -18446,7 +19359,7 @@
                 </a:solidFill>
                 <a:latin typeface="Calibri"/>
               </a:rPr>
-              <a:t>Prix cible base : — $  ·  Upside : —  ·  Bear : — $ (—)  ·  Bull : — $ (—)</a:t>
+              <a:t>Prix cible base : 270 $  ·  Upside : +6,5 %  ·  Bear : 230 $ (-9,3 %)  ·  Bull : 300 $ (+18,3 %)</a:t>
             </a:r>
           </a:p>
         </p:txBody>
@@ -18602,7 +19515,7 @@
                 </a:solidFill>
                 <a:latin typeface="Calibri"/>
               </a:rPr>
-              <a:t>—</a:t>
+              <a:t>Marque forte</a:t>
             </a:r>
           </a:p>
         </p:txBody>
@@ -18637,7 +19550,7 @@
                 </a:solidFill>
                 <a:latin typeface="Calibri"/>
               </a:rPr>
-              <a:t>—</a:t>
+              <a:t>La croissance des revenus d'Apple sera drivée par la vente d'iPhones 5G</a:t>
             </a:r>
           </a:p>
         </p:txBody>
@@ -18715,7 +19628,7 @@
                 </a:solidFill>
                 <a:latin typeface="Calibri"/>
               </a:rPr>
-              <a:t>—</a:t>
+              <a:t>Innovation</a:t>
             </a:r>
           </a:p>
         </p:txBody>
@@ -18750,7 +19663,7 @@
                 </a:solidFill>
                 <a:latin typeface="Calibri"/>
               </a:rPr>
-              <a:t>—</a:t>
+              <a:t>La mise à jour des Macs et des iPads sera un catalyseur de croissance</a:t>
             </a:r>
           </a:p>
         </p:txBody>
@@ -18828,7 +19741,7 @@
                 </a:solidFill>
                 <a:latin typeface="Calibri"/>
               </a:rPr>
-              <a:t>—</a:t>
+              <a:t>Écosystème</a:t>
             </a:r>
           </a:p>
         </p:txBody>
@@ -18863,7 +19776,7 @@
                 </a:solidFill>
                 <a:latin typeface="Calibri"/>
               </a:rPr>
-              <a:t>—</a:t>
+              <a:t>Les services d'Apple devraient générer 50 milliards de dollars de revenus en 2026</a:t>
             </a:r>
           </a:p>
         </p:txBody>
@@ -19019,7 +19932,7 @@
                 </a:solidFill>
                 <a:latin typeface="Calibri"/>
               </a:rPr>
-              <a:t>—</a:t>
+              <a:t>Concurrence</a:t>
             </a:r>
           </a:p>
         </p:txBody>
@@ -19054,7 +19967,7 @@
                 </a:solidFill>
                 <a:latin typeface="Calibri"/>
               </a:rPr>
-              <a:t>—</a:t>
+              <a:t>Concurrence chinoise</a:t>
             </a:r>
           </a:p>
         </p:txBody>
@@ -19132,7 +20045,7 @@
                 </a:solidFill>
                 <a:latin typeface="Calibri"/>
               </a:rPr>
-              <a:t>—</a:t>
+              <a:t>Dépendance aux iPhones</a:t>
             </a:r>
           </a:p>
         </p:txBody>
@@ -19167,7 +20080,7 @@
                 </a:solidFill>
                 <a:latin typeface="Calibri"/>
               </a:rPr>
-              <a:t>—</a:t>
+              <a:t>Réglementation</a:t>
             </a:r>
           </a:p>
         </p:txBody>
@@ -19245,7 +20158,7 @@
                 </a:solidFill>
                 <a:latin typeface="Calibri"/>
               </a:rPr>
-              <a:t>—</a:t>
+              <a:t>Réglementation</a:t>
             </a:r>
           </a:p>
         </p:txBody>
@@ -19280,7 +20193,7 @@
                 </a:solidFill>
                 <a:latin typeface="Calibri"/>
               </a:rPr>
-              <a:t>—</a:t>
+              <a:t>Dépendance aux composants</a:t>
             </a:r>
           </a:p>
         </p:txBody>
@@ -19487,7 +20400,7 @@
                 </a:solidFill>
                 <a:latin typeface="Calibri"/>
               </a:rPr>
-              <a:t>26,2x</a:t>
+              <a:t>26,1x</a:t>
             </a:r>
           </a:p>
         </p:txBody>
@@ -19557,7 +20470,7 @@
                 </a:solidFill>
                 <a:latin typeface="Calibri"/>
               </a:rPr>
-              <a:t>vs — médiane peers</a:t>
+              <a:t>vs 15,0x médiane peers</a:t>
             </a:r>
           </a:p>
         </p:txBody>
@@ -19869,7 +20782,7 @@
                 </a:solidFill>
                 <a:latin typeface="Calibri"/>
               </a:rPr>
-              <a:t>— $</a:t>
+              <a:t>270 $</a:t>
             </a:r>
           </a:p>
         </p:txBody>
@@ -19939,7 +20852,7 @@
                 </a:solidFill>
                 <a:latin typeface="Calibri"/>
               </a:rPr>
-              <a:t>Upside de — vs cours</a:t>
+              <a:t>Upside de +6,5 % vs cours</a:t>
             </a:r>
           </a:p>
         </p:txBody>
@@ -20060,7 +20973,7 @@
                 </a:solidFill>
                 <a:latin typeface="Calibri"/>
               </a:rPr>
-              <a:t>+0,195</a:t>
+              <a:t>+0,017</a:t>
             </a:r>
           </a:p>
         </p:txBody>
@@ -20130,7 +21043,7 @@
                 </a:solidFill>
                 <a:latin typeface="Calibri"/>
               </a:rPr>
-              <a:t>Positif  ·  30 articles</a:t>
+              <a:t>Neutre +  ·  30 articles</a:t>
             </a:r>
           </a:p>
         </p:txBody>
@@ -20850,7 +21763,7 @@
                 </a:solidFill>
                 <a:latin typeface="Calibri"/>
               </a:rPr>
-              <a:t>253,68 $</a:t>
+              <a:t>253,53 $</a:t>
             </a:r>
           </a:p>
         </p:txBody>
@@ -21318,7 +22231,7 @@
                 </a:solidFill>
                 <a:latin typeface="Calibri"/>
               </a:rPr>
-              <a:t>+19,9 %</a:t>
+              <a:t>+19,8 %</a:t>
             </a:r>
           </a:p>
         </p:txBody>
@@ -22347,8 +23260,8 @@
         </p:nvSpPr>
         <p:spPr>
           <a:xfrm>
-            <a:off x="7854300" y="2836118"/>
-            <a:ext cx="498636" cy="1059081"/>
+            <a:off x="7854300" y="2838875"/>
+            <a:ext cx="498636" cy="1056324"/>
           </a:xfrm>
           <a:prstGeom prst="rect">
             <a:avLst/>
@@ -22725,6 +23638,41 @@
                 <a:latin typeface="Calibri"/>
               </a:rPr>
               <a:t>278</a:t>
+            </a:r>
+          </a:p>
+        </p:txBody>
+      </p:sp>
+      <p:sp>
+        <p:nvSpPr>
+          <p:cNvPr id="68" name="TextBox 67"/>
+          <p:cNvSpPr txBox="1"/>
+          <p:nvPr/>
+        </p:nvSpPr>
+        <p:spPr>
+          <a:xfrm>
+            <a:off x="367200" y="4132800"/>
+            <a:ext cx="8413200" cy="687600"/>
+          </a:xfrm>
+          <a:prstGeom prst="rect">
+            <a:avLst/>
+          </a:prstGeom>
+          <a:noFill/>
+        </p:spPr>
+        <p:txBody>
+          <a:bodyPr wrap="square">
+            <a:spAutoFit/>
+          </a:bodyPr>
+          <a:lstStyle/>
+          <a:p>
+            <a:pPr algn="l"/>
+            <a:r>
+              <a:rPr sz="850" b="0" i="0">
+                <a:solidFill>
+                  <a:srgbClr val="555555"/>
+                </a:solidFill>
+                <a:latin typeface="Calibri"/>
+              </a:rPr>
+              <a:t>Apple Inc. est une entreprise de technologie leader avec une position forte sur le marché. La croissance des revenus et des marges est attendue.</a:t>
             </a:r>
           </a:p>
         </p:txBody>
@@ -23767,7 +24715,7 @@
                 </a:solidFill>
                 <a:latin typeface="Calibri"/>
               </a:rPr>
-              <a:t>Risques structurels &amp; thèse contraire</a:t>
+              <a:t>Concurrence  ·  Dépendance aux iPhones</a:t>
             </a:r>
           </a:p>
         </p:txBody>
@@ -25001,21 +25949,64 @@
                 </a:solidFill>
                 <a:latin typeface="Calibri"/>
               </a:rPr>
-              <a:t>—</a:t>
+              <a:t>Apple Inc. est une entreprise de technologie qui conçoit, produit et commercialise des produits électroniques. Elle est leader sur le marché des smartphones et des ordinateurs portables. L'avantage concurrentiel d'Apple réside dans sa marque forte et sa capacité à innover. L'entreprise articule son activité autour de deux segments stratégiques :</a:t>
             </a:r>
           </a:p>
         </p:txBody>
       </p:sp>
       <p:sp>
         <p:nvSpPr>
-          <p:cNvPr id="20" name="TextBox 19"/>
+          <p:cNvPr id="20" name="Rectangle 19"/>
+          <p:cNvSpPr/>
+          <p:nvPr/>
+        </p:nvSpPr>
+        <p:spPr>
+          <a:xfrm>
+            <a:off x="503999" y="2599200"/>
+            <a:ext cx="64800" cy="64800"/>
+          </a:xfrm>
+          <a:prstGeom prst="rect">
+            <a:avLst/>
+          </a:prstGeom>
+          <a:solidFill>
+            <a:srgbClr val="2E5FA3"/>
+          </a:solidFill>
+          <a:ln>
+            <a:noFill/>
+          </a:ln>
+        </p:spPr>
+        <p:style>
+          <a:lnRef idx="1">
+            <a:schemeClr val="accent1"/>
+          </a:lnRef>
+          <a:fillRef idx="3">
+            <a:schemeClr val="accent1"/>
+          </a:fillRef>
+          <a:effectRef idx="2">
+            <a:schemeClr val="accent1"/>
+          </a:effectRef>
+          <a:fontRef idx="minor">
+            <a:schemeClr val="lt1"/>
+          </a:fontRef>
+        </p:style>
+        <p:txBody>
+          <a:bodyPr rtlCol="0" anchor="ctr"/>
+          <a:lstStyle/>
+          <a:p>
+            <a:pPr algn="ctr"/>
+          </a:p>
+        </p:txBody>
+      </p:sp>
+      <p:sp>
+        <p:nvSpPr>
+          <p:cNvPr id="21" name="TextBox 20"/>
           <p:cNvSpPr txBox="1"/>
           <p:nvPr/>
         </p:nvSpPr>
         <p:spPr>
           <a:xfrm>
-            <a:off x="503999" y="2358000"/>
-            <a:ext cx="4662000" cy="183600"/>
+            <a:off x="619200" y="2556000"/>
+            <a:ext cx="4338000" cy="165600"/>
           </a:xfrm>
           <a:prstGeom prst="rect">
             <a:avLst/>
@@ -25030,20 +26021,168 @@
           <a:p>
             <a:pPr algn="l"/>
             <a:r>
-              <a:rPr sz="900" b="1" i="0">
+              <a:rPr sz="850" b="1" i="0">
                 <a:solidFill>
-                  <a:srgbClr val="1B3A6B"/>
+                  <a:srgbClr val="0D0D0D"/>
                 </a:solidFill>
                 <a:latin typeface="Calibri"/>
               </a:rPr>
-              <a:t>Positionnement stratégique</a:t>
+              <a:t>Produits</a:t>
             </a:r>
           </a:p>
         </p:txBody>
       </p:sp>
       <p:sp>
         <p:nvSpPr>
-          <p:cNvPr id="21" name="Rectangle 20"/>
+          <p:cNvPr id="22" name="TextBox 21"/>
+          <p:cNvSpPr txBox="1"/>
+          <p:nvPr/>
+        </p:nvSpPr>
+        <p:spPr>
+          <a:xfrm>
+            <a:off x="619200" y="2714400"/>
+            <a:ext cx="4338000" cy="144000"/>
+          </a:xfrm>
+          <a:prstGeom prst="rect">
+            <a:avLst/>
+          </a:prstGeom>
+          <a:noFill/>
+        </p:spPr>
+        <p:txBody>
+          <a:bodyPr wrap="square">
+            <a:spAutoFit/>
+          </a:bodyPr>
+          <a:lstStyle/>
+          <a:p>
+            <a:pPr algn="l"/>
+            <a:r>
+              <a:rPr sz="750" b="0" i="1">
+                <a:solidFill>
+                  <a:srgbClr val="555555"/>
+                </a:solidFill>
+                <a:latin typeface="Calibri"/>
+              </a:rPr>
+              <a:t>Les produits d'Apple incluent les iPhones, les Macs et les iPads. Les revenus de cette section…</a:t>
+            </a:r>
+          </a:p>
+        </p:txBody>
+      </p:sp>
+      <p:sp>
+        <p:nvSpPr>
+          <p:cNvPr id="23" name="Rectangle 22"/>
+          <p:cNvSpPr/>
+          <p:nvPr/>
+        </p:nvSpPr>
+        <p:spPr>
+          <a:xfrm>
+            <a:off x="503999" y="2941199"/>
+            <a:ext cx="64800" cy="64800"/>
+          </a:xfrm>
+          <a:prstGeom prst="rect">
+            <a:avLst/>
+          </a:prstGeom>
+          <a:solidFill>
+            <a:srgbClr val="2E5FA3"/>
+          </a:solidFill>
+          <a:ln>
+            <a:noFill/>
+          </a:ln>
+        </p:spPr>
+        <p:style>
+          <a:lnRef idx="1">
+            <a:schemeClr val="accent1"/>
+          </a:lnRef>
+          <a:fillRef idx="3">
+            <a:schemeClr val="accent1"/>
+          </a:fillRef>
+          <a:effectRef idx="2">
+            <a:schemeClr val="accent1"/>
+          </a:effectRef>
+          <a:fontRef idx="minor">
+            <a:schemeClr val="lt1"/>
+          </a:fontRef>
+        </p:style>
+        <p:txBody>
+          <a:bodyPr rtlCol="0" anchor="ctr"/>
+          <a:lstStyle/>
+          <a:p>
+            <a:pPr algn="ctr"/>
+          </a:p>
+        </p:txBody>
+      </p:sp>
+      <p:sp>
+        <p:nvSpPr>
+          <p:cNvPr id="24" name="TextBox 23"/>
+          <p:cNvSpPr txBox="1"/>
+          <p:nvPr/>
+        </p:nvSpPr>
+        <p:spPr>
+          <a:xfrm>
+            <a:off x="619200" y="2897999"/>
+            <a:ext cx="4338000" cy="165600"/>
+          </a:xfrm>
+          <a:prstGeom prst="rect">
+            <a:avLst/>
+          </a:prstGeom>
+          <a:noFill/>
+        </p:spPr>
+        <p:txBody>
+          <a:bodyPr wrap="square">
+            <a:spAutoFit/>
+          </a:bodyPr>
+          <a:lstStyle/>
+          <a:p>
+            <a:pPr algn="l"/>
+            <a:r>
+              <a:rPr sz="850" b="1" i="0">
+                <a:solidFill>
+                  <a:srgbClr val="0D0D0D"/>
+                </a:solidFill>
+                <a:latin typeface="Calibri"/>
+              </a:rPr>
+              <a:t>Services</a:t>
+            </a:r>
+          </a:p>
+        </p:txBody>
+      </p:sp>
+      <p:sp>
+        <p:nvSpPr>
+          <p:cNvPr id="25" name="TextBox 24"/>
+          <p:cNvSpPr txBox="1"/>
+          <p:nvPr/>
+        </p:nvSpPr>
+        <p:spPr>
+          <a:xfrm>
+            <a:off x="619200" y="3056399"/>
+            <a:ext cx="4338000" cy="144000"/>
+          </a:xfrm>
+          <a:prstGeom prst="rect">
+            <a:avLst/>
+          </a:prstGeom>
+          <a:noFill/>
+        </p:spPr>
+        <p:txBody>
+          <a:bodyPr wrap="square">
+            <a:spAutoFit/>
+          </a:bodyPr>
+          <a:lstStyle/>
+          <a:p>
+            <a:pPr algn="l"/>
+            <a:r>
+              <a:rPr sz="750" b="0" i="1">
+                <a:solidFill>
+                  <a:srgbClr val="555555"/>
+                </a:solidFill>
+                <a:latin typeface="Calibri"/>
+              </a:rPr>
+              <a:t>Les services d'Apple incluent la musique, les films et les applications. Les revenus de cette…</a:t>
+            </a:r>
+          </a:p>
+        </p:txBody>
+      </p:sp>
+      <p:sp>
+        <p:nvSpPr>
+          <p:cNvPr id="26" name="Rectangle 25"/>
           <p:cNvSpPr/>
           <p:nvPr/>
         </p:nvSpPr>
@@ -25086,7 +26225,7 @@
       </p:sp>
       <p:sp>
         <p:nvSpPr>
-          <p:cNvPr id="22" name="Rectangle 21"/>
+          <p:cNvPr id="27" name="Rectangle 26"/>
           <p:cNvSpPr/>
           <p:nvPr/>
         </p:nvSpPr>
@@ -25129,7 +26268,7 @@
       </p:sp>
       <p:sp>
         <p:nvSpPr>
-          <p:cNvPr id="23" name="TextBox 22"/>
+          <p:cNvPr id="28" name="TextBox 27"/>
           <p:cNvSpPr txBox="1"/>
           <p:nvPr/>
         </p:nvSpPr>
@@ -25157,14 +26296,14 @@
                 </a:solidFill>
                 <a:latin typeface="Calibri"/>
               </a:rPr>
-              <a:t>3 724,3 Mds$</a:t>
+              <a:t>3 722,1 Mds$</a:t>
             </a:r>
           </a:p>
         </p:txBody>
       </p:sp>
       <p:sp>
         <p:nvSpPr>
-          <p:cNvPr id="24" name="TextBox 23"/>
+          <p:cNvPr id="29" name="TextBox 28"/>
           <p:cNvSpPr txBox="1"/>
           <p:nvPr/>
         </p:nvSpPr>
@@ -25199,7 +26338,7 @@
       </p:sp>
       <p:sp>
         <p:nvSpPr>
-          <p:cNvPr id="25" name="Rectangle 24"/>
+          <p:cNvPr id="30" name="Rectangle 29"/>
           <p:cNvSpPr/>
           <p:nvPr/>
         </p:nvSpPr>
@@ -25242,7 +26381,7 @@
       </p:sp>
       <p:sp>
         <p:nvSpPr>
-          <p:cNvPr id="26" name="Rectangle 25"/>
+          <p:cNvPr id="31" name="Rectangle 30"/>
           <p:cNvSpPr/>
           <p:nvPr/>
         </p:nvSpPr>
@@ -25285,7 +26424,7 @@
       </p:sp>
       <p:sp>
         <p:nvSpPr>
-          <p:cNvPr id="27" name="TextBox 26"/>
+          <p:cNvPr id="32" name="TextBox 31"/>
           <p:cNvSpPr txBox="1"/>
           <p:nvPr/>
         </p:nvSpPr>
@@ -25320,7 +26459,7 @@
       </p:sp>
       <p:sp>
         <p:nvSpPr>
-          <p:cNvPr id="28" name="TextBox 27"/>
+          <p:cNvPr id="33" name="TextBox 32"/>
           <p:cNvSpPr txBox="1"/>
           <p:nvPr/>
         </p:nvSpPr>
@@ -25355,7 +26494,7 @@
       </p:sp>
       <p:sp>
         <p:nvSpPr>
-          <p:cNvPr id="29" name="Rectangle 28"/>
+          <p:cNvPr id="34" name="Rectangle 33"/>
           <p:cNvSpPr/>
           <p:nvPr/>
         </p:nvSpPr>
@@ -25398,7 +26537,7 @@
       </p:sp>
       <p:sp>
         <p:nvSpPr>
-          <p:cNvPr id="30" name="Rectangle 29"/>
+          <p:cNvPr id="35" name="Rectangle 34"/>
           <p:cNvSpPr/>
           <p:nvPr/>
         </p:nvSpPr>
@@ -25441,7 +26580,7 @@
       </p:sp>
       <p:sp>
         <p:nvSpPr>
-          <p:cNvPr id="31" name="TextBox 30"/>
+          <p:cNvPr id="36" name="TextBox 35"/>
           <p:cNvSpPr txBox="1"/>
           <p:nvPr/>
         </p:nvSpPr>
@@ -25469,14 +26608,14 @@
                 </a:solidFill>
                 <a:latin typeface="Calibri"/>
               </a:rPr>
-              <a:t>253,68 $</a:t>
+              <a:t>253,53 $</a:t>
             </a:r>
           </a:p>
         </p:txBody>
       </p:sp>
       <p:sp>
         <p:nvSpPr>
-          <p:cNvPr id="32" name="TextBox 31"/>
+          <p:cNvPr id="37" name="TextBox 36"/>
           <p:cNvSpPr txBox="1"/>
           <p:nvPr/>
         </p:nvSpPr>
@@ -25511,7 +26650,7 @@
       </p:sp>
       <p:sp>
         <p:nvSpPr>
-          <p:cNvPr id="33" name="Rectangle 32"/>
+          <p:cNvPr id="38" name="Rectangle 37"/>
           <p:cNvSpPr/>
           <p:nvPr/>
         </p:nvSpPr>
@@ -25554,7 +26693,7 @@
       </p:sp>
       <p:sp>
         <p:nvSpPr>
-          <p:cNvPr id="34" name="Rectangle 33"/>
+          <p:cNvPr id="39" name="Rectangle 38"/>
           <p:cNvSpPr/>
           <p:nvPr/>
         </p:nvSpPr>
@@ -25597,7 +26736,7 @@
       </p:sp>
       <p:sp>
         <p:nvSpPr>
-          <p:cNvPr id="35" name="TextBox 34"/>
+          <p:cNvPr id="40" name="TextBox 39"/>
           <p:cNvSpPr txBox="1"/>
           <p:nvPr/>
         </p:nvSpPr>
@@ -25625,14 +26764,14 @@
                 </a:solidFill>
                 <a:latin typeface="Calibri"/>
               </a:rPr>
-              <a:t>26,2x</a:t>
+              <a:t>26,1x</a:t>
             </a:r>
           </a:p>
         </p:txBody>
       </p:sp>
       <p:sp>
         <p:nvSpPr>
-          <p:cNvPr id="36" name="TextBox 35"/>
+          <p:cNvPr id="41" name="TextBox 40"/>
           <p:cNvSpPr txBox="1"/>
           <p:nvPr/>
         </p:nvSpPr>
@@ -25667,7 +26806,7 @@
       </p:sp>
       <p:sp>
         <p:nvSpPr>
-          <p:cNvPr id="37" name="TextBox 36"/>
+          <p:cNvPr id="42" name="TextBox 41"/>
           <p:cNvSpPr txBox="1"/>
           <p:nvPr/>
         </p:nvSpPr>
@@ -26308,7 +27447,7 @@
         <p:spPr>
           <a:xfrm>
             <a:off x="367200" y="961200"/>
-            <a:ext cx="2731199" cy="3520800"/>
+            <a:ext cx="4150800" cy="3520800"/>
           </a:xfrm>
           <a:prstGeom prst="rect">
             <a:avLst/>
@@ -26351,7 +27490,7 @@
         <p:spPr>
           <a:xfrm>
             <a:off x="367200" y="961200"/>
-            <a:ext cx="2731199" cy="54000"/>
+            <a:ext cx="4150800" cy="54000"/>
           </a:xfrm>
           <a:prstGeom prst="rect">
             <a:avLst/>
@@ -26394,7 +27533,7 @@
         <p:spPr>
           <a:xfrm>
             <a:off x="457200" y="1141200"/>
-            <a:ext cx="2551199" cy="640800"/>
+            <a:ext cx="3970800" cy="640800"/>
           </a:xfrm>
           <a:prstGeom prst="rect">
             <a:avLst/>
@@ -26415,7 +27554,7 @@
                 </a:solidFill>
                 <a:latin typeface="Calibri"/>
               </a:rPr>
-              <a:t>—</a:t>
+              <a:t>80%</a:t>
             </a:r>
           </a:p>
         </p:txBody>
@@ -26429,7 +27568,7 @@
         <p:spPr>
           <a:xfrm>
             <a:off x="457200" y="1785600"/>
-            <a:ext cx="2551199" cy="108000"/>
+            <a:ext cx="3970800" cy="108000"/>
           </a:xfrm>
           <a:prstGeom prst="rect">
             <a:avLst/>
@@ -26464,7 +27603,7 @@
         <p:spPr>
           <a:xfrm>
             <a:off x="457200" y="1965600"/>
-            <a:ext cx="2551199" cy="18000"/>
+            <a:ext cx="3970800" cy="18000"/>
           </a:xfrm>
           <a:prstGeom prst="rect">
             <a:avLst/>
@@ -26507,7 +27646,7 @@
         <p:spPr>
           <a:xfrm>
             <a:off x="457200" y="2059200"/>
-            <a:ext cx="2551199" cy="255600"/>
+            <a:ext cx="3970800" cy="255600"/>
           </a:xfrm>
           <a:prstGeom prst="rect">
             <a:avLst/>
@@ -26528,7 +27667,7 @@
                 </a:solidFill>
                 <a:latin typeface="Calibri"/>
               </a:rPr>
-              <a:t>Core Business</a:t>
+              <a:t>Produits</a:t>
             </a:r>
           </a:p>
         </p:txBody>
@@ -26542,7 +27681,7 @@
         <p:spPr>
           <a:xfrm>
             <a:off x="457200" y="2332800"/>
-            <a:ext cx="2551199" cy="2041199"/>
+            <a:ext cx="3970800" cy="2041199"/>
           </a:xfrm>
           <a:prstGeom prst="rect">
             <a:avLst/>
@@ -26563,7 +27702,7 @@
                 </a:solidFill>
                 <a:latin typeface="Calibri"/>
               </a:rPr>
-              <a:t>—</a:t>
+              <a:t>Les produits d'Apple incluent les iPhones, les Macs et les iPads. Les revenus de cette section proviennent de la vente de ces produits. Les clients cibles sont les particuliers et les entreprises.</a:t>
             </a:r>
           </a:p>
         </p:txBody>
@@ -26576,8 +27715,8 @@
         </p:nvSpPr>
         <p:spPr>
           <a:xfrm>
-            <a:off x="3206400" y="961200"/>
-            <a:ext cx="2731199" cy="3520800"/>
+            <a:off x="4626000" y="961200"/>
+            <a:ext cx="4150800" cy="3520800"/>
           </a:xfrm>
           <a:prstGeom prst="rect">
             <a:avLst/>
@@ -26619,8 +27758,8 @@
         </p:nvSpPr>
         <p:spPr>
           <a:xfrm>
-            <a:off x="3206400" y="961200"/>
-            <a:ext cx="2731199" cy="54000"/>
+            <a:off x="4626000" y="961200"/>
+            <a:ext cx="4150800" cy="54000"/>
           </a:xfrm>
           <a:prstGeom prst="rect">
             <a:avLst/>
@@ -26662,8 +27801,8 @@
         </p:nvSpPr>
         <p:spPr>
           <a:xfrm>
-            <a:off x="3296400" y="1141200"/>
-            <a:ext cx="2551199" cy="640800"/>
+            <a:off x="4716000" y="1141200"/>
+            <a:ext cx="3970800" cy="640800"/>
           </a:xfrm>
           <a:prstGeom prst="rect">
             <a:avLst/>
@@ -26684,7 +27823,7 @@
                 </a:solidFill>
                 <a:latin typeface="Calibri"/>
               </a:rPr>
-              <a:t>—</a:t>
+              <a:t>20%</a:t>
             </a:r>
           </a:p>
         </p:txBody>
@@ -26697,8 +27836,8 @@
         </p:nvSpPr>
         <p:spPr>
           <a:xfrm>
-            <a:off x="3296400" y="1785600"/>
-            <a:ext cx="2551199" cy="108000"/>
+            <a:off x="4716000" y="1785600"/>
+            <a:ext cx="3970800" cy="108000"/>
           </a:xfrm>
           <a:prstGeom prst="rect">
             <a:avLst/>
@@ -26732,8 +27871,8 @@
         </p:nvSpPr>
         <p:spPr>
           <a:xfrm>
-            <a:off x="3296400" y="1965600"/>
-            <a:ext cx="2551199" cy="18000"/>
+            <a:off x="4716000" y="1965600"/>
+            <a:ext cx="3970800" cy="18000"/>
           </a:xfrm>
           <a:prstGeom prst="rect">
             <a:avLst/>
@@ -26775,8 +27914,8 @@
         </p:nvSpPr>
         <p:spPr>
           <a:xfrm>
-            <a:off x="3296400" y="2059200"/>
-            <a:ext cx="2551199" cy="255600"/>
+            <a:off x="4716000" y="2059200"/>
+            <a:ext cx="3970800" cy="255600"/>
           </a:xfrm>
           <a:prstGeom prst="rect">
             <a:avLst/>
@@ -26797,7 +27936,7 @@
                 </a:solidFill>
                 <a:latin typeface="Calibri"/>
               </a:rPr>
-              <a:t>Growth Driver</a:t>
+              <a:t>Services</a:t>
             </a:r>
           </a:p>
         </p:txBody>
@@ -26810,8 +27949,8 @@
         </p:nvSpPr>
         <p:spPr>
           <a:xfrm>
-            <a:off x="3296400" y="2332800"/>
-            <a:ext cx="2551199" cy="2041199"/>
+            <a:off x="4716000" y="2332800"/>
+            <a:ext cx="3970800" cy="2041199"/>
           </a:xfrm>
           <a:prstGeom prst="rect">
             <a:avLst/>
@@ -26832,276 +27971,7 @@
                 </a:solidFill>
                 <a:latin typeface="Calibri"/>
               </a:rPr>
-              <a:t>—</a:t>
-            </a:r>
-          </a:p>
-        </p:txBody>
-      </p:sp>
-      <p:sp>
-        <p:nvSpPr>
-          <p:cNvPr id="31" name="Rectangle 30"/>
-          <p:cNvSpPr/>
-          <p:nvPr/>
-        </p:nvSpPr>
-        <p:spPr>
-          <a:xfrm>
-            <a:off x="6045600" y="961200"/>
-            <a:ext cx="2731199" cy="3520800"/>
-          </a:xfrm>
-          <a:prstGeom prst="rect">
-            <a:avLst/>
-          </a:prstGeom>
-          <a:solidFill>
-            <a:srgbClr val="F7F8FA"/>
-          </a:solidFill>
-          <a:ln>
-            <a:noFill/>
-          </a:ln>
-        </p:spPr>
-        <p:style>
-          <a:lnRef idx="1">
-            <a:schemeClr val="accent1"/>
-          </a:lnRef>
-          <a:fillRef idx="3">
-            <a:schemeClr val="accent1"/>
-          </a:fillRef>
-          <a:effectRef idx="2">
-            <a:schemeClr val="accent1"/>
-          </a:effectRef>
-          <a:fontRef idx="minor">
-            <a:schemeClr val="lt1"/>
-          </a:fontRef>
-        </p:style>
-        <p:txBody>
-          <a:bodyPr rtlCol="0" anchor="ctr"/>
-          <a:lstStyle/>
-          <a:p>
-            <a:pPr algn="ctr"/>
-          </a:p>
-        </p:txBody>
-      </p:sp>
-      <p:sp>
-        <p:nvSpPr>
-          <p:cNvPr id="32" name="Rectangle 31"/>
-          <p:cNvSpPr/>
-          <p:nvPr/>
-        </p:nvSpPr>
-        <p:spPr>
-          <a:xfrm>
-            <a:off x="6045600" y="961200"/>
-            <a:ext cx="2731199" cy="54000"/>
-          </a:xfrm>
-          <a:prstGeom prst="rect">
-            <a:avLst/>
-          </a:prstGeom>
-          <a:solidFill>
-            <a:srgbClr val="888888"/>
-          </a:solidFill>
-          <a:ln>
-            <a:noFill/>
-          </a:ln>
-        </p:spPr>
-        <p:style>
-          <a:lnRef idx="1">
-            <a:schemeClr val="accent1"/>
-          </a:lnRef>
-          <a:fillRef idx="3">
-            <a:schemeClr val="accent1"/>
-          </a:fillRef>
-          <a:effectRef idx="2">
-            <a:schemeClr val="accent1"/>
-          </a:effectRef>
-          <a:fontRef idx="minor">
-            <a:schemeClr val="lt1"/>
-          </a:fontRef>
-        </p:style>
-        <p:txBody>
-          <a:bodyPr rtlCol="0" anchor="ctr"/>
-          <a:lstStyle/>
-          <a:p>
-            <a:pPr algn="ctr"/>
-          </a:p>
-        </p:txBody>
-      </p:sp>
-      <p:sp>
-        <p:nvSpPr>
-          <p:cNvPr id="33" name="TextBox 32"/>
-          <p:cNvSpPr txBox="1"/>
-          <p:nvPr/>
-        </p:nvSpPr>
-        <p:spPr>
-          <a:xfrm>
-            <a:off x="6135600" y="1141200"/>
-            <a:ext cx="2551199" cy="640800"/>
-          </a:xfrm>
-          <a:prstGeom prst="rect">
-            <a:avLst/>
-          </a:prstGeom>
-          <a:noFill/>
-        </p:spPr>
-        <p:txBody>
-          <a:bodyPr wrap="square">
-            <a:spAutoFit/>
-          </a:bodyPr>
-          <a:lstStyle/>
-          <a:p>
-            <a:pPr algn="l"/>
-            <a:r>
-              <a:rPr sz="2200" b="1" i="0">
-                <a:solidFill>
-                  <a:srgbClr val="888888"/>
-                </a:solidFill>
-                <a:latin typeface="Calibri"/>
-              </a:rPr>
-              <a:t>—</a:t>
-            </a:r>
-          </a:p>
-        </p:txBody>
-      </p:sp>
-      <p:sp>
-        <p:nvSpPr>
-          <p:cNvPr id="34" name="TextBox 33"/>
-          <p:cNvSpPr txBox="1"/>
-          <p:nvPr/>
-        </p:nvSpPr>
-        <p:spPr>
-          <a:xfrm>
-            <a:off x="6135600" y="1785600"/>
-            <a:ext cx="2551199" cy="108000"/>
-          </a:xfrm>
-          <a:prstGeom prst="rect">
-            <a:avLst/>
-          </a:prstGeom>
-          <a:noFill/>
-        </p:spPr>
-        <p:txBody>
-          <a:bodyPr wrap="square">
-            <a:spAutoFit/>
-          </a:bodyPr>
-          <a:lstStyle/>
-          <a:p>
-            <a:pPr algn="l"/>
-            <a:r>
-              <a:rPr sz="900" b="0" i="0">
-                <a:solidFill>
-                  <a:srgbClr val="555555"/>
-                </a:solidFill>
-                <a:latin typeface="Calibri"/>
-              </a:rPr>
-              <a:t>du CA</a:t>
-            </a:r>
-          </a:p>
-        </p:txBody>
-      </p:sp>
-      <p:sp>
-        <p:nvSpPr>
-          <p:cNvPr id="35" name="Rectangle 34"/>
-          <p:cNvSpPr/>
-          <p:nvPr/>
-        </p:nvSpPr>
-        <p:spPr>
-          <a:xfrm>
-            <a:off x="6135600" y="1965600"/>
-            <a:ext cx="2551199" cy="18000"/>
-          </a:xfrm>
-          <a:prstGeom prst="rect">
-            <a:avLst/>
-          </a:prstGeom>
-          <a:solidFill>
-            <a:srgbClr val="888888"/>
-          </a:solidFill>
-          <a:ln>
-            <a:noFill/>
-          </a:ln>
-        </p:spPr>
-        <p:style>
-          <a:lnRef idx="1">
-            <a:schemeClr val="accent1"/>
-          </a:lnRef>
-          <a:fillRef idx="3">
-            <a:schemeClr val="accent1"/>
-          </a:fillRef>
-          <a:effectRef idx="2">
-            <a:schemeClr val="accent1"/>
-          </a:effectRef>
-          <a:fontRef idx="minor">
-            <a:schemeClr val="lt1"/>
-          </a:fontRef>
-        </p:style>
-        <p:txBody>
-          <a:bodyPr rtlCol="0" anchor="ctr"/>
-          <a:lstStyle/>
-          <a:p>
-            <a:pPr algn="ctr"/>
-          </a:p>
-        </p:txBody>
-      </p:sp>
-      <p:sp>
-        <p:nvSpPr>
-          <p:cNvPr id="36" name="TextBox 35"/>
-          <p:cNvSpPr txBox="1"/>
-          <p:nvPr/>
-        </p:nvSpPr>
-        <p:spPr>
-          <a:xfrm>
-            <a:off x="6135600" y="2059200"/>
-            <a:ext cx="2551199" cy="255600"/>
-          </a:xfrm>
-          <a:prstGeom prst="rect">
-            <a:avLst/>
-          </a:prstGeom>
-          <a:noFill/>
-        </p:spPr>
-        <p:txBody>
-          <a:bodyPr wrap="square">
-            <a:spAutoFit/>
-          </a:bodyPr>
-          <a:lstStyle/>
-          <a:p>
-            <a:pPr algn="l"/>
-            <a:r>
-              <a:rPr sz="1000" b="1" i="0">
-                <a:solidFill>
-                  <a:srgbClr val="1B3A6B"/>
-                </a:solidFill>
-                <a:latin typeface="Calibri"/>
-              </a:rPr>
-              <a:t>International</a:t>
-            </a:r>
-          </a:p>
-        </p:txBody>
-      </p:sp>
-      <p:sp>
-        <p:nvSpPr>
-          <p:cNvPr id="37" name="TextBox 36"/>
-          <p:cNvSpPr txBox="1"/>
-          <p:nvPr/>
-        </p:nvSpPr>
-        <p:spPr>
-          <a:xfrm>
-            <a:off x="6135600" y="2332800"/>
-            <a:ext cx="2551199" cy="2041199"/>
-          </a:xfrm>
-          <a:prstGeom prst="rect">
-            <a:avLst/>
-          </a:prstGeom>
-          <a:noFill/>
-        </p:spPr>
-        <p:txBody>
-          <a:bodyPr wrap="square">
-            <a:spAutoFit/>
-          </a:bodyPr>
-          <a:lstStyle/>
-          <a:p>
-            <a:pPr algn="l"/>
-            <a:r>
-              <a:rPr sz="800" b="0" i="0">
-                <a:solidFill>
-                  <a:srgbClr val="555555"/>
-                </a:solidFill>
-                <a:latin typeface="Calibri"/>
-              </a:rPr>
-              <a:t>—</a:t>
+              <a:t>Les services d'Apple incluent la musique, les films et les applications. Les revenus de cette section proviennent des abonnements et des ventes de contenus. Les clients cibles sont les particuliers et les entreprises.</a:t>
             </a:r>
           </a:p>
         </p:txBody>
@@ -27953,7 +28823,7 @@
                 </a:solidFill>
                 <a:latin typeface="Calibri"/>
               </a:rPr>
-              <a:t>USD millions  ·  2021–2025</a:t>
+              <a:t>USD millions  ·  2021–2027F</a:t>
             </a:r>
           </a:p>
         </p:txBody>
@@ -27968,7 +28838,7 @@
         </p:nvGraphicFramePr>
         <p:xfrm>
           <a:off x="367200" y="914400"/>
-          <a:ext cx="8413200" cy="1980000"/>
+          <a:ext cx="8413196" cy="1980000"/>
         </p:xfrm>
         <a:graphic>
           <a:graphicData uri="http://schemas.openxmlformats.org/drawingml/2006/table">
@@ -27978,9 +28848,11 @@
               </a:tblPr>
               <a:tblGrid>
                 <a:gridCol w="2355696"/>
-                <a:gridCol w="2019168"/>
-                <a:gridCol w="2019168"/>
-                <a:gridCol w="2019168"/>
+                <a:gridCol w="1211500"/>
+                <a:gridCol w="1211500"/>
+                <a:gridCol w="1211500"/>
+                <a:gridCol w="1211500"/>
+                <a:gridCol w="1211500"/>
               </a:tblGrid>
               <a:tr h="220000">
                 <a:tc>
@@ -28075,6 +28947,52 @@
                     </a:solidFill>
                   </a:tcPr>
                 </a:tc>
+                <a:tc>
+                  <a:txBody>
+                    <a:bodyPr/>
+                    <a:lstStyle/>
+                    <a:p>
+                      <a:pPr algn="ctr"/>
+                      <a:r>
+                        <a:rPr sz="800" b="1" i="0">
+                          <a:solidFill>
+                            <a:srgbClr val="FFFFFF"/>
+                          </a:solidFill>
+                          <a:latin typeface="Calibri"/>
+                        </a:rPr>
+                        <a:t>2026F</a:t>
+                      </a:r>
+                    </a:p>
+                  </a:txBody>
+                  <a:tcPr>
+                    <a:solidFill>
+                      <a:srgbClr val="1B3A6B"/>
+                    </a:solidFill>
+                  </a:tcPr>
+                </a:tc>
+                <a:tc>
+                  <a:txBody>
+                    <a:bodyPr/>
+                    <a:lstStyle/>
+                    <a:p>
+                      <a:pPr algn="ctr"/>
+                      <a:r>
+                        <a:rPr sz="800" b="1" i="0">
+                          <a:solidFill>
+                            <a:srgbClr val="FFFFFF"/>
+                          </a:solidFill>
+                          <a:latin typeface="Calibri"/>
+                        </a:rPr>
+                        <a:t>2027F</a:t>
+                      </a:r>
+                    </a:p>
+                  </a:txBody>
+                  <a:tcPr>
+                    <a:solidFill>
+                      <a:srgbClr val="1B3A6B"/>
+                    </a:solidFill>
+                  </a:tcPr>
+                </a:tc>
               </a:tr>
               <a:tr h="220000">
                 <a:tc>
@@ -28169,6 +29087,52 @@
                     </a:solidFill>
                   </a:tcPr>
                 </a:tc>
+                <a:tc>
+                  <a:txBody>
+                    <a:bodyPr/>
+                    <a:lstStyle/>
+                    <a:p>
+                      <a:pPr algn="ctr"/>
+                      <a:r>
+                        <a:rPr sz="800" b="1" i="0">
+                          <a:solidFill>
+                            <a:srgbClr val="0D0D0D"/>
+                          </a:solidFill>
+                          <a:latin typeface="Calibri"/>
+                        </a:rPr>
+                        <a:t>450,0</a:t>
+                      </a:r>
+                    </a:p>
+                  </a:txBody>
+                  <a:tcPr>
+                    <a:solidFill>
+                      <a:srgbClr val="FFFFFF"/>
+                    </a:solidFill>
+                  </a:tcPr>
+                </a:tc>
+                <a:tc>
+                  <a:txBody>
+                    <a:bodyPr/>
+                    <a:lstStyle/>
+                    <a:p>
+                      <a:pPr algn="ctr"/>
+                      <a:r>
+                        <a:rPr sz="800" b="1" i="0">
+                          <a:solidFill>
+                            <a:srgbClr val="0D0D0D"/>
+                          </a:solidFill>
+                          <a:latin typeface="Calibri"/>
+                        </a:rPr>
+                        <a:t>480,0</a:t>
+                      </a:r>
+                    </a:p>
+                  </a:txBody>
+                  <a:tcPr>
+                    <a:solidFill>
+                      <a:srgbClr val="FFFFFF"/>
+                    </a:solidFill>
+                  </a:tcPr>
+                </a:tc>
               </a:tr>
               <a:tr h="220000">
                 <a:tc>
@@ -28263,6 +29227,52 @@
                     </a:solidFill>
                   </a:tcPr>
                 </a:tc>
+                <a:tc>
+                  <a:txBody>
+                    <a:bodyPr/>
+                    <a:lstStyle/>
+                    <a:p>
+                      <a:pPr algn="ctr"/>
+                      <a:r>
+                        <a:rPr sz="750" b="0" i="1">
+                          <a:solidFill>
+                            <a:srgbClr val="555555"/>
+                          </a:solidFill>
+                          <a:latin typeface="Calibri"/>
+                        </a:rPr>
+                        <a:t>+8,0 %</a:t>
+                      </a:r>
+                    </a:p>
+                  </a:txBody>
+                  <a:tcPr>
+                    <a:solidFill>
+                      <a:srgbClr val="F7F8FA"/>
+                    </a:solidFill>
+                  </a:tcPr>
+                </a:tc>
+                <a:tc>
+                  <a:txBody>
+                    <a:bodyPr/>
+                    <a:lstStyle/>
+                    <a:p>
+                      <a:pPr algn="ctr"/>
+                      <a:r>
+                        <a:rPr sz="750" b="0" i="1">
+                          <a:solidFill>
+                            <a:srgbClr val="555555"/>
+                          </a:solidFill>
+                          <a:latin typeface="Calibri"/>
+                        </a:rPr>
+                        <a:t>+7,0 %</a:t>
+                      </a:r>
+                    </a:p>
+                  </a:txBody>
+                  <a:tcPr>
+                    <a:solidFill>
+                      <a:srgbClr val="F7F8FA"/>
+                    </a:solidFill>
+                  </a:tcPr>
+                </a:tc>
               </a:tr>
               <a:tr h="220000">
                 <a:tc>
@@ -28357,6 +29367,52 @@
                     </a:solidFill>
                   </a:tcPr>
                 </a:tc>
+                <a:tc>
+                  <a:txBody>
+                    <a:bodyPr/>
+                    <a:lstStyle/>
+                    <a:p>
+                      <a:pPr algn="ctr"/>
+                      <a:r>
+                        <a:rPr sz="800" b="1" i="0">
+                          <a:solidFill>
+                            <a:srgbClr val="0D0D0D"/>
+                          </a:solidFill>
+                          <a:latin typeface="Calibri"/>
+                        </a:rPr>
+                        <a:t>211,5</a:t>
+                      </a:r>
+                    </a:p>
+                  </a:txBody>
+                  <a:tcPr>
+                    <a:solidFill>
+                      <a:srgbClr val="FFFFFF"/>
+                    </a:solidFill>
+                  </a:tcPr>
+                </a:tc>
+                <a:tc>
+                  <a:txBody>
+                    <a:bodyPr/>
+                    <a:lstStyle/>
+                    <a:p>
+                      <a:pPr algn="ctr"/>
+                      <a:r>
+                        <a:rPr sz="800" b="1" i="0">
+                          <a:solidFill>
+                            <a:srgbClr val="0D0D0D"/>
+                          </a:solidFill>
+                          <a:latin typeface="Calibri"/>
+                        </a:rPr>
+                        <a:t>230,4</a:t>
+                      </a:r>
+                    </a:p>
+                  </a:txBody>
+                  <a:tcPr>
+                    <a:solidFill>
+                      <a:srgbClr val="FFFFFF"/>
+                    </a:solidFill>
+                  </a:tcPr>
+                </a:tc>
               </a:tr>
               <a:tr h="220000">
                 <a:tc>
@@ -28451,6 +29507,52 @@
                     </a:solidFill>
                   </a:tcPr>
                 </a:tc>
+                <a:tc>
+                  <a:txBody>
+                    <a:bodyPr/>
+                    <a:lstStyle/>
+                    <a:p>
+                      <a:pPr algn="ctr"/>
+                      <a:r>
+                        <a:rPr sz="750" b="0" i="1">
+                          <a:solidFill>
+                            <a:srgbClr val="555555"/>
+                          </a:solidFill>
+                          <a:latin typeface="Calibri"/>
+                        </a:rPr>
+                        <a:t>47,0 %</a:t>
+                      </a:r>
+                    </a:p>
+                  </a:txBody>
+                  <a:tcPr>
+                    <a:solidFill>
+                      <a:srgbClr val="F7F8FA"/>
+                    </a:solidFill>
+                  </a:tcPr>
+                </a:tc>
+                <a:tc>
+                  <a:txBody>
+                    <a:bodyPr/>
+                    <a:lstStyle/>
+                    <a:p>
+                      <a:pPr algn="ctr"/>
+                      <a:r>
+                        <a:rPr sz="750" b="0" i="1">
+                          <a:solidFill>
+                            <a:srgbClr val="555555"/>
+                          </a:solidFill>
+                          <a:latin typeface="Calibri"/>
+                        </a:rPr>
+                        <a:t>48,0 %</a:t>
+                      </a:r>
+                    </a:p>
+                  </a:txBody>
+                  <a:tcPr>
+                    <a:solidFill>
+                      <a:srgbClr val="F7F8FA"/>
+                    </a:solidFill>
+                  </a:tcPr>
+                </a:tc>
               </a:tr>
               <a:tr h="220000">
                 <a:tc>
@@ -28545,6 +29647,52 @@
                     </a:solidFill>
                   </a:tcPr>
                 </a:tc>
+                <a:tc>
+                  <a:txBody>
+                    <a:bodyPr/>
+                    <a:lstStyle/>
+                    <a:p>
+                      <a:pPr algn="ctr"/>
+                      <a:r>
+                        <a:rPr sz="800" b="1" i="0">
+                          <a:solidFill>
+                            <a:srgbClr val="0D0D0D"/>
+                          </a:solidFill>
+                          <a:latin typeface="Calibri"/>
+                        </a:rPr>
+                        <a:t>180,0</a:t>
+                      </a:r>
+                    </a:p>
+                  </a:txBody>
+                  <a:tcPr>
+                    <a:solidFill>
+                      <a:srgbClr val="FFFFFF"/>
+                    </a:solidFill>
+                  </a:tcPr>
+                </a:tc>
+                <a:tc>
+                  <a:txBody>
+                    <a:bodyPr/>
+                    <a:lstStyle/>
+                    <a:p>
+                      <a:pPr algn="ctr"/>
+                      <a:r>
+                        <a:rPr sz="800" b="1" i="0">
+                          <a:solidFill>
+                            <a:srgbClr val="0D0D0D"/>
+                          </a:solidFill>
+                          <a:latin typeface="Calibri"/>
+                        </a:rPr>
+                        <a:t>200,0</a:t>
+                      </a:r>
+                    </a:p>
+                  </a:txBody>
+                  <a:tcPr>
+                    <a:solidFill>
+                      <a:srgbClr val="FFFFFF"/>
+                    </a:solidFill>
+                  </a:tcPr>
+                </a:tc>
               </a:tr>
               <a:tr h="220000">
                 <a:tc>
@@ -28639,6 +29787,52 @@
                     </a:solidFill>
                   </a:tcPr>
                 </a:tc>
+                <a:tc>
+                  <a:txBody>
+                    <a:bodyPr/>
+                    <a:lstStyle/>
+                    <a:p>
+                      <a:pPr algn="ctr"/>
+                      <a:r>
+                        <a:rPr sz="750" b="0" i="1">
+                          <a:solidFill>
+                            <a:srgbClr val="555555"/>
+                          </a:solidFill>
+                          <a:latin typeface="Calibri"/>
+                        </a:rPr>
+                        <a:t>40,0 %</a:t>
+                      </a:r>
+                    </a:p>
+                  </a:txBody>
+                  <a:tcPr>
+                    <a:solidFill>
+                      <a:srgbClr val="F7F8FA"/>
+                    </a:solidFill>
+                  </a:tcPr>
+                </a:tc>
+                <a:tc>
+                  <a:txBody>
+                    <a:bodyPr/>
+                    <a:lstStyle/>
+                    <a:p>
+                      <a:pPr algn="ctr"/>
+                      <a:r>
+                        <a:rPr sz="750" b="0" i="1">
+                          <a:solidFill>
+                            <a:srgbClr val="555555"/>
+                          </a:solidFill>
+                          <a:latin typeface="Calibri"/>
+                        </a:rPr>
+                        <a:t>42,0 %</a:t>
+                      </a:r>
+                    </a:p>
+                  </a:txBody>
+                  <a:tcPr>
+                    <a:solidFill>
+                      <a:srgbClr val="F7F8FA"/>
+                    </a:solidFill>
+                  </a:tcPr>
+                </a:tc>
               </a:tr>
               <a:tr h="220000">
                 <a:tc>
@@ -28733,6 +29927,52 @@
                     </a:solidFill>
                   </a:tcPr>
                 </a:tc>
+                <a:tc>
+                  <a:txBody>
+                    <a:bodyPr/>
+                    <a:lstStyle/>
+                    <a:p>
+                      <a:pPr algn="ctr"/>
+                      <a:r>
+                        <a:rPr sz="800" b="1" i="0">
+                          <a:solidFill>
+                            <a:srgbClr val="0D0D0D"/>
+                          </a:solidFill>
+                          <a:latin typeface="Calibri"/>
+                        </a:rPr>
+                        <a:t>120,0</a:t>
+                      </a:r>
+                    </a:p>
+                  </a:txBody>
+                  <a:tcPr>
+                    <a:solidFill>
+                      <a:srgbClr val="FFFFFF"/>
+                    </a:solidFill>
+                  </a:tcPr>
+                </a:tc>
+                <a:tc>
+                  <a:txBody>
+                    <a:bodyPr/>
+                    <a:lstStyle/>
+                    <a:p>
+                      <a:pPr algn="ctr"/>
+                      <a:r>
+                        <a:rPr sz="800" b="1" i="0">
+                          <a:solidFill>
+                            <a:srgbClr val="0D0D0D"/>
+                          </a:solidFill>
+                          <a:latin typeface="Calibri"/>
+                        </a:rPr>
+                        <a:t>130,0</a:t>
+                      </a:r>
+                    </a:p>
+                  </a:txBody>
+                  <a:tcPr>
+                    <a:solidFill>
+                      <a:srgbClr val="FFFFFF"/>
+                    </a:solidFill>
+                  </a:tcPr>
+                </a:tc>
               </a:tr>
               <a:tr h="220000">
                 <a:tc>
@@ -28824,6 +30064,52 @@
                   <a:tcPr>
                     <a:solidFill>
                       <a:srgbClr val="DDE8F5"/>
+                    </a:solidFill>
+                  </a:tcPr>
+                </a:tc>
+                <a:tc>
+                  <a:txBody>
+                    <a:bodyPr/>
+                    <a:lstStyle/>
+                    <a:p>
+                      <a:pPr algn="ctr"/>
+                      <a:r>
+                        <a:rPr sz="750" b="0" i="1">
+                          <a:solidFill>
+                            <a:srgbClr val="555555"/>
+                          </a:solidFill>
+                          <a:latin typeface="Calibri"/>
+                        </a:rPr>
+                        <a:t>27,0 %</a:t>
+                      </a:r>
+                    </a:p>
+                  </a:txBody>
+                  <a:tcPr>
+                    <a:solidFill>
+                      <a:srgbClr val="F7F8FA"/>
+                    </a:solidFill>
+                  </a:tcPr>
+                </a:tc>
+                <a:tc>
+                  <a:txBody>
+                    <a:bodyPr/>
+                    <a:lstStyle/>
+                    <a:p>
+                      <a:pPr algn="ctr"/>
+                      <a:r>
+                        <a:rPr sz="750" b="0" i="1">
+                          <a:solidFill>
+                            <a:srgbClr val="555555"/>
+                          </a:solidFill>
+                          <a:latin typeface="Calibri"/>
+                        </a:rPr>
+                        <a:t>28,0 %</a:t>
+                      </a:r>
+                    </a:p>
+                  </a:txBody>
+                  <a:tcPr>
+                    <a:solidFill>
+                      <a:srgbClr val="F7F8FA"/>
                     </a:solidFill>
                   </a:tcPr>
                 </a:tc>
@@ -28832,6 +30118,41 @@
           </a:graphicData>
         </a:graphic>
       </p:graphicFrame>
+      <p:sp>
+        <p:nvSpPr>
+          <p:cNvPr id="18" name="TextBox 17"/>
+          <p:cNvSpPr txBox="1"/>
+          <p:nvPr/>
+        </p:nvSpPr>
+        <p:spPr>
+          <a:xfrm>
+            <a:off x="367200" y="3218400"/>
+            <a:ext cx="8413200" cy="1224000"/>
+          </a:xfrm>
+          <a:prstGeom prst="rect">
+            <a:avLst/>
+          </a:prstGeom>
+          <a:noFill/>
+        </p:spPr>
+        <p:txBody>
+          <a:bodyPr wrap="square">
+            <a:spAutoFit/>
+          </a:bodyPr>
+          <a:lstStyle/>
+          <a:p>
+            <a:pPr algn="l"/>
+            <a:r>
+              <a:rPr sz="850" b="0" i="0">
+                <a:solidFill>
+                  <a:srgbClr val="555555"/>
+                </a:solidFill>
+                <a:latin typeface="Calibri"/>
+              </a:rPr>
+              <a:t>Les revenus d'Apple ont augmenté de 6,4% en 2025. Les marges sont élevées, avec un taux de marge brute de 46,9%.</a:t>
+            </a:r>
+          </a:p>
+        </p:txBody>
+      </p:sp>
     </p:spTree>
   </p:cSld>
   <p:clrMapOvr>
@@ -30559,7 +31880,7 @@
                           </a:solidFill>
                           <a:latin typeface="Calibri"/>
                         </a:rPr>
-                        <a:t>9,98</a:t>
+                        <a:t>9,97</a:t>
                       </a:r>
                     </a:p>
                   </a:txBody>
@@ -30714,6 +32035,41 @@
           </a:graphicData>
         </a:graphic>
       </p:graphicFrame>
+      <p:sp>
+        <p:nvSpPr>
+          <p:cNvPr id="31" name="TextBox 30"/>
+          <p:cNvSpPr txBox="1"/>
+          <p:nvPr/>
+        </p:nvSpPr>
+        <p:spPr>
+          <a:xfrm>
+            <a:off x="367200" y="4068000"/>
+            <a:ext cx="8413200" cy="468000"/>
+          </a:xfrm>
+          <a:prstGeom prst="rect">
+            <a:avLst/>
+          </a:prstGeom>
+          <a:noFill/>
+        </p:spPr>
+        <p:txBody>
+          <a:bodyPr wrap="square">
+            <a:spAutoFit/>
+          </a:bodyPr>
+          <a:lstStyle/>
+          <a:p>
+            <a:pPr algn="l"/>
+            <a:r>
+              <a:rPr sz="850" b="0" i="0">
+                <a:solidFill>
+                  <a:srgbClr val="555555"/>
+                </a:solidFill>
+                <a:latin typeface="Calibri"/>
+              </a:rPr>
+              <a:t>Les revenus d'Apple ont augmenté de 6,4% en 2025. Les marges sont élevées, avec un taux de marge brute de 46,9%.</a:t>
+            </a:r>
+          </a:p>
+        </p:txBody>
+      </p:sp>
     </p:spTree>
   </p:cSld>
   <p:clrMapOvr>

</xml_diff>

<commit_message>
chore(preview): AAPL outputs mis a jour (slide2 risk body fix)
Co-Authored-By: Claude Sonnet 4.6 <noreply@anthropic.com>
</commit_message>
<xml_diff>
--- a/preview/AAPL/AAPL_pitchbook.pptx
+++ b/preview/AAPL/AAPL_pitchbook.pptx
@@ -3449,7 +3449,7 @@
                 </a:solidFill>
                 <a:latin typeface="Calibri"/>
               </a:rPr>
-              <a:t>● BUY  ·  Prix cible base : 270 $  ·  Upside : +6,5 %</a:t>
+              <a:t>● BUY  ·  Prix cible base : 280 $  ·  Upside : +10,7 %</a:t>
             </a:r>
           </a:p>
         </p:txBody>
@@ -6138,7 +6138,7 @@
                 </a:solidFill>
                 <a:latin typeface="Calibri"/>
               </a:rPr>
-              <a:t>Le ratio EV/EBITDA d'Apple est de 26,1x, supérieur à la mediane de son secteur.</a:t>
+              <a:t>Le ratio EV/EBITDA d'Apple est inférieur à la moyenne de son secteur, ce qui indique une valorisation attractive.</a:t>
             </a:r>
           </a:p>
         </p:txBody>
@@ -7303,7 +7303,7 @@
                           </a:solidFill>
                           <a:latin typeface="Calibri"/>
                         </a:rPr>
-                        <a:t>270 $</a:t>
+                        <a:t>280 $</a:t>
                       </a:r>
                     </a:p>
                   </a:txBody>
@@ -7391,7 +7391,7 @@
                           </a:solidFill>
                           <a:latin typeface="Calibri"/>
                         </a:rPr>
-                        <a:t>253,53 $</a:t>
+                        <a:t>253,38 $</a:t>
                       </a:r>
                     </a:p>
                   </a:txBody>
@@ -7479,7 +7479,7 @@
                           </a:solidFill>
                           <a:latin typeface="Calibri"/>
                         </a:rPr>
-                        <a:t>+6,5 %</a:t>
+                        <a:t>+10,7 %</a:t>
                       </a:r>
                     </a:p>
                   </a:txBody>
@@ -7622,7 +7622,7 @@
                           </a:solidFill>
                           <a:latin typeface="Calibri"/>
                         </a:rPr>
-                        <a:t>230 $</a:t>
+                        <a:t>241 $</a:t>
                       </a:r>
                     </a:p>
                   </a:txBody>
@@ -7645,7 +7645,7 @@
                           </a:solidFill>
                           <a:latin typeface="Calibri"/>
                         </a:rPr>
-                        <a:t>270 $</a:t>
+                        <a:t>280 $</a:t>
                       </a:r>
                     </a:p>
                   </a:txBody>
@@ -7668,7 +7668,7 @@
                           </a:solidFill>
                           <a:latin typeface="Calibri"/>
                         </a:rPr>
-                        <a:t>300 $</a:t>
+                        <a:t>310 $</a:t>
                       </a:r>
                     </a:p>
                   </a:txBody>
@@ -7693,7 +7693,7 @@
                           </a:solidFill>
                           <a:latin typeface="Calibri"/>
                         </a:rPr>
-                        <a:t>-9,3 %</a:t>
+                        <a:t>-5,0 %</a:t>
                       </a:r>
                     </a:p>
                   </a:txBody>
@@ -7716,7 +7716,7 @@
                           </a:solidFill>
                           <a:latin typeface="Calibri"/>
                         </a:rPr>
-                        <a:t>+6,5 %</a:t>
+                        <a:t>+10,7 %</a:t>
                       </a:r>
                     </a:p>
                   </a:txBody>
@@ -7739,7 +7739,7 @@
                           </a:solidFill>
                           <a:latin typeface="Calibri"/>
                         </a:rPr>
-                        <a:t>+18,3 %</a:t>
+                        <a:t>+22,4 %</a:t>
                       </a:r>
                     </a:p>
                   </a:txBody>
@@ -8203,7 +8203,7 @@
                           </a:solidFill>
                           <a:latin typeface="Calibri"/>
                         </a:rPr>
-                        <a:t>313</a:t>
+                        <a:t>325</a:t>
                       </a:r>
                     </a:p>
                   </a:txBody>
@@ -8246,7 +8246,7 @@
                           </a:solidFill>
                           <a:latin typeface="Calibri"/>
                         </a:rPr>
-                        <a:t>340</a:t>
+                        <a:t>353</a:t>
                       </a:r>
                     </a:p>
                   </a:txBody>
@@ -8289,7 +8289,7 @@
                           </a:solidFill>
                           <a:latin typeface="Calibri"/>
                         </a:rPr>
-                        <a:t>372</a:t>
+                        <a:t>386</a:t>
                       </a:r>
                     </a:p>
                   </a:txBody>
@@ -8332,7 +8332,7 @@
                           </a:solidFill>
                           <a:latin typeface="Calibri"/>
                         </a:rPr>
-                        <a:t>410</a:t>
+                        <a:t>426</a:t>
                       </a:r>
                     </a:p>
                   </a:txBody>
@@ -8375,7 +8375,7 @@
                           </a:solidFill>
                           <a:latin typeface="Calibri"/>
                         </a:rPr>
-                        <a:t>458</a:t>
+                        <a:t>475</a:t>
                       </a:r>
                     </a:p>
                   </a:txBody>
@@ -8463,7 +8463,7 @@
                           </a:solidFill>
                           <a:latin typeface="Calibri"/>
                         </a:rPr>
-                        <a:t>270</a:t>
+                        <a:t>280</a:t>
                       </a:r>
                     </a:p>
                   </a:txBody>
@@ -8506,7 +8506,7 @@
                           </a:solidFill>
                           <a:latin typeface="Calibri"/>
                         </a:rPr>
-                        <a:t>290</a:t>
+                        <a:t>301</a:t>
                       </a:r>
                     </a:p>
                   </a:txBody>
@@ -8549,7 +8549,7 @@
                           </a:solidFill>
                           <a:latin typeface="Calibri"/>
                         </a:rPr>
-                        <a:t>313</a:t>
+                        <a:t>325</a:t>
                       </a:r>
                     </a:p>
                   </a:txBody>
@@ -8592,7 +8592,7 @@
                           </a:solidFill>
                           <a:latin typeface="Calibri"/>
                         </a:rPr>
-                        <a:t>340</a:t>
+                        <a:t>353</a:t>
                       </a:r>
                     </a:p>
                   </a:txBody>
@@ -8635,7 +8635,7 @@
                           </a:solidFill>
                           <a:latin typeface="Calibri"/>
                         </a:rPr>
-                        <a:t>372</a:t>
+                        <a:t>386</a:t>
                       </a:r>
                     </a:p>
                   </a:txBody>
@@ -8723,7 +8723,7 @@
                           </a:solidFill>
                           <a:latin typeface="Calibri"/>
                         </a:rPr>
-                        <a:t>238</a:t>
+                        <a:t>247</a:t>
                       </a:r>
                     </a:p>
                   </a:txBody>
@@ -8766,7 +8766,7 @@
                           </a:solidFill>
                           <a:latin typeface="Calibri"/>
                         </a:rPr>
-                        <a:t>253</a:t>
+                        <a:t>263</a:t>
                       </a:r>
                     </a:p>
                   </a:txBody>
@@ -8809,7 +8809,7 @@
                           </a:solidFill>
                           <a:latin typeface="Calibri"/>
                         </a:rPr>
-                        <a:t>270</a:t>
+                        <a:t>280</a:t>
                       </a:r>
                     </a:p>
                   </a:txBody>
@@ -8852,7 +8852,7 @@
                           </a:solidFill>
                           <a:latin typeface="Calibri"/>
                         </a:rPr>
-                        <a:t>290</a:t>
+                        <a:t>301</a:t>
                       </a:r>
                     </a:p>
                   </a:txBody>
@@ -8895,7 +8895,7 @@
                           </a:solidFill>
                           <a:latin typeface="Calibri"/>
                         </a:rPr>
-                        <a:t>313</a:t>
+                        <a:t>325</a:t>
                       </a:r>
                     </a:p>
                   </a:txBody>
@@ -8983,7 +8983,7 @@
                           </a:solidFill>
                           <a:latin typeface="Calibri"/>
                         </a:rPr>
-                        <a:t>212</a:t>
+                        <a:t>220</a:t>
                       </a:r>
                     </a:p>
                   </a:txBody>
@@ -9026,7 +9026,7 @@
                           </a:solidFill>
                           <a:latin typeface="Calibri"/>
                         </a:rPr>
-                        <a:t>224</a:t>
+                        <a:t>233</a:t>
                       </a:r>
                     </a:p>
                   </a:txBody>
@@ -9069,7 +9069,7 @@
                           </a:solidFill>
                           <a:latin typeface="Calibri"/>
                         </a:rPr>
-                        <a:t>238</a:t>
+                        <a:t>247</a:t>
                       </a:r>
                     </a:p>
                   </a:txBody>
@@ -9112,7 +9112,7 @@
                           </a:solidFill>
                           <a:latin typeface="Calibri"/>
                         </a:rPr>
-                        <a:t>253</a:t>
+                        <a:t>263</a:t>
                       </a:r>
                     </a:p>
                   </a:txBody>
@@ -9155,7 +9155,7 @@
                           </a:solidFill>
                           <a:latin typeface="Calibri"/>
                         </a:rPr>
-                        <a:t>270</a:t>
+                        <a:t>281</a:t>
                       </a:r>
                     </a:p>
                   </a:txBody>
@@ -9243,7 +9243,7 @@
                           </a:solidFill>
                           <a:latin typeface="Calibri"/>
                         </a:rPr>
-                        <a:t>191</a:t>
+                        <a:t>199</a:t>
                       </a:r>
                     </a:p>
                   </a:txBody>
@@ -9286,7 +9286,7 @@
                           </a:solidFill>
                           <a:latin typeface="Calibri"/>
                         </a:rPr>
-                        <a:t>201</a:t>
+                        <a:t>209</a:t>
                       </a:r>
                     </a:p>
                   </a:txBody>
@@ -9329,7 +9329,7 @@
                           </a:solidFill>
                           <a:latin typeface="Calibri"/>
                         </a:rPr>
-                        <a:t>212</a:t>
+                        <a:t>220</a:t>
                       </a:r>
                     </a:p>
                   </a:txBody>
@@ -9372,7 +9372,7 @@
                           </a:solidFill>
                           <a:latin typeface="Calibri"/>
                         </a:rPr>
-                        <a:t>224</a:t>
+                        <a:t>233</a:t>
                       </a:r>
                     </a:p>
                   </a:txBody>
@@ -9415,7 +9415,7 @@
                           </a:solidFill>
                           <a:latin typeface="Calibri"/>
                         </a:rPr>
-                        <a:t>238</a:t>
+                        <a:t>247</a:t>
                       </a:r>
                     </a:p>
                   </a:txBody>
@@ -9480,7 +9480,7 @@
                 </a:solidFill>
                 <a:latin typeface="Calibri"/>
               </a:rPr>
-              <a:t>La DCF d'Apple implique un WACC de 10,3% et un TGR de 3,0%.</a:t>
+              <a:t>Le prix implicite d'Apple sur la base d'un modèle de flux de trésorerie disponible est de 280,5 USD, ce qui suggère un upside de 10% par rapport au cours actuel.</a:t>
             </a:r>
           </a:p>
         </p:txBody>
@@ -10358,7 +10358,7 @@
                           </a:solidFill>
                           <a:latin typeface="Calibri"/>
                         </a:rPr>
-                        <a:t>3 722,1</a:t>
+                        <a:t>3 719,9</a:t>
                       </a:r>
                     </a:p>
                   </a:txBody>
@@ -10498,7 +10498,7 @@
                           </a:solidFill>
                           <a:latin typeface="Calibri"/>
                         </a:rPr>
-                        <a:t>Alphabet</a:t>
+                        <a:t>Microsoft</a:t>
                       </a:r>
                     </a:p>
                   </a:txBody>
@@ -10521,7 +10521,7 @@
                           </a:solidFill>
                           <a:latin typeface="Calibri"/>
                         </a:rPr>
-                        <a:t>GOOGL</a:t>
+                        <a:t>MSFT</a:t>
                       </a:r>
                     </a:p>
                   </a:txBody>
@@ -10544,7 +10544,7 @@
                           </a:solidFill>
                           <a:latin typeface="Calibri"/>
                         </a:rPr>
-                        <a:t>1 500,0</a:t>
+                        <a:t>2 351,9</a:t>
                       </a:r>
                     </a:p>
                   </a:txBody>
@@ -10567,7 +10567,7 @@
                           </a:solidFill>
                           <a:latin typeface="Calibri"/>
                         </a:rPr>
-                        <a:t>20,0x</a:t>
+                        <a:t>23,1x</a:t>
                       </a:r>
                     </a:p>
                   </a:txBody>
@@ -10590,7 +10590,7 @@
                           </a:solidFill>
                           <a:latin typeface="Calibri"/>
                         </a:rPr>
-                        <a:t>6,0x</a:t>
+                        <a:t>8,5x</a:t>
                       </a:r>
                     </a:p>
                   </a:txBody>
@@ -10613,7 +10613,7 @@
                           </a:solidFill>
                           <a:latin typeface="Calibri"/>
                         </a:rPr>
-                        <a:t>30,0x</a:t>
+                        <a:t>34,2x</a:t>
                       </a:r>
                     </a:p>
                   </a:txBody>
@@ -10636,7 +10636,7 @@
                           </a:solidFill>
                           <a:latin typeface="Calibri"/>
                         </a:rPr>
-                        <a:t>55,0 %</a:t>
+                        <a:t>68,0 %</a:t>
                       </a:r>
                     </a:p>
                   </a:txBody>
@@ -10659,7 +10659,7 @@
                           </a:solidFill>
                           <a:latin typeface="Calibri"/>
                         </a:rPr>
-                        <a:t>25,0 %</a:t>
+                        <a:t>43,0 %</a:t>
                       </a:r>
                     </a:p>
                   </a:txBody>
@@ -10684,7 +10684,7 @@
                           </a:solidFill>
                           <a:latin typeface="Calibri"/>
                         </a:rPr>
-                        <a:t>Amazon</a:t>
+                        <a:t>Alphabet</a:t>
                       </a:r>
                     </a:p>
                   </a:txBody>
@@ -10707,7 +10707,7 @@
                           </a:solidFill>
                           <a:latin typeface="Calibri"/>
                         </a:rPr>
-                        <a:t>AMZN</a:t>
+                        <a:t>GOOGL</a:t>
                       </a:r>
                     </a:p>
                   </a:txBody>
@@ -10730,7 +10730,7 @@
                           </a:solidFill>
                           <a:latin typeface="Calibri"/>
                         </a:rPr>
-                        <a:t>1 000,0</a:t>
+                        <a:t>1 571,9</a:t>
                       </a:r>
                     </a:p>
                   </a:txBody>
@@ -10753,7 +10753,7 @@
                           </a:solidFill>
                           <a:latin typeface="Calibri"/>
                         </a:rPr>
-                        <a:t>15,0x</a:t>
+                        <a:t>20,5x</a:t>
                       </a:r>
                     </a:p>
                   </a:txBody>
@@ -10776,7 +10776,7 @@
                           </a:solidFill>
                           <a:latin typeface="Calibri"/>
                         </a:rPr>
-                        <a:t>5,0x</a:t>
+                        <a:t>7,3x</a:t>
                       </a:r>
                     </a:p>
                   </a:txBody>
@@ -10799,7 +10799,7 @@
                           </a:solidFill>
                           <a:latin typeface="Calibri"/>
                         </a:rPr>
-                        <a:t>25,0x</a:t>
+                        <a:t>29,1x</a:t>
                       </a:r>
                     </a:p>
                   </a:txBody>
@@ -10822,7 +10822,7 @@
                           </a:solidFill>
                           <a:latin typeface="Calibri"/>
                         </a:rPr>
-                        <a:t>40,0 %</a:t>
+                        <a:t>55,0 %</a:t>
                       </a:r>
                     </a:p>
                   </a:txBody>
@@ -10845,7 +10845,7 @@
                           </a:solidFill>
                           <a:latin typeface="Calibri"/>
                         </a:rPr>
-                        <a:t>20,0 %</a:t>
+                        <a:t>32,0 %</a:t>
                       </a:r>
                     </a:p>
                   </a:txBody>
@@ -10870,7 +10870,7 @@
                           </a:solidFill>
                           <a:latin typeface="Calibri"/>
                         </a:rPr>
-                        <a:t>Facebook</a:t>
+                        <a:t>Amazon</a:t>
                       </a:r>
                     </a:p>
                   </a:txBody>
@@ -10893,7 +10893,7 @@
                           </a:solidFill>
                           <a:latin typeface="Calibri"/>
                         </a:rPr>
-                        <a:t>FB</a:t>
+                        <a:t>AMZN</a:t>
                       </a:r>
                     </a:p>
                   </a:txBody>
@@ -10916,7 +10916,7 @@
                           </a:solidFill>
                           <a:latin typeface="Calibri"/>
                         </a:rPr>
-                        <a:t>800,0</a:t>
+                        <a:t>1 034,9</a:t>
                       </a:r>
                     </a:p>
                   </a:txBody>
@@ -10939,7 +10939,7 @@
                           </a:solidFill>
                           <a:latin typeface="Calibri"/>
                         </a:rPr>
-                        <a:t>12,0x</a:t>
+                        <a:t>18,3x</a:t>
                       </a:r>
                     </a:p>
                   </a:txBody>
@@ -10962,7 +10962,7 @@
                           </a:solidFill>
                           <a:latin typeface="Calibri"/>
                         </a:rPr>
-                        <a:t>4,0x</a:t>
+                        <a:t>6,5x</a:t>
                       </a:r>
                     </a:p>
                   </a:txBody>
@@ -10985,7 +10985,7 @@
                           </a:solidFill>
                           <a:latin typeface="Calibri"/>
                         </a:rPr>
-                        <a:t>20,0x</a:t>
+                        <a:t>24,5x</a:t>
                       </a:r>
                     </a:p>
                   </a:txBody>
@@ -11008,7 +11008,7 @@
                           </a:solidFill>
                           <a:latin typeface="Calibri"/>
                         </a:rPr>
-                        <a:t>80,0 %</a:t>
+                        <a:t>42,0 %</a:t>
                       </a:r>
                     </a:p>
                   </a:txBody>
@@ -11031,7 +11031,7 @@
                           </a:solidFill>
                           <a:latin typeface="Calibri"/>
                         </a:rPr>
-                        <a:t>30,0 %</a:t>
+                        <a:t>25,0 %</a:t>
                       </a:r>
                     </a:p>
                   </a:txBody>
@@ -11056,7 +11056,7 @@
                           </a:solidFill>
                           <a:latin typeface="Calibri"/>
                         </a:rPr>
-                        <a:t>Microsoft</a:t>
+                        <a:t>Facebook</a:t>
                       </a:r>
                     </a:p>
                   </a:txBody>
@@ -11079,7 +11079,7 @@
                           </a:solidFill>
                           <a:latin typeface="Calibri"/>
                         </a:rPr>
-                        <a:t>MSFT</a:t>
+                        <a:t>META</a:t>
                       </a:r>
                     </a:p>
                   </a:txBody>
@@ -11102,7 +11102,7 @@
                           </a:solidFill>
                           <a:latin typeface="Calibri"/>
                         </a:rPr>
-                        <a:t>2 000,0</a:t>
+                        <a:t>846,9</a:t>
                       </a:r>
                     </a:p>
                   </a:txBody>
@@ -11125,7 +11125,7 @@
                           </a:solidFill>
                           <a:latin typeface="Calibri"/>
                         </a:rPr>
-                        <a:t>18,0x</a:t>
+                        <a:t>16,2x</a:t>
                       </a:r>
                     </a:p>
                   </a:txBody>
@@ -11148,7 +11148,7 @@
                           </a:solidFill>
                           <a:latin typeface="Calibri"/>
                         </a:rPr>
-                        <a:t>7,0x</a:t>
+                        <a:t>5,8x</a:t>
                       </a:r>
                     </a:p>
                   </a:txBody>
@@ -11171,7 +11171,7 @@
                           </a:solidFill>
                           <a:latin typeface="Calibri"/>
                         </a:rPr>
-                        <a:t>35,0x</a:t>
+                        <a:t>20,5x</a:t>
                       </a:r>
                     </a:p>
                   </a:txBody>
@@ -11194,7 +11194,7 @@
                           </a:solidFill>
                           <a:latin typeface="Calibri"/>
                         </a:rPr>
-                        <a:t>65,0 %</a:t>
+                        <a:t>38,0 %</a:t>
                       </a:r>
                     </a:p>
                   </a:txBody>
@@ -11217,7 +11217,7 @@
                           </a:solidFill>
                           <a:latin typeface="Calibri"/>
                         </a:rPr>
-                        <a:t>35,0 %</a:t>
+                        <a:t>22,0 %</a:t>
                       </a:r>
                     </a:p>
                   </a:txBody>
@@ -11242,7 +11242,7 @@
                           </a:solidFill>
                           <a:latin typeface="Calibri"/>
                         </a:rPr>
-                        <a:t>Samsung</a:t>
+                        <a:t>Tesla</a:t>
                       </a:r>
                     </a:p>
                   </a:txBody>
@@ -11265,7 +11265,7 @@
                           </a:solidFill>
                           <a:latin typeface="Calibri"/>
                         </a:rPr>
-                        <a:t>SSNLF</a:t>
+                        <a:t>TSLA</a:t>
                       </a:r>
                     </a:p>
                   </a:txBody>
@@ -11288,7 +11288,7 @@
                           </a:solidFill>
                           <a:latin typeface="Calibri"/>
                         </a:rPr>
-                        <a:t>500,0</a:t>
+                        <a:t>574,9</a:t>
                       </a:r>
                     </a:p>
                   </a:txBody>
@@ -11311,7 +11311,7 @@
                           </a:solidFill>
                           <a:latin typeface="Calibri"/>
                         </a:rPr>
-                        <a:t>10,0x</a:t>
+                        <a:t>24,9x</a:t>
                       </a:r>
                     </a:p>
                   </a:txBody>
@@ -11334,7 +11334,7 @@
                           </a:solidFill>
                           <a:latin typeface="Calibri"/>
                         </a:rPr>
-                        <a:t>3,0x</a:t>
+                        <a:t>9,2x</a:t>
                       </a:r>
                     </a:p>
                   </a:txBody>
@@ -11357,7 +11357,7 @@
                           </a:solidFill>
                           <a:latin typeface="Calibri"/>
                         </a:rPr>
-                        <a:t>15,0x</a:t>
+                        <a:t>35,1x</a:t>
                       </a:r>
                     </a:p>
                   </a:txBody>
@@ -11380,7 +11380,7 @@
                           </a:solidFill>
                           <a:latin typeface="Calibri"/>
                         </a:rPr>
-                        <a:t>30,0 %</a:t>
+                        <a:t>25,0 %</a:t>
                       </a:r>
                     </a:p>
                   </a:txBody>
@@ -11497,7 +11497,7 @@
                           </a:solidFill>
                           <a:latin typeface="Calibri"/>
                         </a:rPr>
-                        <a:t>15,0x</a:t>
+                        <a:t>20,5x</a:t>
                       </a:r>
                     </a:p>
                   </a:txBody>
@@ -11520,7 +11520,7 @@
                           </a:solidFill>
                           <a:latin typeface="Calibri"/>
                         </a:rPr>
-                        <a:t>5,0x</a:t>
+                        <a:t>7,3x</a:t>
                       </a:r>
                     </a:p>
                   </a:txBody>
@@ -11543,7 +11543,7 @@
                           </a:solidFill>
                           <a:latin typeface="Calibri"/>
                         </a:rPr>
-                        <a:t>25,0x</a:t>
+                        <a:t>29,1x</a:t>
                       </a:r>
                     </a:p>
                   </a:txBody>
@@ -11566,7 +11566,7 @@
                           </a:solidFill>
                           <a:latin typeface="Calibri"/>
                         </a:rPr>
-                        <a:t>55,0 %</a:t>
+                        <a:t>42,0 %</a:t>
                       </a:r>
                     </a:p>
                   </a:txBody>
@@ -11634,7 +11634,7 @@
                 </a:solidFill>
                 <a:latin typeface="Calibri"/>
               </a:rPr>
-              <a:t>Le ratio EV/EBITDA d'Apple est de 26,1x, supérieur à la mediane de son secteur.</a:t>
+              <a:t>Le ratio EV/EBITDA d'Apple est inférieur à la moyenne de son secteur, ce qui indique une valorisation attractive.</a:t>
             </a:r>
           </a:p>
         </p:txBody>
@@ -12238,30 +12238,786 @@
           </a:p>
         </p:txBody>
       </p:sp>
-      <p:pic>
-        <p:nvPicPr>
-          <p:cNvPr id="17" name="Picture 16" descr="image.png"/>
-          <p:cNvPicPr>
-            <a:picLocks noChangeAspect="1"/>
-          </p:cNvPicPr>
-          <p:nvPr/>
-        </p:nvPicPr>
-        <p:blipFill>
-          <a:blip r:embed="rId2"/>
-          <a:stretch>
-            <a:fillRect/>
-          </a:stretch>
-        </p:blipFill>
-        <p:spPr>
-          <a:xfrm>
-            <a:off x="367200" y="914400"/>
-            <a:ext cx="8413200" cy="1980000"/>
-          </a:xfrm>
-          <a:prstGeom prst="rect">
-            <a:avLst/>
-          </a:prstGeom>
-        </p:spPr>
-      </p:pic>
+      <p:graphicFrame>
+        <p:nvGraphicFramePr>
+          <p:cNvPr id="17" name="Table 16"/>
+          <p:cNvGraphicFramePr>
+            <a:graphicFrameLocks noGrp="1"/>
+          </p:cNvGraphicFramePr>
+          <p:nvPr/>
+        </p:nvGraphicFramePr>
+        <p:xfrm>
+          <a:off x="367200" y="914400"/>
+          <a:ext cx="8413200" cy="2149200"/>
+        </p:xfrm>
+        <a:graphic>
+          <a:graphicData uri="http://schemas.openxmlformats.org/drawingml/2006/table">
+            <a:tbl>
+              <a:tblPr firstRow="1" bandRow="1">
+                <a:tableStyleId>{5C22544A-7EE6-4342-B048-85BDC9FD1C3A}</a:tableStyleId>
+              </a:tblPr>
+              <a:tblGrid>
+                <a:gridCol w="2944620"/>
+                <a:gridCol w="1682640"/>
+                <a:gridCol w="1682640"/>
+                <a:gridCol w="2103300"/>
+              </a:tblGrid>
+              <a:tr h="268650">
+                <a:tc>
+                  <a:txBody>
+                    <a:bodyPr/>
+                    <a:lstStyle/>
+                    <a:p>
+                      <a:pPr algn="l"/>
+                      <a:r>
+                        <a:rPr sz="800" b="1" i="0">
+                          <a:solidFill>
+                            <a:srgbClr val="FFFFFF"/>
+                          </a:solidFill>
+                          <a:latin typeface="Calibri"/>
+                        </a:rPr>
+                        <a:t>Methode</a:t>
+                      </a:r>
+                    </a:p>
+                  </a:txBody>
+                  <a:tcPr>
+                    <a:solidFill>
+                      <a:srgbClr val="1B3A6B"/>
+                    </a:solidFill>
+                  </a:tcPr>
+                </a:tc>
+                <a:tc>
+                  <a:txBody>
+                    <a:bodyPr/>
+                    <a:lstStyle/>
+                    <a:p>
+                      <a:pPr algn="ctr"/>
+                      <a:r>
+                        <a:rPr sz="800" b="1" i="0">
+                          <a:solidFill>
+                            <a:srgbClr val="FFFFFF"/>
+                          </a:solidFill>
+                          <a:latin typeface="Calibri"/>
+                        </a:rPr>
+                        <a:t>Fourchette basse</a:t>
+                      </a:r>
+                    </a:p>
+                  </a:txBody>
+                  <a:tcPr>
+                    <a:solidFill>
+                      <a:srgbClr val="1B3A6B"/>
+                    </a:solidFill>
+                  </a:tcPr>
+                </a:tc>
+                <a:tc>
+                  <a:txBody>
+                    <a:bodyPr/>
+                    <a:lstStyle/>
+                    <a:p>
+                      <a:pPr algn="ctr"/>
+                      <a:r>
+                        <a:rPr sz="800" b="1" i="0">
+                          <a:solidFill>
+                            <a:srgbClr val="FFFFFF"/>
+                          </a:solidFill>
+                          <a:latin typeface="Calibri"/>
+                        </a:rPr>
+                        <a:t>Fourchette haute</a:t>
+                      </a:r>
+                    </a:p>
+                  </a:txBody>
+                  <a:tcPr>
+                    <a:solidFill>
+                      <a:srgbClr val="1B3A6B"/>
+                    </a:solidFill>
+                  </a:tcPr>
+                </a:tc>
+                <a:tc>
+                  <a:txBody>
+                    <a:bodyPr/>
+                    <a:lstStyle/>
+                    <a:p>
+                      <a:pPr algn="ctr"/>
+                      <a:r>
+                        <a:rPr sz="800" b="1" i="0">
+                          <a:solidFill>
+                            <a:srgbClr val="FFFFFF"/>
+                          </a:solidFill>
+                          <a:latin typeface="Calibri"/>
+                        </a:rPr>
+                        <a:t>Point central</a:t>
+                      </a:r>
+                    </a:p>
+                  </a:txBody>
+                  <a:tcPr>
+                    <a:solidFill>
+                      <a:srgbClr val="1B3A6B"/>
+                    </a:solidFill>
+                  </a:tcPr>
+                </a:tc>
+              </a:tr>
+              <a:tr h="268650">
+                <a:tc>
+                  <a:txBody>
+                    <a:bodyPr/>
+                    <a:lstStyle/>
+                    <a:p>
+                      <a:pPr algn="l"/>
+                      <a:r>
+                        <a:rPr sz="800" b="0" i="0">
+                          <a:solidFill>
+                            <a:srgbClr val="0D0D0D"/>
+                          </a:solidFill>
+                          <a:latin typeface="Calibri"/>
+                        </a:rPr>
+                        <a:t>DCF - Bear</a:t>
+                      </a:r>
+                    </a:p>
+                  </a:txBody>
+                  <a:tcPr>
+                    <a:solidFill>
+                      <a:srgbClr val="FAF0EF"/>
+                    </a:solidFill>
+                  </a:tcPr>
+                </a:tc>
+                <a:tc>
+                  <a:txBody>
+                    <a:bodyPr/>
+                    <a:lstStyle/>
+                    <a:p>
+                      <a:pPr algn="ctr"/>
+                      <a:r>
+                        <a:rPr sz="800" b="0" i="0">
+                          <a:solidFill>
+                            <a:srgbClr val="0D0D0D"/>
+                          </a:solidFill>
+                          <a:latin typeface="Calibri"/>
+                        </a:rPr>
+                        <a:t>220</a:t>
+                      </a:r>
+                    </a:p>
+                  </a:txBody>
+                  <a:tcPr>
+                    <a:solidFill>
+                      <a:srgbClr val="FAF0EF"/>
+                    </a:solidFill>
+                  </a:tcPr>
+                </a:tc>
+                <a:tc>
+                  <a:txBody>
+                    <a:bodyPr/>
+                    <a:lstStyle/>
+                    <a:p>
+                      <a:pPr algn="ctr"/>
+                      <a:r>
+                        <a:rPr sz="800" b="0" i="0">
+                          <a:solidFill>
+                            <a:srgbClr val="0D0D0D"/>
+                          </a:solidFill>
+                          <a:latin typeface="Calibri"/>
+                        </a:rPr>
+                        <a:t>250</a:t>
+                      </a:r>
+                    </a:p>
+                  </a:txBody>
+                  <a:tcPr>
+                    <a:solidFill>
+                      <a:srgbClr val="FAF0EF"/>
+                    </a:solidFill>
+                  </a:tcPr>
+                </a:tc>
+                <a:tc>
+                  <a:txBody>
+                    <a:bodyPr/>
+                    <a:lstStyle/>
+                    <a:p>
+                      <a:pPr algn="ctr"/>
+                      <a:r>
+                        <a:rPr sz="800" b="0" i="0">
+                          <a:solidFill>
+                            <a:srgbClr val="0D0D0D"/>
+                          </a:solidFill>
+                          <a:latin typeface="Calibri"/>
+                        </a:rPr>
+                        <a:t>241</a:t>
+                      </a:r>
+                    </a:p>
+                  </a:txBody>
+                  <a:tcPr>
+                    <a:solidFill>
+                      <a:srgbClr val="FAF0EF"/>
+                    </a:solidFill>
+                  </a:tcPr>
+                </a:tc>
+              </a:tr>
+              <a:tr h="268650">
+                <a:tc>
+                  <a:txBody>
+                    <a:bodyPr/>
+                    <a:lstStyle/>
+                    <a:p>
+                      <a:pPr algn="l"/>
+                      <a:r>
+                        <a:rPr sz="800" b="0" i="0">
+                          <a:solidFill>
+                            <a:srgbClr val="0D0D0D"/>
+                          </a:solidFill>
+                          <a:latin typeface="Calibri"/>
+                        </a:rPr>
+                        <a:t>DCF - Base</a:t>
+                      </a:r>
+                    </a:p>
+                  </a:txBody>
+                  <a:tcPr>
+                    <a:solidFill>
+                      <a:srgbClr val="EEF3FA"/>
+                    </a:solidFill>
+                  </a:tcPr>
+                </a:tc>
+                <a:tc>
+                  <a:txBody>
+                    <a:bodyPr/>
+                    <a:lstStyle/>
+                    <a:p>
+                      <a:pPr algn="ctr"/>
+                      <a:r>
+                        <a:rPr sz="800" b="0" i="0">
+                          <a:solidFill>
+                            <a:srgbClr val="0D0D0D"/>
+                          </a:solidFill>
+                          <a:latin typeface="Calibri"/>
+                        </a:rPr>
+                        <a:t>250</a:t>
+                      </a:r>
+                    </a:p>
+                  </a:txBody>
+                  <a:tcPr>
+                    <a:solidFill>
+                      <a:srgbClr val="EEF3FA"/>
+                    </a:solidFill>
+                  </a:tcPr>
+                </a:tc>
+                <a:tc>
+                  <a:txBody>
+                    <a:bodyPr/>
+                    <a:lstStyle/>
+                    <a:p>
+                      <a:pPr algn="ctr"/>
+                      <a:r>
+                        <a:rPr sz="800" b="0" i="0">
+                          <a:solidFill>
+                            <a:srgbClr val="0D0D0D"/>
+                          </a:solidFill>
+                          <a:latin typeface="Calibri"/>
+                        </a:rPr>
+                        <a:t>300</a:t>
+                      </a:r>
+                    </a:p>
+                  </a:txBody>
+                  <a:tcPr>
+                    <a:solidFill>
+                      <a:srgbClr val="EEF3FA"/>
+                    </a:solidFill>
+                  </a:tcPr>
+                </a:tc>
+                <a:tc>
+                  <a:txBody>
+                    <a:bodyPr/>
+                    <a:lstStyle/>
+                    <a:p>
+                      <a:pPr algn="ctr"/>
+                      <a:r>
+                        <a:rPr sz="800" b="0" i="0">
+                          <a:solidFill>
+                            <a:srgbClr val="0D0D0D"/>
+                          </a:solidFill>
+                          <a:latin typeface="Calibri"/>
+                        </a:rPr>
+                        <a:t>280</a:t>
+                      </a:r>
+                    </a:p>
+                  </a:txBody>
+                  <a:tcPr>
+                    <a:solidFill>
+                      <a:srgbClr val="EEF3FA"/>
+                    </a:solidFill>
+                  </a:tcPr>
+                </a:tc>
+              </a:tr>
+              <a:tr h="268650">
+                <a:tc>
+                  <a:txBody>
+                    <a:bodyPr/>
+                    <a:lstStyle/>
+                    <a:p>
+                      <a:pPr algn="l"/>
+                      <a:r>
+                        <a:rPr sz="800" b="0" i="0">
+                          <a:solidFill>
+                            <a:srgbClr val="0D0D0D"/>
+                          </a:solidFill>
+                          <a:latin typeface="Calibri"/>
+                        </a:rPr>
+                        <a:t>DCF - Bull</a:t>
+                      </a:r>
+                    </a:p>
+                  </a:txBody>
+                  <a:tcPr>
+                    <a:solidFill>
+                      <a:srgbClr val="EAF4EF"/>
+                    </a:solidFill>
+                  </a:tcPr>
+                </a:tc>
+                <a:tc>
+                  <a:txBody>
+                    <a:bodyPr/>
+                    <a:lstStyle/>
+                    <a:p>
+                      <a:pPr algn="ctr"/>
+                      <a:r>
+                        <a:rPr sz="800" b="0" i="0">
+                          <a:solidFill>
+                            <a:srgbClr val="0D0D0D"/>
+                          </a:solidFill>
+                          <a:latin typeface="Calibri"/>
+                        </a:rPr>
+                        <a:t>300</a:t>
+                      </a:r>
+                    </a:p>
+                  </a:txBody>
+                  <a:tcPr>
+                    <a:solidFill>
+                      <a:srgbClr val="EAF4EF"/>
+                    </a:solidFill>
+                  </a:tcPr>
+                </a:tc>
+                <a:tc>
+                  <a:txBody>
+                    <a:bodyPr/>
+                    <a:lstStyle/>
+                    <a:p>
+                      <a:pPr algn="ctr"/>
+                      <a:r>
+                        <a:rPr sz="800" b="0" i="0">
+                          <a:solidFill>
+                            <a:srgbClr val="0D0D0D"/>
+                          </a:solidFill>
+                          <a:latin typeface="Calibri"/>
+                        </a:rPr>
+                        <a:t>350</a:t>
+                      </a:r>
+                    </a:p>
+                  </a:txBody>
+                  <a:tcPr>
+                    <a:solidFill>
+                      <a:srgbClr val="EAF4EF"/>
+                    </a:solidFill>
+                  </a:tcPr>
+                </a:tc>
+                <a:tc>
+                  <a:txBody>
+                    <a:bodyPr/>
+                    <a:lstStyle/>
+                    <a:p>
+                      <a:pPr algn="ctr"/>
+                      <a:r>
+                        <a:rPr sz="800" b="0" i="0">
+                          <a:solidFill>
+                            <a:srgbClr val="0D0D0D"/>
+                          </a:solidFill>
+                          <a:latin typeface="Calibri"/>
+                        </a:rPr>
+                        <a:t>310</a:t>
+                      </a:r>
+                    </a:p>
+                  </a:txBody>
+                  <a:tcPr>
+                    <a:solidFill>
+                      <a:srgbClr val="EAF4EF"/>
+                    </a:solidFill>
+                  </a:tcPr>
+                </a:tc>
+              </a:tr>
+              <a:tr h="268650">
+                <a:tc>
+                  <a:txBody>
+                    <a:bodyPr/>
+                    <a:lstStyle/>
+                    <a:p>
+                      <a:pPr algn="l"/>
+                      <a:r>
+                        <a:rPr sz="800" b="0" i="0">
+                          <a:solidFill>
+                            <a:srgbClr val="0D0D0D"/>
+                          </a:solidFill>
+                          <a:latin typeface="Calibri"/>
+                        </a:rPr>
+                        <a:t>EV/EBITDA - Mediane peers</a:t>
+                      </a:r>
+                    </a:p>
+                  </a:txBody>
+                  <a:tcPr>
+                    <a:solidFill>
+                      <a:srgbClr val="F7F8FA"/>
+                    </a:solidFill>
+                  </a:tcPr>
+                </a:tc>
+                <a:tc>
+                  <a:txBody>
+                    <a:bodyPr/>
+                    <a:lstStyle/>
+                    <a:p>
+                      <a:pPr algn="ctr"/>
+                      <a:r>
+                        <a:rPr sz="800" b="0" i="0">
+                          <a:solidFill>
+                            <a:srgbClr val="0D0D0D"/>
+                          </a:solidFill>
+                          <a:latin typeface="Calibri"/>
+                        </a:rPr>
+                        <a:t>240</a:t>
+                      </a:r>
+                    </a:p>
+                  </a:txBody>
+                  <a:tcPr>
+                    <a:solidFill>
+                      <a:srgbClr val="F7F8FA"/>
+                    </a:solidFill>
+                  </a:tcPr>
+                </a:tc>
+                <a:tc>
+                  <a:txBody>
+                    <a:bodyPr/>
+                    <a:lstStyle/>
+                    <a:p>
+                      <a:pPr algn="ctr"/>
+                      <a:r>
+                        <a:rPr sz="800" b="0" i="0">
+                          <a:solidFill>
+                            <a:srgbClr val="0D0D0D"/>
+                          </a:solidFill>
+                          <a:latin typeface="Calibri"/>
+                        </a:rPr>
+                        <a:t>280</a:t>
+                      </a:r>
+                    </a:p>
+                  </a:txBody>
+                  <a:tcPr>
+                    <a:solidFill>
+                      <a:srgbClr val="F7F8FA"/>
+                    </a:solidFill>
+                  </a:tcPr>
+                </a:tc>
+                <a:tc>
+                  <a:txBody>
+                    <a:bodyPr/>
+                    <a:lstStyle/>
+                    <a:p>
+                      <a:pPr algn="ctr"/>
+                      <a:r>
+                        <a:rPr sz="800" b="0" i="0">
+                          <a:solidFill>
+                            <a:srgbClr val="0D0D0D"/>
+                          </a:solidFill>
+                          <a:latin typeface="Calibri"/>
+                        </a:rPr>
+                        <a:t>260</a:t>
+                      </a:r>
+                    </a:p>
+                  </a:txBody>
+                  <a:tcPr>
+                    <a:solidFill>
+                      <a:srgbClr val="F7F8FA"/>
+                    </a:solidFill>
+                  </a:tcPr>
+                </a:tc>
+              </a:tr>
+              <a:tr h="268650">
+                <a:tc>
+                  <a:txBody>
+                    <a:bodyPr/>
+                    <a:lstStyle/>
+                    <a:p>
+                      <a:pPr algn="l"/>
+                      <a:r>
+                        <a:rPr sz="800" b="0" i="0">
+                          <a:solidFill>
+                            <a:srgbClr val="0D0D0D"/>
+                          </a:solidFill>
+                          <a:latin typeface="Calibri"/>
+                        </a:rPr>
+                        <a:t>EV/EBITDA - Prime tech +50%</a:t>
+                      </a:r>
+                    </a:p>
+                  </a:txBody>
+                  <a:tcPr>
+                    <a:solidFill>
+                      <a:srgbClr val="F7F8FA"/>
+                    </a:solidFill>
+                  </a:tcPr>
+                </a:tc>
+                <a:tc>
+                  <a:txBody>
+                    <a:bodyPr/>
+                    <a:lstStyle/>
+                    <a:p>
+                      <a:pPr algn="ctr"/>
+                      <a:r>
+                        <a:rPr sz="800" b="0" i="0">
+                          <a:solidFill>
+                            <a:srgbClr val="0D0D0D"/>
+                          </a:solidFill>
+                          <a:latin typeface="Calibri"/>
+                        </a:rPr>
+                        <a:t>280</a:t>
+                      </a:r>
+                    </a:p>
+                  </a:txBody>
+                  <a:tcPr>
+                    <a:solidFill>
+                      <a:srgbClr val="F7F8FA"/>
+                    </a:solidFill>
+                  </a:tcPr>
+                </a:tc>
+                <a:tc>
+                  <a:txBody>
+                    <a:bodyPr/>
+                    <a:lstStyle/>
+                    <a:p>
+                      <a:pPr algn="ctr"/>
+                      <a:r>
+                        <a:rPr sz="800" b="0" i="0">
+                          <a:solidFill>
+                            <a:srgbClr val="0D0D0D"/>
+                          </a:solidFill>
+                          <a:latin typeface="Calibri"/>
+                        </a:rPr>
+                        <a:t>330</a:t>
+                      </a:r>
+                    </a:p>
+                  </a:txBody>
+                  <a:tcPr>
+                    <a:solidFill>
+                      <a:srgbClr val="F7F8FA"/>
+                    </a:solidFill>
+                  </a:tcPr>
+                </a:tc>
+                <a:tc>
+                  <a:txBody>
+                    <a:bodyPr/>
+                    <a:lstStyle/>
+                    <a:p>
+                      <a:pPr algn="ctr"/>
+                      <a:r>
+                        <a:rPr sz="800" b="0" i="0">
+                          <a:solidFill>
+                            <a:srgbClr val="0D0D0D"/>
+                          </a:solidFill>
+                          <a:latin typeface="Calibri"/>
+                        </a:rPr>
+                        <a:t>300</a:t>
+                      </a:r>
+                    </a:p>
+                  </a:txBody>
+                  <a:tcPr>
+                    <a:solidFill>
+                      <a:srgbClr val="F7F8FA"/>
+                    </a:solidFill>
+                  </a:tcPr>
+                </a:tc>
+              </a:tr>
+              <a:tr h="268650">
+                <a:tc>
+                  <a:txBody>
+                    <a:bodyPr/>
+                    <a:lstStyle/>
+                    <a:p>
+                      <a:pPr algn="l"/>
+                      <a:r>
+                        <a:rPr sz="800" b="0" i="0">
+                          <a:solidFill>
+                            <a:srgbClr val="0D0D0D"/>
+                          </a:solidFill>
+                          <a:latin typeface="Calibri"/>
+                        </a:rPr>
+                        <a:t>EV/Revenue - Mediane peers</a:t>
+                      </a:r>
+                    </a:p>
+                  </a:txBody>
+                  <a:tcPr>
+                    <a:solidFill>
+                      <a:srgbClr val="F7F8FA"/>
+                    </a:solidFill>
+                  </a:tcPr>
+                </a:tc>
+                <a:tc>
+                  <a:txBody>
+                    <a:bodyPr/>
+                    <a:lstStyle/>
+                    <a:p>
+                      <a:pPr algn="ctr"/>
+                      <a:r>
+                        <a:rPr sz="800" b="0" i="0">
+                          <a:solidFill>
+                            <a:srgbClr val="0D0D0D"/>
+                          </a:solidFill>
+                          <a:latin typeface="Calibri"/>
+                        </a:rPr>
+                        <a:t>200</a:t>
+                      </a:r>
+                    </a:p>
+                  </a:txBody>
+                  <a:tcPr>
+                    <a:solidFill>
+                      <a:srgbClr val="F7F8FA"/>
+                    </a:solidFill>
+                  </a:tcPr>
+                </a:tc>
+                <a:tc>
+                  <a:txBody>
+                    <a:bodyPr/>
+                    <a:lstStyle/>
+                    <a:p>
+                      <a:pPr algn="ctr"/>
+                      <a:r>
+                        <a:rPr sz="800" b="0" i="0">
+                          <a:solidFill>
+                            <a:srgbClr val="0D0D0D"/>
+                          </a:solidFill>
+                          <a:latin typeface="Calibri"/>
+                        </a:rPr>
+                        <a:t>240</a:t>
+                      </a:r>
+                    </a:p>
+                  </a:txBody>
+                  <a:tcPr>
+                    <a:solidFill>
+                      <a:srgbClr val="F7F8FA"/>
+                    </a:solidFill>
+                  </a:tcPr>
+                </a:tc>
+                <a:tc>
+                  <a:txBody>
+                    <a:bodyPr/>
+                    <a:lstStyle/>
+                    <a:p>
+                      <a:pPr algn="ctr"/>
+                      <a:r>
+                        <a:rPr sz="800" b="0" i="0">
+                          <a:solidFill>
+                            <a:srgbClr val="0D0D0D"/>
+                          </a:solidFill>
+                          <a:latin typeface="Calibri"/>
+                        </a:rPr>
+                        <a:t>220</a:t>
+                      </a:r>
+                    </a:p>
+                  </a:txBody>
+                  <a:tcPr>
+                    <a:solidFill>
+                      <a:srgbClr val="F7F8FA"/>
+                    </a:solidFill>
+                  </a:tcPr>
+                </a:tc>
+              </a:tr>
+              <a:tr h="268650">
+                <a:tc>
+                  <a:txBody>
+                    <a:bodyPr/>
+                    <a:lstStyle/>
+                    <a:p>
+                      <a:pPr algn="l"/>
+                      <a:r>
+                        <a:rPr sz="800" b="0" i="0">
+                          <a:solidFill>
+                            <a:srgbClr val="0D0D0D"/>
+                          </a:solidFill>
+                          <a:latin typeface="Calibri"/>
+                        </a:rPr>
+                        <a:t>Cours actuel (253,38)</a:t>
+                      </a:r>
+                    </a:p>
+                  </a:txBody>
+                  <a:tcPr>
+                    <a:solidFill>
+                      <a:srgbClr val="EEF3FA"/>
+                    </a:solidFill>
+                  </a:tcPr>
+                </a:tc>
+                <a:tc>
+                  <a:txBody>
+                    <a:bodyPr/>
+                    <a:lstStyle/>
+                    <a:p>
+                      <a:pPr algn="ctr"/>
+                      <a:r>
+                        <a:rPr sz="800" b="0" i="0">
+                          <a:solidFill>
+                            <a:srgbClr val="0D0D0D"/>
+                          </a:solidFill>
+                          <a:latin typeface="Calibri"/>
+                        </a:rPr>
+                        <a:t>—</a:t>
+                      </a:r>
+                    </a:p>
+                  </a:txBody>
+                  <a:tcPr>
+                    <a:solidFill>
+                      <a:srgbClr val="EEF3FA"/>
+                    </a:solidFill>
+                  </a:tcPr>
+                </a:tc>
+                <a:tc>
+                  <a:txBody>
+                    <a:bodyPr/>
+                    <a:lstStyle/>
+                    <a:p>
+                      <a:pPr algn="ctr"/>
+                      <a:r>
+                        <a:rPr sz="800" b="0" i="0">
+                          <a:solidFill>
+                            <a:srgbClr val="0D0D0D"/>
+                          </a:solidFill>
+                          <a:latin typeface="Calibri"/>
+                        </a:rPr>
+                        <a:t>—</a:t>
+                      </a:r>
+                    </a:p>
+                  </a:txBody>
+                  <a:tcPr>
+                    <a:solidFill>
+                      <a:srgbClr val="EEF3FA"/>
+                    </a:solidFill>
+                  </a:tcPr>
+                </a:tc>
+                <a:tc>
+                  <a:txBody>
+                    <a:bodyPr/>
+                    <a:lstStyle/>
+                    <a:p>
+                      <a:pPr algn="ctr"/>
+                      <a:r>
+                        <a:rPr sz="800" b="0" i="0">
+                          <a:solidFill>
+                            <a:srgbClr val="0D0D0D"/>
+                          </a:solidFill>
+                          <a:latin typeface="Calibri"/>
+                        </a:rPr>
+                        <a:t>253,38</a:t>
+                      </a:r>
+                    </a:p>
+                  </a:txBody>
+                  <a:tcPr>
+                    <a:solidFill>
+                      <a:srgbClr val="EEF3FA"/>
+                    </a:solidFill>
+                  </a:tcPr>
+                </a:tc>
+              </a:tr>
+            </a:tbl>
+          </a:graphicData>
+        </a:graphic>
+      </p:graphicFrame>
       <p:sp>
         <p:nvSpPr>
           <p:cNvPr id="18" name="TextBox 17"/>
@@ -12292,7 +13048,7 @@
                 </a:solidFill>
                 <a:latin typeface="Calibri"/>
               </a:rPr>
-              <a:t>La DCF d'Apple implique un WACC de 10,3% et un TGR de 3,0%.</a:t>
+              <a:t>Le prix implicite d'Apple sur la base d'un modèle de flux de trésorerie disponible est de 280,5 USD, ce qui suggère un upside de 10% par rapport au cours actuel.</a:t>
             </a:r>
           </a:p>
         </p:txBody>
@@ -13265,7 +14021,7 @@
                 </a:solidFill>
                 <a:latin typeface="Calibri"/>
               </a:rPr>
-              <a:t>Risque Concurrentiel</a:t>
+              <a:t>Concurrence accrue</a:t>
             </a:r>
           </a:p>
         </p:txBody>
@@ -13300,7 +14056,7 @@
                 </a:solidFill>
                 <a:latin typeface="Calibri"/>
               </a:rPr>
-              <a:t>AAPL est surévaluée avec un P/E de 33,23x, dépassant la moyenne sectorielle de 10%</a:t>
+              <a:t>Concurrence accrue</a:t>
             </a:r>
           </a:p>
         </p:txBody>
@@ -13421,7 +14177,7 @@
                 </a:solidFill>
                 <a:latin typeface="Calibri"/>
               </a:rPr>
-              <a:t>Risque Sectoriel</a:t>
+              <a:t>Dépendance aux smartphones</a:t>
             </a:r>
           </a:p>
         </p:txBody>
@@ -13456,7 +14212,7 @@
                 </a:solidFill>
                 <a:latin typeface="Calibri"/>
               </a:rPr>
-              <a:t>Les ratios de marge bénéficiaire sont sous pression debido à la concurrence accrue, avec une marge brute de 46,9% qui pourrait baisser de 2% d'ici 2026</a:t>
+              <a:t>Risques politiques</a:t>
             </a:r>
           </a:p>
         </p:txBody>
@@ -13577,7 +14333,7 @@
                 </a:solidFill>
                 <a:latin typeface="Calibri"/>
               </a:rPr>
-              <a:t>Risque Financier</a:t>
+              <a:t>Risques politiques</a:t>
             </a:r>
           </a:p>
         </p:txBody>
@@ -13612,7 +14368,7 @@
                 </a:solidFill>
                 <a:latin typeface="Calibri"/>
               </a:rPr>
-              <a:t>Le déclin du marché des smartphones pourrait impacter les ventes d'AAPL, avec une croissance des revenus prévue à seulement 6,4% en 2025</a:t>
+              <a:t>Dépendance aux smartphones</a:t>
             </a:r>
           </a:p>
         </p:txBody>
@@ -13826,7 +14582,7 @@
                           </a:solidFill>
                           <a:latin typeface="Calibri"/>
                         </a:rPr>
-                        <a:t>Récession économique</a:t>
+                        <a:t>Récession économique mondiale</a:t>
                       </a:r>
                     </a:p>
                   </a:txBody>
@@ -13968,7 +14724,7 @@
                           </a:solidFill>
                           <a:latin typeface="Calibri"/>
                         </a:rPr>
-                        <a:t>Problèmes de production d'iPhones</a:t>
+                        <a:t>Problèmes de production ou de livraison</a:t>
                       </a:r>
                     </a:p>
                   </a:txBody>
@@ -15044,7 +15800,7 @@
                 </a:solidFill>
                 <a:latin typeface="Calibri"/>
               </a:rPr>
-              <a:t>Score agrege : +0,017</a:t>
+              <a:t>Score agrege : +0,035</a:t>
             </a:r>
           </a:p>
         </p:txBody>
@@ -15356,7 +16112,7 @@
                 </a:solidFill>
                 <a:latin typeface="Calibri"/>
               </a:rPr>
-              <a:t>45,0 %</a:t>
+              <a:t>49,7 %</a:t>
             </a:r>
           </a:p>
         </p:txBody>
@@ -15835,7 +16591,7 @@
                           </a:solidFill>
                           <a:latin typeface="Calibri"/>
                         </a:rPr>
-                        <a:t>+0,284</a:t>
+                        <a:t>+0,269</a:t>
                       </a:r>
                     </a:p>
                   </a:txBody>
@@ -15858,7 +16614,7 @@
                           </a:solidFill>
                           <a:latin typeface="Calibri"/>
                         </a:rPr>
-                        <a:t>5G, IA, Sécurité</a:t>
+                        <a:t>Croissance de la demande pour les smartphones, Expansion de l'écosystème d'Apple, Innovation</a:t>
                       </a:r>
                     </a:p>
                   </a:txBody>
@@ -15906,7 +16662,7 @@
                           </a:solidFill>
                           <a:latin typeface="Calibri"/>
                         </a:rPr>
-                        <a:t>15</a:t>
+                        <a:t>17</a:t>
                       </a:r>
                     </a:p>
                   </a:txBody>
@@ -15929,7 +16685,7 @@
                           </a:solidFill>
                           <a:latin typeface="Calibri"/>
                         </a:rPr>
-                        <a:t>+0,450</a:t>
+                        <a:t>+0,497</a:t>
                       </a:r>
                     </a:p>
                   </a:txBody>
@@ -16000,7 +16756,7 @@
                           </a:solidFill>
                           <a:latin typeface="Calibri"/>
                         </a:rPr>
-                        <a:t>8</a:t>
+                        <a:t>6</a:t>
                       </a:r>
                     </a:p>
                   </a:txBody>
@@ -16023,7 +16779,7 @@
                           </a:solidFill>
                           <a:latin typeface="Calibri"/>
                         </a:rPr>
-                        <a:t>+0,267</a:t>
+                        <a:t>+0,234</a:t>
                       </a:r>
                     </a:p>
                   </a:txBody>
@@ -16046,7 +16802,7 @@
                           </a:solidFill>
                           <a:latin typeface="Calibri"/>
                         </a:rPr>
-                        <a:t>Concurrence chinoise, Réglementation, Dépendance aux composants</a:t>
+                        <a:t>Concurrence accrue, Risques politiques, Dépendance aux smartphones</a:t>
                       </a:r>
                     </a:p>
                   </a:txBody>
@@ -16091,7 +16847,7 @@
                 </a:solidFill>
                 <a:latin typeface="Calibri"/>
               </a:rPr>
-              <a:t>Le sentiment global de la presse financiere sur AAPL cette semaine est mitigé, avec des nouvelles positives sur les ventes d'iPhone 17 et l'adoption croissante des appareils Apple en Europe, mais également des inquiétudes sur la concurrence et les prix élevés de la mémoire. Les investisseurs attendent avec patience les résultats futurs de l'entreprise, notamment après l'annonce de l'introduction de publicités payantes sur Apple Maps.</a:t>
+              <a:t>Le sentiment global de la presse financiere sur AAPL cette semaine est mitige, avec certains titres laissant apparaitre une croissance potentielle pour l'entreprise, notamment en termes d'adoption de ses produits en Europe. Cependant, d'autres titres font etat de defis potentiels pour l'entreprise, tels que la concurrence accrue dans le marché des smartphones et les risques lies aux partenariats avec d'autres entreprises technologiques.</a:t>
             </a:r>
           </a:p>
         </p:txBody>
@@ -19029,7 +19785,7 @@
                 </a:solidFill>
                 <a:latin typeface="Calibri"/>
               </a:rPr>
-              <a:t>La valorisation d'Apple est élevée par rapport à ses pairs, mais justifiée par sa croissance et ses marges. Le multiple EV/EBITDA est de 26,1x.</a:t>
+              <a:t>La valorisation d'Apple est attractive par rapport à ses pairs, avec un ratio EV/EBITDA inférieur à 25. L'entreprise présente également un multiple de prix sur bénéfice inférieur à 30.</a:t>
             </a:r>
           </a:p>
         </p:txBody>
@@ -19359,7 +20115,7 @@
                 </a:solidFill>
                 <a:latin typeface="Calibri"/>
               </a:rPr>
-              <a:t>Prix cible base : 270 $  ·  Upside : +6,5 %  ·  Bear : 230 $ (-9,3 %)  ·  Bull : 300 $ (+18,3 %)</a:t>
+              <a:t>Prix cible base : 280 $  ·  Upside : +10,7 %  ·  Bear : 241 $ (-5,0 %)  ·  Bull : 310 $ (+22,4 %)</a:t>
             </a:r>
           </a:p>
         </p:txBody>
@@ -19550,7 +20306,7 @@
                 </a:solidFill>
                 <a:latin typeface="Calibri"/>
               </a:rPr>
-              <a:t>La croissance des revenus d'Apple sera drivée par la vente d'iPhones 5G</a:t>
+              <a:t>La croissance de la demande pour les smartphones et les ordinateurs portables devrait atteindre 10% d'ici 2027</a:t>
             </a:r>
           </a:p>
         </p:txBody>
@@ -19607,6 +20363,119 @@
         <p:spPr>
           <a:xfrm>
             <a:off x="503999" y="2178000"/>
+            <a:ext cx="3931200" cy="183600"/>
+          </a:xfrm>
+          <a:prstGeom prst="rect">
+            <a:avLst/>
+          </a:prstGeom>
+          <a:noFill/>
+        </p:spPr>
+        <p:txBody>
+          <a:bodyPr wrap="square">
+            <a:spAutoFit/>
+          </a:bodyPr>
+          <a:lstStyle/>
+          <a:p>
+            <a:pPr algn="l"/>
+            <a:r>
+              <a:rPr sz="850" b="1" i="0">
+                <a:solidFill>
+                  <a:srgbClr val="1B3A6B"/>
+                </a:solidFill>
+                <a:latin typeface="Calibri"/>
+              </a:rPr>
+              <a:t>Ecosystème intégré</a:t>
+            </a:r>
+          </a:p>
+        </p:txBody>
+      </p:sp>
+      <p:sp>
+        <p:nvSpPr>
+          <p:cNvPr id="17" name="TextBox 16"/>
+          <p:cNvSpPr txBox="1"/>
+          <p:nvPr/>
+        </p:nvSpPr>
+        <p:spPr>
+          <a:xfrm>
+            <a:off x="503999" y="2347200"/>
+            <a:ext cx="3931200" cy="327600"/>
+          </a:xfrm>
+          <a:prstGeom prst="rect">
+            <a:avLst/>
+          </a:prstGeom>
+          <a:noFill/>
+        </p:spPr>
+        <p:txBody>
+          <a:bodyPr wrap="square">
+            <a:spAutoFit/>
+          </a:bodyPr>
+          <a:lstStyle/>
+          <a:p>
+            <a:pPr algn="l"/>
+            <a:r>
+              <a:rPr sz="750" b="0" i="0">
+                <a:solidFill>
+                  <a:srgbClr val="333333"/>
+                </a:solidFill>
+                <a:latin typeface="Calibri"/>
+              </a:rPr>
+              <a:t>Les services d'Apple devraient générer 20% des revenus de l'entreprise d'ici 2028</a:t>
+            </a:r>
+          </a:p>
+        </p:txBody>
+      </p:sp>
+      <p:sp>
+        <p:nvSpPr>
+          <p:cNvPr id="18" name="Rectangle 17"/>
+          <p:cNvSpPr/>
+          <p:nvPr/>
+        </p:nvSpPr>
+        <p:spPr>
+          <a:xfrm>
+            <a:off x="367200" y="2728800"/>
+            <a:ext cx="54000" cy="129600"/>
+          </a:xfrm>
+          <a:prstGeom prst="rect">
+            <a:avLst/>
+          </a:prstGeom>
+          <a:solidFill>
+            <a:srgbClr val="2E5FA3"/>
+          </a:solidFill>
+          <a:ln>
+            <a:noFill/>
+          </a:ln>
+        </p:spPr>
+        <p:style>
+          <a:lnRef idx="1">
+            <a:schemeClr val="accent1"/>
+          </a:lnRef>
+          <a:fillRef idx="3">
+            <a:schemeClr val="accent1"/>
+          </a:fillRef>
+          <a:effectRef idx="2">
+            <a:schemeClr val="accent1"/>
+          </a:effectRef>
+          <a:fontRef idx="minor">
+            <a:schemeClr val="lt1"/>
+          </a:fontRef>
+        </p:style>
+        <p:txBody>
+          <a:bodyPr rtlCol="0" anchor="ctr"/>
+          <a:lstStyle/>
+          <a:p>
+            <a:pPr algn="ctr"/>
+          </a:p>
+        </p:txBody>
+      </p:sp>
+      <p:sp>
+        <p:nvSpPr>
+          <p:cNvPr id="19" name="TextBox 18"/>
+          <p:cNvSpPr txBox="1"/>
+          <p:nvPr/>
+        </p:nvSpPr>
+        <p:spPr>
+          <a:xfrm>
+            <a:off x="503999" y="2710800"/>
             <a:ext cx="3931200" cy="183600"/>
           </a:xfrm>
           <a:prstGeom prst="rect">
@@ -19635,13 +20504,13 @@
       </p:sp>
       <p:sp>
         <p:nvSpPr>
-          <p:cNvPr id="17" name="TextBox 16"/>
+          <p:cNvPr id="20" name="TextBox 19"/>
           <p:cNvSpPr txBox="1"/>
           <p:nvPr/>
         </p:nvSpPr>
         <p:spPr>
           <a:xfrm>
-            <a:off x="503999" y="2347200"/>
+            <a:off x="503999" y="2880000"/>
             <a:ext cx="3931200" cy="327600"/>
           </a:xfrm>
           <a:prstGeom prst="rect">
@@ -19663,120 +20532,7 @@
                 </a:solidFill>
                 <a:latin typeface="Calibri"/>
               </a:rPr>
-              <a:t>La mise à jour des Macs et des iPads sera un catalyseur de croissance</a:t>
-            </a:r>
-          </a:p>
-        </p:txBody>
-      </p:sp>
-      <p:sp>
-        <p:nvSpPr>
-          <p:cNvPr id="18" name="Rectangle 17"/>
-          <p:cNvSpPr/>
-          <p:nvPr/>
-        </p:nvSpPr>
-        <p:spPr>
-          <a:xfrm>
-            <a:off x="367200" y="2728800"/>
-            <a:ext cx="54000" cy="129600"/>
-          </a:xfrm>
-          <a:prstGeom prst="rect">
-            <a:avLst/>
-          </a:prstGeom>
-          <a:solidFill>
-            <a:srgbClr val="2E5FA3"/>
-          </a:solidFill>
-          <a:ln>
-            <a:noFill/>
-          </a:ln>
-        </p:spPr>
-        <p:style>
-          <a:lnRef idx="1">
-            <a:schemeClr val="accent1"/>
-          </a:lnRef>
-          <a:fillRef idx="3">
-            <a:schemeClr val="accent1"/>
-          </a:fillRef>
-          <a:effectRef idx="2">
-            <a:schemeClr val="accent1"/>
-          </a:effectRef>
-          <a:fontRef idx="minor">
-            <a:schemeClr val="lt1"/>
-          </a:fontRef>
-        </p:style>
-        <p:txBody>
-          <a:bodyPr rtlCol="0" anchor="ctr"/>
-          <a:lstStyle/>
-          <a:p>
-            <a:pPr algn="ctr"/>
-          </a:p>
-        </p:txBody>
-      </p:sp>
-      <p:sp>
-        <p:nvSpPr>
-          <p:cNvPr id="19" name="TextBox 18"/>
-          <p:cNvSpPr txBox="1"/>
-          <p:nvPr/>
-        </p:nvSpPr>
-        <p:spPr>
-          <a:xfrm>
-            <a:off x="503999" y="2710800"/>
-            <a:ext cx="3931200" cy="183600"/>
-          </a:xfrm>
-          <a:prstGeom prst="rect">
-            <a:avLst/>
-          </a:prstGeom>
-          <a:noFill/>
-        </p:spPr>
-        <p:txBody>
-          <a:bodyPr wrap="square">
-            <a:spAutoFit/>
-          </a:bodyPr>
-          <a:lstStyle/>
-          <a:p>
-            <a:pPr algn="l"/>
-            <a:r>
-              <a:rPr sz="850" b="1" i="0">
-                <a:solidFill>
-                  <a:srgbClr val="1B3A6B"/>
-                </a:solidFill>
-                <a:latin typeface="Calibri"/>
-              </a:rPr>
-              <a:t>Écosystème</a:t>
-            </a:r>
-          </a:p>
-        </p:txBody>
-      </p:sp>
-      <p:sp>
-        <p:nvSpPr>
-          <p:cNvPr id="20" name="TextBox 19"/>
-          <p:cNvSpPr txBox="1"/>
-          <p:nvPr/>
-        </p:nvSpPr>
-        <p:spPr>
-          <a:xfrm>
-            <a:off x="503999" y="2880000"/>
-            <a:ext cx="3931200" cy="327600"/>
-          </a:xfrm>
-          <a:prstGeom prst="rect">
-            <a:avLst/>
-          </a:prstGeom>
-          <a:noFill/>
-        </p:spPr>
-        <p:txBody>
-          <a:bodyPr wrap="square">
-            <a:spAutoFit/>
-          </a:bodyPr>
-          <a:lstStyle/>
-          <a:p>
-            <a:pPr algn="l"/>
-            <a:r>
-              <a:rPr sz="750" b="0" i="0">
-                <a:solidFill>
-                  <a:srgbClr val="333333"/>
-                </a:solidFill>
-                <a:latin typeface="Calibri"/>
-              </a:rPr>
-              <a:t>Les services d'Apple devraient générer 50 milliards de dollars de revenus en 2026</a:t>
+              <a:t>L'expansion de l'écosystème d'Apple devrait atteindre 500 millions d'utilisateurs actifs d'ici 2029</a:t>
             </a:r>
           </a:p>
         </p:txBody>
@@ -19932,7 +20688,7 @@
                 </a:solidFill>
                 <a:latin typeface="Calibri"/>
               </a:rPr>
-              <a:t>Concurrence</a:t>
+              <a:t>Concurrence accrue</a:t>
             </a:r>
           </a:p>
         </p:txBody>
@@ -19967,7 +20723,7 @@
                 </a:solidFill>
                 <a:latin typeface="Calibri"/>
               </a:rPr>
-              <a:t>Concurrence chinoise</a:t>
+              <a:t>Concurrence accrue</a:t>
             </a:r>
           </a:p>
         </p:txBody>
@@ -20045,7 +20801,7 @@
                 </a:solidFill>
                 <a:latin typeface="Calibri"/>
               </a:rPr>
-              <a:t>Dépendance aux iPhones</a:t>
+              <a:t>Dépendance aux smartphones</a:t>
             </a:r>
           </a:p>
         </p:txBody>
@@ -20080,7 +20836,7 @@
                 </a:solidFill>
                 <a:latin typeface="Calibri"/>
               </a:rPr>
-              <a:t>Réglementation</a:t>
+              <a:t>Risques politiques</a:t>
             </a:r>
           </a:p>
         </p:txBody>
@@ -20158,7 +20914,7 @@
                 </a:solidFill>
                 <a:latin typeface="Calibri"/>
               </a:rPr>
-              <a:t>Réglementation</a:t>
+              <a:t>Risques politiques</a:t>
             </a:r>
           </a:p>
         </p:txBody>
@@ -20193,7 +20949,7 @@
                 </a:solidFill>
                 <a:latin typeface="Calibri"/>
               </a:rPr>
-              <a:t>Dépendance aux composants</a:t>
+              <a:t>Dépendance aux smartphones</a:t>
             </a:r>
           </a:p>
         </p:txBody>
@@ -20470,7 +21226,7 @@
                 </a:solidFill>
                 <a:latin typeface="Calibri"/>
               </a:rPr>
-              <a:t>vs 15,0x médiane peers</a:t>
+              <a:t>vs 20,5x médiane peers</a:t>
             </a:r>
           </a:p>
         </p:txBody>
@@ -20782,7 +21538,7 @@
                 </a:solidFill>
                 <a:latin typeface="Calibri"/>
               </a:rPr>
-              <a:t>270 $</a:t>
+              <a:t>280 $</a:t>
             </a:r>
           </a:p>
         </p:txBody>
@@ -20852,7 +21608,7 @@
                 </a:solidFill>
                 <a:latin typeface="Calibri"/>
               </a:rPr>
-              <a:t>Upside de +6,5 % vs cours</a:t>
+              <a:t>Upside de +10,7 % vs cours</a:t>
             </a:r>
           </a:p>
         </p:txBody>
@@ -20973,7 +21729,7 @@
                 </a:solidFill>
                 <a:latin typeface="Calibri"/>
               </a:rPr>
-              <a:t>+0,017</a:t>
+              <a:t>+0,035</a:t>
             </a:r>
           </a:p>
         </p:txBody>
@@ -21763,7 +22519,7 @@
                 </a:solidFill>
                 <a:latin typeface="Calibri"/>
               </a:rPr>
-              <a:t>253,53 $</a:t>
+              <a:t>253,38 $</a:t>
             </a:r>
           </a:p>
         </p:txBody>
@@ -22231,7 +22987,7 @@
                 </a:solidFill>
                 <a:latin typeface="Calibri"/>
               </a:rPr>
-              <a:t>+19,8 %</a:t>
+              <a:t>+19,7 %</a:t>
             </a:r>
           </a:p>
         </p:txBody>
@@ -23260,8 +24016,8 @@
         </p:nvSpPr>
         <p:spPr>
           <a:xfrm>
-            <a:off x="7854300" y="2838875"/>
-            <a:ext cx="498636" cy="1056324"/>
+            <a:off x="7854300" y="2842183"/>
+            <a:ext cx="498636" cy="1053016"/>
           </a:xfrm>
           <a:prstGeom prst="rect">
             <a:avLst/>
@@ -23332,57 +24088,14 @@
       </p:sp>
       <p:sp>
         <p:nvSpPr>
-          <p:cNvPr id="60" name="Rectangle 59"/>
-          <p:cNvSpPr/>
-          <p:nvPr/>
-        </p:nvSpPr>
-        <p:spPr>
-          <a:xfrm>
-            <a:off x="601200" y="3823200"/>
-            <a:ext cx="8179200" cy="7200"/>
-          </a:xfrm>
-          <a:prstGeom prst="rect">
-            <a:avLst/>
-          </a:prstGeom>
-          <a:solidFill>
-            <a:srgbClr val="D0D5DD"/>
-          </a:solidFill>
-          <a:ln>
-            <a:noFill/>
-          </a:ln>
-        </p:spPr>
-        <p:style>
-          <a:lnRef idx="1">
-            <a:schemeClr val="accent1"/>
-          </a:lnRef>
-          <a:fillRef idx="3">
-            <a:schemeClr val="accent1"/>
-          </a:fillRef>
-          <a:effectRef idx="2">
-            <a:schemeClr val="accent1"/>
-          </a:effectRef>
-          <a:fontRef idx="minor">
-            <a:schemeClr val="lt1"/>
-          </a:fontRef>
-        </p:style>
-        <p:txBody>
-          <a:bodyPr rtlCol="0" anchor="ctr"/>
-          <a:lstStyle/>
-          <a:p>
-            <a:pPr algn="ctr"/>
-          </a:p>
-        </p:txBody>
-      </p:sp>
-      <p:sp>
-        <p:nvSpPr>
-          <p:cNvPr id="61" name="TextBox 60"/>
+          <p:cNvPr id="60" name="TextBox 59"/>
           <p:cNvSpPr txBox="1"/>
           <p:nvPr/>
         </p:nvSpPr>
         <p:spPr>
           <a:xfrm>
-            <a:off x="367200" y="3751200"/>
-            <a:ext cx="216000" cy="144000"/>
+            <a:off x="439200" y="2174400"/>
+            <a:ext cx="1800000" cy="144000"/>
           </a:xfrm>
           <a:prstGeom prst="rect">
             <a:avLst/>
@@ -23397,254 +24110,55 @@
           <a:p>
             <a:pPr algn="l"/>
             <a:r>
-              <a:rPr sz="600" b="0" i="0">
+              <a:rPr sz="700" b="0" i="0">
+                <a:solidFill>
+                  <a:srgbClr val="2E5FA3"/>
+                </a:solidFill>
+                <a:latin typeface="Calibri"/>
+              </a:rPr>
+              <a:t>▲ Max : 278,32 $</a:t>
+            </a:r>
+          </a:p>
+        </p:txBody>
+      </p:sp>
+      <p:sp>
+        <p:nvSpPr>
+          <p:cNvPr id="61" name="TextBox 60"/>
+          <p:cNvSpPr txBox="1"/>
+          <p:nvPr/>
+        </p:nvSpPr>
+        <p:spPr>
+          <a:xfrm>
+            <a:off x="439200" y="3643199"/>
+            <a:ext cx="1800000" cy="144000"/>
+          </a:xfrm>
+          <a:prstGeom prst="rect">
+            <a:avLst/>
+          </a:prstGeom>
+          <a:noFill/>
+        </p:spPr>
+        <p:txBody>
+          <a:bodyPr wrap="square">
+            <a:spAutoFit/>
+          </a:bodyPr>
+          <a:lstStyle/>
+          <a:p>
+            <a:pPr algn="l"/>
+            <a:r>
+              <a:rPr sz="700" b="0" i="0">
                 <a:solidFill>
                   <a:srgbClr val="555555"/>
                 </a:solidFill>
                 <a:latin typeface="Calibri"/>
               </a:rPr>
-              <a:t>199</a:t>
+              <a:t>▼ Min : 199,98 $</a:t>
             </a:r>
           </a:p>
         </p:txBody>
       </p:sp>
       <p:sp>
         <p:nvSpPr>
-          <p:cNvPr id="62" name="Rectangle 61"/>
-          <p:cNvSpPr/>
-          <p:nvPr/>
-        </p:nvSpPr>
-        <p:spPr>
-          <a:xfrm>
-            <a:off x="601200" y="3348000"/>
-            <a:ext cx="8179200" cy="7200"/>
-          </a:xfrm>
-          <a:prstGeom prst="rect">
-            <a:avLst/>
-          </a:prstGeom>
-          <a:solidFill>
-            <a:srgbClr val="D0D5DD"/>
-          </a:solidFill>
-          <a:ln>
-            <a:noFill/>
-          </a:ln>
-        </p:spPr>
-        <p:style>
-          <a:lnRef idx="1">
-            <a:schemeClr val="accent1"/>
-          </a:lnRef>
-          <a:fillRef idx="3">
-            <a:schemeClr val="accent1"/>
-          </a:fillRef>
-          <a:effectRef idx="2">
-            <a:schemeClr val="accent1"/>
-          </a:effectRef>
-          <a:fontRef idx="minor">
-            <a:schemeClr val="lt1"/>
-          </a:fontRef>
-        </p:style>
-        <p:txBody>
-          <a:bodyPr rtlCol="0" anchor="ctr"/>
-          <a:lstStyle/>
-          <a:p>
-            <a:pPr algn="ctr"/>
-          </a:p>
-        </p:txBody>
-      </p:sp>
-      <p:sp>
-        <p:nvSpPr>
-          <p:cNvPr id="63" name="TextBox 62"/>
-          <p:cNvSpPr txBox="1"/>
-          <p:nvPr/>
-        </p:nvSpPr>
-        <p:spPr>
-          <a:xfrm>
-            <a:off x="367200" y="3276000"/>
-            <a:ext cx="216000" cy="144000"/>
-          </a:xfrm>
-          <a:prstGeom prst="rect">
-            <a:avLst/>
-          </a:prstGeom>
-          <a:noFill/>
-        </p:spPr>
-        <p:txBody>
-          <a:bodyPr wrap="square">
-            <a:spAutoFit/>
-          </a:bodyPr>
-          <a:lstStyle/>
-          <a:p>
-            <a:pPr algn="l"/>
-            <a:r>
-              <a:rPr sz="600" b="0" i="0">
-                <a:solidFill>
-                  <a:srgbClr val="555555"/>
-                </a:solidFill>
-                <a:latin typeface="Calibri"/>
-              </a:rPr>
-              <a:t>225</a:t>
-            </a:r>
-          </a:p>
-        </p:txBody>
-      </p:sp>
-      <p:sp>
-        <p:nvSpPr>
-          <p:cNvPr id="64" name="Rectangle 63"/>
-          <p:cNvSpPr/>
-          <p:nvPr/>
-        </p:nvSpPr>
-        <p:spPr>
-          <a:xfrm>
-            <a:off x="601200" y="2858400"/>
-            <a:ext cx="8179200" cy="7200"/>
-          </a:xfrm>
-          <a:prstGeom prst="rect">
-            <a:avLst/>
-          </a:prstGeom>
-          <a:solidFill>
-            <a:srgbClr val="D0D5DD"/>
-          </a:solidFill>
-          <a:ln>
-            <a:noFill/>
-          </a:ln>
-        </p:spPr>
-        <p:style>
-          <a:lnRef idx="1">
-            <a:schemeClr val="accent1"/>
-          </a:lnRef>
-          <a:fillRef idx="3">
-            <a:schemeClr val="accent1"/>
-          </a:fillRef>
-          <a:effectRef idx="2">
-            <a:schemeClr val="accent1"/>
-          </a:effectRef>
-          <a:fontRef idx="minor">
-            <a:schemeClr val="lt1"/>
-          </a:fontRef>
-        </p:style>
-        <p:txBody>
-          <a:bodyPr rtlCol="0" anchor="ctr"/>
-          <a:lstStyle/>
-          <a:p>
-            <a:pPr algn="ctr"/>
-          </a:p>
-        </p:txBody>
-      </p:sp>
-      <p:sp>
-        <p:nvSpPr>
-          <p:cNvPr id="65" name="TextBox 64"/>
-          <p:cNvSpPr txBox="1"/>
-          <p:nvPr/>
-        </p:nvSpPr>
-        <p:spPr>
-          <a:xfrm>
-            <a:off x="367200" y="2786399"/>
-            <a:ext cx="216000" cy="144000"/>
-          </a:xfrm>
-          <a:prstGeom prst="rect">
-            <a:avLst/>
-          </a:prstGeom>
-          <a:noFill/>
-        </p:spPr>
-        <p:txBody>
-          <a:bodyPr wrap="square">
-            <a:spAutoFit/>
-          </a:bodyPr>
-          <a:lstStyle/>
-          <a:p>
-            <a:pPr algn="l"/>
-            <a:r>
-              <a:rPr sz="600" b="0" i="0">
-                <a:solidFill>
-                  <a:srgbClr val="555555"/>
-                </a:solidFill>
-                <a:latin typeface="Calibri"/>
-              </a:rPr>
-              <a:t>252</a:t>
-            </a:r>
-          </a:p>
-        </p:txBody>
-      </p:sp>
-      <p:sp>
-        <p:nvSpPr>
-          <p:cNvPr id="66" name="Rectangle 65"/>
-          <p:cNvSpPr/>
-          <p:nvPr/>
-        </p:nvSpPr>
-        <p:spPr>
-          <a:xfrm>
-            <a:off x="601200" y="2383200"/>
-            <a:ext cx="8179200" cy="7200"/>
-          </a:xfrm>
-          <a:prstGeom prst="rect">
-            <a:avLst/>
-          </a:prstGeom>
-          <a:solidFill>
-            <a:srgbClr val="D0D5DD"/>
-          </a:solidFill>
-          <a:ln>
-            <a:noFill/>
-          </a:ln>
-        </p:spPr>
-        <p:style>
-          <a:lnRef idx="1">
-            <a:schemeClr val="accent1"/>
-          </a:lnRef>
-          <a:fillRef idx="3">
-            <a:schemeClr val="accent1"/>
-          </a:fillRef>
-          <a:effectRef idx="2">
-            <a:schemeClr val="accent1"/>
-          </a:effectRef>
-          <a:fontRef idx="minor">
-            <a:schemeClr val="lt1"/>
-          </a:fontRef>
-        </p:style>
-        <p:txBody>
-          <a:bodyPr rtlCol="0" anchor="ctr"/>
-          <a:lstStyle/>
-          <a:p>
-            <a:pPr algn="ctr"/>
-          </a:p>
-        </p:txBody>
-      </p:sp>
-      <p:sp>
-        <p:nvSpPr>
-          <p:cNvPr id="67" name="TextBox 66"/>
-          <p:cNvSpPr txBox="1"/>
-          <p:nvPr/>
-        </p:nvSpPr>
-        <p:spPr>
-          <a:xfrm>
-            <a:off x="367200" y="2311200"/>
-            <a:ext cx="216000" cy="144000"/>
-          </a:xfrm>
-          <a:prstGeom prst="rect">
-            <a:avLst/>
-          </a:prstGeom>
-          <a:noFill/>
-        </p:spPr>
-        <p:txBody>
-          <a:bodyPr wrap="square">
-            <a:spAutoFit/>
-          </a:bodyPr>
-          <a:lstStyle/>
-          <a:p>
-            <a:pPr algn="l"/>
-            <a:r>
-              <a:rPr sz="600" b="0" i="0">
-                <a:solidFill>
-                  <a:srgbClr val="555555"/>
-                </a:solidFill>
-                <a:latin typeface="Calibri"/>
-              </a:rPr>
-              <a:t>278</a:t>
-            </a:r>
-          </a:p>
-        </p:txBody>
-      </p:sp>
-      <p:sp>
-        <p:nvSpPr>
-          <p:cNvPr id="68" name="TextBox 67"/>
+          <p:cNvPr id="62" name="TextBox 61"/>
           <p:cNvSpPr txBox="1"/>
           <p:nvPr/>
         </p:nvSpPr>
@@ -23672,7 +24186,7 @@
                 </a:solidFill>
                 <a:latin typeface="Calibri"/>
               </a:rPr>
-              <a:t>Apple Inc. est une entreprise de technologie leader avec une position forte sur le marché. La croissance des revenus et des marges est attendue.</a:t>
+              <a:t>Apple Inc. presente une opportunité d'investissement attractive avec des perspectives de croissance solides et une position dominante sur le marché. L'entreprise devrait poursuivre sa croissance grâce à ses produits innovants et à son écosystème intégré.</a:t>
             </a:r>
           </a:p>
         </p:txBody>
@@ -24715,7 +25229,7 @@
                 </a:solidFill>
                 <a:latin typeface="Calibri"/>
               </a:rPr>
-              <a:t>Concurrence  ·  Dépendance aux iPhones</a:t>
+              <a:t>Concurrence accrue  ·  Dépendance aux smartphones</a:t>
             </a:r>
           </a:p>
         </p:txBody>
@@ -25949,7 +26463,7 @@
                 </a:solidFill>
                 <a:latin typeface="Calibri"/>
               </a:rPr>
-              <a:t>Apple Inc. est une entreprise de technologie qui conçoit, produit et commercialise des produits électroniques. Elle est leader sur le marché des smartphones et des ordinateurs portables. L'avantage concurrentiel d'Apple réside dans sa marque forte et sa capacité à innover. L'entreprise articule son activité autour de deux segments stratégiques :</a:t>
+              <a:t>Apple Inc. est un leader mondial dans la conception, la fabrication et la commercialisation de produits électroniques grand public. L'entreprise est positionnée comme un acteur majeur sur le marché des smartphones et des ordinateurs portables. Ses avantages concurrentiels incluent son écosystème intégré, sa marque forte et son innovante gamme de produits. L'entreprise articule son activité autour de deux segments stratégiques :</a:t>
             </a:r>
           </a:p>
         </p:txBody>
@@ -26062,7 +26576,7 @@
                 </a:solidFill>
                 <a:latin typeface="Calibri"/>
               </a:rPr>
-              <a:t>Les produits d'Apple incluent les iPhones, les Macs et les iPads. Les revenus de cette section…</a:t>
+              <a:t>Les produits d'Apple incluent les iPhone, les Mac, les iPad, les Apple Watch et les AirPods.…</a:t>
             </a:r>
           </a:p>
         </p:txBody>
@@ -26175,7 +26689,7 @@
                 </a:solidFill>
                 <a:latin typeface="Calibri"/>
               </a:rPr>
-              <a:t>Les services d'Apple incluent la musique, les films et les applications. Les revenus de cette…</a:t>
+              <a:t>Les services d'Apple incluent la musique, les films, les applications et les abonnements.…</a:t>
             </a:r>
           </a:p>
         </p:txBody>
@@ -26296,7 +26810,7 @@
                 </a:solidFill>
                 <a:latin typeface="Calibri"/>
               </a:rPr>
-              <a:t>3 722,1 Mds$</a:t>
+              <a:t>3 719,9 Mds$</a:t>
             </a:r>
           </a:p>
         </p:txBody>
@@ -26608,7 +27122,7 @@
                 </a:solidFill>
                 <a:latin typeface="Calibri"/>
               </a:rPr>
-              <a:t>253,53 $</a:t>
+              <a:t>253,38 $</a:t>
             </a:r>
           </a:p>
         </p:txBody>
@@ -27554,7 +28068,7 @@
                 </a:solidFill>
                 <a:latin typeface="Calibri"/>
               </a:rPr>
-              <a:t>80%</a:t>
+              <a:t>1%</a:t>
             </a:r>
           </a:p>
         </p:txBody>
@@ -27681,7 +28195,7 @@
         <p:spPr>
           <a:xfrm>
             <a:off x="457200" y="2332800"/>
-            <a:ext cx="3970800" cy="2041199"/>
+            <a:ext cx="3970800" cy="1800000"/>
           </a:xfrm>
           <a:prstGeom prst="rect">
             <a:avLst/>
@@ -27702,7 +28216,7 @@
                 </a:solidFill>
                 <a:latin typeface="Calibri"/>
               </a:rPr>
-              <a:t>Les produits d'Apple incluent les iPhones, les Macs et les iPads. Les revenus de cette section proviennent de la vente de ces produits. Les clients cibles sont les particuliers et les entreprises.</a:t>
+              <a:t>Les produits d'Apple incluent les iPhone, les Mac, les iPad, les Apple Watch et les AirPods. L'entreprise génère la majorité de ses revenus grâce à la vente de ces produits. Les principaux moteurs de croissance sont la demande croissante pour les…</a:t>
             </a:r>
           </a:p>
         </p:txBody>
@@ -27823,7 +28337,7 @@
                 </a:solidFill>
                 <a:latin typeface="Calibri"/>
               </a:rPr>
-              <a:t>20%</a:t>
+              <a:t>0%</a:t>
             </a:r>
           </a:p>
         </p:txBody>
@@ -27950,7 +28464,7 @@
         <p:spPr>
           <a:xfrm>
             <a:off x="4716000" y="2332800"/>
-            <a:ext cx="3970800" cy="2041199"/>
+            <a:ext cx="3970800" cy="1800000"/>
           </a:xfrm>
           <a:prstGeom prst="rect">
             <a:avLst/>
@@ -27971,7 +28485,7 @@
                 </a:solidFill>
                 <a:latin typeface="Calibri"/>
               </a:rPr>
-              <a:t>Les services d'Apple incluent la musique, les films et les applications. Les revenus de cette section proviennent des abonnements et des ventes de contenus. Les clients cibles sont les particuliers et les entreprises.</a:t>
+              <a:t>Les services d'Apple incluent la musique, les films, les applications et les abonnements. L'entreprise cherche à diversifier ses sources de revenus en développant ses services. Les moteurs de croissance incluent la croissance du marché des services…</a:t>
             </a:r>
           </a:p>
         </p:txBody>
@@ -29100,7 +29614,7 @@
                           </a:solidFill>
                           <a:latin typeface="Calibri"/>
                         </a:rPr>
-                        <a:t>450,0</a:t>
+                        <a:t>437,2</a:t>
                       </a:r>
                     </a:p>
                   </a:txBody>
@@ -29123,7 +29637,7 @@
                           </a:solidFill>
                           <a:latin typeface="Calibri"/>
                         </a:rPr>
-                        <a:t>480,0</a:t>
+                        <a:t>468,4</a:t>
                       </a:r>
                     </a:p>
                   </a:txBody>
@@ -29240,7 +29754,7 @@
                           </a:solidFill>
                           <a:latin typeface="Calibri"/>
                         </a:rPr>
-                        <a:t>+8,0 %</a:t>
+                        <a:t>+5,0 %</a:t>
                       </a:r>
                     </a:p>
                   </a:txBody>
@@ -29380,7 +29894,7 @@
                           </a:solidFill>
                           <a:latin typeface="Calibri"/>
                         </a:rPr>
-                        <a:t>211,5</a:t>
+                        <a:t>205,5</a:t>
                       </a:r>
                     </a:p>
                   </a:txBody>
@@ -29403,7 +29917,7 @@
                           </a:solidFill>
                           <a:latin typeface="Calibri"/>
                         </a:rPr>
-                        <a:t>230,4</a:t>
+                        <a:t>224,8</a:t>
                       </a:r>
                     </a:p>
                   </a:txBody>
@@ -29660,7 +30174,7 @@
                           </a:solidFill>
                           <a:latin typeface="Calibri"/>
                         </a:rPr>
-                        <a:t>180,0</a:t>
+                        <a:t>157,8</a:t>
                       </a:r>
                     </a:p>
                   </a:txBody>
@@ -29683,7 +30197,7 @@
                           </a:solidFill>
                           <a:latin typeface="Calibri"/>
                         </a:rPr>
-                        <a:t>200,0</a:t>
+                        <a:t>173,2</a:t>
                       </a:r>
                     </a:p>
                   </a:txBody>
@@ -29800,7 +30314,7 @@
                           </a:solidFill>
                           <a:latin typeface="Calibri"/>
                         </a:rPr>
-                        <a:t>40,0 %</a:t>
+                        <a:t>36,0 %</a:t>
                       </a:r>
                     </a:p>
                   </a:txBody>
@@ -29823,7 +30337,7 @@
                           </a:solidFill>
                           <a:latin typeface="Calibri"/>
                         </a:rPr>
-                        <a:t>42,0 %</a:t>
+                        <a:t>37,0 %</a:t>
                       </a:r>
                     </a:p>
                   </a:txBody>
@@ -29940,7 +30454,7 @@
                           </a:solidFill>
                           <a:latin typeface="Calibri"/>
                         </a:rPr>
-                        <a:t>120,0</a:t>
+                        <a:t>114,8</a:t>
                       </a:r>
                     </a:p>
                   </a:txBody>
@@ -29963,7 +30477,7 @@
                           </a:solidFill>
                           <a:latin typeface="Calibri"/>
                         </a:rPr>
-                        <a:t>130,0</a:t>
+                        <a:t>124,9</a:t>
                       </a:r>
                     </a:p>
                   </a:txBody>
@@ -30080,30 +30594,30 @@
                           </a:solidFill>
                           <a:latin typeface="Calibri"/>
                         </a:rPr>
+                        <a:t>26,0 %</a:t>
+                      </a:r>
+                    </a:p>
+                  </a:txBody>
+                  <a:tcPr>
+                    <a:solidFill>
+                      <a:srgbClr val="F7F8FA"/>
+                    </a:solidFill>
+                  </a:tcPr>
+                </a:tc>
+                <a:tc>
+                  <a:txBody>
+                    <a:bodyPr/>
+                    <a:lstStyle/>
+                    <a:p>
+                      <a:pPr algn="ctr"/>
+                      <a:r>
+                        <a:rPr sz="750" b="0" i="1">
+                          <a:solidFill>
+                            <a:srgbClr val="555555"/>
+                          </a:solidFill>
+                          <a:latin typeface="Calibri"/>
+                        </a:rPr>
                         <a:t>27,0 %</a:t>
-                      </a:r>
-                    </a:p>
-                  </a:txBody>
-                  <a:tcPr>
-                    <a:solidFill>
-                      <a:srgbClr val="F7F8FA"/>
-                    </a:solidFill>
-                  </a:tcPr>
-                </a:tc>
-                <a:tc>
-                  <a:txBody>
-                    <a:bodyPr/>
-                    <a:lstStyle/>
-                    <a:p>
-                      <a:pPr algn="ctr"/>
-                      <a:r>
-                        <a:rPr sz="750" b="0" i="1">
-                          <a:solidFill>
-                            <a:srgbClr val="555555"/>
-                          </a:solidFill>
-                          <a:latin typeface="Calibri"/>
-                        </a:rPr>
-                        <a:t>28,0 %</a:t>
                       </a:r>
                     </a:p>
                   </a:txBody>
@@ -30148,7 +30662,7 @@
                 </a:solidFill>
                 <a:latin typeface="Calibri"/>
               </a:rPr>
-              <a:t>Les revenus d'Apple ont augmenté de 6,4% en 2025. Les marges sont élevées, avec un taux de marge brute de 46,9%.</a:t>
+              <a:t>Les revenus d'Apple devraient augmenter de 5% en 2026 et de 7% en 2027, grâce à la croissance de la demande pour les smartphones et les ordinateurs portables.</a:t>
             </a:r>
           </a:p>
         </p:txBody>
@@ -32065,7 +32579,7 @@
                 </a:solidFill>
                 <a:latin typeface="Calibri"/>
               </a:rPr>
-              <a:t>Les revenus d'Apple ont augmenté de 6,4% en 2025. Les marges sont élevées, avec un taux de marge brute de 46,9%.</a:t>
+              <a:t>Les revenus d'Apple devraient augmenter de 5% en 2026 et de 7% en 2027, grâce à la croissance de la demande pour les smartphones et les ordinateurs portables.</a:t>
             </a:r>
           </a:p>
         </p:txBody>

</xml_diff>

<commit_message>
fix(pdf): EBITDA unite incorrecte — supprimer heuristique 50k dans _frm + previews AAPL/TSLA/MSFT
Correction : _frm() divisait par 1000 seulement si valeur > 50 000, laissant
l'EBITDA TSLA (17 657M = 17,7Md$) s'afficher comme '17 657' au lieu de '17,7'.
Toutes les valeurs sont en millions (yfinance + LLM prompt) — toujours diviser par 1000.

Previews regeneres avec tous les correctifs PDF de la session :
- AAPL : nouveau format (Points cles, vigilance, graphiques remplis)
- TSLA : synthese BUY conviction=0.8, EBITDA en Md$ corriges
- MSFT : mise a jour livrables

Co-Authored-By: Claude Sonnet 4.6 <noreply@anthropic.com>
</commit_message>
<xml_diff>
--- a/preview/AAPL/AAPL_pitchbook.pptx
+++ b/preview/AAPL/AAPL_pitchbook.pptx
@@ -3449,7 +3449,7 @@
                 </a:solidFill>
                 <a:latin typeface="Calibri"/>
               </a:rPr>
-              <a:t>● BUY  ·  Prix cible base : 280 $  ·  Upside : +10,7 %</a:t>
+              <a:t>● BUY  ·  Prix cible base : 285 $  ·  Upside : +12,1 %</a:t>
             </a:r>
           </a:p>
         </p:txBody>
@@ -4421,7 +4421,7 @@
                           </a:solidFill>
                           <a:latin typeface="Calibri"/>
                         </a:rPr>
-                        <a:t>33,2x</a:t>
+                        <a:t>33,3x</a:t>
                       </a:r>
                     </a:p>
                   </a:txBody>
@@ -4595,7 +4595,7 @@
                           </a:solidFill>
                           <a:latin typeface="Calibri"/>
                         </a:rPr>
-                        <a:t>26,1x</a:t>
+                        <a:t>26,2x</a:t>
                       </a:r>
                     </a:p>
                   </a:txBody>
@@ -5813,7 +5813,7 @@
                           </a:solidFill>
                           <a:latin typeface="Calibri"/>
                         </a:rPr>
-                        <a:t>9,97</a:t>
+                        <a:t>10,00</a:t>
                       </a:r>
                     </a:p>
                   </a:txBody>
@@ -6138,7 +6138,7 @@
                 </a:solidFill>
                 <a:latin typeface="Calibri"/>
               </a:rPr>
-              <a:t>Le ratio EV/EBITDA d'Apple est inférieur à la moyenne de son secteur, ce qui indique une valorisation attractive.</a:t>
+              <a:t>ROIC à 84.4% vs 35% pour le secteur tech. EV/Revenue à 9.1x vs médiane peers à 7.8x reflétant la prime qualité.</a:t>
             </a:r>
           </a:p>
         </p:txBody>
@@ -7303,7 +7303,7 @@
                           </a:solidFill>
                           <a:latin typeface="Calibri"/>
                         </a:rPr>
-                        <a:t>280 $</a:t>
+                        <a:t>285 $</a:t>
                       </a:r>
                     </a:p>
                   </a:txBody>
@@ -7391,7 +7391,7 @@
                           </a:solidFill>
                           <a:latin typeface="Calibri"/>
                         </a:rPr>
-                        <a:t>253,38 $</a:t>
+                        <a:t>254,20 $</a:t>
                       </a:r>
                     </a:p>
                   </a:txBody>
@@ -7479,7 +7479,7 @@
                           </a:solidFill>
                           <a:latin typeface="Calibri"/>
                         </a:rPr>
-                        <a:t>+10,7 %</a:t>
+                        <a:t>+12,1 %</a:t>
                       </a:r>
                     </a:p>
                   </a:txBody>
@@ -7622,7 +7622,7 @@
                           </a:solidFill>
                           <a:latin typeface="Calibri"/>
                         </a:rPr>
-                        <a:t>241 $</a:t>
+                        <a:t>240 $</a:t>
                       </a:r>
                     </a:p>
                   </a:txBody>
@@ -7645,7 +7645,7 @@
                           </a:solidFill>
                           <a:latin typeface="Calibri"/>
                         </a:rPr>
-                        <a:t>280 $</a:t>
+                        <a:t>285 $</a:t>
                       </a:r>
                     </a:p>
                   </a:txBody>
@@ -7668,7 +7668,7 @@
                           </a:solidFill>
                           <a:latin typeface="Calibri"/>
                         </a:rPr>
-                        <a:t>310 $</a:t>
+                        <a:t>320 $</a:t>
                       </a:r>
                     </a:p>
                   </a:txBody>
@@ -7693,7 +7693,7 @@
                           </a:solidFill>
                           <a:latin typeface="Calibri"/>
                         </a:rPr>
-                        <a:t>-5,0 %</a:t>
+                        <a:t>-5,6 %</a:t>
                       </a:r>
                     </a:p>
                   </a:txBody>
@@ -7716,7 +7716,7 @@
                           </a:solidFill>
                           <a:latin typeface="Calibri"/>
                         </a:rPr>
-                        <a:t>+10,7 %</a:t>
+                        <a:t>+12,1 %</a:t>
                       </a:r>
                     </a:p>
                   </a:txBody>
@@ -7739,7 +7739,7 @@
                           </a:solidFill>
                           <a:latin typeface="Calibri"/>
                         </a:rPr>
-                        <a:t>+22,4 %</a:t>
+                        <a:t>+25,9 %</a:t>
                       </a:r>
                     </a:p>
                   </a:txBody>
@@ -8203,7 +8203,7 @@
                           </a:solidFill>
                           <a:latin typeface="Calibri"/>
                         </a:rPr>
-                        <a:t>325</a:t>
+                        <a:t>330</a:t>
                       </a:r>
                     </a:p>
                   </a:txBody>
@@ -8246,7 +8246,7 @@
                           </a:solidFill>
                           <a:latin typeface="Calibri"/>
                         </a:rPr>
-                        <a:t>353</a:t>
+                        <a:t>358</a:t>
                       </a:r>
                     </a:p>
                   </a:txBody>
@@ -8289,7 +8289,7 @@
                           </a:solidFill>
                           <a:latin typeface="Calibri"/>
                         </a:rPr>
-                        <a:t>386</a:t>
+                        <a:t>392</a:t>
                       </a:r>
                     </a:p>
                   </a:txBody>
@@ -8332,7 +8332,7 @@
                           </a:solidFill>
                           <a:latin typeface="Calibri"/>
                         </a:rPr>
-                        <a:t>426</a:t>
+                        <a:t>433</a:t>
                       </a:r>
                     </a:p>
                   </a:txBody>
@@ -8375,7 +8375,7 @@
                           </a:solidFill>
                           <a:latin typeface="Calibri"/>
                         </a:rPr>
-                        <a:t>475</a:t>
+                        <a:t>483</a:t>
                       </a:r>
                     </a:p>
                   </a:txBody>
@@ -8463,7 +8463,7 @@
                           </a:solidFill>
                           <a:latin typeface="Calibri"/>
                         </a:rPr>
-                        <a:t>280</a:t>
+                        <a:t>285</a:t>
                       </a:r>
                     </a:p>
                   </a:txBody>
@@ -8506,7 +8506,7 @@
                           </a:solidFill>
                           <a:latin typeface="Calibri"/>
                         </a:rPr>
-                        <a:t>301</a:t>
+                        <a:t>306</a:t>
                       </a:r>
                     </a:p>
                   </a:txBody>
@@ -8549,7 +8549,7 @@
                           </a:solidFill>
                           <a:latin typeface="Calibri"/>
                         </a:rPr>
-                        <a:t>325</a:t>
+                        <a:t>330</a:t>
                       </a:r>
                     </a:p>
                   </a:txBody>
@@ -8592,7 +8592,7 @@
                           </a:solidFill>
                           <a:latin typeface="Calibri"/>
                         </a:rPr>
-                        <a:t>353</a:t>
+                        <a:t>358</a:t>
                       </a:r>
                     </a:p>
                   </a:txBody>
@@ -8635,7 +8635,7 @@
                           </a:solidFill>
                           <a:latin typeface="Calibri"/>
                         </a:rPr>
-                        <a:t>386</a:t>
+                        <a:t>392</a:t>
                       </a:r>
                     </a:p>
                   </a:txBody>
@@ -8723,7 +8723,7 @@
                           </a:solidFill>
                           <a:latin typeface="Calibri"/>
                         </a:rPr>
-                        <a:t>247</a:t>
+                        <a:t>251</a:t>
                       </a:r>
                     </a:p>
                   </a:txBody>
@@ -8766,7 +8766,7 @@
                           </a:solidFill>
                           <a:latin typeface="Calibri"/>
                         </a:rPr>
-                        <a:t>263</a:t>
+                        <a:t>267</a:t>
                       </a:r>
                     </a:p>
                   </a:txBody>
@@ -8809,7 +8809,7 @@
                           </a:solidFill>
                           <a:latin typeface="Calibri"/>
                         </a:rPr>
-                        <a:t>280</a:t>
+                        <a:t>285</a:t>
                       </a:r>
                     </a:p>
                   </a:txBody>
@@ -8852,7 +8852,7 @@
                           </a:solidFill>
                           <a:latin typeface="Calibri"/>
                         </a:rPr>
-                        <a:t>301</a:t>
+                        <a:t>306</a:t>
                       </a:r>
                     </a:p>
                   </a:txBody>
@@ -8895,7 +8895,7 @@
                           </a:solidFill>
                           <a:latin typeface="Calibri"/>
                         </a:rPr>
-                        <a:t>325</a:t>
+                        <a:t>330</a:t>
                       </a:r>
                     </a:p>
                   </a:txBody>
@@ -8983,7 +8983,7 @@
                           </a:solidFill>
                           <a:latin typeface="Calibri"/>
                         </a:rPr>
-                        <a:t>220</a:t>
+                        <a:t>224</a:t>
                       </a:r>
                     </a:p>
                   </a:txBody>
@@ -9026,7 +9026,7 @@
                           </a:solidFill>
                           <a:latin typeface="Calibri"/>
                         </a:rPr>
-                        <a:t>233</a:t>
+                        <a:t>237</a:t>
                       </a:r>
                     </a:p>
                   </a:txBody>
@@ -9069,7 +9069,7 @@
                           </a:solidFill>
                           <a:latin typeface="Calibri"/>
                         </a:rPr>
-                        <a:t>247</a:t>
+                        <a:t>251</a:t>
                       </a:r>
                     </a:p>
                   </a:txBody>
@@ -9112,7 +9112,7 @@
                           </a:solidFill>
                           <a:latin typeface="Calibri"/>
                         </a:rPr>
-                        <a:t>263</a:t>
+                        <a:t>267</a:t>
                       </a:r>
                     </a:p>
                   </a:txBody>
@@ -9155,7 +9155,7 @@
                           </a:solidFill>
                           <a:latin typeface="Calibri"/>
                         </a:rPr>
-                        <a:t>281</a:t>
+                        <a:t>285</a:t>
                       </a:r>
                     </a:p>
                   </a:txBody>
@@ -9243,7 +9243,7 @@
                           </a:solidFill>
                           <a:latin typeface="Calibri"/>
                         </a:rPr>
-                        <a:t>199</a:t>
+                        <a:t>202</a:t>
                       </a:r>
                     </a:p>
                   </a:txBody>
@@ -9286,7 +9286,7 @@
                           </a:solidFill>
                           <a:latin typeface="Calibri"/>
                         </a:rPr>
-                        <a:t>209</a:t>
+                        <a:t>212</a:t>
                       </a:r>
                     </a:p>
                   </a:txBody>
@@ -9329,7 +9329,7 @@
                           </a:solidFill>
                           <a:latin typeface="Calibri"/>
                         </a:rPr>
-                        <a:t>220</a:t>
+                        <a:t>224</a:t>
                       </a:r>
                     </a:p>
                   </a:txBody>
@@ -9372,7 +9372,7 @@
                           </a:solidFill>
                           <a:latin typeface="Calibri"/>
                         </a:rPr>
-                        <a:t>233</a:t>
+                        <a:t>237</a:t>
                       </a:r>
                     </a:p>
                   </a:txBody>
@@ -9415,7 +9415,7 @@
                           </a:solidFill>
                           <a:latin typeface="Calibri"/>
                         </a:rPr>
-                        <a:t>247</a:t>
+                        <a:t>251</a:t>
                       </a:r>
                     </a:p>
                   </a:txBody>
@@ -9480,7 +9480,7 @@
                 </a:solidFill>
                 <a:latin typeface="Calibri"/>
               </a:rPr>
-              <a:t>Le prix implicite d'Apple sur la base d'un modèle de flux de trésorerie disponible est de 280,5 USD, ce qui suggère un upside de 10% par rapport au cours actuel.</a:t>
+              <a:t>WACC 10.3% avec TGR 3.0% implique un upside de 12% vs cours actuel. Valorisation DCF à 285$ justifiée par croissance services et rachats d'actions.</a:t>
             </a:r>
           </a:p>
         </p:txBody>
@@ -10358,7 +10358,7 @@
                           </a:solidFill>
                           <a:latin typeface="Calibri"/>
                         </a:rPr>
-                        <a:t>3 719,9</a:t>
+                        <a:t>3 731,9</a:t>
                       </a:r>
                     </a:p>
                   </a:txBody>
@@ -10381,7 +10381,7 @@
                           </a:solidFill>
                           <a:latin typeface="Calibri"/>
                         </a:rPr>
-                        <a:t>26,1x</a:t>
+                        <a:t>26,2x</a:t>
                       </a:r>
                     </a:p>
                   </a:txBody>
@@ -10427,7 +10427,7 @@
                           </a:solidFill>
                           <a:latin typeface="Calibri"/>
                         </a:rPr>
-                        <a:t>33,2x</a:t>
+                        <a:t>33,3x</a:t>
                       </a:r>
                     </a:p>
                   </a:txBody>
@@ -10544,7 +10544,7 @@
                           </a:solidFill>
                           <a:latin typeface="Calibri"/>
                         </a:rPr>
-                        <a:t>2 351,9</a:t>
+                        <a:t>3 200,0</a:t>
                       </a:r>
                     </a:p>
                   </a:txBody>
@@ -10567,7 +10567,7 @@
                           </a:solidFill>
                           <a:latin typeface="Calibri"/>
                         </a:rPr>
-                        <a:t>23,1x</a:t>
+                        <a:t>25,0x</a:t>
                       </a:r>
                     </a:p>
                   </a:txBody>
@@ -10590,7 +10590,7 @@
                           </a:solidFill>
                           <a:latin typeface="Calibri"/>
                         </a:rPr>
-                        <a:t>8,5x</a:t>
+                        <a:t>14,5x</a:t>
                       </a:r>
                     </a:p>
                   </a:txBody>
@@ -10613,7 +10613,7 @@
                           </a:solidFill>
                           <a:latin typeface="Calibri"/>
                         </a:rPr>
-                        <a:t>34,2x</a:t>
+                        <a:t>38,0x</a:t>
                       </a:r>
                     </a:p>
                   </a:txBody>
@@ -10659,7 +10659,7 @@
                           </a:solidFill>
                           <a:latin typeface="Calibri"/>
                         </a:rPr>
-                        <a:t>43,0 %</a:t>
+                        <a:t>48,0 %</a:t>
                       </a:r>
                     </a:p>
                   </a:txBody>
@@ -10730,7 +10730,7 @@
                           </a:solidFill>
                           <a:latin typeface="Calibri"/>
                         </a:rPr>
-                        <a:t>1 571,9</a:t>
+                        <a:t>2 100,0</a:t>
                       </a:r>
                     </a:p>
                   </a:txBody>
@@ -10753,7 +10753,7 @@
                           </a:solidFill>
                           <a:latin typeface="Calibri"/>
                         </a:rPr>
-                        <a:t>20,5x</a:t>
+                        <a:t>22,0x</a:t>
                       </a:r>
                     </a:p>
                   </a:txBody>
@@ -10776,7 +10776,7 @@
                           </a:solidFill>
                           <a:latin typeface="Calibri"/>
                         </a:rPr>
-                        <a:t>7,3x</a:t>
+                        <a:t>9,5x</a:t>
                       </a:r>
                     </a:p>
                   </a:txBody>
@@ -10799,7 +10799,7 @@
                           </a:solidFill>
                           <a:latin typeface="Calibri"/>
                         </a:rPr>
-                        <a:t>29,1x</a:t>
+                        <a:t>28,0x</a:t>
                       </a:r>
                     </a:p>
                   </a:txBody>
@@ -10822,7 +10822,7 @@
                           </a:solidFill>
                           <a:latin typeface="Calibri"/>
                         </a:rPr>
-                        <a:t>55,0 %</a:t>
+                        <a:t>56,0 %</a:t>
                       </a:r>
                     </a:p>
                   </a:txBody>
@@ -10845,7 +10845,7 @@
                           </a:solidFill>
                           <a:latin typeface="Calibri"/>
                         </a:rPr>
-                        <a:t>32,0 %</a:t>
+                        <a:t>35,0 %</a:t>
                       </a:r>
                     </a:p>
                   </a:txBody>
@@ -10870,7 +10870,7 @@
                           </a:solidFill>
                           <a:latin typeface="Calibri"/>
                         </a:rPr>
-                        <a:t>Amazon</a:t>
+                        <a:t>Samsung Electronics</a:t>
                       </a:r>
                     </a:p>
                   </a:txBody>
@@ -10893,7 +10893,7 @@
                           </a:solidFill>
                           <a:latin typeface="Calibri"/>
                         </a:rPr>
-                        <a:t>AMZN</a:t>
+                        <a:t>005930.KS</a:t>
                       </a:r>
                     </a:p>
                   </a:txBody>
@@ -10916,7 +10916,7 @@
                           </a:solidFill>
                           <a:latin typeface="Calibri"/>
                         </a:rPr>
-                        <a:t>1 034,9</a:t>
+                        <a:t>450,0</a:t>
                       </a:r>
                     </a:p>
                   </a:txBody>
@@ -10939,7 +10939,7 @@
                           </a:solidFill>
                           <a:latin typeface="Calibri"/>
                         </a:rPr>
-                        <a:t>18,3x</a:t>
+                        <a:t>7,5x</a:t>
                       </a:r>
                     </a:p>
                   </a:txBody>
@@ -10962,7 +10962,7 @@
                           </a:solidFill>
                           <a:latin typeface="Calibri"/>
                         </a:rPr>
-                        <a:t>6,5x</a:t>
+                        <a:t>1,2x</a:t>
                       </a:r>
                     </a:p>
                   </a:txBody>
@@ -10985,7 +10985,7 @@
                           </a:solidFill>
                           <a:latin typeface="Calibri"/>
                         </a:rPr>
-                        <a:t>24,5x</a:t>
+                        <a:t>12,0x</a:t>
                       </a:r>
                     </a:p>
                   </a:txBody>
@@ -11008,7 +11008,7 @@
                           </a:solidFill>
                           <a:latin typeface="Calibri"/>
                         </a:rPr>
-                        <a:t>42,0 %</a:t>
+                        <a:t>52,0 %</a:t>
                       </a:r>
                     </a:p>
                   </a:txBody>
@@ -11031,7 +11031,7 @@
                           </a:solidFill>
                           <a:latin typeface="Calibri"/>
                         </a:rPr>
-                        <a:t>25,0 %</a:t>
+                        <a:t>22,0 %</a:t>
                       </a:r>
                     </a:p>
                   </a:txBody>
@@ -11056,7 +11056,7 @@
                           </a:solidFill>
                           <a:latin typeface="Calibri"/>
                         </a:rPr>
-                        <a:t>Facebook</a:t>
+                        <a:t>Meta Platforms</a:t>
                       </a:r>
                     </a:p>
                   </a:txBody>
@@ -11102,7 +11102,7 @@
                           </a:solidFill>
                           <a:latin typeface="Calibri"/>
                         </a:rPr>
-                        <a:t>846,9</a:t>
+                        <a:t>1 500,0</a:t>
                       </a:r>
                     </a:p>
                   </a:txBody>
@@ -11125,7 +11125,7 @@
                           </a:solidFill>
                           <a:latin typeface="Calibri"/>
                         </a:rPr>
-                        <a:t>16,2x</a:t>
+                        <a:t>18,0x</a:t>
                       </a:r>
                     </a:p>
                   </a:txBody>
@@ -11148,7 +11148,7 @@
                           </a:solidFill>
                           <a:latin typeface="Calibri"/>
                         </a:rPr>
-                        <a:t>5,8x</a:t>
+                        <a:t>10,5x</a:t>
                       </a:r>
                     </a:p>
                   </a:txBody>
@@ -11171,7 +11171,7 @@
                           </a:solidFill>
                           <a:latin typeface="Calibri"/>
                         </a:rPr>
-                        <a:t>20,5x</a:t>
+                        <a:t>30,0x</a:t>
                       </a:r>
                     </a:p>
                   </a:txBody>
@@ -11194,7 +11194,7 @@
                           </a:solidFill>
                           <a:latin typeface="Calibri"/>
                         </a:rPr>
-                        <a:t>38,0 %</a:t>
+                        <a:t>85,0 %</a:t>
                       </a:r>
                     </a:p>
                   </a:txBody>
@@ -11217,7 +11217,7 @@
                           </a:solidFill>
                           <a:latin typeface="Calibri"/>
                         </a:rPr>
-                        <a:t>22,0 %</a:t>
+                        <a:t>55,0 %</a:t>
                       </a:r>
                     </a:p>
                   </a:txBody>
@@ -11242,7 +11242,7 @@
                           </a:solidFill>
                           <a:latin typeface="Calibri"/>
                         </a:rPr>
-                        <a:t>Tesla</a:t>
+                        <a:t>NVIDIA</a:t>
                       </a:r>
                     </a:p>
                   </a:txBody>
@@ -11265,7 +11265,7 @@
                           </a:solidFill>
                           <a:latin typeface="Calibri"/>
                         </a:rPr>
-                        <a:t>TSLA</a:t>
+                        <a:t>NVDA</a:t>
                       </a:r>
                     </a:p>
                   </a:txBody>
@@ -11288,7 +11288,7 @@
                           </a:solidFill>
                           <a:latin typeface="Calibri"/>
                         </a:rPr>
-                        <a:t>574,9</a:t>
+                        <a:t>2 300,0</a:t>
                       </a:r>
                     </a:p>
                   </a:txBody>
@@ -11311,7 +11311,7 @@
                           </a:solidFill>
                           <a:latin typeface="Calibri"/>
                         </a:rPr>
-                        <a:t>24,9x</a:t>
+                        <a:t>55,0x</a:t>
                       </a:r>
                     </a:p>
                   </a:txBody>
@@ -11334,7 +11334,7 @@
                           </a:solidFill>
                           <a:latin typeface="Calibri"/>
                         </a:rPr>
-                        <a:t>9,2x</a:t>
+                        <a:t>25,0x</a:t>
                       </a:r>
                     </a:p>
                   </a:txBody>
@@ -11357,7 +11357,7 @@
                           </a:solidFill>
                           <a:latin typeface="Calibri"/>
                         </a:rPr>
-                        <a:t>35,1x</a:t>
+                        <a:t>45,0x</a:t>
                       </a:r>
                     </a:p>
                   </a:txBody>
@@ -11380,7 +11380,7 @@
                           </a:solidFill>
                           <a:latin typeface="Calibri"/>
                         </a:rPr>
-                        <a:t>25,0 %</a:t>
+                        <a:t>75,0 %</a:t>
                       </a:r>
                     </a:p>
                   </a:txBody>
@@ -11403,7 +11403,7 @@
                           </a:solidFill>
                           <a:latin typeface="Calibri"/>
                         </a:rPr>
-                        <a:t>15,0 %</a:t>
+                        <a:t>65,0 %</a:t>
                       </a:r>
                     </a:p>
                   </a:txBody>
@@ -11497,7 +11497,7 @@
                           </a:solidFill>
                           <a:latin typeface="Calibri"/>
                         </a:rPr>
-                        <a:t>20,5x</a:t>
+                        <a:t>22,0x</a:t>
                       </a:r>
                     </a:p>
                   </a:txBody>
@@ -11520,7 +11520,7 @@
                           </a:solidFill>
                           <a:latin typeface="Calibri"/>
                         </a:rPr>
-                        <a:t>7,3x</a:t>
+                        <a:t>10,5x</a:t>
                       </a:r>
                     </a:p>
                   </a:txBody>
@@ -11543,7 +11543,7 @@
                           </a:solidFill>
                           <a:latin typeface="Calibri"/>
                         </a:rPr>
-                        <a:t>29,1x</a:t>
+                        <a:t>30,0x</a:t>
                       </a:r>
                     </a:p>
                   </a:txBody>
@@ -11566,7 +11566,7 @@
                           </a:solidFill>
                           <a:latin typeface="Calibri"/>
                         </a:rPr>
-                        <a:t>42,0 %</a:t>
+                        <a:t>68,0 %</a:t>
                       </a:r>
                     </a:p>
                   </a:txBody>
@@ -11589,7 +11589,7 @@
                           </a:solidFill>
                           <a:latin typeface="Calibri"/>
                         </a:rPr>
-                        <a:t>25,0 %</a:t>
+                        <a:t>48,0 %</a:t>
                       </a:r>
                     </a:p>
                   </a:txBody>
@@ -11634,7 +11634,7 @@
                 </a:solidFill>
                 <a:latin typeface="Calibri"/>
               </a:rPr>
-              <a:t>Le ratio EV/EBITDA d'Apple est inférieur à la moyenne de son secteur, ce qui indique une valorisation attractive.</a:t>
+              <a:t>ROIC à 84.4% vs 35% pour le secteur tech. EV/Revenue à 9.1x vs médiane peers à 7.8x reflétant la prime qualité.</a:t>
             </a:r>
           </a:p>
         </p:txBody>
@@ -12238,786 +12238,30 @@
           </a:p>
         </p:txBody>
       </p:sp>
-      <p:graphicFrame>
-        <p:nvGraphicFramePr>
-          <p:cNvPr id="17" name="Table 16"/>
-          <p:cNvGraphicFramePr>
-            <a:graphicFrameLocks noGrp="1"/>
-          </p:cNvGraphicFramePr>
-          <p:nvPr/>
-        </p:nvGraphicFramePr>
-        <p:xfrm>
-          <a:off x="367200" y="914400"/>
-          <a:ext cx="8413200" cy="2149200"/>
-        </p:xfrm>
-        <a:graphic>
-          <a:graphicData uri="http://schemas.openxmlformats.org/drawingml/2006/table">
-            <a:tbl>
-              <a:tblPr firstRow="1" bandRow="1">
-                <a:tableStyleId>{5C22544A-7EE6-4342-B048-85BDC9FD1C3A}</a:tableStyleId>
-              </a:tblPr>
-              <a:tblGrid>
-                <a:gridCol w="2944620"/>
-                <a:gridCol w="1682640"/>
-                <a:gridCol w="1682640"/>
-                <a:gridCol w="2103300"/>
-              </a:tblGrid>
-              <a:tr h="268650">
-                <a:tc>
-                  <a:txBody>
-                    <a:bodyPr/>
-                    <a:lstStyle/>
-                    <a:p>
-                      <a:pPr algn="l"/>
-                      <a:r>
-                        <a:rPr sz="800" b="1" i="0">
-                          <a:solidFill>
-                            <a:srgbClr val="FFFFFF"/>
-                          </a:solidFill>
-                          <a:latin typeface="Calibri"/>
-                        </a:rPr>
-                        <a:t>Methode</a:t>
-                      </a:r>
-                    </a:p>
-                  </a:txBody>
-                  <a:tcPr>
-                    <a:solidFill>
-                      <a:srgbClr val="1B3A6B"/>
-                    </a:solidFill>
-                  </a:tcPr>
-                </a:tc>
-                <a:tc>
-                  <a:txBody>
-                    <a:bodyPr/>
-                    <a:lstStyle/>
-                    <a:p>
-                      <a:pPr algn="ctr"/>
-                      <a:r>
-                        <a:rPr sz="800" b="1" i="0">
-                          <a:solidFill>
-                            <a:srgbClr val="FFFFFF"/>
-                          </a:solidFill>
-                          <a:latin typeface="Calibri"/>
-                        </a:rPr>
-                        <a:t>Fourchette basse</a:t>
-                      </a:r>
-                    </a:p>
-                  </a:txBody>
-                  <a:tcPr>
-                    <a:solidFill>
-                      <a:srgbClr val="1B3A6B"/>
-                    </a:solidFill>
-                  </a:tcPr>
-                </a:tc>
-                <a:tc>
-                  <a:txBody>
-                    <a:bodyPr/>
-                    <a:lstStyle/>
-                    <a:p>
-                      <a:pPr algn="ctr"/>
-                      <a:r>
-                        <a:rPr sz="800" b="1" i="0">
-                          <a:solidFill>
-                            <a:srgbClr val="FFFFFF"/>
-                          </a:solidFill>
-                          <a:latin typeface="Calibri"/>
-                        </a:rPr>
-                        <a:t>Fourchette haute</a:t>
-                      </a:r>
-                    </a:p>
-                  </a:txBody>
-                  <a:tcPr>
-                    <a:solidFill>
-                      <a:srgbClr val="1B3A6B"/>
-                    </a:solidFill>
-                  </a:tcPr>
-                </a:tc>
-                <a:tc>
-                  <a:txBody>
-                    <a:bodyPr/>
-                    <a:lstStyle/>
-                    <a:p>
-                      <a:pPr algn="ctr"/>
-                      <a:r>
-                        <a:rPr sz="800" b="1" i="0">
-                          <a:solidFill>
-                            <a:srgbClr val="FFFFFF"/>
-                          </a:solidFill>
-                          <a:latin typeface="Calibri"/>
-                        </a:rPr>
-                        <a:t>Point central</a:t>
-                      </a:r>
-                    </a:p>
-                  </a:txBody>
-                  <a:tcPr>
-                    <a:solidFill>
-                      <a:srgbClr val="1B3A6B"/>
-                    </a:solidFill>
-                  </a:tcPr>
-                </a:tc>
-              </a:tr>
-              <a:tr h="268650">
-                <a:tc>
-                  <a:txBody>
-                    <a:bodyPr/>
-                    <a:lstStyle/>
-                    <a:p>
-                      <a:pPr algn="l"/>
-                      <a:r>
-                        <a:rPr sz="800" b="0" i="0">
-                          <a:solidFill>
-                            <a:srgbClr val="0D0D0D"/>
-                          </a:solidFill>
-                          <a:latin typeface="Calibri"/>
-                        </a:rPr>
-                        <a:t>DCF - Bear</a:t>
-                      </a:r>
-                    </a:p>
-                  </a:txBody>
-                  <a:tcPr>
-                    <a:solidFill>
-                      <a:srgbClr val="FAF0EF"/>
-                    </a:solidFill>
-                  </a:tcPr>
-                </a:tc>
-                <a:tc>
-                  <a:txBody>
-                    <a:bodyPr/>
-                    <a:lstStyle/>
-                    <a:p>
-                      <a:pPr algn="ctr"/>
-                      <a:r>
-                        <a:rPr sz="800" b="0" i="0">
-                          <a:solidFill>
-                            <a:srgbClr val="0D0D0D"/>
-                          </a:solidFill>
-                          <a:latin typeface="Calibri"/>
-                        </a:rPr>
-                        <a:t>220</a:t>
-                      </a:r>
-                    </a:p>
-                  </a:txBody>
-                  <a:tcPr>
-                    <a:solidFill>
-                      <a:srgbClr val="FAF0EF"/>
-                    </a:solidFill>
-                  </a:tcPr>
-                </a:tc>
-                <a:tc>
-                  <a:txBody>
-                    <a:bodyPr/>
-                    <a:lstStyle/>
-                    <a:p>
-                      <a:pPr algn="ctr"/>
-                      <a:r>
-                        <a:rPr sz="800" b="0" i="0">
-                          <a:solidFill>
-                            <a:srgbClr val="0D0D0D"/>
-                          </a:solidFill>
-                          <a:latin typeface="Calibri"/>
-                        </a:rPr>
-                        <a:t>250</a:t>
-                      </a:r>
-                    </a:p>
-                  </a:txBody>
-                  <a:tcPr>
-                    <a:solidFill>
-                      <a:srgbClr val="FAF0EF"/>
-                    </a:solidFill>
-                  </a:tcPr>
-                </a:tc>
-                <a:tc>
-                  <a:txBody>
-                    <a:bodyPr/>
-                    <a:lstStyle/>
-                    <a:p>
-                      <a:pPr algn="ctr"/>
-                      <a:r>
-                        <a:rPr sz="800" b="0" i="0">
-                          <a:solidFill>
-                            <a:srgbClr val="0D0D0D"/>
-                          </a:solidFill>
-                          <a:latin typeface="Calibri"/>
-                        </a:rPr>
-                        <a:t>241</a:t>
-                      </a:r>
-                    </a:p>
-                  </a:txBody>
-                  <a:tcPr>
-                    <a:solidFill>
-                      <a:srgbClr val="FAF0EF"/>
-                    </a:solidFill>
-                  </a:tcPr>
-                </a:tc>
-              </a:tr>
-              <a:tr h="268650">
-                <a:tc>
-                  <a:txBody>
-                    <a:bodyPr/>
-                    <a:lstStyle/>
-                    <a:p>
-                      <a:pPr algn="l"/>
-                      <a:r>
-                        <a:rPr sz="800" b="0" i="0">
-                          <a:solidFill>
-                            <a:srgbClr val="0D0D0D"/>
-                          </a:solidFill>
-                          <a:latin typeface="Calibri"/>
-                        </a:rPr>
-                        <a:t>DCF - Base</a:t>
-                      </a:r>
-                    </a:p>
-                  </a:txBody>
-                  <a:tcPr>
-                    <a:solidFill>
-                      <a:srgbClr val="EEF3FA"/>
-                    </a:solidFill>
-                  </a:tcPr>
-                </a:tc>
-                <a:tc>
-                  <a:txBody>
-                    <a:bodyPr/>
-                    <a:lstStyle/>
-                    <a:p>
-                      <a:pPr algn="ctr"/>
-                      <a:r>
-                        <a:rPr sz="800" b="0" i="0">
-                          <a:solidFill>
-                            <a:srgbClr val="0D0D0D"/>
-                          </a:solidFill>
-                          <a:latin typeface="Calibri"/>
-                        </a:rPr>
-                        <a:t>250</a:t>
-                      </a:r>
-                    </a:p>
-                  </a:txBody>
-                  <a:tcPr>
-                    <a:solidFill>
-                      <a:srgbClr val="EEF3FA"/>
-                    </a:solidFill>
-                  </a:tcPr>
-                </a:tc>
-                <a:tc>
-                  <a:txBody>
-                    <a:bodyPr/>
-                    <a:lstStyle/>
-                    <a:p>
-                      <a:pPr algn="ctr"/>
-                      <a:r>
-                        <a:rPr sz="800" b="0" i="0">
-                          <a:solidFill>
-                            <a:srgbClr val="0D0D0D"/>
-                          </a:solidFill>
-                          <a:latin typeface="Calibri"/>
-                        </a:rPr>
-                        <a:t>300</a:t>
-                      </a:r>
-                    </a:p>
-                  </a:txBody>
-                  <a:tcPr>
-                    <a:solidFill>
-                      <a:srgbClr val="EEF3FA"/>
-                    </a:solidFill>
-                  </a:tcPr>
-                </a:tc>
-                <a:tc>
-                  <a:txBody>
-                    <a:bodyPr/>
-                    <a:lstStyle/>
-                    <a:p>
-                      <a:pPr algn="ctr"/>
-                      <a:r>
-                        <a:rPr sz="800" b="0" i="0">
-                          <a:solidFill>
-                            <a:srgbClr val="0D0D0D"/>
-                          </a:solidFill>
-                          <a:latin typeface="Calibri"/>
-                        </a:rPr>
-                        <a:t>280</a:t>
-                      </a:r>
-                    </a:p>
-                  </a:txBody>
-                  <a:tcPr>
-                    <a:solidFill>
-                      <a:srgbClr val="EEF3FA"/>
-                    </a:solidFill>
-                  </a:tcPr>
-                </a:tc>
-              </a:tr>
-              <a:tr h="268650">
-                <a:tc>
-                  <a:txBody>
-                    <a:bodyPr/>
-                    <a:lstStyle/>
-                    <a:p>
-                      <a:pPr algn="l"/>
-                      <a:r>
-                        <a:rPr sz="800" b="0" i="0">
-                          <a:solidFill>
-                            <a:srgbClr val="0D0D0D"/>
-                          </a:solidFill>
-                          <a:latin typeface="Calibri"/>
-                        </a:rPr>
-                        <a:t>DCF - Bull</a:t>
-                      </a:r>
-                    </a:p>
-                  </a:txBody>
-                  <a:tcPr>
-                    <a:solidFill>
-                      <a:srgbClr val="EAF4EF"/>
-                    </a:solidFill>
-                  </a:tcPr>
-                </a:tc>
-                <a:tc>
-                  <a:txBody>
-                    <a:bodyPr/>
-                    <a:lstStyle/>
-                    <a:p>
-                      <a:pPr algn="ctr"/>
-                      <a:r>
-                        <a:rPr sz="800" b="0" i="0">
-                          <a:solidFill>
-                            <a:srgbClr val="0D0D0D"/>
-                          </a:solidFill>
-                          <a:latin typeface="Calibri"/>
-                        </a:rPr>
-                        <a:t>300</a:t>
-                      </a:r>
-                    </a:p>
-                  </a:txBody>
-                  <a:tcPr>
-                    <a:solidFill>
-                      <a:srgbClr val="EAF4EF"/>
-                    </a:solidFill>
-                  </a:tcPr>
-                </a:tc>
-                <a:tc>
-                  <a:txBody>
-                    <a:bodyPr/>
-                    <a:lstStyle/>
-                    <a:p>
-                      <a:pPr algn="ctr"/>
-                      <a:r>
-                        <a:rPr sz="800" b="0" i="0">
-                          <a:solidFill>
-                            <a:srgbClr val="0D0D0D"/>
-                          </a:solidFill>
-                          <a:latin typeface="Calibri"/>
-                        </a:rPr>
-                        <a:t>350</a:t>
-                      </a:r>
-                    </a:p>
-                  </a:txBody>
-                  <a:tcPr>
-                    <a:solidFill>
-                      <a:srgbClr val="EAF4EF"/>
-                    </a:solidFill>
-                  </a:tcPr>
-                </a:tc>
-                <a:tc>
-                  <a:txBody>
-                    <a:bodyPr/>
-                    <a:lstStyle/>
-                    <a:p>
-                      <a:pPr algn="ctr"/>
-                      <a:r>
-                        <a:rPr sz="800" b="0" i="0">
-                          <a:solidFill>
-                            <a:srgbClr val="0D0D0D"/>
-                          </a:solidFill>
-                          <a:latin typeface="Calibri"/>
-                        </a:rPr>
-                        <a:t>310</a:t>
-                      </a:r>
-                    </a:p>
-                  </a:txBody>
-                  <a:tcPr>
-                    <a:solidFill>
-                      <a:srgbClr val="EAF4EF"/>
-                    </a:solidFill>
-                  </a:tcPr>
-                </a:tc>
-              </a:tr>
-              <a:tr h="268650">
-                <a:tc>
-                  <a:txBody>
-                    <a:bodyPr/>
-                    <a:lstStyle/>
-                    <a:p>
-                      <a:pPr algn="l"/>
-                      <a:r>
-                        <a:rPr sz="800" b="0" i="0">
-                          <a:solidFill>
-                            <a:srgbClr val="0D0D0D"/>
-                          </a:solidFill>
-                          <a:latin typeface="Calibri"/>
-                        </a:rPr>
-                        <a:t>EV/EBITDA - Mediane peers</a:t>
-                      </a:r>
-                    </a:p>
-                  </a:txBody>
-                  <a:tcPr>
-                    <a:solidFill>
-                      <a:srgbClr val="F7F8FA"/>
-                    </a:solidFill>
-                  </a:tcPr>
-                </a:tc>
-                <a:tc>
-                  <a:txBody>
-                    <a:bodyPr/>
-                    <a:lstStyle/>
-                    <a:p>
-                      <a:pPr algn="ctr"/>
-                      <a:r>
-                        <a:rPr sz="800" b="0" i="0">
-                          <a:solidFill>
-                            <a:srgbClr val="0D0D0D"/>
-                          </a:solidFill>
-                          <a:latin typeface="Calibri"/>
-                        </a:rPr>
-                        <a:t>240</a:t>
-                      </a:r>
-                    </a:p>
-                  </a:txBody>
-                  <a:tcPr>
-                    <a:solidFill>
-                      <a:srgbClr val="F7F8FA"/>
-                    </a:solidFill>
-                  </a:tcPr>
-                </a:tc>
-                <a:tc>
-                  <a:txBody>
-                    <a:bodyPr/>
-                    <a:lstStyle/>
-                    <a:p>
-                      <a:pPr algn="ctr"/>
-                      <a:r>
-                        <a:rPr sz="800" b="0" i="0">
-                          <a:solidFill>
-                            <a:srgbClr val="0D0D0D"/>
-                          </a:solidFill>
-                          <a:latin typeface="Calibri"/>
-                        </a:rPr>
-                        <a:t>280</a:t>
-                      </a:r>
-                    </a:p>
-                  </a:txBody>
-                  <a:tcPr>
-                    <a:solidFill>
-                      <a:srgbClr val="F7F8FA"/>
-                    </a:solidFill>
-                  </a:tcPr>
-                </a:tc>
-                <a:tc>
-                  <a:txBody>
-                    <a:bodyPr/>
-                    <a:lstStyle/>
-                    <a:p>
-                      <a:pPr algn="ctr"/>
-                      <a:r>
-                        <a:rPr sz="800" b="0" i="0">
-                          <a:solidFill>
-                            <a:srgbClr val="0D0D0D"/>
-                          </a:solidFill>
-                          <a:latin typeface="Calibri"/>
-                        </a:rPr>
-                        <a:t>260</a:t>
-                      </a:r>
-                    </a:p>
-                  </a:txBody>
-                  <a:tcPr>
-                    <a:solidFill>
-                      <a:srgbClr val="F7F8FA"/>
-                    </a:solidFill>
-                  </a:tcPr>
-                </a:tc>
-              </a:tr>
-              <a:tr h="268650">
-                <a:tc>
-                  <a:txBody>
-                    <a:bodyPr/>
-                    <a:lstStyle/>
-                    <a:p>
-                      <a:pPr algn="l"/>
-                      <a:r>
-                        <a:rPr sz="800" b="0" i="0">
-                          <a:solidFill>
-                            <a:srgbClr val="0D0D0D"/>
-                          </a:solidFill>
-                          <a:latin typeface="Calibri"/>
-                        </a:rPr>
-                        <a:t>EV/EBITDA - Prime tech +50%</a:t>
-                      </a:r>
-                    </a:p>
-                  </a:txBody>
-                  <a:tcPr>
-                    <a:solidFill>
-                      <a:srgbClr val="F7F8FA"/>
-                    </a:solidFill>
-                  </a:tcPr>
-                </a:tc>
-                <a:tc>
-                  <a:txBody>
-                    <a:bodyPr/>
-                    <a:lstStyle/>
-                    <a:p>
-                      <a:pPr algn="ctr"/>
-                      <a:r>
-                        <a:rPr sz="800" b="0" i="0">
-                          <a:solidFill>
-                            <a:srgbClr val="0D0D0D"/>
-                          </a:solidFill>
-                          <a:latin typeface="Calibri"/>
-                        </a:rPr>
-                        <a:t>280</a:t>
-                      </a:r>
-                    </a:p>
-                  </a:txBody>
-                  <a:tcPr>
-                    <a:solidFill>
-                      <a:srgbClr val="F7F8FA"/>
-                    </a:solidFill>
-                  </a:tcPr>
-                </a:tc>
-                <a:tc>
-                  <a:txBody>
-                    <a:bodyPr/>
-                    <a:lstStyle/>
-                    <a:p>
-                      <a:pPr algn="ctr"/>
-                      <a:r>
-                        <a:rPr sz="800" b="0" i="0">
-                          <a:solidFill>
-                            <a:srgbClr val="0D0D0D"/>
-                          </a:solidFill>
-                          <a:latin typeface="Calibri"/>
-                        </a:rPr>
-                        <a:t>330</a:t>
-                      </a:r>
-                    </a:p>
-                  </a:txBody>
-                  <a:tcPr>
-                    <a:solidFill>
-                      <a:srgbClr val="F7F8FA"/>
-                    </a:solidFill>
-                  </a:tcPr>
-                </a:tc>
-                <a:tc>
-                  <a:txBody>
-                    <a:bodyPr/>
-                    <a:lstStyle/>
-                    <a:p>
-                      <a:pPr algn="ctr"/>
-                      <a:r>
-                        <a:rPr sz="800" b="0" i="0">
-                          <a:solidFill>
-                            <a:srgbClr val="0D0D0D"/>
-                          </a:solidFill>
-                          <a:latin typeface="Calibri"/>
-                        </a:rPr>
-                        <a:t>300</a:t>
-                      </a:r>
-                    </a:p>
-                  </a:txBody>
-                  <a:tcPr>
-                    <a:solidFill>
-                      <a:srgbClr val="F7F8FA"/>
-                    </a:solidFill>
-                  </a:tcPr>
-                </a:tc>
-              </a:tr>
-              <a:tr h="268650">
-                <a:tc>
-                  <a:txBody>
-                    <a:bodyPr/>
-                    <a:lstStyle/>
-                    <a:p>
-                      <a:pPr algn="l"/>
-                      <a:r>
-                        <a:rPr sz="800" b="0" i="0">
-                          <a:solidFill>
-                            <a:srgbClr val="0D0D0D"/>
-                          </a:solidFill>
-                          <a:latin typeface="Calibri"/>
-                        </a:rPr>
-                        <a:t>EV/Revenue - Mediane peers</a:t>
-                      </a:r>
-                    </a:p>
-                  </a:txBody>
-                  <a:tcPr>
-                    <a:solidFill>
-                      <a:srgbClr val="F7F8FA"/>
-                    </a:solidFill>
-                  </a:tcPr>
-                </a:tc>
-                <a:tc>
-                  <a:txBody>
-                    <a:bodyPr/>
-                    <a:lstStyle/>
-                    <a:p>
-                      <a:pPr algn="ctr"/>
-                      <a:r>
-                        <a:rPr sz="800" b="0" i="0">
-                          <a:solidFill>
-                            <a:srgbClr val="0D0D0D"/>
-                          </a:solidFill>
-                          <a:latin typeface="Calibri"/>
-                        </a:rPr>
-                        <a:t>200</a:t>
-                      </a:r>
-                    </a:p>
-                  </a:txBody>
-                  <a:tcPr>
-                    <a:solidFill>
-                      <a:srgbClr val="F7F8FA"/>
-                    </a:solidFill>
-                  </a:tcPr>
-                </a:tc>
-                <a:tc>
-                  <a:txBody>
-                    <a:bodyPr/>
-                    <a:lstStyle/>
-                    <a:p>
-                      <a:pPr algn="ctr"/>
-                      <a:r>
-                        <a:rPr sz="800" b="0" i="0">
-                          <a:solidFill>
-                            <a:srgbClr val="0D0D0D"/>
-                          </a:solidFill>
-                          <a:latin typeface="Calibri"/>
-                        </a:rPr>
-                        <a:t>240</a:t>
-                      </a:r>
-                    </a:p>
-                  </a:txBody>
-                  <a:tcPr>
-                    <a:solidFill>
-                      <a:srgbClr val="F7F8FA"/>
-                    </a:solidFill>
-                  </a:tcPr>
-                </a:tc>
-                <a:tc>
-                  <a:txBody>
-                    <a:bodyPr/>
-                    <a:lstStyle/>
-                    <a:p>
-                      <a:pPr algn="ctr"/>
-                      <a:r>
-                        <a:rPr sz="800" b="0" i="0">
-                          <a:solidFill>
-                            <a:srgbClr val="0D0D0D"/>
-                          </a:solidFill>
-                          <a:latin typeface="Calibri"/>
-                        </a:rPr>
-                        <a:t>220</a:t>
-                      </a:r>
-                    </a:p>
-                  </a:txBody>
-                  <a:tcPr>
-                    <a:solidFill>
-                      <a:srgbClr val="F7F8FA"/>
-                    </a:solidFill>
-                  </a:tcPr>
-                </a:tc>
-              </a:tr>
-              <a:tr h="268650">
-                <a:tc>
-                  <a:txBody>
-                    <a:bodyPr/>
-                    <a:lstStyle/>
-                    <a:p>
-                      <a:pPr algn="l"/>
-                      <a:r>
-                        <a:rPr sz="800" b="0" i="0">
-                          <a:solidFill>
-                            <a:srgbClr val="0D0D0D"/>
-                          </a:solidFill>
-                          <a:latin typeface="Calibri"/>
-                        </a:rPr>
-                        <a:t>Cours actuel (253,38)</a:t>
-                      </a:r>
-                    </a:p>
-                  </a:txBody>
-                  <a:tcPr>
-                    <a:solidFill>
-                      <a:srgbClr val="EEF3FA"/>
-                    </a:solidFill>
-                  </a:tcPr>
-                </a:tc>
-                <a:tc>
-                  <a:txBody>
-                    <a:bodyPr/>
-                    <a:lstStyle/>
-                    <a:p>
-                      <a:pPr algn="ctr"/>
-                      <a:r>
-                        <a:rPr sz="800" b="0" i="0">
-                          <a:solidFill>
-                            <a:srgbClr val="0D0D0D"/>
-                          </a:solidFill>
-                          <a:latin typeface="Calibri"/>
-                        </a:rPr>
-                        <a:t>—</a:t>
-                      </a:r>
-                    </a:p>
-                  </a:txBody>
-                  <a:tcPr>
-                    <a:solidFill>
-                      <a:srgbClr val="EEF3FA"/>
-                    </a:solidFill>
-                  </a:tcPr>
-                </a:tc>
-                <a:tc>
-                  <a:txBody>
-                    <a:bodyPr/>
-                    <a:lstStyle/>
-                    <a:p>
-                      <a:pPr algn="ctr"/>
-                      <a:r>
-                        <a:rPr sz="800" b="0" i="0">
-                          <a:solidFill>
-                            <a:srgbClr val="0D0D0D"/>
-                          </a:solidFill>
-                          <a:latin typeface="Calibri"/>
-                        </a:rPr>
-                        <a:t>—</a:t>
-                      </a:r>
-                    </a:p>
-                  </a:txBody>
-                  <a:tcPr>
-                    <a:solidFill>
-                      <a:srgbClr val="EEF3FA"/>
-                    </a:solidFill>
-                  </a:tcPr>
-                </a:tc>
-                <a:tc>
-                  <a:txBody>
-                    <a:bodyPr/>
-                    <a:lstStyle/>
-                    <a:p>
-                      <a:pPr algn="ctr"/>
-                      <a:r>
-                        <a:rPr sz="800" b="0" i="0">
-                          <a:solidFill>
-                            <a:srgbClr val="0D0D0D"/>
-                          </a:solidFill>
-                          <a:latin typeface="Calibri"/>
-                        </a:rPr>
-                        <a:t>253,38</a:t>
-                      </a:r>
-                    </a:p>
-                  </a:txBody>
-                  <a:tcPr>
-                    <a:solidFill>
-                      <a:srgbClr val="EEF3FA"/>
-                    </a:solidFill>
-                  </a:tcPr>
-                </a:tc>
-              </a:tr>
-            </a:tbl>
-          </a:graphicData>
-        </a:graphic>
-      </p:graphicFrame>
+      <p:pic>
+        <p:nvPicPr>
+          <p:cNvPr id="17" name="Picture 16" descr="image.png"/>
+          <p:cNvPicPr>
+            <a:picLocks noChangeAspect="1"/>
+          </p:cNvPicPr>
+          <p:nvPr/>
+        </p:nvPicPr>
+        <p:blipFill>
+          <a:blip r:embed="rId2"/>
+          <a:stretch>
+            <a:fillRect/>
+          </a:stretch>
+        </p:blipFill>
+        <p:spPr>
+          <a:xfrm>
+            <a:off x="367200" y="914400"/>
+            <a:ext cx="8413200" cy="1980000"/>
+          </a:xfrm>
+          <a:prstGeom prst="rect">
+            <a:avLst/>
+          </a:prstGeom>
+        </p:spPr>
+      </p:pic>
       <p:sp>
         <p:nvSpPr>
           <p:cNvPr id="18" name="TextBox 17"/>
@@ -13048,7 +12292,7 @@
                 </a:solidFill>
                 <a:latin typeface="Calibri"/>
               </a:rPr>
-              <a:t>Le prix implicite d'Apple sur la base d'un modèle de flux de trésorerie disponible est de 280,5 USD, ce qui suggère un upside de 10% par rapport au cours actuel.</a:t>
+              <a:t>WACC 10.3% avec TGR 3.0% implique un upside de 12% vs cours actuel. Valorisation DCF à 285$ justifiée par croissance services et rachats d'actions.</a:t>
             </a:r>
           </a:p>
         </p:txBody>
@@ -14021,7 +13265,7 @@
                 </a:solidFill>
                 <a:latin typeface="Calibri"/>
               </a:rPr>
-              <a:t>Concurrence accrue</a:t>
+              <a:t>Régulation App Store</a:t>
             </a:r>
           </a:p>
         </p:txBody>
@@ -14056,7 +13300,7 @@
                 </a:solidFill>
                 <a:latin typeface="Calibri"/>
               </a:rPr>
-              <a:t>Concurrence accrue</a:t>
+              <a:t>Régulation européenne sur l'App Store</a:t>
             </a:r>
           </a:p>
         </p:txBody>
@@ -14177,7 +13421,7 @@
                 </a:solidFill>
                 <a:latin typeface="Calibri"/>
               </a:rPr>
-              <a:t>Dépendance aux smartphones</a:t>
+              <a:t>Concurrence IA</a:t>
             </a:r>
           </a:p>
         </p:txBody>
@@ -14212,7 +13456,7 @@
                 </a:solidFill>
                 <a:latin typeface="Calibri"/>
               </a:rPr>
-              <a:t>Risques politiques</a:t>
+              <a:t>Concurrence accrue en IA (Google, Microsoft)</a:t>
             </a:r>
           </a:p>
         </p:txBody>
@@ -14333,7 +13577,7 @@
                 </a:solidFill>
                 <a:latin typeface="Calibri"/>
               </a:rPr>
-              <a:t>Risques politiques</a:t>
+              <a:t>Dépendance iPhone</a:t>
             </a:r>
           </a:p>
         </p:txBody>
@@ -14368,7 +13612,7 @@
                 </a:solidFill>
                 <a:latin typeface="Calibri"/>
               </a:rPr>
-              <a:t>Dépendance aux smartphones</a:t>
+              <a:t>Ralentissement économique en Chine</a:t>
             </a:r>
           </a:p>
         </p:txBody>
@@ -14582,7 +13826,7 @@
                           </a:solidFill>
                           <a:latin typeface="Calibri"/>
                         </a:rPr>
-                        <a:t>Récession économique mondiale</a:t>
+                        <a:t>Récession mondiale 2026 réduisant la demande de 10%</a:t>
                       </a:r>
                     </a:p>
                   </a:txBody>
@@ -14653,7 +13897,7 @@
                           </a:solidFill>
                           <a:latin typeface="Calibri"/>
                         </a:rPr>
-                        <a:t>Concurrence accrue dans le secteur des smartphones</a:t>
+                        <a:t>Régulation stricte sur l'App Store en UE/US amputant 15% des revenus services</a:t>
                       </a:r>
                     </a:p>
                   </a:txBody>
@@ -14724,7 +13968,7 @@
                           </a:solidFill>
                           <a:latin typeface="Calibri"/>
                         </a:rPr>
-                        <a:t>Problèmes de production ou de livraison</a:t>
+                        <a:t>Échec commercial iPhone 17 avec baisse ARPU de 10%</a:t>
                       </a:r>
                     </a:p>
                   </a:txBody>
@@ -14747,7 +13991,7 @@
                           </a:solidFill>
                           <a:latin typeface="Calibri"/>
                         </a:rPr>
-                        <a:t>2-3 trimestres</a:t>
+                        <a:t>2-3 trim.</a:t>
                       </a:r>
                     </a:p>
                   </a:txBody>
@@ -15730,7 +14974,7 @@
                 </a:solidFill>
                 <a:latin typeface="Calibri"/>
               </a:rPr>
-              <a:t>Neutre +</a:t>
+              <a:t>Positif</a:t>
             </a:r>
           </a:p>
         </p:txBody>
@@ -15800,7 +15044,7 @@
                 </a:solidFill>
                 <a:latin typeface="Calibri"/>
               </a:rPr>
-              <a:t>Score agrege : +0,035</a:t>
+              <a:t>Score agrege : +0,339</a:t>
             </a:r>
           </a:p>
         </p:txBody>
@@ -16112,7 +15356,7 @@
                 </a:solidFill>
                 <a:latin typeface="Calibri"/>
               </a:rPr>
-              <a:t>49,7 %</a:t>
+              <a:t>52,5 %</a:t>
             </a:r>
           </a:p>
         </p:txBody>
@@ -16568,7 +15812,7 @@
                           </a:solidFill>
                           <a:latin typeface="Calibri"/>
                         </a:rPr>
-                        <a:t>7</a:t>
+                        <a:t>17</a:t>
                       </a:r>
                     </a:p>
                   </a:txBody>
@@ -16591,7 +15835,7 @@
                           </a:solidFill>
                           <a:latin typeface="Calibri"/>
                         </a:rPr>
-                        <a:t>+0,269</a:t>
+                        <a:t>+0,525</a:t>
                       </a:r>
                     </a:p>
                   </a:txBody>
@@ -16614,7 +15858,7 @@
                           </a:solidFill>
                           <a:latin typeface="Calibri"/>
                         </a:rPr>
-                        <a:t>Croissance de la demande pour les smartphones, Expansion de l'écosystème d'Apple, Innovation</a:t>
+                        <a:t>Croissance services &gt;15% CAGR 2025-2027, Rachat d'actions 100Md$ en 2025, Lancement iPhone 17 avec IA intégrée</a:t>
                       </a:r>
                     </a:p>
                   </a:txBody>
@@ -16662,7 +15906,7 @@
                           </a:solidFill>
                           <a:latin typeface="Calibri"/>
                         </a:rPr>
-                        <a:t>17</a:t>
+                        <a:t>7</a:t>
                       </a:r>
                     </a:p>
                   </a:txBody>
@@ -16685,7 +15929,7 @@
                           </a:solidFill>
                           <a:latin typeface="Calibri"/>
                         </a:rPr>
-                        <a:t>+0,497</a:t>
+                        <a:t>+0,288</a:t>
                       </a:r>
                     </a:p>
                   </a:txBody>
@@ -16779,7 +16023,7 @@
                           </a:solidFill>
                           <a:latin typeface="Calibri"/>
                         </a:rPr>
-                        <a:t>+0,234</a:t>
+                        <a:t>+0,186</a:t>
                       </a:r>
                     </a:p>
                   </a:txBody>
@@ -16802,7 +16046,7 @@
                           </a:solidFill>
                           <a:latin typeface="Calibri"/>
                         </a:rPr>
-                        <a:t>Concurrence accrue, Risques politiques, Dépendance aux smartphones</a:t>
+                        <a:t>Régulation européenne sur l'App Store, Concurrence accrue en IA (Google, Microsoft), Ralentissement économique en Chine</a:t>
                       </a:r>
                     </a:p>
                   </a:txBody>
@@ -16847,7 +16091,7 @@
                 </a:solidFill>
                 <a:latin typeface="Calibri"/>
               </a:rPr>
-              <a:t>Le sentiment global de la presse financiere sur AAPL cette semaine est mitige, avec certains titres laissant apparaitre une croissance potentielle pour l'entreprise, notamment en termes d'adoption de ses produits en Europe. Cependant, d'autres titres font etat de defis potentiels pour l'entreprise, tels que la concurrence accrue dans le marché des smartphones et les risques lies aux partenariats avec d'autres entreprises technologiques.</a:t>
+              <a:t>Le sentiment positif (score +0.339) est basé sur 30 articles analysés sur 7 jours. Confiance IA : 53%. Cohérence avec la recommandation BUY : validée.</a:t>
             </a:r>
           </a:p>
         </p:txBody>
@@ -19785,7 +19029,7 @@
                 </a:solidFill>
                 <a:latin typeface="Calibri"/>
               </a:rPr>
-              <a:t>La valorisation d'Apple est attractive par rapport à ses pairs, avec un ratio EV/EBITDA inférieur à 25. L'entreprise présente également un multiple de prix sur bénéfice inférieur à 30.</a:t>
+              <a:t>Les multiples (P/E 33.3x, EV/EBITDA 26.2x) sont élevés mais justifiés par la qualité des marges et la récurrence des revenus. Comparables tech affichent des ratios similaires avec upside limité.</a:t>
             </a:r>
           </a:p>
         </p:txBody>
@@ -20115,7 +19359,7 @@
                 </a:solidFill>
                 <a:latin typeface="Calibri"/>
               </a:rPr>
-              <a:t>Prix cible base : 280 $  ·  Upside : +10,7 %  ·  Bear : 241 $ (-5,0 %)  ·  Bull : 310 $ (+22,4 %)</a:t>
+              <a:t>Prix cible base : 285 $  ·  Upside : +12,1 %  ·  Bear : 240 $ (-5,6 %)  ·  Bull : 320 $ (+25,9 %)</a:t>
             </a:r>
           </a:p>
         </p:txBody>
@@ -20271,7 +19515,7 @@
                 </a:solidFill>
                 <a:latin typeface="Calibri"/>
               </a:rPr>
-              <a:t>Marque forte</a:t>
+              <a:t>Écosystème fermé</a:t>
             </a:r>
           </a:p>
         </p:txBody>
@@ -20306,7 +19550,7 @@
                 </a:solidFill>
                 <a:latin typeface="Calibri"/>
               </a:rPr>
-              <a:t>La croissance de la demande pour les smartphones et les ordinateurs portables devrait atteindre 10% d'ici 2027</a:t>
+              <a:t>Lancement de l'iPhone 17 en 2026 avec +15% de ventes grâce à l'IA intégrée boostant l'ARPU à 850$</a:t>
             </a:r>
           </a:p>
         </p:txBody>
@@ -20384,7 +19628,7 @@
                 </a:solidFill>
                 <a:latin typeface="Calibri"/>
               </a:rPr>
-              <a:t>Ecosystème intégré</a:t>
+              <a:t>Marges premium</a:t>
             </a:r>
           </a:p>
         </p:txBody>
@@ -20419,7 +19663,7 @@
                 </a:solidFill>
                 <a:latin typeface="Calibri"/>
               </a:rPr>
-              <a:t>Les services d'Apple devraient générer 20% des revenus de l'entreprise d'ici 2028</a:t>
+              <a:t>Expansion des services avec +18% de revenus atteignant 100Md$ en 2027</a:t>
             </a:r>
           </a:p>
         </p:txBody>
@@ -20497,7 +19741,7 @@
                 </a:solidFill>
                 <a:latin typeface="Calibri"/>
               </a:rPr>
-              <a:t>Innovation</a:t>
+              <a:t>Cash-flows massifs</a:t>
             </a:r>
           </a:p>
         </p:txBody>
@@ -20532,7 +19776,7 @@
                 </a:solidFill>
                 <a:latin typeface="Calibri"/>
               </a:rPr>
-              <a:t>L'expansion de l'écosystème d'Apple devrait atteindre 500 millions d'utilisateurs actifs d'ici 2029</a:t>
+              <a:t>Rachat d'actions de 100Md$ annoncé en 2025 soutenant la valorisation.</a:t>
             </a:r>
           </a:p>
         </p:txBody>
@@ -20688,7 +19932,7 @@
                 </a:solidFill>
                 <a:latin typeface="Calibri"/>
               </a:rPr>
-              <a:t>Concurrence accrue</a:t>
+              <a:t>Régulation App Store</a:t>
             </a:r>
           </a:p>
         </p:txBody>
@@ -20723,7 +19967,7 @@
                 </a:solidFill>
                 <a:latin typeface="Calibri"/>
               </a:rPr>
-              <a:t>Concurrence accrue</a:t>
+              <a:t>Régulation européenne sur l'App Store</a:t>
             </a:r>
           </a:p>
         </p:txBody>
@@ -20801,7 +20045,7 @@
                 </a:solidFill>
                 <a:latin typeface="Calibri"/>
               </a:rPr>
-              <a:t>Dépendance aux smartphones</a:t>
+              <a:t>Concurrence IA</a:t>
             </a:r>
           </a:p>
         </p:txBody>
@@ -20836,7 +20080,7 @@
                 </a:solidFill>
                 <a:latin typeface="Calibri"/>
               </a:rPr>
-              <a:t>Risques politiques</a:t>
+              <a:t>Concurrence accrue en IA (Google, Microsoft)</a:t>
             </a:r>
           </a:p>
         </p:txBody>
@@ -20914,7 +20158,7 @@
                 </a:solidFill>
                 <a:latin typeface="Calibri"/>
               </a:rPr>
-              <a:t>Risques politiques</a:t>
+              <a:t>Dépendance iPhone</a:t>
             </a:r>
           </a:p>
         </p:txBody>
@@ -20949,7 +20193,7 @@
                 </a:solidFill>
                 <a:latin typeface="Calibri"/>
               </a:rPr>
-              <a:t>Dépendance aux smartphones</a:t>
+              <a:t>Impact potentiel sur la these d'investissement — surveillance recommandee sur les 6-12 prochains mois.</a:t>
             </a:r>
           </a:p>
         </p:txBody>
@@ -21156,7 +20400,7 @@
                 </a:solidFill>
                 <a:latin typeface="Calibri"/>
               </a:rPr>
-              <a:t>26,1x</a:t>
+              <a:t>26,2x</a:t>
             </a:r>
           </a:p>
         </p:txBody>
@@ -21226,7 +20470,7 @@
                 </a:solidFill>
                 <a:latin typeface="Calibri"/>
               </a:rPr>
-              <a:t>vs 20,5x médiane peers</a:t>
+              <a:t>vs 22,0x médiane peers</a:t>
             </a:r>
           </a:p>
         </p:txBody>
@@ -21538,7 +20782,7 @@
                 </a:solidFill>
                 <a:latin typeface="Calibri"/>
               </a:rPr>
-              <a:t>280 $</a:t>
+              <a:t>285 $</a:t>
             </a:r>
           </a:p>
         </p:txBody>
@@ -21608,7 +20852,7 @@
                 </a:solidFill>
                 <a:latin typeface="Calibri"/>
               </a:rPr>
-              <a:t>Upside de +10,7 % vs cours</a:t>
+              <a:t>Upside de +12,1 % vs cours</a:t>
             </a:r>
           </a:p>
         </p:txBody>
@@ -21729,7 +20973,7 @@
                 </a:solidFill>
                 <a:latin typeface="Calibri"/>
               </a:rPr>
-              <a:t>+0,035</a:t>
+              <a:t>+0,339</a:t>
             </a:r>
           </a:p>
         </p:txBody>
@@ -21799,7 +21043,7 @@
                 </a:solidFill>
                 <a:latin typeface="Calibri"/>
               </a:rPr>
-              <a:t>Neutre +  ·  30 articles</a:t>
+              <a:t>Positif  ·  30 articles</a:t>
             </a:r>
           </a:p>
         </p:txBody>
@@ -22519,7 +21763,7 @@
                 </a:solidFill>
                 <a:latin typeface="Calibri"/>
               </a:rPr>
-              <a:t>253,38 $</a:t>
+              <a:t>254,20 $</a:t>
             </a:r>
           </a:p>
         </p:txBody>
@@ -22987,7 +22231,7 @@
                 </a:solidFill>
                 <a:latin typeface="Calibri"/>
               </a:rPr>
-              <a:t>+19,7 %</a:t>
+              <a:t>+20,1 %</a:t>
             </a:r>
           </a:p>
         </p:txBody>
@@ -24016,8 +23260,8 @@
         </p:nvSpPr>
         <p:spPr>
           <a:xfrm>
-            <a:off x="7854300" y="2842183"/>
-            <a:ext cx="498636" cy="1053016"/>
+            <a:off x="7854300" y="2826559"/>
+            <a:ext cx="498636" cy="1068640"/>
           </a:xfrm>
           <a:prstGeom prst="rect">
             <a:avLst/>
@@ -24088,14 +23332,57 @@
       </p:sp>
       <p:sp>
         <p:nvSpPr>
-          <p:cNvPr id="60" name="TextBox 59"/>
+          <p:cNvPr id="60" name="Rectangle 59"/>
+          <p:cNvSpPr/>
+          <p:nvPr/>
+        </p:nvSpPr>
+        <p:spPr>
+          <a:xfrm>
+            <a:off x="601200" y="3823200"/>
+            <a:ext cx="8179200" cy="7200"/>
+          </a:xfrm>
+          <a:prstGeom prst="rect">
+            <a:avLst/>
+          </a:prstGeom>
+          <a:solidFill>
+            <a:srgbClr val="D0D5DD"/>
+          </a:solidFill>
+          <a:ln>
+            <a:noFill/>
+          </a:ln>
+        </p:spPr>
+        <p:style>
+          <a:lnRef idx="1">
+            <a:schemeClr val="accent1"/>
+          </a:lnRef>
+          <a:fillRef idx="3">
+            <a:schemeClr val="accent1"/>
+          </a:fillRef>
+          <a:effectRef idx="2">
+            <a:schemeClr val="accent1"/>
+          </a:effectRef>
+          <a:fontRef idx="minor">
+            <a:schemeClr val="lt1"/>
+          </a:fontRef>
+        </p:style>
+        <p:txBody>
+          <a:bodyPr rtlCol="0" anchor="ctr"/>
+          <a:lstStyle/>
+          <a:p>
+            <a:pPr algn="ctr"/>
+          </a:p>
+        </p:txBody>
+      </p:sp>
+      <p:sp>
+        <p:nvSpPr>
+          <p:cNvPr id="61" name="TextBox 60"/>
           <p:cNvSpPr txBox="1"/>
           <p:nvPr/>
         </p:nvSpPr>
         <p:spPr>
           <a:xfrm>
-            <a:off x="439200" y="2174400"/>
-            <a:ext cx="1800000" cy="144000"/>
+            <a:off x="367200" y="3751200"/>
+            <a:ext cx="216000" cy="144000"/>
           </a:xfrm>
           <a:prstGeom prst="rect">
             <a:avLst/>
@@ -24110,55 +23397,254 @@
           <a:p>
             <a:pPr algn="l"/>
             <a:r>
-              <a:rPr sz="700" b="0" i="0">
-                <a:solidFill>
-                  <a:srgbClr val="2E5FA3"/>
-                </a:solidFill>
-                <a:latin typeface="Calibri"/>
-              </a:rPr>
-              <a:t>▲ Max : 278,32 $</a:t>
-            </a:r>
-          </a:p>
-        </p:txBody>
-      </p:sp>
-      <p:sp>
-        <p:nvSpPr>
-          <p:cNvPr id="61" name="TextBox 60"/>
-          <p:cNvSpPr txBox="1"/>
-          <p:nvPr/>
-        </p:nvSpPr>
-        <p:spPr>
-          <a:xfrm>
-            <a:off x="439200" y="3643199"/>
-            <a:ext cx="1800000" cy="144000"/>
-          </a:xfrm>
-          <a:prstGeom prst="rect">
-            <a:avLst/>
-          </a:prstGeom>
-          <a:noFill/>
-        </p:spPr>
-        <p:txBody>
-          <a:bodyPr wrap="square">
-            <a:spAutoFit/>
-          </a:bodyPr>
-          <a:lstStyle/>
-          <a:p>
-            <a:pPr algn="l"/>
-            <a:r>
-              <a:rPr sz="700" b="0" i="0">
+              <a:rPr sz="600" b="0" i="0">
                 <a:solidFill>
                   <a:srgbClr val="555555"/>
                 </a:solidFill>
                 <a:latin typeface="Calibri"/>
               </a:rPr>
-              <a:t>▼ Min : 199,98 $</a:t>
+              <a:t>199</a:t>
             </a:r>
           </a:p>
         </p:txBody>
       </p:sp>
       <p:sp>
         <p:nvSpPr>
-          <p:cNvPr id="62" name="TextBox 61"/>
+          <p:cNvPr id="62" name="Rectangle 61"/>
+          <p:cNvSpPr/>
+          <p:nvPr/>
+        </p:nvSpPr>
+        <p:spPr>
+          <a:xfrm>
+            <a:off x="601200" y="3348000"/>
+            <a:ext cx="8179200" cy="7200"/>
+          </a:xfrm>
+          <a:prstGeom prst="rect">
+            <a:avLst/>
+          </a:prstGeom>
+          <a:solidFill>
+            <a:srgbClr val="D0D5DD"/>
+          </a:solidFill>
+          <a:ln>
+            <a:noFill/>
+          </a:ln>
+        </p:spPr>
+        <p:style>
+          <a:lnRef idx="1">
+            <a:schemeClr val="accent1"/>
+          </a:lnRef>
+          <a:fillRef idx="3">
+            <a:schemeClr val="accent1"/>
+          </a:fillRef>
+          <a:effectRef idx="2">
+            <a:schemeClr val="accent1"/>
+          </a:effectRef>
+          <a:fontRef idx="minor">
+            <a:schemeClr val="lt1"/>
+          </a:fontRef>
+        </p:style>
+        <p:txBody>
+          <a:bodyPr rtlCol="0" anchor="ctr"/>
+          <a:lstStyle/>
+          <a:p>
+            <a:pPr algn="ctr"/>
+          </a:p>
+        </p:txBody>
+      </p:sp>
+      <p:sp>
+        <p:nvSpPr>
+          <p:cNvPr id="63" name="TextBox 62"/>
+          <p:cNvSpPr txBox="1"/>
+          <p:nvPr/>
+        </p:nvSpPr>
+        <p:spPr>
+          <a:xfrm>
+            <a:off x="367200" y="3276000"/>
+            <a:ext cx="216000" cy="144000"/>
+          </a:xfrm>
+          <a:prstGeom prst="rect">
+            <a:avLst/>
+          </a:prstGeom>
+          <a:noFill/>
+        </p:spPr>
+        <p:txBody>
+          <a:bodyPr wrap="square">
+            <a:spAutoFit/>
+          </a:bodyPr>
+          <a:lstStyle/>
+          <a:p>
+            <a:pPr algn="l"/>
+            <a:r>
+              <a:rPr sz="600" b="0" i="0">
+                <a:solidFill>
+                  <a:srgbClr val="555555"/>
+                </a:solidFill>
+                <a:latin typeface="Calibri"/>
+              </a:rPr>
+              <a:t>225</a:t>
+            </a:r>
+          </a:p>
+        </p:txBody>
+      </p:sp>
+      <p:sp>
+        <p:nvSpPr>
+          <p:cNvPr id="64" name="Rectangle 63"/>
+          <p:cNvSpPr/>
+          <p:nvPr/>
+        </p:nvSpPr>
+        <p:spPr>
+          <a:xfrm>
+            <a:off x="601200" y="2858400"/>
+            <a:ext cx="8179200" cy="7200"/>
+          </a:xfrm>
+          <a:prstGeom prst="rect">
+            <a:avLst/>
+          </a:prstGeom>
+          <a:solidFill>
+            <a:srgbClr val="D0D5DD"/>
+          </a:solidFill>
+          <a:ln>
+            <a:noFill/>
+          </a:ln>
+        </p:spPr>
+        <p:style>
+          <a:lnRef idx="1">
+            <a:schemeClr val="accent1"/>
+          </a:lnRef>
+          <a:fillRef idx="3">
+            <a:schemeClr val="accent1"/>
+          </a:fillRef>
+          <a:effectRef idx="2">
+            <a:schemeClr val="accent1"/>
+          </a:effectRef>
+          <a:fontRef idx="minor">
+            <a:schemeClr val="lt1"/>
+          </a:fontRef>
+        </p:style>
+        <p:txBody>
+          <a:bodyPr rtlCol="0" anchor="ctr"/>
+          <a:lstStyle/>
+          <a:p>
+            <a:pPr algn="ctr"/>
+          </a:p>
+        </p:txBody>
+      </p:sp>
+      <p:sp>
+        <p:nvSpPr>
+          <p:cNvPr id="65" name="TextBox 64"/>
+          <p:cNvSpPr txBox="1"/>
+          <p:nvPr/>
+        </p:nvSpPr>
+        <p:spPr>
+          <a:xfrm>
+            <a:off x="367200" y="2786399"/>
+            <a:ext cx="216000" cy="144000"/>
+          </a:xfrm>
+          <a:prstGeom prst="rect">
+            <a:avLst/>
+          </a:prstGeom>
+          <a:noFill/>
+        </p:spPr>
+        <p:txBody>
+          <a:bodyPr wrap="square">
+            <a:spAutoFit/>
+          </a:bodyPr>
+          <a:lstStyle/>
+          <a:p>
+            <a:pPr algn="l"/>
+            <a:r>
+              <a:rPr sz="600" b="0" i="0">
+                <a:solidFill>
+                  <a:srgbClr val="555555"/>
+                </a:solidFill>
+                <a:latin typeface="Calibri"/>
+              </a:rPr>
+              <a:t>252</a:t>
+            </a:r>
+          </a:p>
+        </p:txBody>
+      </p:sp>
+      <p:sp>
+        <p:nvSpPr>
+          <p:cNvPr id="66" name="Rectangle 65"/>
+          <p:cNvSpPr/>
+          <p:nvPr/>
+        </p:nvSpPr>
+        <p:spPr>
+          <a:xfrm>
+            <a:off x="601200" y="2383200"/>
+            <a:ext cx="8179200" cy="7200"/>
+          </a:xfrm>
+          <a:prstGeom prst="rect">
+            <a:avLst/>
+          </a:prstGeom>
+          <a:solidFill>
+            <a:srgbClr val="D0D5DD"/>
+          </a:solidFill>
+          <a:ln>
+            <a:noFill/>
+          </a:ln>
+        </p:spPr>
+        <p:style>
+          <a:lnRef idx="1">
+            <a:schemeClr val="accent1"/>
+          </a:lnRef>
+          <a:fillRef idx="3">
+            <a:schemeClr val="accent1"/>
+          </a:fillRef>
+          <a:effectRef idx="2">
+            <a:schemeClr val="accent1"/>
+          </a:effectRef>
+          <a:fontRef idx="minor">
+            <a:schemeClr val="lt1"/>
+          </a:fontRef>
+        </p:style>
+        <p:txBody>
+          <a:bodyPr rtlCol="0" anchor="ctr"/>
+          <a:lstStyle/>
+          <a:p>
+            <a:pPr algn="ctr"/>
+          </a:p>
+        </p:txBody>
+      </p:sp>
+      <p:sp>
+        <p:nvSpPr>
+          <p:cNvPr id="67" name="TextBox 66"/>
+          <p:cNvSpPr txBox="1"/>
+          <p:nvPr/>
+        </p:nvSpPr>
+        <p:spPr>
+          <a:xfrm>
+            <a:off x="367200" y="2311200"/>
+            <a:ext cx="216000" cy="144000"/>
+          </a:xfrm>
+          <a:prstGeom prst="rect">
+            <a:avLst/>
+          </a:prstGeom>
+          <a:noFill/>
+        </p:spPr>
+        <p:txBody>
+          <a:bodyPr wrap="square">
+            <a:spAutoFit/>
+          </a:bodyPr>
+          <a:lstStyle/>
+          <a:p>
+            <a:pPr algn="l"/>
+            <a:r>
+              <a:rPr sz="600" b="0" i="0">
+                <a:solidFill>
+                  <a:srgbClr val="555555"/>
+                </a:solidFill>
+                <a:latin typeface="Calibri"/>
+              </a:rPr>
+              <a:t>278</a:t>
+            </a:r>
+          </a:p>
+        </p:txBody>
+      </p:sp>
+      <p:sp>
+        <p:nvSpPr>
+          <p:cNvPr id="68" name="TextBox 67"/>
           <p:cNvSpPr txBox="1"/>
           <p:nvPr/>
         </p:nvSpPr>
@@ -24186,7 +23672,7 @@
                 </a:solidFill>
                 <a:latin typeface="Calibri"/>
               </a:rPr>
-              <a:t>Apple Inc. presente une opportunité d'investissement attractive avec des perspectives de croissance solides et une position dominante sur le marché. L'entreprise devrait poursuivre sa croissance grâce à ses produits innovants et à son écosystème intégré.</a:t>
+              <a:t>Apple maintient une position dominante dans les services et l'innovation hardware malgré des défis macroéconomiques. La valorisation reste attractive avec une marge nette de 26.9% et un ROIC de 84.4%.</a:t>
             </a:r>
           </a:p>
         </p:txBody>
@@ -25229,7 +24715,7 @@
                 </a:solidFill>
                 <a:latin typeface="Calibri"/>
               </a:rPr>
-              <a:t>Concurrence accrue  ·  Dépendance aux smartphones</a:t>
+              <a:t>Régulation App Store  ·  Concurrence IA</a:t>
             </a:r>
           </a:p>
         </p:txBody>
@@ -26463,7 +25949,7 @@
                 </a:solidFill>
                 <a:latin typeface="Calibri"/>
               </a:rPr>
-              <a:t>Apple Inc. est un leader mondial dans la conception, la fabrication et la commercialisation de produits électroniques grand public. L'entreprise est positionnée comme un acteur majeur sur le marché des smartphones et des ordinateurs portables. Ses avantages concurrentiels incluent son écosystème intégré, sa marque forte et son innovante gamme de produits. L'entreprise articule son activité autour de deux segments stratégiques :</a:t>
+              <a:t>Apple conçoit et commercialise des smartphones, ordinateurs et services numériques haut de gamme. Positionné comme leader premium avec écosystème intégré, l'entreprise bénéficie d'une fidélisation client exceptionnelle et de marges durables. Son avantage concurrentiel repose sur l'innovation, la marque forte et la rentabilité supérieure à ses pairs. L'entreprise articule son activité autour de deux segments stratégiques :</a:t>
             </a:r>
           </a:p>
         </p:txBody>
@@ -26576,7 +26062,7 @@
                 </a:solidFill>
                 <a:latin typeface="Calibri"/>
               </a:rPr>
-              <a:t>Les produits d'Apple incluent les iPhone, les Mac, les iPad, les Apple Watch et les AirPods.…</a:t>
+              <a:t>Ventes de iPhone, Mac, iPad et wearables représentant 80% du chiffre d'affaires. Modèle basé sur…</a:t>
             </a:r>
           </a:p>
         </p:txBody>
@@ -26689,7 +26175,7 @@
                 </a:solidFill>
                 <a:latin typeface="Calibri"/>
               </a:rPr>
-              <a:t>Les services d'Apple incluent la musique, les films, les applications et les abonnements.…</a:t>
+              <a:t>Abonnements (Apple Music, iCloud, App Store) et services financiers (Apple Card) avec marge brute…</a:t>
             </a:r>
           </a:p>
         </p:txBody>
@@ -26810,7 +26296,7 @@
                 </a:solidFill>
                 <a:latin typeface="Calibri"/>
               </a:rPr>
-              <a:t>3 719,9 Mds$</a:t>
+              <a:t>3 731,9 Mds$</a:t>
             </a:r>
           </a:p>
         </p:txBody>
@@ -27122,7 +26608,7 @@
                 </a:solidFill>
                 <a:latin typeface="Calibri"/>
               </a:rPr>
-              <a:t>253,38 $</a:t>
+              <a:t>254,20 $</a:t>
             </a:r>
           </a:p>
         </p:txBody>
@@ -27278,7 +26764,7 @@
                 </a:solidFill>
                 <a:latin typeface="Calibri"/>
               </a:rPr>
-              <a:t>26,1x</a:t>
+              <a:t>26,2x</a:t>
             </a:r>
           </a:p>
         </p:txBody>
@@ -27348,7 +26834,7 @@
                 </a:solidFill>
                 <a:latin typeface="Calibri"/>
               </a:rPr>
-              <a:t>P/E : 33,2x</a:t>
+              <a:t>P/E : 33,3x</a:t>
             </a:r>
           </a:p>
         </p:txBody>
@@ -28068,7 +27554,7 @@
                 </a:solidFill>
                 <a:latin typeface="Calibri"/>
               </a:rPr>
-              <a:t>1%</a:t>
+              <a:t>80%</a:t>
             </a:r>
           </a:p>
         </p:txBody>
@@ -28195,7 +27681,7 @@
         <p:spPr>
           <a:xfrm>
             <a:off x="457200" y="2332800"/>
-            <a:ext cx="3970800" cy="1800000"/>
+            <a:ext cx="3970800" cy="2041199"/>
           </a:xfrm>
           <a:prstGeom prst="rect">
             <a:avLst/>
@@ -28216,7 +27702,7 @@
                 </a:solidFill>
                 <a:latin typeface="Calibri"/>
               </a:rPr>
-              <a:t>Les produits d'Apple incluent les iPhone, les Mac, les iPad, les Apple Watch et les AirPods. L'entreprise génère la majorité de ses revenus grâce à la vente de ces produits. Les principaux moteurs de croissance sont la demande croissante pour les…</a:t>
+              <a:t>Ventes de iPhone, Mac, iPad et wearables représentant 80% du chiffre d'affaires. Modèle basé sur des cycles de renouvellement rapides et des prix premium ciblant les consommateurs haut de gamme. Croissance tirée par l'Asie et les services associés.</a:t>
             </a:r>
           </a:p>
         </p:txBody>
@@ -28337,7 +27823,7 @@
                 </a:solidFill>
                 <a:latin typeface="Calibri"/>
               </a:rPr>
-              <a:t>0%</a:t>
+              <a:t>20%</a:t>
             </a:r>
           </a:p>
         </p:txBody>
@@ -28464,7 +27950,7 @@
         <p:spPr>
           <a:xfrm>
             <a:off x="4716000" y="2332800"/>
-            <a:ext cx="3970800" cy="1800000"/>
+            <a:ext cx="3970800" cy="2041199"/>
           </a:xfrm>
           <a:prstGeom prst="rect">
             <a:avLst/>
@@ -28485,7 +27971,7 @@
                 </a:solidFill>
                 <a:latin typeface="Calibri"/>
               </a:rPr>
-              <a:t>Les services d'Apple incluent la musique, les films, les applications et les abonnements. L'entreprise cherche à diversifier ses sources de revenus en développant ses services. Les moteurs de croissance incluent la croissance du marché des services…</a:t>
+              <a:t>Abonnements (Apple Music, iCloud, App Store) et services financiers (Apple Card) avec marge brute &gt;70%. Modèle récurrent générant 20% du CA avec croissance à deux chiffres. Cible les 1.5Md utilisateurs actifs de l'écosystème.</a:t>
             </a:r>
           </a:p>
         </p:txBody>
@@ -29614,7 +29100,7 @@
                           </a:solidFill>
                           <a:latin typeface="Calibri"/>
                         </a:rPr>
-                        <a:t>437,2</a:t>
+                        <a:t>445,0</a:t>
                       </a:r>
                     </a:p>
                   </a:txBody>
@@ -29637,7 +29123,7 @@
                           </a:solidFill>
                           <a:latin typeface="Calibri"/>
                         </a:rPr>
-                        <a:t>468,4</a:t>
+                        <a:t>475,0</a:t>
                       </a:r>
                     </a:p>
                   </a:txBody>
@@ -29754,7 +29240,7 @@
                           </a:solidFill>
                           <a:latin typeface="Calibri"/>
                         </a:rPr>
-                        <a:t>+5,0 %</a:t>
+                        <a:t>+7,0 %</a:t>
                       </a:r>
                     </a:p>
                   </a:txBody>
@@ -29777,7 +29263,7 @@
                           </a:solidFill>
                           <a:latin typeface="Calibri"/>
                         </a:rPr>
-                        <a:t>+7,0 %</a:t>
+                        <a:t>+6,7 %</a:t>
                       </a:r>
                     </a:p>
                   </a:txBody>
@@ -29894,7 +29380,7 @@
                           </a:solidFill>
                           <a:latin typeface="Calibri"/>
                         </a:rPr>
-                        <a:t>205,5</a:t>
+                        <a:t>209,2</a:t>
                       </a:r>
                     </a:p>
                   </a:txBody>
@@ -29917,7 +29403,7 @@
                           </a:solidFill>
                           <a:latin typeface="Calibri"/>
                         </a:rPr>
-                        <a:t>224,8</a:t>
+                        <a:t>225,6</a:t>
                       </a:r>
                     </a:p>
                   </a:txBody>
@@ -30057,7 +29543,7 @@
                           </a:solidFill>
                           <a:latin typeface="Calibri"/>
                         </a:rPr>
-                        <a:t>48,0 %</a:t>
+                        <a:t>47,5 %</a:t>
                       </a:r>
                     </a:p>
                   </a:txBody>
@@ -30174,7 +29660,7 @@
                           </a:solidFill>
                           <a:latin typeface="Calibri"/>
                         </a:rPr>
-                        <a:t>157,8</a:t>
+                        <a:t>165,0</a:t>
                       </a:r>
                     </a:p>
                   </a:txBody>
@@ -30197,7 +29683,7 @@
                           </a:solidFill>
                           <a:latin typeface="Calibri"/>
                         </a:rPr>
-                        <a:t>173,2</a:t>
+                        <a:t>175,0</a:t>
                       </a:r>
                     </a:p>
                   </a:txBody>
@@ -30314,7 +29800,7 @@
                           </a:solidFill>
                           <a:latin typeface="Calibri"/>
                         </a:rPr>
-                        <a:t>36,0 %</a:t>
+                        <a:t>37,0 %</a:t>
                       </a:r>
                     </a:p>
                   </a:txBody>
@@ -30337,7 +29823,7 @@
                           </a:solidFill>
                           <a:latin typeface="Calibri"/>
                         </a:rPr>
-                        <a:t>37,0 %</a:t>
+                        <a:t>36,8 %</a:t>
                       </a:r>
                     </a:p>
                   </a:txBody>
@@ -30454,7 +29940,7 @@
                           </a:solidFill>
                           <a:latin typeface="Calibri"/>
                         </a:rPr>
-                        <a:t>114,8</a:t>
+                        <a:t>120,0</a:t>
                       </a:r>
                     </a:p>
                   </a:txBody>
@@ -30477,7 +29963,7 @@
                           </a:solidFill>
                           <a:latin typeface="Calibri"/>
                         </a:rPr>
-                        <a:t>124,9</a:t>
+                        <a:t>128,0</a:t>
                       </a:r>
                     </a:p>
                   </a:txBody>
@@ -30594,7 +30080,7 @@
                           </a:solidFill>
                           <a:latin typeface="Calibri"/>
                         </a:rPr>
-                        <a:t>26,0 %</a:t>
+                        <a:t>27,0 %</a:t>
                       </a:r>
                     </a:p>
                   </a:txBody>
@@ -30662,7 +30148,7 @@
                 </a:solidFill>
                 <a:latin typeface="Calibri"/>
               </a:rPr>
-              <a:t>Les revenus d'Apple devraient augmenter de 5% en 2026 et de 7% en 2027, grâce à la croissance de la demande pour les smartphones et les ordinateurs portables.</a:t>
+              <a:t>Croissance revenue de 6.4% en 2025 soutenue par les services (+15%). Marges stables à 46.9% malgré pression sur les coûts. Free cash-flow de 110Md$ en 2025, en hausse de 8%.</a:t>
             </a:r>
           </a:p>
         </p:txBody>
@@ -32394,7 +31880,7 @@
                           </a:solidFill>
                           <a:latin typeface="Calibri"/>
                         </a:rPr>
-                        <a:t>9,97</a:t>
+                        <a:t>10,00</a:t>
                       </a:r>
                     </a:p>
                   </a:txBody>
@@ -32579,7 +32065,7 @@
                 </a:solidFill>
                 <a:latin typeface="Calibri"/>
               </a:rPr>
-              <a:t>Les revenus d'Apple devraient augmenter de 5% en 2026 et de 7% en 2027, grâce à la croissance de la demande pour les smartphones et les ordinateurs portables.</a:t>
+              <a:t>Croissance revenue de 6.4% en 2025 soutenue par les services (+15%). Marges stables à 46.9% malgré pression sur les coûts. Free cash-flow de 110Md$ en 2025, en hausse de 8%.</a:t>
             </a:r>
           </a:p>
         </p:txBody>

</xml_diff>

<commit_message>
fix(pdf): legende p5 sous les barres + donut p7 fallback secteur si peers sans ticker
Page 5 — Marge chart : legende deplacee sous l'axe X (bbox_to_anchor, ncol=3)
pour eliminer le chevauchement avec les annotations de valeurs sur les barres.

Page 7 — Donut sectoriel : ajout fallback par secteur quand la synthese LLM
ne fournit pas de ticker dans comparable_peers. Mapping pour 11 secteurs
(consumer cyclical, technology, health, financ, energy, etc.) — TSLA affiche
desormais 95% du secteur Consumer Cyclical vs GM/F/RIVN/LCID/XPEV.

Previews AAPL et TSLA mis a jour.

Co-Authored-By: Claude Sonnet 4.6 <noreply@anthropic.com>
</commit_message>
<xml_diff>
--- a/preview/AAPL/AAPL_pitchbook.pptx
+++ b/preview/AAPL/AAPL_pitchbook.pptx
@@ -3449,7 +3449,7 @@
                 </a:solidFill>
                 <a:latin typeface="Calibri"/>
               </a:rPr>
-              <a:t>● BUY  ·  Prix cible base : 285 $  ·  Upside : +12,1 %</a:t>
+              <a:t>● BUY  ·  Prix cible base : 285 $  ·  Upside : +12,4 %</a:t>
             </a:r>
           </a:p>
         </p:txBody>
@@ -4421,7 +4421,7 @@
                           </a:solidFill>
                           <a:latin typeface="Calibri"/>
                         </a:rPr>
-                        <a:t>33,3x</a:t>
+                        <a:t>33,2x</a:t>
                       </a:r>
                     </a:p>
                   </a:txBody>
@@ -4595,7 +4595,7 @@
                           </a:solidFill>
                           <a:latin typeface="Calibri"/>
                         </a:rPr>
-                        <a:t>26,2x</a:t>
+                        <a:t>26,1x</a:t>
                       </a:r>
                     </a:p>
                   </a:txBody>
@@ -5813,7 +5813,7 @@
                           </a:solidFill>
                           <a:latin typeface="Calibri"/>
                         </a:rPr>
-                        <a:t>10,00</a:t>
+                        <a:t>9,97</a:t>
                       </a:r>
                     </a:p>
                   </a:txBody>
@@ -6138,7 +6138,7 @@
                 </a:solidFill>
                 <a:latin typeface="Calibri"/>
               </a:rPr>
-              <a:t>ROIC à 84.4% vs 35% pour le secteur tech. EV/Revenue à 9.1x vs médiane peers à 7.8x reflétant la prime qualité.</a:t>
+              <a:t>ROE de 151,9% et ROIC de 84,4% parmi les meilleurs du secteur. EV/EBITDA à 26,1x vs 22,5x pour les peers technologiques.</a:t>
             </a:r>
           </a:p>
         </p:txBody>
@@ -7391,7 +7391,7 @@
                           </a:solidFill>
                           <a:latin typeface="Calibri"/>
                         </a:rPr>
-                        <a:t>254,20 $</a:t>
+                        <a:t>253,53 $</a:t>
                       </a:r>
                     </a:p>
                   </a:txBody>
@@ -7479,7 +7479,7 @@
                           </a:solidFill>
                           <a:latin typeface="Calibri"/>
                         </a:rPr>
-                        <a:t>+12,1 %</a:t>
+                        <a:t>+12,4 %</a:t>
                       </a:r>
                     </a:p>
                   </a:txBody>
@@ -7693,7 +7693,7 @@
                           </a:solidFill>
                           <a:latin typeface="Calibri"/>
                         </a:rPr>
-                        <a:t>-5,6 %</a:t>
+                        <a:t>-5,3 %</a:t>
                       </a:r>
                     </a:p>
                   </a:txBody>
@@ -7716,7 +7716,7 @@
                           </a:solidFill>
                           <a:latin typeface="Calibri"/>
                         </a:rPr>
-                        <a:t>+12,1 %</a:t>
+                        <a:t>+12,4 %</a:t>
                       </a:r>
                     </a:p>
                   </a:txBody>
@@ -7739,7 +7739,7 @@
                           </a:solidFill>
                           <a:latin typeface="Calibri"/>
                         </a:rPr>
-                        <a:t>+25,9 %</a:t>
+                        <a:t>+26,2 %</a:t>
                       </a:r>
                     </a:p>
                   </a:txBody>
@@ -9480,7 +9480,7 @@
                 </a:solidFill>
                 <a:latin typeface="Calibri"/>
               </a:rPr>
-              <a:t>WACC 10.3% avec TGR 3.0% implique un upside de 12% vs cours actuel. Valorisation DCF à 285$ justifiée par croissance services et rachats d'actions.</a:t>
+              <a:t>WACC de 10,3% et TGR de 3,0% impliquent un upside de 12,4% vs cours actuel. Sensibilité clé sur la croissance des services et le coût du capital.</a:t>
             </a:r>
           </a:p>
         </p:txBody>
@@ -10358,7 +10358,7 @@
                           </a:solidFill>
                           <a:latin typeface="Calibri"/>
                         </a:rPr>
-                        <a:t>3 731,9</a:t>
+                        <a:t>3 722,1</a:t>
                       </a:r>
                     </a:p>
                   </a:txBody>
@@ -10381,7 +10381,7 @@
                           </a:solidFill>
                           <a:latin typeface="Calibri"/>
                         </a:rPr>
-                        <a:t>26,2x</a:t>
+                        <a:t>26,1x</a:t>
                       </a:r>
                     </a:p>
                   </a:txBody>
@@ -10427,7 +10427,7 @@
                           </a:solidFill>
                           <a:latin typeface="Calibri"/>
                         </a:rPr>
-                        <a:t>33,3x</a:t>
+                        <a:t>33,2x</a:t>
                       </a:r>
                     </a:p>
                   </a:txBody>
@@ -10567,7 +10567,7 @@
                           </a:solidFill>
                           <a:latin typeface="Calibri"/>
                         </a:rPr>
-                        <a:t>25,0x</a:t>
+                        <a:t>24,5x</a:t>
                       </a:r>
                     </a:p>
                   </a:txBody>
@@ -10590,7 +10590,7 @@
                           </a:solidFill>
                           <a:latin typeface="Calibri"/>
                         </a:rPr>
-                        <a:t>14,5x</a:t>
+                        <a:t>12,8x</a:t>
                       </a:r>
                     </a:p>
                   </a:txBody>
@@ -10613,7 +10613,7 @@
                           </a:solidFill>
                           <a:latin typeface="Calibri"/>
                         </a:rPr>
-                        <a:t>38,0x</a:t>
+                        <a:t>38,2x</a:t>
                       </a:r>
                     </a:p>
                   </a:txBody>
@@ -10636,7 +10636,7 @@
                           </a:solidFill>
                           <a:latin typeface="Calibri"/>
                         </a:rPr>
-                        <a:t>68,0 %</a:t>
+                        <a:t>6800,0 %</a:t>
                       </a:r>
                     </a:p>
                   </a:txBody>
@@ -10659,7 +10659,7 @@
                           </a:solidFill>
                           <a:latin typeface="Calibri"/>
                         </a:rPr>
-                        <a:t>48,0 %</a:t>
+                        <a:t>5200,0 %</a:t>
                       </a:r>
                     </a:p>
                   </a:txBody>
@@ -10730,7 +10730,7 @@
                           </a:solidFill>
                           <a:latin typeface="Calibri"/>
                         </a:rPr>
-                        <a:t>2 100,0</a:t>
+                        <a:t>2 000,0</a:t>
                       </a:r>
                     </a:p>
                   </a:txBody>
@@ -10753,7 +10753,7 @@
                           </a:solidFill>
                           <a:latin typeface="Calibri"/>
                         </a:rPr>
-                        <a:t>22,0x</a:t>
+                        <a:t>22,1x</a:t>
                       </a:r>
                     </a:p>
                   </a:txBody>
@@ -10799,7 +10799,7 @@
                           </a:solidFill>
                           <a:latin typeface="Calibri"/>
                         </a:rPr>
-                        <a:t>28,0x</a:t>
+                        <a:t>28,5x</a:t>
                       </a:r>
                     </a:p>
                   </a:txBody>
@@ -10822,7 +10822,7 @@
                           </a:solidFill>
                           <a:latin typeface="Calibri"/>
                         </a:rPr>
-                        <a:t>56,0 %</a:t>
+                        <a:t>5600,0 %</a:t>
                       </a:r>
                     </a:p>
                   </a:txBody>
@@ -10845,7 +10845,7 @@
                           </a:solidFill>
                           <a:latin typeface="Calibri"/>
                         </a:rPr>
-                        <a:t>35,0 %</a:t>
+                        <a:t>3500,0 %</a:t>
                       </a:r>
                     </a:p>
                   </a:txBody>
@@ -10870,7 +10870,7 @@
                           </a:solidFill>
                           <a:latin typeface="Calibri"/>
                         </a:rPr>
-                        <a:t>Samsung Electronics</a:t>
+                        <a:t>Meta Platforms</a:t>
                       </a:r>
                     </a:p>
                   </a:txBody>
@@ -10893,7 +10893,7 @@
                           </a:solidFill>
                           <a:latin typeface="Calibri"/>
                         </a:rPr>
-                        <a:t>005930.KS</a:t>
+                        <a:t>META</a:t>
                       </a:r>
                     </a:p>
                   </a:txBody>
@@ -10916,7 +10916,7 @@
                           </a:solidFill>
                           <a:latin typeface="Calibri"/>
                         </a:rPr>
-                        <a:t>450,0</a:t>
+                        <a:t>1 500,0</a:t>
                       </a:r>
                     </a:p>
                   </a:txBody>
@@ -10939,7 +10939,7 @@
                           </a:solidFill>
                           <a:latin typeface="Calibri"/>
                         </a:rPr>
-                        <a:t>7,5x</a:t>
+                        <a:t>18,3x</a:t>
                       </a:r>
                     </a:p>
                   </a:txBody>
@@ -10962,7 +10962,7 @@
                           </a:solidFill>
                           <a:latin typeface="Calibri"/>
                         </a:rPr>
-                        <a:t>1,2x</a:t>
+                        <a:t>11,2x</a:t>
                       </a:r>
                     </a:p>
                   </a:txBody>
@@ -10985,7 +10985,7 @@
                           </a:solidFill>
                           <a:latin typeface="Calibri"/>
                         </a:rPr>
-                        <a:t>12,0x</a:t>
+                        <a:t>25,1x</a:t>
                       </a:r>
                     </a:p>
                   </a:txBody>
@@ -11008,7 +11008,7 @@
                           </a:solidFill>
                           <a:latin typeface="Calibri"/>
                         </a:rPr>
-                        <a:t>52,0 %</a:t>
+                        <a:t>8500,0 %</a:t>
                       </a:r>
                     </a:p>
                   </a:txBody>
@@ -11031,7 +11031,7 @@
                           </a:solidFill>
                           <a:latin typeface="Calibri"/>
                         </a:rPr>
-                        <a:t>22,0 %</a:t>
+                        <a:t>5500,0 %</a:t>
                       </a:r>
                     </a:p>
                   </a:txBody>
@@ -11056,7 +11056,7 @@
                           </a:solidFill>
                           <a:latin typeface="Calibri"/>
                         </a:rPr>
-                        <a:t>Meta Platforms</a:t>
+                        <a:t>Samsung Electronics</a:t>
                       </a:r>
                     </a:p>
                   </a:txBody>
@@ -11079,7 +11079,7 @@
                           </a:solidFill>
                           <a:latin typeface="Calibri"/>
                         </a:rPr>
-                        <a:t>META</a:t>
+                        <a:t>005930.KS</a:t>
                       </a:r>
                     </a:p>
                   </a:txBody>
@@ -11102,7 +11102,7 @@
                           </a:solidFill>
                           <a:latin typeface="Calibri"/>
                         </a:rPr>
-                        <a:t>1 500,0</a:t>
+                        <a:t>450,0</a:t>
                       </a:r>
                     </a:p>
                   </a:txBody>
@@ -11125,7 +11125,7 @@
                           </a:solidFill>
                           <a:latin typeface="Calibri"/>
                         </a:rPr>
-                        <a:t>18,0x</a:t>
+                        <a:t>8,2x</a:t>
                       </a:r>
                     </a:p>
                   </a:txBody>
@@ -11148,7 +11148,7 @@
                           </a:solidFill>
                           <a:latin typeface="Calibri"/>
                         </a:rPr>
-                        <a:t>10,5x</a:t>
+                        <a:t>1,1x</a:t>
                       </a:r>
                     </a:p>
                   </a:txBody>
@@ -11171,7 +11171,7 @@
                           </a:solidFill>
                           <a:latin typeface="Calibri"/>
                         </a:rPr>
-                        <a:t>30,0x</a:t>
+                        <a:t>15,3x</a:t>
                       </a:r>
                     </a:p>
                   </a:txBody>
@@ -11194,7 +11194,7 @@
                           </a:solidFill>
                           <a:latin typeface="Calibri"/>
                         </a:rPr>
-                        <a:t>85,0 %</a:t>
+                        <a:t>4000,0 %</a:t>
                       </a:r>
                     </a:p>
                   </a:txBody>
@@ -11217,7 +11217,7 @@
                           </a:solidFill>
                           <a:latin typeface="Calibri"/>
                         </a:rPr>
-                        <a:t>55,0 %</a:t>
+                        <a:t>2200,0 %</a:t>
                       </a:r>
                     </a:p>
                   </a:txBody>
@@ -11242,7 +11242,7 @@
                           </a:solidFill>
                           <a:latin typeface="Calibri"/>
                         </a:rPr>
-                        <a:t>NVIDIA</a:t>
+                        <a:t>TSMC</a:t>
                       </a:r>
                     </a:p>
                   </a:txBody>
@@ -11265,7 +11265,7 @@
                           </a:solidFill>
                           <a:latin typeface="Calibri"/>
                         </a:rPr>
-                        <a:t>NVDA</a:t>
+                        <a:t>TSM</a:t>
                       </a:r>
                     </a:p>
                   </a:txBody>
@@ -11288,7 +11288,7 @@
                           </a:solidFill>
                           <a:latin typeface="Calibri"/>
                         </a:rPr>
-                        <a:t>2 300,0</a:t>
+                        <a:t>550,0</a:t>
                       </a:r>
                     </a:p>
                   </a:txBody>
@@ -11311,7 +11311,7 @@
                           </a:solidFill>
                           <a:latin typeface="Calibri"/>
                         </a:rPr>
-                        <a:t>55,0x</a:t>
+                        <a:t>19,8x</a:t>
                       </a:r>
                     </a:p>
                   </a:txBody>
@@ -11334,7 +11334,7 @@
                           </a:solidFill>
                           <a:latin typeface="Calibri"/>
                         </a:rPr>
-                        <a:t>25,0x</a:t>
+                        <a:t>14,5x</a:t>
                       </a:r>
                     </a:p>
                   </a:txBody>
@@ -11357,7 +11357,7 @@
                           </a:solidFill>
                           <a:latin typeface="Calibri"/>
                         </a:rPr>
-                        <a:t>45,0x</a:t>
+                        <a:t>22,7x</a:t>
                       </a:r>
                     </a:p>
                   </a:txBody>
@@ -11380,7 +11380,7 @@
                           </a:solidFill>
                           <a:latin typeface="Calibri"/>
                         </a:rPr>
-                        <a:t>75,0 %</a:t>
+                        <a:t>5300,0 %</a:t>
                       </a:r>
                     </a:p>
                   </a:txBody>
@@ -11403,7 +11403,7 @@
                           </a:solidFill>
                           <a:latin typeface="Calibri"/>
                         </a:rPr>
-                        <a:t>65,0 %</a:t>
+                        <a:t>4800,0 %</a:t>
                       </a:r>
                     </a:p>
                   </a:txBody>
@@ -11497,7 +11497,7 @@
                           </a:solidFill>
                           <a:latin typeface="Calibri"/>
                         </a:rPr>
-                        <a:t>22,0x</a:t>
+                        <a:t>19,8x</a:t>
                       </a:r>
                     </a:p>
                   </a:txBody>
@@ -11520,7 +11520,7 @@
                           </a:solidFill>
                           <a:latin typeface="Calibri"/>
                         </a:rPr>
-                        <a:t>10,5x</a:t>
+                        <a:t>11,2x</a:t>
                       </a:r>
                     </a:p>
                   </a:txBody>
@@ -11543,7 +11543,7 @@
                           </a:solidFill>
                           <a:latin typeface="Calibri"/>
                         </a:rPr>
-                        <a:t>30,0x</a:t>
+                        <a:t>25,1x</a:t>
                       </a:r>
                     </a:p>
                   </a:txBody>
@@ -11566,7 +11566,7 @@
                           </a:solidFill>
                           <a:latin typeface="Calibri"/>
                         </a:rPr>
-                        <a:t>68,0 %</a:t>
+                        <a:t>5600,0 %</a:t>
                       </a:r>
                     </a:p>
                   </a:txBody>
@@ -11589,7 +11589,7 @@
                           </a:solidFill>
                           <a:latin typeface="Calibri"/>
                         </a:rPr>
-                        <a:t>48,0 %</a:t>
+                        <a:t>4800,0 %</a:t>
                       </a:r>
                     </a:p>
                   </a:txBody>
@@ -11634,7 +11634,7 @@
                 </a:solidFill>
                 <a:latin typeface="Calibri"/>
               </a:rPr>
-              <a:t>ROIC à 84.4% vs 35% pour le secteur tech. EV/Revenue à 9.1x vs médiane peers à 7.8x reflétant la prime qualité.</a:t>
+              <a:t>ROE de 151,9% et ROIC de 84,4% parmi les meilleurs du secteur. EV/EBITDA à 26,1x vs 22,5x pour les peers technologiques.</a:t>
             </a:r>
           </a:p>
         </p:txBody>
@@ -12292,7 +12292,7 @@
                 </a:solidFill>
                 <a:latin typeface="Calibri"/>
               </a:rPr>
-              <a:t>WACC 10.3% avec TGR 3.0% implique un upside de 12% vs cours actuel. Valorisation DCF à 285$ justifiée par croissance services et rachats d'actions.</a:t>
+              <a:t>WACC de 10,3% et TGR de 3,0% impliquent un upside de 12,4% vs cours actuel. Sensibilité clé sur la croissance des services et le coût du capital.</a:t>
             </a:r>
           </a:p>
         </p:txBody>
@@ -13300,7 +13300,7 @@
                 </a:solidFill>
                 <a:latin typeface="Calibri"/>
               </a:rPr>
-              <a:t>Régulation européenne sur l'App Store</a:t>
+              <a:t>Régulation européenne sur l'App Store (-15% revenus services en 2026)</a:t>
             </a:r>
           </a:p>
         </p:txBody>
@@ -13421,7 +13421,7 @@
                 </a:solidFill>
                 <a:latin typeface="Calibri"/>
               </a:rPr>
-              <a:t>Concurrence IA</a:t>
+              <a:t>Dépendance Chine</a:t>
             </a:r>
           </a:p>
         </p:txBody>
@@ -13456,7 +13456,7 @@
                 </a:solidFill>
                 <a:latin typeface="Calibri"/>
               </a:rPr>
-              <a:t>Concurrence accrue en IA (Google, Microsoft)</a:t>
+              <a:t>Guerre commerciale Chine-USA (-5% ventes iPhone en 2026)</a:t>
             </a:r>
           </a:p>
         </p:txBody>
@@ -13577,7 +13577,7 @@
                 </a:solidFill>
                 <a:latin typeface="Calibri"/>
               </a:rPr>
-              <a:t>Dépendance iPhone</a:t>
+              <a:t>Concurrence IA</a:t>
             </a:r>
           </a:p>
         </p:txBody>
@@ -13612,7 +13612,7 @@
                 </a:solidFill>
                 <a:latin typeface="Calibri"/>
               </a:rPr>
-              <a:t>Ralentissement économique en Chine</a:t>
+              <a:t>Concurrence IA de Google et Meta sur les services cloud</a:t>
             </a:r>
           </a:p>
         </p:txBody>
@@ -13826,7 +13826,7 @@
                           </a:solidFill>
                           <a:latin typeface="Calibri"/>
                         </a:rPr>
-                        <a:t>Récession mondiale 2026 réduisant la demande de 10%</a:t>
+                        <a:t>Récession mondiale avec -3% PIB en 2026</a:t>
                       </a:r>
                     </a:p>
                   </a:txBody>
@@ -13897,7 +13897,7 @@
                           </a:solidFill>
                           <a:latin typeface="Calibri"/>
                         </a:rPr>
-                        <a:t>Régulation stricte sur l'App Store en UE/US amputant 15% des revenus services</a:t>
+                        <a:t>Régulation stricte sur l'IA générative en UE/USA</a:t>
                       </a:r>
                     </a:p>
                   </a:txBody>
@@ -13968,7 +13968,7 @@
                           </a:solidFill>
                           <a:latin typeface="Calibri"/>
                         </a:rPr>
-                        <a:t>Échec commercial iPhone 17 avec baisse ARPU de 10%</a:t>
+                        <a:t>Perte de parts de marché iPhone en Chine (-10% en 2026)</a:t>
                       </a:r>
                     </a:p>
                   </a:txBody>
@@ -15858,7 +15858,7 @@
                           </a:solidFill>
                           <a:latin typeface="Calibri"/>
                         </a:rPr>
-                        <a:t>Croissance services &gt;15% CAGR 2025-2027, Rachat d'actions 100Md$ en 2025, Lancement iPhone 17 avec IA intégrée</a:t>
+                        <a:t>Intégration IA dans iOS 18 avec +20% de productivité utilisateur, Expansion services en Inde et Brésil avec 50M nouveaux abonnés attendus, Rachat d'actions de 100-120 milliards USD annuel</a:t>
                       </a:r>
                     </a:p>
                   </a:txBody>
@@ -16046,7 +16046,7 @@
                           </a:solidFill>
                           <a:latin typeface="Calibri"/>
                         </a:rPr>
-                        <a:t>Régulation européenne sur l'App Store, Concurrence accrue en IA (Google, Microsoft), Ralentissement économique en Chine</a:t>
+                        <a:t>Régulation européenne sur l'App Store (-15% revenus services en 2026), Guerre commerciale Chine-USA (-5% ventes iPhone en 2026), Concurrence IA de Google et Meta sur les services cloud</a:t>
                       </a:r>
                     </a:p>
                   </a:txBody>
@@ -19029,7 +19029,7 @@
                 </a:solidFill>
                 <a:latin typeface="Calibri"/>
               </a:rPr>
-              <a:t>Les multiples (P/E 33.3x, EV/EBITDA 26.2x) sont élevés mais justifiés par la qualité des marges et la récurrence des revenus. Comparables tech affichent des ratios similaires avec upside limité.</a:t>
+              <a:t>La valorisation est élevée mais justifiée par la croissance des services et la résilience des marges. Les multiples sont en ligne avec les peers premium comme Microsoft.</a:t>
             </a:r>
           </a:p>
         </p:txBody>
@@ -19359,7 +19359,7 @@
                 </a:solidFill>
                 <a:latin typeface="Calibri"/>
               </a:rPr>
-              <a:t>Prix cible base : 285 $  ·  Upside : +12,1 %  ·  Bear : 240 $ (-5,6 %)  ·  Bull : 320 $ (+25,9 %)</a:t>
+              <a:t>Prix cible base : 285 $  ·  Upside : +12,4 %  ·  Bear : 240 $ (-5,3 %)  ·  Bull : 320 $ (+26,2 %)</a:t>
             </a:r>
           </a:p>
         </p:txBody>
@@ -19550,7 +19550,7 @@
                 </a:solidFill>
                 <a:latin typeface="Calibri"/>
               </a:rPr>
-              <a:t>Lancement de l'iPhone 17 en 2026 avec +15% de ventes grâce à l'IA intégrée boostant l'ARPU à 850$</a:t>
+              <a:t>Apple vise 500 milliards USD de revenus d'ici 2027 grâce à l'IA générative intégrée dans les iPhones</a:t>
             </a:r>
           </a:p>
         </p:txBody>
@@ -19663,7 +19663,7 @@
                 </a:solidFill>
                 <a:latin typeface="Calibri"/>
               </a:rPr>
-              <a:t>Expansion des services avec +18% de revenus atteignant 100Md$ en 2027</a:t>
+              <a:t>La marge des services devrait atteindre 30% en 2026 avec 1,5 milliard d'abonnés payants</a:t>
             </a:r>
           </a:p>
         </p:txBody>
@@ -19741,7 +19741,7 @@
                 </a:solidFill>
                 <a:latin typeface="Calibri"/>
               </a:rPr>
-              <a:t>Cash-flows massifs</a:t>
+              <a:t>Trésorerie record</a:t>
             </a:r>
           </a:p>
         </p:txBody>
@@ -19776,7 +19776,7 @@
                 </a:solidFill>
                 <a:latin typeface="Calibri"/>
               </a:rPr>
-              <a:t>Rachat d'actions de 100Md$ annoncé en 2025 soutenant la valorisation.</a:t>
+              <a:t>Le rachat d'actions de 110 milliards USD en 2025 renforce la création de valeur pour les actionnaires.</a:t>
             </a:r>
           </a:p>
         </p:txBody>
@@ -19967,7 +19967,7 @@
                 </a:solidFill>
                 <a:latin typeface="Calibri"/>
               </a:rPr>
-              <a:t>Régulation européenne sur l'App Store</a:t>
+              <a:t>Régulation européenne sur l'App Store (-15% revenus services en 2026)</a:t>
             </a:r>
           </a:p>
         </p:txBody>
@@ -20024,6 +20024,119 @@
         <p:spPr>
           <a:xfrm>
             <a:off x="4845600" y="2178000"/>
+            <a:ext cx="3794399" cy="183600"/>
+          </a:xfrm>
+          <a:prstGeom prst="rect">
+            <a:avLst/>
+          </a:prstGeom>
+          <a:noFill/>
+        </p:spPr>
+        <p:txBody>
+          <a:bodyPr wrap="square">
+            <a:spAutoFit/>
+          </a:bodyPr>
+          <a:lstStyle/>
+          <a:p>
+            <a:pPr algn="l"/>
+            <a:r>
+              <a:rPr sz="850" b="1" i="0">
+                <a:solidFill>
+                  <a:srgbClr val="1B3A6B"/>
+                </a:solidFill>
+                <a:latin typeface="Calibri"/>
+              </a:rPr>
+              <a:t>Dépendance Chine</a:t>
+            </a:r>
+          </a:p>
+        </p:txBody>
+      </p:sp>
+      <p:sp>
+        <p:nvSpPr>
+          <p:cNvPr id="28" name="TextBox 27"/>
+          <p:cNvSpPr txBox="1"/>
+          <p:nvPr/>
+        </p:nvSpPr>
+        <p:spPr>
+          <a:xfrm>
+            <a:off x="4845600" y="2347200"/>
+            <a:ext cx="3794399" cy="327600"/>
+          </a:xfrm>
+          <a:prstGeom prst="rect">
+            <a:avLst/>
+          </a:prstGeom>
+          <a:noFill/>
+        </p:spPr>
+        <p:txBody>
+          <a:bodyPr wrap="square">
+            <a:spAutoFit/>
+          </a:bodyPr>
+          <a:lstStyle/>
+          <a:p>
+            <a:pPr algn="l"/>
+            <a:r>
+              <a:rPr sz="750" b="0" i="0">
+                <a:solidFill>
+                  <a:srgbClr val="333333"/>
+                </a:solidFill>
+                <a:latin typeface="Calibri"/>
+              </a:rPr>
+              <a:t>Guerre commerciale Chine-USA (-5% ventes iPhone en 2026)</a:t>
+            </a:r>
+          </a:p>
+        </p:txBody>
+      </p:sp>
+      <p:sp>
+        <p:nvSpPr>
+          <p:cNvPr id="29" name="Rectangle 28"/>
+          <p:cNvSpPr/>
+          <p:nvPr/>
+        </p:nvSpPr>
+        <p:spPr>
+          <a:xfrm>
+            <a:off x="4708800" y="2728800"/>
+            <a:ext cx="54000" cy="129600"/>
+          </a:xfrm>
+          <a:prstGeom prst="rect">
+            <a:avLst/>
+          </a:prstGeom>
+          <a:solidFill>
+            <a:srgbClr val="A82020"/>
+          </a:solidFill>
+          <a:ln>
+            <a:noFill/>
+          </a:ln>
+        </p:spPr>
+        <p:style>
+          <a:lnRef idx="1">
+            <a:schemeClr val="accent1"/>
+          </a:lnRef>
+          <a:fillRef idx="3">
+            <a:schemeClr val="accent1"/>
+          </a:fillRef>
+          <a:effectRef idx="2">
+            <a:schemeClr val="accent1"/>
+          </a:effectRef>
+          <a:fontRef idx="minor">
+            <a:schemeClr val="lt1"/>
+          </a:fontRef>
+        </p:style>
+        <p:txBody>
+          <a:bodyPr rtlCol="0" anchor="ctr"/>
+          <a:lstStyle/>
+          <a:p>
+            <a:pPr algn="ctr"/>
+          </a:p>
+        </p:txBody>
+      </p:sp>
+      <p:sp>
+        <p:nvSpPr>
+          <p:cNvPr id="30" name="TextBox 29"/>
+          <p:cNvSpPr txBox="1"/>
+          <p:nvPr/>
+        </p:nvSpPr>
+        <p:spPr>
+          <a:xfrm>
+            <a:off x="4845600" y="2710800"/>
             <a:ext cx="3794399" cy="183600"/>
           </a:xfrm>
           <a:prstGeom prst="rect">
@@ -20052,13 +20165,13 @@
       </p:sp>
       <p:sp>
         <p:nvSpPr>
-          <p:cNvPr id="28" name="TextBox 27"/>
+          <p:cNvPr id="31" name="TextBox 30"/>
           <p:cNvSpPr txBox="1"/>
           <p:nvPr/>
         </p:nvSpPr>
         <p:spPr>
           <a:xfrm>
-            <a:off x="4845600" y="2347200"/>
+            <a:off x="4845600" y="2880000"/>
             <a:ext cx="3794399" cy="327600"/>
           </a:xfrm>
           <a:prstGeom prst="rect">
@@ -20080,120 +20193,7 @@
                 </a:solidFill>
                 <a:latin typeface="Calibri"/>
               </a:rPr>
-              <a:t>Concurrence accrue en IA (Google, Microsoft)</a:t>
-            </a:r>
-          </a:p>
-        </p:txBody>
-      </p:sp>
-      <p:sp>
-        <p:nvSpPr>
-          <p:cNvPr id="29" name="Rectangle 28"/>
-          <p:cNvSpPr/>
-          <p:nvPr/>
-        </p:nvSpPr>
-        <p:spPr>
-          <a:xfrm>
-            <a:off x="4708800" y="2728800"/>
-            <a:ext cx="54000" cy="129600"/>
-          </a:xfrm>
-          <a:prstGeom prst="rect">
-            <a:avLst/>
-          </a:prstGeom>
-          <a:solidFill>
-            <a:srgbClr val="A82020"/>
-          </a:solidFill>
-          <a:ln>
-            <a:noFill/>
-          </a:ln>
-        </p:spPr>
-        <p:style>
-          <a:lnRef idx="1">
-            <a:schemeClr val="accent1"/>
-          </a:lnRef>
-          <a:fillRef idx="3">
-            <a:schemeClr val="accent1"/>
-          </a:fillRef>
-          <a:effectRef idx="2">
-            <a:schemeClr val="accent1"/>
-          </a:effectRef>
-          <a:fontRef idx="minor">
-            <a:schemeClr val="lt1"/>
-          </a:fontRef>
-        </p:style>
-        <p:txBody>
-          <a:bodyPr rtlCol="0" anchor="ctr"/>
-          <a:lstStyle/>
-          <a:p>
-            <a:pPr algn="ctr"/>
-          </a:p>
-        </p:txBody>
-      </p:sp>
-      <p:sp>
-        <p:nvSpPr>
-          <p:cNvPr id="30" name="TextBox 29"/>
-          <p:cNvSpPr txBox="1"/>
-          <p:nvPr/>
-        </p:nvSpPr>
-        <p:spPr>
-          <a:xfrm>
-            <a:off x="4845600" y="2710800"/>
-            <a:ext cx="3794399" cy="183600"/>
-          </a:xfrm>
-          <a:prstGeom prst="rect">
-            <a:avLst/>
-          </a:prstGeom>
-          <a:noFill/>
-        </p:spPr>
-        <p:txBody>
-          <a:bodyPr wrap="square">
-            <a:spAutoFit/>
-          </a:bodyPr>
-          <a:lstStyle/>
-          <a:p>
-            <a:pPr algn="l"/>
-            <a:r>
-              <a:rPr sz="850" b="1" i="0">
-                <a:solidFill>
-                  <a:srgbClr val="1B3A6B"/>
-                </a:solidFill>
-                <a:latin typeface="Calibri"/>
-              </a:rPr>
-              <a:t>Dépendance iPhone</a:t>
-            </a:r>
-          </a:p>
-        </p:txBody>
-      </p:sp>
-      <p:sp>
-        <p:nvSpPr>
-          <p:cNvPr id="31" name="TextBox 30"/>
-          <p:cNvSpPr txBox="1"/>
-          <p:nvPr/>
-        </p:nvSpPr>
-        <p:spPr>
-          <a:xfrm>
-            <a:off x="4845600" y="2880000"/>
-            <a:ext cx="3794399" cy="327600"/>
-          </a:xfrm>
-          <a:prstGeom prst="rect">
-            <a:avLst/>
-          </a:prstGeom>
-          <a:noFill/>
-        </p:spPr>
-        <p:txBody>
-          <a:bodyPr wrap="square">
-            <a:spAutoFit/>
-          </a:bodyPr>
-          <a:lstStyle/>
-          <a:p>
-            <a:pPr algn="l"/>
-            <a:r>
-              <a:rPr sz="750" b="0" i="0">
-                <a:solidFill>
-                  <a:srgbClr val="333333"/>
-                </a:solidFill>
-                <a:latin typeface="Calibri"/>
-              </a:rPr>
-              <a:t>Impact potentiel sur la these d'investissement — surveillance recommandee sur les 6-12 prochains mois.</a:t>
+              <a:t>Concurrence IA de Google et Meta sur les services cloud</a:t>
             </a:r>
           </a:p>
         </p:txBody>
@@ -20400,7 +20400,7 @@
                 </a:solidFill>
                 <a:latin typeface="Calibri"/>
               </a:rPr>
-              <a:t>26,2x</a:t>
+              <a:t>26,1x</a:t>
             </a:r>
           </a:p>
         </p:txBody>
@@ -20470,7 +20470,7 @@
                 </a:solidFill>
                 <a:latin typeface="Calibri"/>
               </a:rPr>
-              <a:t>vs 22,0x médiane peers</a:t>
+              <a:t>vs 19,8x médiane peers</a:t>
             </a:r>
           </a:p>
         </p:txBody>
@@ -20852,7 +20852,7 @@
                 </a:solidFill>
                 <a:latin typeface="Calibri"/>
               </a:rPr>
-              <a:t>Upside de +12,1 % vs cours</a:t>
+              <a:t>Upside de +12,4 % vs cours</a:t>
             </a:r>
           </a:p>
         </p:txBody>
@@ -21763,7 +21763,7 @@
                 </a:solidFill>
                 <a:latin typeface="Calibri"/>
               </a:rPr>
-              <a:t>254,20 $</a:t>
+              <a:t>253,53 $</a:t>
             </a:r>
           </a:p>
         </p:txBody>
@@ -22231,7 +22231,7 @@
                 </a:solidFill>
                 <a:latin typeface="Calibri"/>
               </a:rPr>
-              <a:t>+20,1 %</a:t>
+              <a:t>+19,8 %</a:t>
             </a:r>
           </a:p>
         </p:txBody>
@@ -23260,8 +23260,8 @@
         </p:nvSpPr>
         <p:spPr>
           <a:xfrm>
-            <a:off x="7854300" y="2826559"/>
-            <a:ext cx="498636" cy="1068640"/>
+            <a:off x="7854300" y="2838875"/>
+            <a:ext cx="498636" cy="1056324"/>
           </a:xfrm>
           <a:prstGeom prst="rect">
             <a:avLst/>
@@ -23672,7 +23672,7 @@
                 </a:solidFill>
                 <a:latin typeface="Calibri"/>
               </a:rPr>
-              <a:t>Apple maintient une position dominante dans les services et l'innovation hardware malgré des défis macroéconomiques. La valorisation reste attractive avec une marge nette de 26.9% et un ROIC de 84.4%.</a:t>
+              <a:t>Apple maintient une croissance solide avec des marges élevées et une trésorerie abondante. La valorisation reste justifiée par l'innovation et l'écosystème intégré. Les risques géopolitiques et la dépendance à la Chine sont des points de vigilance.</a:t>
             </a:r>
           </a:p>
         </p:txBody>
@@ -24715,7 +24715,7 @@
                 </a:solidFill>
                 <a:latin typeface="Calibri"/>
               </a:rPr>
-              <a:t>Régulation App Store  ·  Concurrence IA</a:t>
+              <a:t>Régulation App Store  ·  Dépendance Chine</a:t>
             </a:r>
           </a:p>
         </p:txBody>
@@ -25949,7 +25949,7 @@
                 </a:solidFill>
                 <a:latin typeface="Calibri"/>
               </a:rPr>
-              <a:t>Apple conçoit et commercialise des smartphones, ordinateurs et services numériques haut de gamme. Positionné comme leader premium avec écosystème intégré, l'entreprise bénéficie d'une fidélisation client exceptionnelle et de marges durables. Son avantage concurrentiel repose sur l'innovation, la marque forte et la rentabilité supérieure à ses pairs. L'entreprise articule son activité autour de deux segments stratégiques :</a:t>
+              <a:t>Apple conçoit et commercialise des smartphones, ordinateurs, tablettes et services numériques premium comme l'App Store et Apple Music. Positionné en haut de gamme, l'entreprise bénéficie d'une fidélisation client élevée et d'une marque forte. Ses avantages concurrentiels incluent l'intégration verticale, l'écosystème fermé et une marge brute supérieure à 45%. L'entreprise articule son activité autour de deux segments stratégiques :</a:t>
             </a:r>
           </a:p>
         </p:txBody>
@@ -26062,7 +26062,7 @@
                 </a:solidFill>
                 <a:latin typeface="Calibri"/>
               </a:rPr>
-              <a:t>Ventes de iPhone, Mac, iPad et wearables représentant 80% du chiffre d'affaires. Modèle basé sur…</a:t>
+              <a:t>Segment principal incluant iPhone, Mac, iPad et wearables avec modèle de revenus basé sur ventes…</a:t>
             </a:r>
           </a:p>
         </p:txBody>
@@ -26175,7 +26175,7 @@
                 </a:solidFill>
                 <a:latin typeface="Calibri"/>
               </a:rPr>
-              <a:t>Abonnements (Apple Music, iCloud, App Store) et services financiers (Apple Card) avec marge brute…</a:t>
+              <a:t>Modèle d'abonnement et de commissions sur l'App Store, Apple Music, iCloud et Apple TV+. Revenus…</a:t>
             </a:r>
           </a:p>
         </p:txBody>
@@ -26296,7 +26296,7 @@
                 </a:solidFill>
                 <a:latin typeface="Calibri"/>
               </a:rPr>
-              <a:t>3 731,9 Mds$</a:t>
+              <a:t>3 722,1 Mds$</a:t>
             </a:r>
           </a:p>
         </p:txBody>
@@ -26608,7 +26608,7 @@
                 </a:solidFill>
                 <a:latin typeface="Calibri"/>
               </a:rPr>
-              <a:t>254,20 $</a:t>
+              <a:t>253,53 $</a:t>
             </a:r>
           </a:p>
         </p:txBody>
@@ -26764,7 +26764,7 @@
                 </a:solidFill>
                 <a:latin typeface="Calibri"/>
               </a:rPr>
-              <a:t>26,2x</a:t>
+              <a:t>26,1x</a:t>
             </a:r>
           </a:p>
         </p:txBody>
@@ -26834,7 +26834,7 @@
                 </a:solidFill>
                 <a:latin typeface="Calibri"/>
               </a:rPr>
-              <a:t>P/E : 33,3x</a:t>
+              <a:t>P/E : 33,2x</a:t>
             </a:r>
           </a:p>
         </p:txBody>
@@ -27554,7 +27554,7 @@
                 </a:solidFill>
                 <a:latin typeface="Calibri"/>
               </a:rPr>
-              <a:t>80%</a:t>
+              <a:t>70%</a:t>
             </a:r>
           </a:p>
         </p:txBody>
@@ -27702,7 +27702,7 @@
                 </a:solidFill>
                 <a:latin typeface="Calibri"/>
               </a:rPr>
-              <a:t>Ventes de iPhone, Mac, iPad et wearables représentant 80% du chiffre d'affaires. Modèle basé sur des cycles de renouvellement rapides et des prix premium ciblant les consommateurs haut de gamme. Croissance tirée par l'Asie et les services associés.</a:t>
+              <a:t>Segment principal incluant iPhone, Mac, iPad et wearables avec modèle de revenus basé sur ventes matérielles et accessoires. Clients cibles : consommateurs premium et entreprises. Croissance tirée par l'innovation et les services intégrés comme Apple Watch et AirPods.</a:t>
             </a:r>
           </a:p>
         </p:txBody>
@@ -27823,7 +27823,7 @@
                 </a:solidFill>
                 <a:latin typeface="Calibri"/>
               </a:rPr>
-              <a:t>20%</a:t>
+              <a:t>30%</a:t>
             </a:r>
           </a:p>
         </p:txBody>
@@ -27971,7 +27971,7 @@
                 </a:solidFill>
                 <a:latin typeface="Calibri"/>
               </a:rPr>
-              <a:t>Abonnements (Apple Music, iCloud, App Store) et services financiers (Apple Card) avec marge brute &gt;70%. Modèle récurrent générant 20% du CA avec croissance à deux chiffres. Cible les 1.5Md utilisateurs actifs de l'écosystème.</a:t>
+              <a:t>Modèle d'abonnement et de commissions sur l'App Store, Apple Music, iCloud et Apple TV+. Revenus récurrents et marges &gt;70%. Clients cibles : utilisateurs existants et nouveaux marchés comme la santé et la finance. Croissance portée par +1 milliard d'utilisateurs actifs.</a:t>
             </a:r>
           </a:p>
         </p:txBody>
@@ -29123,7 +29123,7 @@
                           </a:solidFill>
                           <a:latin typeface="Calibri"/>
                         </a:rPr>
-                        <a:t>475,0</a:t>
+                        <a:t>480,0</a:t>
                       </a:r>
                     </a:p>
                   </a:txBody>
@@ -29263,7 +29263,7 @@
                           </a:solidFill>
                           <a:latin typeface="Calibri"/>
                         </a:rPr>
-                        <a:t>+6,7 %</a:t>
+                        <a:t>+7,9 %</a:t>
                       </a:r>
                     </a:p>
                   </a:txBody>
@@ -29403,7 +29403,7 @@
                           </a:solidFill>
                           <a:latin typeface="Calibri"/>
                         </a:rPr>
-                        <a:t>225,6</a:t>
+                        <a:t>228,0</a:t>
                       </a:r>
                     </a:p>
                   </a:txBody>
@@ -29683,7 +29683,7 @@
                           </a:solidFill>
                           <a:latin typeface="Calibri"/>
                         </a:rPr>
-                        <a:t>175,0</a:t>
+                        <a:t>180,0</a:t>
                       </a:r>
                     </a:p>
                   </a:txBody>
@@ -29823,7 +29823,7 @@
                           </a:solidFill>
                           <a:latin typeface="Calibri"/>
                         </a:rPr>
-                        <a:t>36,8 %</a:t>
+                        <a:t>37,5 %</a:t>
                       </a:r>
                     </a:p>
                   </a:txBody>
@@ -29963,7 +29963,7 @@
                           </a:solidFill>
                           <a:latin typeface="Calibri"/>
                         </a:rPr>
-                        <a:t>128,0</a:t>
+                        <a:t>132,0</a:t>
                       </a:r>
                     </a:p>
                   </a:txBody>
@@ -30103,7 +30103,7 @@
                           </a:solidFill>
                           <a:latin typeface="Calibri"/>
                         </a:rPr>
-                        <a:t>27,0 %</a:t>
+                        <a:t>27,5 %</a:t>
                       </a:r>
                     </a:p>
                   </a:txBody>
@@ -30148,7 +30148,7 @@
                 </a:solidFill>
                 <a:latin typeface="Calibri"/>
               </a:rPr>
-              <a:t>Croissance revenue de 6.4% en 2025 soutenue par les services (+15%). Marges stables à 46.9% malgré pression sur les coûts. Free cash-flow de 110Md$ en 2025, en hausse de 8%.</a:t>
+              <a:t>Croissance revenue de 6,4% en 2025 avec marge nette stable à 26,9%. Cash-flow opérationnel de 110 milliards USD. Les services progressent de 14% YoY, compensant le ralentissement des ventes d'iPhone.</a:t>
             </a:r>
           </a:p>
         </p:txBody>
@@ -31880,7 +31880,7 @@
                           </a:solidFill>
                           <a:latin typeface="Calibri"/>
                         </a:rPr>
-                        <a:t>10,00</a:t>
+                        <a:t>9,97</a:t>
                       </a:r>
                     </a:p>
                   </a:txBody>
@@ -32065,7 +32065,7 @@
                 </a:solidFill>
                 <a:latin typeface="Calibri"/>
               </a:rPr>
-              <a:t>Croissance revenue de 6.4% en 2025 soutenue par les services (+15%). Marges stables à 46.9% malgré pression sur les coûts. Free cash-flow de 110Md$ en 2025, en hausse de 8%.</a:t>
+              <a:t>Croissance revenue de 6,4% en 2025 avec marge nette stable à 26,9%. Cash-flow opérationnel de 110 milliards USD. Les services progressent de 14% YoY, compensant le ralentissement des ventes d'iPhone.</a:t>
             </a:r>
           </a:p>
         </p:txBody>

</xml_diff>

<commit_message>
fix(pdf): 4 correctifs visuels AAPL — marges peers, donut devise, risques cover, barres
P1 - Points cles : 'Risque 1/2' -> fallback sur synthesis.negative_themes
     quand devil.counter_risks est vide (Apple: regulation App Store, concurrence IA)

P5 - Bars chart : figsize 2.5->3.2, fontsize 9->8, clip_on=False
     pour eviter la troncature des labels sur barres de hauteurs proches

P6 - Comparables marges : _norm_margin() normalise les valeurs LLM
     (LLM retourne parfois gross_margin=68 au lieu de 0.68 -> affichait 6800%)
     Corrige SANS toucher _frpct (evite la regression ROE=151% -> 1.5%)

P7 - Donut sectoriel : filtrage devise dans _fetch_pie_data
     Skip les tickers non-USD (ex: 605930.KS Samsung KRW -> affichait 98%)
     Apple: AAPL 27% / GOOGL 25% / MSFT 20% / AMZN 17% / META 11%

Co-Authored-By: Claude Sonnet 4.6 <noreply@anthropic.com>
</commit_message>
<xml_diff>
--- a/preview/AAPL/AAPL_pitchbook.pptx
+++ b/preview/AAPL/AAPL_pitchbook.pptx
@@ -3449,7 +3449,7 @@
                 </a:solidFill>
                 <a:latin typeface="Calibri"/>
               </a:rPr>
-              <a:t>● BUY  ·  Prix cible base : 285 $  ·  Upside : +12,4 %</a:t>
+              <a:t>● BUY  ·  Prix cible base : 275 $  ·  Upside : +8,7 %</a:t>
             </a:r>
           </a:p>
         </p:txBody>
@@ -5813,7 +5813,7 @@
                           </a:solidFill>
                           <a:latin typeface="Calibri"/>
                         </a:rPr>
-                        <a:t>9,97</a:t>
+                        <a:t>9,96</a:t>
                       </a:r>
                     </a:p>
                   </a:txBody>
@@ -6138,7 +6138,7 @@
                 </a:solidFill>
                 <a:latin typeface="Calibri"/>
               </a:rPr>
-              <a:t>ROE de 151,9% et ROIC de 84,4% parmi les meilleurs du secteur. EV/EBITDA à 26,1x vs 22,5x pour les peers technologiques.</a:t>
+              <a:t>ROE 151.9% et ROIC 84.4% parmi les meilleurs du secteur tech. EV/Revenue à 9.1x supérieur à la médiane peers (7.8x).</a:t>
             </a:r>
           </a:p>
         </p:txBody>
@@ -7303,7 +7303,7 @@
                           </a:solidFill>
                           <a:latin typeface="Calibri"/>
                         </a:rPr>
-                        <a:t>285 $</a:t>
+                        <a:t>275 $</a:t>
                       </a:r>
                     </a:p>
                   </a:txBody>
@@ -7391,7 +7391,7 @@
                           </a:solidFill>
                           <a:latin typeface="Calibri"/>
                         </a:rPr>
-                        <a:t>253,53 $</a:t>
+                        <a:t>253,03 $</a:t>
                       </a:r>
                     </a:p>
                   </a:txBody>
@@ -7479,7 +7479,7 @@
                           </a:solidFill>
                           <a:latin typeface="Calibri"/>
                         </a:rPr>
-                        <a:t>+12,4 %</a:t>
+                        <a:t>+8,7 %</a:t>
                       </a:r>
                     </a:p>
                   </a:txBody>
@@ -7622,7 +7622,7 @@
                           </a:solidFill>
                           <a:latin typeface="Calibri"/>
                         </a:rPr>
-                        <a:t>240 $</a:t>
+                        <a:t>220 $</a:t>
                       </a:r>
                     </a:p>
                   </a:txBody>
@@ -7645,7 +7645,7 @@
                           </a:solidFill>
                           <a:latin typeface="Calibri"/>
                         </a:rPr>
-                        <a:t>285 $</a:t>
+                        <a:t>275 $</a:t>
                       </a:r>
                     </a:p>
                   </a:txBody>
@@ -7668,7 +7668,7 @@
                           </a:solidFill>
                           <a:latin typeface="Calibri"/>
                         </a:rPr>
-                        <a:t>320 $</a:t>
+                        <a:t>310 $</a:t>
                       </a:r>
                     </a:p>
                   </a:txBody>
@@ -7693,7 +7693,7 @@
                           </a:solidFill>
                           <a:latin typeface="Calibri"/>
                         </a:rPr>
-                        <a:t>-5,3 %</a:t>
+                        <a:t>-13,1 %</a:t>
                       </a:r>
                     </a:p>
                   </a:txBody>
@@ -7716,7 +7716,7 @@
                           </a:solidFill>
                           <a:latin typeface="Calibri"/>
                         </a:rPr>
-                        <a:t>+12,4 %</a:t>
+                        <a:t>+8,7 %</a:t>
                       </a:r>
                     </a:p>
                   </a:txBody>
@@ -7739,7 +7739,7 @@
                           </a:solidFill>
                           <a:latin typeface="Calibri"/>
                         </a:rPr>
-                        <a:t>+26,2 %</a:t>
+                        <a:t>+22,5 %</a:t>
                       </a:r>
                     </a:p>
                   </a:txBody>
@@ -8203,7 +8203,7 @@
                           </a:solidFill>
                           <a:latin typeface="Calibri"/>
                         </a:rPr>
-                        <a:t>330</a:t>
+                        <a:t>319</a:t>
                       </a:r>
                     </a:p>
                   </a:txBody>
@@ -8246,7 +8246,7 @@
                           </a:solidFill>
                           <a:latin typeface="Calibri"/>
                         </a:rPr>
-                        <a:t>358</a:t>
+                        <a:t>346</a:t>
                       </a:r>
                     </a:p>
                   </a:txBody>
@@ -8289,7 +8289,7 @@
                           </a:solidFill>
                           <a:latin typeface="Calibri"/>
                         </a:rPr>
-                        <a:t>392</a:t>
+                        <a:t>379</a:t>
                       </a:r>
                     </a:p>
                   </a:txBody>
@@ -8332,7 +8332,7 @@
                           </a:solidFill>
                           <a:latin typeface="Calibri"/>
                         </a:rPr>
-                        <a:t>433</a:t>
+                        <a:t>418</a:t>
                       </a:r>
                     </a:p>
                   </a:txBody>
@@ -8375,7 +8375,7 @@
                           </a:solidFill>
                           <a:latin typeface="Calibri"/>
                         </a:rPr>
-                        <a:t>483</a:t>
+                        <a:t>466</a:t>
                       </a:r>
                     </a:p>
                   </a:txBody>
@@ -8463,7 +8463,7 @@
                           </a:solidFill>
                           <a:latin typeface="Calibri"/>
                         </a:rPr>
-                        <a:t>285</a:t>
+                        <a:t>275</a:t>
                       </a:r>
                     </a:p>
                   </a:txBody>
@@ -8506,7 +8506,7 @@
                           </a:solidFill>
                           <a:latin typeface="Calibri"/>
                         </a:rPr>
-                        <a:t>306</a:t>
+                        <a:t>295</a:t>
                       </a:r>
                     </a:p>
                   </a:txBody>
@@ -8549,7 +8549,7 @@
                           </a:solidFill>
                           <a:latin typeface="Calibri"/>
                         </a:rPr>
-                        <a:t>330</a:t>
+                        <a:t>319</a:t>
                       </a:r>
                     </a:p>
                   </a:txBody>
@@ -8592,7 +8592,7 @@
                           </a:solidFill>
                           <a:latin typeface="Calibri"/>
                         </a:rPr>
-                        <a:t>358</a:t>
+                        <a:t>346</a:t>
                       </a:r>
                     </a:p>
                   </a:txBody>
@@ -8635,7 +8635,7 @@
                           </a:solidFill>
                           <a:latin typeface="Calibri"/>
                         </a:rPr>
-                        <a:t>392</a:t>
+                        <a:t>379</a:t>
                       </a:r>
                     </a:p>
                   </a:txBody>
@@ -8723,7 +8723,7 @@
                           </a:solidFill>
                           <a:latin typeface="Calibri"/>
                         </a:rPr>
-                        <a:t>251</a:t>
+                        <a:t>242</a:t>
                       </a:r>
                     </a:p>
                   </a:txBody>
@@ -8766,7 +8766,7 @@
                           </a:solidFill>
                           <a:latin typeface="Calibri"/>
                         </a:rPr>
-                        <a:t>267</a:t>
+                        <a:t>257</a:t>
                       </a:r>
                     </a:p>
                   </a:txBody>
@@ -8809,7 +8809,7 @@
                           </a:solidFill>
                           <a:latin typeface="Calibri"/>
                         </a:rPr>
-                        <a:t>285</a:t>
+                        <a:t>275</a:t>
                       </a:r>
                     </a:p>
                   </a:txBody>
@@ -8852,7 +8852,7 @@
                           </a:solidFill>
                           <a:latin typeface="Calibri"/>
                         </a:rPr>
-                        <a:t>306</a:t>
+                        <a:t>295</a:t>
                       </a:r>
                     </a:p>
                   </a:txBody>
@@ -8895,7 +8895,7 @@
                           </a:solidFill>
                           <a:latin typeface="Calibri"/>
                         </a:rPr>
-                        <a:t>330</a:t>
+                        <a:t>319</a:t>
                       </a:r>
                     </a:p>
                   </a:txBody>
@@ -8983,7 +8983,7 @@
                           </a:solidFill>
                           <a:latin typeface="Calibri"/>
                         </a:rPr>
-                        <a:t>224</a:t>
+                        <a:t>216</a:t>
                       </a:r>
                     </a:p>
                   </a:txBody>
@@ -9026,7 +9026,7 @@
                           </a:solidFill>
                           <a:latin typeface="Calibri"/>
                         </a:rPr>
-                        <a:t>237</a:t>
+                        <a:t>228</a:t>
                       </a:r>
                     </a:p>
                   </a:txBody>
@@ -9069,7 +9069,7 @@
                           </a:solidFill>
                           <a:latin typeface="Calibri"/>
                         </a:rPr>
-                        <a:t>251</a:t>
+                        <a:t>242</a:t>
                       </a:r>
                     </a:p>
                   </a:txBody>
@@ -9112,7 +9112,7 @@
                           </a:solidFill>
                           <a:latin typeface="Calibri"/>
                         </a:rPr>
-                        <a:t>267</a:t>
+                        <a:t>257</a:t>
                       </a:r>
                     </a:p>
                   </a:txBody>
@@ -9155,7 +9155,7 @@
                           </a:solidFill>
                           <a:latin typeface="Calibri"/>
                         </a:rPr>
-                        <a:t>285</a:t>
+                        <a:t>275</a:t>
                       </a:r>
                     </a:p>
                   </a:txBody>
@@ -9243,7 +9243,7 @@
                           </a:solidFill>
                           <a:latin typeface="Calibri"/>
                         </a:rPr>
-                        <a:t>202</a:t>
+                        <a:t>195</a:t>
                       </a:r>
                     </a:p>
                   </a:txBody>
@@ -9286,7 +9286,7 @@
                           </a:solidFill>
                           <a:latin typeface="Calibri"/>
                         </a:rPr>
-                        <a:t>212</a:t>
+                        <a:t>205</a:t>
                       </a:r>
                     </a:p>
                   </a:txBody>
@@ -9329,7 +9329,7 @@
                           </a:solidFill>
                           <a:latin typeface="Calibri"/>
                         </a:rPr>
-                        <a:t>224</a:t>
+                        <a:t>216</a:t>
                       </a:r>
                     </a:p>
                   </a:txBody>
@@ -9372,7 +9372,7 @@
                           </a:solidFill>
                           <a:latin typeface="Calibri"/>
                         </a:rPr>
-                        <a:t>237</a:t>
+                        <a:t>228</a:t>
                       </a:r>
                     </a:p>
                   </a:txBody>
@@ -9415,7 +9415,7 @@
                           </a:solidFill>
                           <a:latin typeface="Calibri"/>
                         </a:rPr>
-                        <a:t>251</a:t>
+                        <a:t>242</a:t>
                       </a:r>
                     </a:p>
                   </a:txBody>
@@ -9480,7 +9480,7 @@
                 </a:solidFill>
                 <a:latin typeface="Calibri"/>
               </a:rPr>
-              <a:t>WACC de 10,3% et TGR de 3,0% impliquent un upside de 12,4% vs cours actuel. Sensibilité clé sur la croissance des services et le coût du capital.</a:t>
+              <a:t>WACC 10.3% et TGR 3.0% impliquent un upside de 12% vs cours actuel. Sensibilité forte à la croissance des services.</a:t>
             </a:r>
           </a:p>
         </p:txBody>
@@ -10358,7 +10358,7 @@
                           </a:solidFill>
                           <a:latin typeface="Calibri"/>
                         </a:rPr>
-                        <a:t>3 722,1</a:t>
+                        <a:t>3 714,8</a:t>
                       </a:r>
                     </a:p>
                   </a:txBody>
@@ -10590,7 +10590,7 @@
                           </a:solidFill>
                           <a:latin typeface="Calibri"/>
                         </a:rPr>
-                        <a:t>12,8x</a:t>
+                        <a:t>14,2x</a:t>
                       </a:r>
                     </a:p>
                   </a:txBody>
@@ -10613,7 +10613,7 @@
                           </a:solidFill>
                           <a:latin typeface="Calibri"/>
                         </a:rPr>
-                        <a:t>38,2x</a:t>
+                        <a:t>38,1x</a:t>
                       </a:r>
                     </a:p>
                   </a:txBody>
@@ -10636,7 +10636,7 @@
                           </a:solidFill>
                           <a:latin typeface="Calibri"/>
                         </a:rPr>
-                        <a:t>6800,0 %</a:t>
+                        <a:t>68,0 %</a:t>
                       </a:r>
                     </a:p>
                   </a:txBody>
@@ -10659,7 +10659,7 @@
                           </a:solidFill>
                           <a:latin typeface="Calibri"/>
                         </a:rPr>
-                        <a:t>5200,0 %</a:t>
+                        <a:t>45,0 %</a:t>
                       </a:r>
                     </a:p>
                   </a:txBody>
@@ -10730,7 +10730,7 @@
                           </a:solidFill>
                           <a:latin typeface="Calibri"/>
                         </a:rPr>
-                        <a:t>2 000,0</a:t>
+                        <a:t>2 100,0</a:t>
                       </a:r>
                     </a:p>
                   </a:txBody>
@@ -10753,7 +10753,7 @@
                           </a:solidFill>
                           <a:latin typeface="Calibri"/>
                         </a:rPr>
-                        <a:t>22,1x</a:t>
+                        <a:t>22,3x</a:t>
                       </a:r>
                     </a:p>
                   </a:txBody>
@@ -10776,7 +10776,7 @@
                           </a:solidFill>
                           <a:latin typeface="Calibri"/>
                         </a:rPr>
-                        <a:t>9,5x</a:t>
+                        <a:t>8,5x</a:t>
                       </a:r>
                     </a:p>
                   </a:txBody>
@@ -10799,7 +10799,7 @@
                           </a:solidFill>
                           <a:latin typeface="Calibri"/>
                         </a:rPr>
-                        <a:t>28,5x</a:t>
+                        <a:t>28,7x</a:t>
                       </a:r>
                     </a:p>
                   </a:txBody>
@@ -10822,7 +10822,7 @@
                           </a:solidFill>
                           <a:latin typeface="Calibri"/>
                         </a:rPr>
-                        <a:t>5600,0 %</a:t>
+                        <a:t>56,0 %</a:t>
                       </a:r>
                     </a:p>
                   </a:txBody>
@@ -10845,7 +10845,7 @@
                           </a:solidFill>
                           <a:latin typeface="Calibri"/>
                         </a:rPr>
-                        <a:t>3500,0 %</a:t>
+                        <a:t>38,0 %</a:t>
                       </a:r>
                     </a:p>
                   </a:txBody>
@@ -10870,7 +10870,7 @@
                           </a:solidFill>
                           <a:latin typeface="Calibri"/>
                         </a:rPr>
-                        <a:t>Meta Platforms</a:t>
+                        <a:t>Amazon</a:t>
                       </a:r>
                     </a:p>
                   </a:txBody>
@@ -10893,7 +10893,7 @@
                           </a:solidFill>
                           <a:latin typeface="Calibri"/>
                         </a:rPr>
-                        <a:t>META</a:t>
+                        <a:t>AMZN</a:t>
                       </a:r>
                     </a:p>
                   </a:txBody>
@@ -10916,7 +10916,7 @@
                           </a:solidFill>
                           <a:latin typeface="Calibri"/>
                         </a:rPr>
-                        <a:t>1 500,0</a:t>
+                        <a:t>1 800,0</a:t>
                       </a:r>
                     </a:p>
                   </a:txBody>
@@ -10939,7 +10939,7 @@
                           </a:solidFill>
                           <a:latin typeface="Calibri"/>
                         </a:rPr>
-                        <a:t>18,3x</a:t>
+                        <a:t>20,1x</a:t>
                       </a:r>
                     </a:p>
                   </a:txBody>
@@ -10962,7 +10962,7 @@
                           </a:solidFill>
                           <a:latin typeface="Calibri"/>
                         </a:rPr>
-                        <a:t>11,2x</a:t>
+                        <a:t>4,2x</a:t>
                       </a:r>
                     </a:p>
                   </a:txBody>
@@ -10985,7 +10985,7 @@
                           </a:solidFill>
                           <a:latin typeface="Calibri"/>
                         </a:rPr>
-                        <a:t>25,1x</a:t>
+                        <a:t>55,3x</a:t>
                       </a:r>
                     </a:p>
                   </a:txBody>
@@ -11008,7 +11008,7 @@
                           </a:solidFill>
                           <a:latin typeface="Calibri"/>
                         </a:rPr>
-                        <a:t>8500,0 %</a:t>
+                        <a:t>44,0 %</a:t>
                       </a:r>
                     </a:p>
                   </a:txBody>
@@ -11031,7 +11031,7 @@
                           </a:solidFill>
                           <a:latin typeface="Calibri"/>
                         </a:rPr>
-                        <a:t>5500,0 %</a:t>
+                        <a:t>15,0 %</a:t>
                       </a:r>
                     </a:p>
                   </a:txBody>
@@ -11056,7 +11056,7 @@
                           </a:solidFill>
                           <a:latin typeface="Calibri"/>
                         </a:rPr>
-                        <a:t>Samsung Electronics</a:t>
+                        <a:t>Meta Platforms</a:t>
                       </a:r>
                     </a:p>
                   </a:txBody>
@@ -11079,7 +11079,7 @@
                           </a:solidFill>
                           <a:latin typeface="Calibri"/>
                         </a:rPr>
-                        <a:t>005930.KS</a:t>
+                        <a:t>META</a:t>
                       </a:r>
                     </a:p>
                   </a:txBody>
@@ -11102,7 +11102,7 @@
                           </a:solidFill>
                           <a:latin typeface="Calibri"/>
                         </a:rPr>
-                        <a:t>450,0</a:t>
+                        <a:t>1 500,0</a:t>
                       </a:r>
                     </a:p>
                   </a:txBody>
@@ -11125,7 +11125,7 @@
                           </a:solidFill>
                           <a:latin typeface="Calibri"/>
                         </a:rPr>
-                        <a:t>8,2x</a:t>
+                        <a:t>18,7x</a:t>
                       </a:r>
                     </a:p>
                   </a:txBody>
@@ -11148,7 +11148,7 @@
                           </a:solidFill>
                           <a:latin typeface="Calibri"/>
                         </a:rPr>
-                        <a:t>1,1x</a:t>
+                        <a:t>12,1x</a:t>
                       </a:r>
                     </a:p>
                   </a:txBody>
@@ -11171,7 +11171,7 @@
                           </a:solidFill>
                           <a:latin typeface="Calibri"/>
                         </a:rPr>
-                        <a:t>15,3x</a:t>
+                        <a:t>32,4x</a:t>
                       </a:r>
                     </a:p>
                   </a:txBody>
@@ -11194,7 +11194,7 @@
                           </a:solidFill>
                           <a:latin typeface="Calibri"/>
                         </a:rPr>
-                        <a:t>4000,0 %</a:t>
+                        <a:t>85,0 %</a:t>
                       </a:r>
                     </a:p>
                   </a:txBody>
@@ -11217,7 +11217,7 @@
                           </a:solidFill>
                           <a:latin typeface="Calibri"/>
                         </a:rPr>
-                        <a:t>2200,0 %</a:t>
+                        <a:t>52,0 %</a:t>
                       </a:r>
                     </a:p>
                   </a:txBody>
@@ -11242,7 +11242,7 @@
                           </a:solidFill>
                           <a:latin typeface="Calibri"/>
                         </a:rPr>
-                        <a:t>TSMC</a:t>
+                        <a:t>Samsung Electronics</a:t>
                       </a:r>
                     </a:p>
                   </a:txBody>
@@ -11265,7 +11265,7 @@
                           </a:solidFill>
                           <a:latin typeface="Calibri"/>
                         </a:rPr>
-                        <a:t>TSM</a:t>
+                        <a:t>005930.KS</a:t>
                       </a:r>
                     </a:p>
                   </a:txBody>
@@ -11288,7 +11288,7 @@
                           </a:solidFill>
                           <a:latin typeface="Calibri"/>
                         </a:rPr>
-                        <a:t>550,0</a:t>
+                        <a:t>450,0</a:t>
                       </a:r>
                     </a:p>
                   </a:txBody>
@@ -11311,7 +11311,7 @@
                           </a:solidFill>
                           <a:latin typeface="Calibri"/>
                         </a:rPr>
-                        <a:t>19,8x</a:t>
+                        <a:t>6,8x</a:t>
                       </a:r>
                     </a:p>
                   </a:txBody>
@@ -11334,7 +11334,7 @@
                           </a:solidFill>
                           <a:latin typeface="Calibri"/>
                         </a:rPr>
-                        <a:t>14,5x</a:t>
+                        <a:t>1,2x</a:t>
                       </a:r>
                     </a:p>
                   </a:txBody>
@@ -11357,7 +11357,7 @@
                           </a:solidFill>
                           <a:latin typeface="Calibri"/>
                         </a:rPr>
-                        <a:t>22,7x</a:t>
+                        <a:t>15,2x</a:t>
                       </a:r>
                     </a:p>
                   </a:txBody>
@@ -11380,7 +11380,7 @@
                           </a:solidFill>
                           <a:latin typeface="Calibri"/>
                         </a:rPr>
-                        <a:t>5300,0 %</a:t>
+                        <a:t>48,0 %</a:t>
                       </a:r>
                     </a:p>
                   </a:txBody>
@@ -11403,7 +11403,7 @@
                           </a:solidFill>
                           <a:latin typeface="Calibri"/>
                         </a:rPr>
-                        <a:t>4800,0 %</a:t>
+                        <a:t>22,0 %</a:t>
                       </a:r>
                     </a:p>
                   </a:txBody>
@@ -11497,7 +11497,7 @@
                           </a:solidFill>
                           <a:latin typeface="Calibri"/>
                         </a:rPr>
-                        <a:t>19,8x</a:t>
+                        <a:t>20,1x</a:t>
                       </a:r>
                     </a:p>
                   </a:txBody>
@@ -11520,7 +11520,7 @@
                           </a:solidFill>
                           <a:latin typeface="Calibri"/>
                         </a:rPr>
-                        <a:t>11,2x</a:t>
+                        <a:t>8,5x</a:t>
                       </a:r>
                     </a:p>
                   </a:txBody>
@@ -11543,7 +11543,7 @@
                           </a:solidFill>
                           <a:latin typeface="Calibri"/>
                         </a:rPr>
-                        <a:t>25,1x</a:t>
+                        <a:t>32,4x</a:t>
                       </a:r>
                     </a:p>
                   </a:txBody>
@@ -11566,7 +11566,7 @@
                           </a:solidFill>
                           <a:latin typeface="Calibri"/>
                         </a:rPr>
-                        <a:t>5600,0 %</a:t>
+                        <a:t>56,0 %</a:t>
                       </a:r>
                     </a:p>
                   </a:txBody>
@@ -11589,7 +11589,7 @@
                           </a:solidFill>
                           <a:latin typeface="Calibri"/>
                         </a:rPr>
-                        <a:t>4800,0 %</a:t>
+                        <a:t>38,0 %</a:t>
                       </a:r>
                     </a:p>
                   </a:txBody>
@@ -11634,7 +11634,7 @@
                 </a:solidFill>
                 <a:latin typeface="Calibri"/>
               </a:rPr>
-              <a:t>ROE de 151,9% et ROIC de 84,4% parmi les meilleurs du secteur. EV/EBITDA à 26,1x vs 22,5x pour les peers technologiques.</a:t>
+              <a:t>ROE 151.9% et ROIC 84.4% parmi les meilleurs du secteur tech. EV/Revenue à 9.1x supérieur à la médiane peers (7.8x).</a:t>
             </a:r>
           </a:p>
         </p:txBody>
@@ -12292,7 +12292,7 @@
                 </a:solidFill>
                 <a:latin typeface="Calibri"/>
               </a:rPr>
-              <a:t>WACC de 10,3% et TGR de 3,0% impliquent un upside de 12,4% vs cours actuel. Sensibilité clé sur la croissance des services et le coût du capital.</a:t>
+              <a:t>WACC 10.3% et TGR 3.0% impliquent un upside de 12% vs cours actuel. Sensibilité forte à la croissance des services.</a:t>
             </a:r>
           </a:p>
         </p:txBody>
@@ -13265,7 +13265,7 @@
                 </a:solidFill>
                 <a:latin typeface="Calibri"/>
               </a:rPr>
-              <a:t>Régulation App Store</a:t>
+              <a:t>Dépendance iPhone</a:t>
             </a:r>
           </a:p>
         </p:txBody>
@@ -13300,7 +13300,7 @@
                 </a:solidFill>
                 <a:latin typeface="Calibri"/>
               </a:rPr>
-              <a:t>Régulation européenne sur l'App Store (-15% revenus services en 2026)</a:t>
+              <a:t>Régulation App Store en UE</a:t>
             </a:r>
           </a:p>
         </p:txBody>
@@ -13421,7 +13421,7 @@
                 </a:solidFill>
                 <a:latin typeface="Calibri"/>
               </a:rPr>
-              <a:t>Dépendance Chine</a:t>
+              <a:t>Régulation</a:t>
             </a:r>
           </a:p>
         </p:txBody>
@@ -13456,7 +13456,7 @@
                 </a:solidFill>
                 <a:latin typeface="Calibri"/>
               </a:rPr>
-              <a:t>Guerre commerciale Chine-USA (-5% ventes iPhone en 2026)</a:t>
+              <a:t>Concurrence Android en Asie</a:t>
             </a:r>
           </a:p>
         </p:txBody>
@@ -13612,7 +13612,7 @@
                 </a:solidFill>
                 <a:latin typeface="Calibri"/>
               </a:rPr>
-              <a:t>Concurrence IA de Google et Meta sur les services cloud</a:t>
+              <a:t>Ralentissement Chine</a:t>
             </a:r>
           </a:p>
         </p:txBody>
@@ -13826,7 +13826,7 @@
                           </a:solidFill>
                           <a:latin typeface="Calibri"/>
                         </a:rPr>
-                        <a:t>Récession mondiale avec -3% PIB en 2026</a:t>
+                        <a:t>Récession mondiale 2026 avec -3% PIB US</a:t>
                       </a:r>
                     </a:p>
                   </a:txBody>
@@ -13897,7 +13897,7 @@
                           </a:solidFill>
                           <a:latin typeface="Calibri"/>
                         </a:rPr>
-                        <a:t>Régulation stricte sur l'IA générative en UE/USA</a:t>
+                        <a:t>Régulation stricte IA en UE réduisant l'innovation</a:t>
                       </a:r>
                     </a:p>
                   </a:txBody>
@@ -13968,7 +13968,7 @@
                           </a:solidFill>
                           <a:latin typeface="Calibri"/>
                         </a:rPr>
-                        <a:t>Perte de parts de marché iPhone en Chine (-10% en 2026)</a:t>
+                        <a:t>Échec commercial iPhone 16 avec -10% ventes</a:t>
                       </a:r>
                     </a:p>
                   </a:txBody>
@@ -15858,7 +15858,7 @@
                           </a:solidFill>
                           <a:latin typeface="Calibri"/>
                         </a:rPr>
-                        <a:t>Intégration IA dans iOS 18 avec +20% de productivité utilisateur, Expansion services en Inde et Brésil avec 50M nouveaux abonnés attendus, Rachat d'actions de 100-120 milliards USD annuel</a:t>
+                        <a:t>Croissance services +15% YoY, Lancement iPhone 16 avec IA intégrée, Rachat actions 110 Mds USD</a:t>
                       </a:r>
                     </a:p>
                   </a:txBody>
@@ -16046,7 +16046,7 @@
                           </a:solidFill>
                           <a:latin typeface="Calibri"/>
                         </a:rPr>
-                        <a:t>Régulation européenne sur l'App Store (-15% revenus services en 2026), Guerre commerciale Chine-USA (-5% ventes iPhone en 2026), Concurrence IA de Google et Meta sur les services cloud</a:t>
+                        <a:t>Régulation App Store en UE, Concurrence Android en Asie, Ralentissement Chine</a:t>
                       </a:r>
                     </a:p>
                   </a:txBody>
@@ -19029,7 +19029,7 @@
                 </a:solidFill>
                 <a:latin typeface="Calibri"/>
               </a:rPr>
-              <a:t>La valorisation est élevée mais justifiée par la croissance des services et la résilience des marges. Les multiples sont en ligne avec les peers premium comme Microsoft.</a:t>
+              <a:t>Les multiples (33.2x P/E, 26.1x EV/EBITDA) sont élevés mais justifiés par la qualité des revenus. Comparables affichent des primes similaires pour la récurrence des services.</a:t>
             </a:r>
           </a:p>
         </p:txBody>
@@ -19359,7 +19359,7 @@
                 </a:solidFill>
                 <a:latin typeface="Calibri"/>
               </a:rPr>
-              <a:t>Prix cible base : 285 $  ·  Upside : +12,4 %  ·  Bear : 240 $ (-5,3 %)  ·  Bull : 320 $ (+26,2 %)</a:t>
+              <a:t>Prix cible base : 275 $  ·  Upside : +8,7 %  ·  Bear : 220 $ (-13,1 %)  ·  Bull : 310 $ (+22,5 %)</a:t>
             </a:r>
           </a:p>
         </p:txBody>
@@ -19550,7 +19550,7 @@
                 </a:solidFill>
                 <a:latin typeface="Calibri"/>
               </a:rPr>
-              <a:t>Apple vise 500 milliards USD de revenus d'ici 2027 grâce à l'IA générative intégrée dans les iPhones</a:t>
+              <a:t>L'intégration de l'IA dans les produits 2026 pourrait générer +15 Md USD de revenus supplémentaires</a:t>
             </a:r>
           </a:p>
         </p:txBody>
@@ -19628,7 +19628,7 @@
                 </a:solidFill>
                 <a:latin typeface="Calibri"/>
               </a:rPr>
-              <a:t>Marges premium</a:t>
+              <a:t>Marges élevées</a:t>
             </a:r>
           </a:p>
         </p:txBody>
@@ -19663,7 +19663,7 @@
                 </a:solidFill>
                 <a:latin typeface="Calibri"/>
               </a:rPr>
-              <a:t>La marge des services devrait atteindre 30% en 2026 avec 1,5 milliard d'abonnés payants</a:t>
+              <a:t>La marge des services devrait atteindre 72% d'ici 2027 grâce à l'augmentation des abonnements</a:t>
             </a:r>
           </a:p>
         </p:txBody>
@@ -19741,7 +19741,7 @@
                 </a:solidFill>
                 <a:latin typeface="Calibri"/>
               </a:rPr>
-              <a:t>Trésorerie record</a:t>
+              <a:t>Trésorerie massive</a:t>
             </a:r>
           </a:p>
         </p:txBody>
@@ -19776,7 +19776,7 @@
                 </a:solidFill>
                 <a:latin typeface="Calibri"/>
               </a:rPr>
-              <a:t>Le rachat d'actions de 110 milliards USD en 2025 renforce la création de valeur pour les actionnaires.</a:t>
+              <a:t>Le rachat d'actions de 110 Mds USD prévu en 2026 soutient la valorisation.</a:t>
             </a:r>
           </a:p>
         </p:txBody>
@@ -19932,7 +19932,7 @@
                 </a:solidFill>
                 <a:latin typeface="Calibri"/>
               </a:rPr>
-              <a:t>Régulation App Store</a:t>
+              <a:t>Dépendance iPhone</a:t>
             </a:r>
           </a:p>
         </p:txBody>
@@ -19967,7 +19967,7 @@
                 </a:solidFill>
                 <a:latin typeface="Calibri"/>
               </a:rPr>
-              <a:t>Régulation européenne sur l'App Store (-15% revenus services en 2026)</a:t>
+              <a:t>Impact potentiel sur la these d'investissement — surveillance recommandee sur les 6-12 prochains mois.</a:t>
             </a:r>
           </a:p>
         </p:txBody>
@@ -20045,7 +20045,7 @@
                 </a:solidFill>
                 <a:latin typeface="Calibri"/>
               </a:rPr>
-              <a:t>Dépendance Chine</a:t>
+              <a:t>Régulation</a:t>
             </a:r>
           </a:p>
         </p:txBody>
@@ -20080,7 +20080,7 @@
                 </a:solidFill>
                 <a:latin typeface="Calibri"/>
               </a:rPr>
-              <a:t>Guerre commerciale Chine-USA (-5% ventes iPhone en 2026)</a:t>
+              <a:t>Impact potentiel sur la these d'investissement — surveillance recommandee sur les 6-12 prochains mois.</a:t>
             </a:r>
           </a:p>
         </p:txBody>
@@ -20193,7 +20193,7 @@
                 </a:solidFill>
                 <a:latin typeface="Calibri"/>
               </a:rPr>
-              <a:t>Concurrence IA de Google et Meta sur les services cloud</a:t>
+              <a:t>Impact potentiel sur la these d'investissement — surveillance recommandee sur les 6-12 prochains mois.</a:t>
             </a:r>
           </a:p>
         </p:txBody>
@@ -20470,7 +20470,7 @@
                 </a:solidFill>
                 <a:latin typeface="Calibri"/>
               </a:rPr>
-              <a:t>vs 19,8x médiane peers</a:t>
+              <a:t>vs 20,1x médiane peers</a:t>
             </a:r>
           </a:p>
         </p:txBody>
@@ -20782,7 +20782,7 @@
                 </a:solidFill>
                 <a:latin typeface="Calibri"/>
               </a:rPr>
-              <a:t>285 $</a:t>
+              <a:t>275 $</a:t>
             </a:r>
           </a:p>
         </p:txBody>
@@ -20852,7 +20852,7 @@
                 </a:solidFill>
                 <a:latin typeface="Calibri"/>
               </a:rPr>
-              <a:t>Upside de +12,4 % vs cours</a:t>
+              <a:t>Upside de +8,7 % vs cours</a:t>
             </a:r>
           </a:p>
         </p:txBody>
@@ -21763,7 +21763,7 @@
                 </a:solidFill>
                 <a:latin typeface="Calibri"/>
               </a:rPr>
-              <a:t>253,53 $</a:t>
+              <a:t>253,03 $</a:t>
             </a:r>
           </a:p>
         </p:txBody>
@@ -22231,7 +22231,7 @@
                 </a:solidFill>
                 <a:latin typeface="Calibri"/>
               </a:rPr>
-              <a:t>+19,8 %</a:t>
+              <a:t>+19,6 %</a:t>
             </a:r>
           </a:p>
         </p:txBody>
@@ -23260,8 +23260,8 @@
         </p:nvSpPr>
         <p:spPr>
           <a:xfrm>
-            <a:off x="7854300" y="2838875"/>
-            <a:ext cx="498636" cy="1056324"/>
+            <a:off x="7854300" y="2848249"/>
+            <a:ext cx="498636" cy="1046950"/>
           </a:xfrm>
           <a:prstGeom prst="rect">
             <a:avLst/>
@@ -23672,7 +23672,7 @@
                 </a:solidFill>
                 <a:latin typeface="Calibri"/>
               </a:rPr>
-              <a:t>Apple maintient une croissance solide avec des marges élevées et une trésorerie abondante. La valorisation reste justifiée par l'innovation et l'écosystème intégré. Les risques géopolitiques et la dépendance à la Chine sont des points de vigilance.</a:t>
+              <a:t>Apple affiche une croissance résiliente avec des marges robustes et une trésorerie abondante. Le cours actuel sous-évalue le potentiel de l'IA intégrée et des services récurrents. La valorisation reste attractive malgré un premium sectoriel.</a:t>
             </a:r>
           </a:p>
         </p:txBody>
@@ -24715,7 +24715,7 @@
                 </a:solidFill>
                 <a:latin typeface="Calibri"/>
               </a:rPr>
-              <a:t>Régulation App Store  ·  Dépendance Chine</a:t>
+              <a:t>Dépendance iPhone  ·  Régulation</a:t>
             </a:r>
           </a:p>
         </p:txBody>
@@ -25949,7 +25949,7 @@
                 </a:solidFill>
                 <a:latin typeface="Calibri"/>
               </a:rPr>
-              <a:t>Apple conçoit et commercialise des smartphones, ordinateurs, tablettes et services numériques premium comme l'App Store et Apple Music. Positionné en haut de gamme, l'entreprise bénéficie d'une fidélisation client élevée et d'une marque forte. Ses avantages concurrentiels incluent l'intégration verticale, l'écosystème fermé et une marge brute supérieure à 45%. L'entreprise articule son activité autour de deux segments stratégiques :</a:t>
+              <a:t>Apple conçoit et commercialise des produits technologiques premium (iPhone, Mac, iPad, Wearables) et des services (App Store, Apple Music, iCloud). Positionné en haut de gamme, le groupe mise sur l'écosystème fermé et l'innovation pour fidéliser ses clients. Ses avantages concurrentiels incluent une marge brute élevée, une trésorerie nette de 166 Mds USD et une forte récurrence des revenus services. L'entreprise articule son activité autour de deux segments stratégiques :</a:t>
             </a:r>
           </a:p>
         </p:txBody>
@@ -26062,7 +26062,7 @@
                 </a:solidFill>
                 <a:latin typeface="Calibri"/>
               </a:rPr>
-              <a:t>Segment principal incluant iPhone, Mac, iPad et wearables avec modèle de revenus basé sur ventes…</a:t>
+              <a:t>Ventes de matériel (iPhone 60%, Mac 7%, iPad 7%, Wearables 8%) avec marge brute ~35%. Clients…</a:t>
             </a:r>
           </a:p>
         </p:txBody>
@@ -26175,7 +26175,7 @@
                 </a:solidFill>
                 <a:latin typeface="Calibri"/>
               </a:rPr>
-              <a:t>Modèle d'abonnement et de commissions sur l'App Store, Apple Music, iCloud et Apple TV+. Revenus…</a:t>
+              <a:t>Abonnements (App Store, Apple Music, iCloud) et licences avec marge brute ~70%. Base d'utilisateurs…</a:t>
             </a:r>
           </a:p>
         </p:txBody>
@@ -26296,7 +26296,7 @@
                 </a:solidFill>
                 <a:latin typeface="Calibri"/>
               </a:rPr>
-              <a:t>3 722,1 Mds$</a:t>
+              <a:t>3 714,8 Mds$</a:t>
             </a:r>
           </a:p>
         </p:txBody>
@@ -26608,7 +26608,7 @@
                 </a:solidFill>
                 <a:latin typeface="Calibri"/>
               </a:rPr>
-              <a:t>253,53 $</a:t>
+              <a:t>253,03 $</a:t>
             </a:r>
           </a:p>
         </p:txBody>
@@ -27554,7 +27554,7 @@
                 </a:solidFill>
                 <a:latin typeface="Calibri"/>
               </a:rPr>
-              <a:t>70%</a:t>
+              <a:t>82%</a:t>
             </a:r>
           </a:p>
         </p:txBody>
@@ -27702,7 +27702,7 @@
                 </a:solidFill>
                 <a:latin typeface="Calibri"/>
               </a:rPr>
-              <a:t>Segment principal incluant iPhone, Mac, iPad et wearables avec modèle de revenus basé sur ventes matérielles et accessoires. Clients cibles : consommateurs premium et entreprises. Croissance tirée par l'innovation et les services intégrés comme Apple Watch et AirPods.</a:t>
+              <a:t>Ventes de matériel (iPhone 60%, Mac 7%, iPad 7%, Wearables 8%) avec marge brute ~35%. Clients premium en Amérique du Nord et Europe. Croissance portée par l'iPhone 15 et l'expansion en Chine.</a:t>
             </a:r>
           </a:p>
         </p:txBody>
@@ -27823,7 +27823,7 @@
                 </a:solidFill>
                 <a:latin typeface="Calibri"/>
               </a:rPr>
-              <a:t>30%</a:t>
+              <a:t>18%</a:t>
             </a:r>
           </a:p>
         </p:txBody>
@@ -27971,7 +27971,7 @@
                 </a:solidFill>
                 <a:latin typeface="Calibri"/>
               </a:rPr>
-              <a:t>Modèle d'abonnement et de commissions sur l'App Store, Apple Music, iCloud et Apple TV+. Revenus récurrents et marges &gt;70%. Clients cibles : utilisateurs existants et nouveaux marchés comme la santé et la finance. Croissance portée par +1 milliard d'utilisateurs actifs.</a:t>
+              <a:t>Abonnements (App Store, Apple Music, iCloud) et licences avec marge brute ~70%. Base d'utilisateurs 1.5 Md et croissance annuelle 15%. Revenus récurrents à 80% du segment.</a:t>
             </a:r>
           </a:p>
         </p:txBody>
@@ -29100,7 +29100,7 @@
                           </a:solidFill>
                           <a:latin typeface="Calibri"/>
                         </a:rPr>
-                        <a:t>445,0</a:t>
+                        <a:t>440,0</a:t>
                       </a:r>
                     </a:p>
                   </a:txBody>
@@ -29123,7 +29123,7 @@
                           </a:solidFill>
                           <a:latin typeface="Calibri"/>
                         </a:rPr>
-                        <a:t>480,0</a:t>
+                        <a:t>470,0</a:t>
                       </a:r>
                     </a:p>
                   </a:txBody>
@@ -29240,7 +29240,7 @@
                           </a:solidFill>
                           <a:latin typeface="Calibri"/>
                         </a:rPr>
-                        <a:t>+7,0 %</a:t>
+                        <a:t>+5,7 %</a:t>
                       </a:r>
                     </a:p>
                   </a:txBody>
@@ -29263,7 +29263,7 @@
                           </a:solidFill>
                           <a:latin typeface="Calibri"/>
                         </a:rPr>
-                        <a:t>+7,9 %</a:t>
+                        <a:t>+6,8 %</a:t>
                       </a:r>
                     </a:p>
                   </a:txBody>
@@ -29380,7 +29380,7 @@
                           </a:solidFill>
                           <a:latin typeface="Calibri"/>
                         </a:rPr>
-                        <a:t>209,2</a:t>
+                        <a:t>207,7</a:t>
                       </a:r>
                     </a:p>
                   </a:txBody>
@@ -29403,7 +29403,7 @@
                           </a:solidFill>
                           <a:latin typeface="Calibri"/>
                         </a:rPr>
-                        <a:t>228,0</a:t>
+                        <a:t>223,2</a:t>
                       </a:r>
                     </a:p>
                   </a:txBody>
@@ -29520,7 +29520,7 @@
                           </a:solidFill>
                           <a:latin typeface="Calibri"/>
                         </a:rPr>
-                        <a:t>47,0 %</a:t>
+                        <a:t>47,2 %</a:t>
                       </a:r>
                     </a:p>
                   </a:txBody>
@@ -29660,7 +29660,7 @@
                           </a:solidFill>
                           <a:latin typeface="Calibri"/>
                         </a:rPr>
-                        <a:t>165,0</a:t>
+                        <a:t>162,0</a:t>
                       </a:r>
                     </a:p>
                   </a:txBody>
@@ -29683,7 +29683,7 @@
                           </a:solidFill>
                           <a:latin typeface="Calibri"/>
                         </a:rPr>
-                        <a:t>180,0</a:t>
+                        <a:t>175,0</a:t>
                       </a:r>
                     </a:p>
                   </a:txBody>
@@ -29800,7 +29800,7 @@
                           </a:solidFill>
                           <a:latin typeface="Calibri"/>
                         </a:rPr>
-                        <a:t>37,0 %</a:t>
+                        <a:t>36,8 %</a:t>
                       </a:r>
                     </a:p>
                   </a:txBody>
@@ -29823,7 +29823,7 @@
                           </a:solidFill>
                           <a:latin typeface="Calibri"/>
                         </a:rPr>
-                        <a:t>37,5 %</a:t>
+                        <a:t>37,2 %</a:t>
                       </a:r>
                     </a:p>
                   </a:txBody>
@@ -29940,7 +29940,7 @@
                           </a:solidFill>
                           <a:latin typeface="Calibri"/>
                         </a:rPr>
-                        <a:t>120,0</a:t>
+                        <a:t>115,0</a:t>
                       </a:r>
                     </a:p>
                   </a:txBody>
@@ -29963,7 +29963,7 @@
                           </a:solidFill>
                           <a:latin typeface="Calibri"/>
                         </a:rPr>
-                        <a:t>132,0</a:t>
+                        <a:t>125,0</a:t>
                       </a:r>
                     </a:p>
                   </a:txBody>
@@ -30080,7 +30080,7 @@
                           </a:solidFill>
                           <a:latin typeface="Calibri"/>
                         </a:rPr>
-                        <a:t>27,0 %</a:t>
+                        <a:t>26,1 %</a:t>
                       </a:r>
                     </a:p>
                   </a:txBody>
@@ -30103,7 +30103,7 @@
                           </a:solidFill>
                           <a:latin typeface="Calibri"/>
                         </a:rPr>
-                        <a:t>27,5 %</a:t>
+                        <a:t>26,6 %</a:t>
                       </a:r>
                     </a:p>
                   </a:txBody>
@@ -30148,7 +30148,7 @@
                 </a:solidFill>
                 <a:latin typeface="Calibri"/>
               </a:rPr>
-              <a:t>Croissance revenue de 6,4% en 2025 avec marge nette stable à 26,9%. Cash-flow opérationnel de 110 milliards USD. Les services progressent de 14% YoY, compensant le ralentissement des ventes d'iPhone.</a:t>
+              <a:t>Croissance revenue 6.4% en 2025 malgré un environnement macro difficile. Marges nettes stables à 26.9% grâce à la mixité services/produits. Free cash flow de 105 Mds USD en 2025.</a:t>
             </a:r>
           </a:p>
         </p:txBody>
@@ -31880,7 +31880,7 @@
                           </a:solidFill>
                           <a:latin typeface="Calibri"/>
                         </a:rPr>
-                        <a:t>9,97</a:t>
+                        <a:t>9,96</a:t>
                       </a:r>
                     </a:p>
                   </a:txBody>
@@ -32065,7 +32065,7 @@
                 </a:solidFill>
                 <a:latin typeface="Calibri"/>
               </a:rPr>
-              <a:t>Croissance revenue de 6,4% en 2025 avec marge nette stable à 26,9%. Cash-flow opérationnel de 110 milliards USD. Les services progressent de 14% YoY, compensant le ralentissement des ventes d'iPhone.</a:t>
+              <a:t>Croissance revenue 6.4% en 2025 malgré un environnement macro difficile. Marges nettes stables à 26.9% grâce à la mixité services/produits. Free cash flow de 105 Mds USD en 2025.</a:t>
             </a:r>
           </a:p>
         </p:txBody>

</xml_diff>

<commit_message>
chore(preview): AAPL outputs regeneres
</commit_message>
<xml_diff>
--- a/preview/AAPL/AAPL_pitchbook.pptx
+++ b/preview/AAPL/AAPL_pitchbook.pptx
@@ -3348,7 +3348,7 @@
             <a:avLst/>
           </a:prstGeom>
           <a:solidFill>
-            <a:srgbClr val="EAF4EF"/>
+            <a:srgbClr val="FDF6E8"/>
           </a:solidFill>
           <a:ln>
             <a:noFill/>
@@ -3391,7 +3391,7 @@
             <a:avLst/>
           </a:prstGeom>
           <a:solidFill>
-            <a:srgbClr val="1A7A4A"/>
+            <a:srgbClr val="B06000"/>
           </a:solidFill>
           <a:ln>
             <a:noFill/>
@@ -3445,11 +3445,11 @@
             <a:r>
               <a:rPr sz="900" b="1" i="0">
                 <a:solidFill>
-                  <a:srgbClr val="1A7A4A"/>
+                  <a:srgbClr val="B06000"/>
                 </a:solidFill>
                 <a:latin typeface="Calibri"/>
               </a:rPr>
-              <a:t>● BUY  ·  Prix cible base : 285 $  ·  Upside : +14,5 %</a:t>
+              <a:t>● HOLD  ·  Prix cible base : — $  ·  Upside : —</a:t>
             </a:r>
           </a:p>
         </p:txBody>
@@ -3562,7 +3562,7 @@
                 </a:solidFill>
                 <a:latin typeface="Calibri"/>
               </a:rPr>
-              <a:t>27 mars 2026</a:t>
+              <a:t>28 mars 2026</a:t>
             </a:r>
           </a:p>
         </p:txBody>
@@ -4677,17 +4677,17 @@
                       <a:r>
                         <a:rPr sz="800" b="1" i="0">
                           <a:solidFill>
-                            <a:srgbClr val="555555"/>
+                            <a:srgbClr val="A82020"/>
                           </a:solidFill>
                           <a:latin typeface="Calibri"/>
                         </a:rPr>
-                        <a:t>Tres eleve</a:t>
+                        <a:t>Très élevé</a:t>
                       </a:r>
                     </a:p>
                   </a:txBody>
                   <a:tcPr>
                     <a:solidFill>
-                      <a:srgbClr val="F7F8FA"/>
+                      <a:srgbClr val="FAF0EF"/>
                     </a:solidFill>
                     <a:lnL w="6350">
                       <a:solidFill>
@@ -5721,17 +5721,17 @@
                       <a:r>
                         <a:rPr sz="800" b="1" i="0">
                           <a:solidFill>
-                            <a:srgbClr val="1A7A4A"/>
+                            <a:srgbClr val="555555"/>
                           </a:solidFill>
                           <a:latin typeface="Calibri"/>
                         </a:rPr>
-                        <a:t>Leger</a:t>
+                        <a:t>Léger</a:t>
                       </a:r>
                     </a:p>
                   </a:txBody>
                   <a:tcPr>
                     <a:solidFill>
-                      <a:srgbClr val="EAF4EF"/>
+                      <a:srgbClr val="F7F8FA"/>
                     </a:solidFill>
                     <a:lnL w="6350">
                       <a:solidFill>
@@ -6108,41 +6108,6 @@
           </a:graphicData>
         </a:graphic>
       </p:graphicFrame>
-      <p:sp>
-        <p:nvSpPr>
-          <p:cNvPr id="18" name="TextBox 17"/>
-          <p:cNvSpPr txBox="1"/>
-          <p:nvPr/>
-        </p:nvSpPr>
-        <p:spPr>
-          <a:xfrm>
-            <a:off x="367200" y="3628800"/>
-            <a:ext cx="8413200" cy="824400"/>
-          </a:xfrm>
-          <a:prstGeom prst="rect">
-            <a:avLst/>
-          </a:prstGeom>
-          <a:noFill/>
-        </p:spPr>
-        <p:txBody>
-          <a:bodyPr wrap="square">
-            <a:spAutoFit/>
-          </a:bodyPr>
-          <a:lstStyle/>
-          <a:p>
-            <a:pPr algn="l"/>
-            <a:r>
-              <a:rPr sz="850" b="0" i="0">
-                <a:solidFill>
-                  <a:srgbClr val="555555"/>
-                </a:solidFill>
-                <a:latin typeface="Calibri"/>
-              </a:rPr>
-              <a:t>Les marges brutes sont passées de 43.3% en 2022 à 46.9% en 2025, reflétant un mix produit plus premium et une meilleure gestion des coûts logistiques. Les marges EBITDA (34.8%) et nettes (26.9%) bénéficient du levier opérationnel sur les services à forte marge. Cette tendance structurelle soutient la durabilité des niveaux actuels et limite le risque de compression.</a:t>
-            </a:r>
-          </a:p>
-        </p:txBody>
-      </p:sp>
     </p:spTree>
   </p:cSld>
   <p:clrMapOvr>
@@ -7303,7 +7268,7 @@
                           </a:solidFill>
                           <a:latin typeface="Calibri"/>
                         </a:rPr>
-                        <a:t>285 $</a:t>
+                        <a:t>—</a:t>
                       </a:r>
                     </a:p>
                   </a:txBody>
@@ -7479,7 +7444,7 @@
                           </a:solidFill>
                           <a:latin typeface="Calibri"/>
                         </a:rPr>
-                        <a:t>+14,5 %</a:t>
+                        <a:t>—</a:t>
                       </a:r>
                     </a:p>
                   </a:txBody>
@@ -7622,7 +7587,7 @@
                           </a:solidFill>
                           <a:latin typeface="Calibri"/>
                         </a:rPr>
-                        <a:t>240 $</a:t>
+                        <a:t>—</a:t>
                       </a:r>
                     </a:p>
                   </a:txBody>
@@ -7645,7 +7610,7 @@
                           </a:solidFill>
                           <a:latin typeface="Calibri"/>
                         </a:rPr>
-                        <a:t>285 $</a:t>
+                        <a:t>—</a:t>
                       </a:r>
                     </a:p>
                   </a:txBody>
@@ -7668,7 +7633,7 @@
                           </a:solidFill>
                           <a:latin typeface="Calibri"/>
                         </a:rPr>
-                        <a:t>320 $</a:t>
+                        <a:t>—</a:t>
                       </a:r>
                     </a:p>
                   </a:txBody>
@@ -7693,7 +7658,7 @@
                           </a:solidFill>
                           <a:latin typeface="Calibri"/>
                         </a:rPr>
-                        <a:t>-3,5 %</a:t>
+                        <a:t>—</a:t>
                       </a:r>
                     </a:p>
                   </a:txBody>
@@ -7716,7 +7681,7 @@
                           </a:solidFill>
                           <a:latin typeface="Calibri"/>
                         </a:rPr>
-                        <a:t>+14,5 %</a:t>
+                        <a:t>—</a:t>
                       </a:r>
                     </a:p>
                   </a:txBody>
@@ -7739,7 +7704,7 @@
                           </a:solidFill>
                           <a:latin typeface="Calibri"/>
                         </a:rPr>
-                        <a:t>+28,6 %</a:t>
+                        <a:t>—</a:t>
                       </a:r>
                     </a:p>
                   </a:txBody>
@@ -8203,7 +8168,7 @@
                           </a:solidFill>
                           <a:latin typeface="Calibri"/>
                         </a:rPr>
-                        <a:t>329</a:t>
+                        <a:t>—</a:t>
                       </a:r>
                     </a:p>
                   </a:txBody>
@@ -8246,7 +8211,7 @@
                           </a:solidFill>
                           <a:latin typeface="Calibri"/>
                         </a:rPr>
-                        <a:t>357</a:t>
+                        <a:t>—</a:t>
                       </a:r>
                     </a:p>
                   </a:txBody>
@@ -8289,7 +8254,7 @@
                           </a:solidFill>
                           <a:latin typeface="Calibri"/>
                         </a:rPr>
-                        <a:t>390</a:t>
+                        <a:t>—</a:t>
                       </a:r>
                     </a:p>
                   </a:txBody>
@@ -8332,7 +8297,7 @@
                           </a:solidFill>
                           <a:latin typeface="Calibri"/>
                         </a:rPr>
-                        <a:t>430</a:t>
+                        <a:t>—</a:t>
                       </a:r>
                     </a:p>
                   </a:txBody>
@@ -8375,7 +8340,7 @@
                           </a:solidFill>
                           <a:latin typeface="Calibri"/>
                         </a:rPr>
-                        <a:t>478</a:t>
+                        <a:t>—</a:t>
                       </a:r>
                     </a:p>
                   </a:txBody>
@@ -8463,7 +8428,7 @@
                           </a:solidFill>
                           <a:latin typeface="Calibri"/>
                         </a:rPr>
-                        <a:t>285</a:t>
+                        <a:t>—</a:t>
                       </a:r>
                     </a:p>
                   </a:txBody>
@@ -8506,7 +8471,7 @@
                           </a:solidFill>
                           <a:latin typeface="Calibri"/>
                         </a:rPr>
-                        <a:t>306</a:t>
+                        <a:t>—</a:t>
                       </a:r>
                     </a:p>
                   </a:txBody>
@@ -8549,7 +8514,7 @@
                           </a:solidFill>
                           <a:latin typeface="Calibri"/>
                         </a:rPr>
-                        <a:t>329</a:t>
+                        <a:t>—</a:t>
                       </a:r>
                     </a:p>
                   </a:txBody>
@@ -8592,7 +8557,7 @@
                           </a:solidFill>
                           <a:latin typeface="Calibri"/>
                         </a:rPr>
-                        <a:t>357</a:t>
+                        <a:t>—</a:t>
                       </a:r>
                     </a:p>
                   </a:txBody>
@@ -8635,7 +8600,7 @@
                           </a:solidFill>
                           <a:latin typeface="Calibri"/>
                         </a:rPr>
-                        <a:t>390</a:t>
+                        <a:t>—</a:t>
                       </a:r>
                     </a:p>
                   </a:txBody>
@@ -8723,7 +8688,7 @@
                           </a:solidFill>
                           <a:latin typeface="Calibri"/>
                         </a:rPr>
-                        <a:t>251</a:t>
+                        <a:t>—</a:t>
                       </a:r>
                     </a:p>
                   </a:txBody>
@@ -8766,7 +8731,7 @@
                           </a:solidFill>
                           <a:latin typeface="Calibri"/>
                         </a:rPr>
-                        <a:t>267</a:t>
+                        <a:t>—</a:t>
                       </a:r>
                     </a:p>
                   </a:txBody>
@@ -8809,7 +8774,7 @@
                           </a:solidFill>
                           <a:latin typeface="Calibri"/>
                         </a:rPr>
-                        <a:t>285</a:t>
+                        <a:t>—</a:t>
                       </a:r>
                     </a:p>
                   </a:txBody>
@@ -8852,7 +8817,7 @@
                           </a:solidFill>
                           <a:latin typeface="Calibri"/>
                         </a:rPr>
-                        <a:t>306</a:t>
+                        <a:t>—</a:t>
                       </a:r>
                     </a:p>
                   </a:txBody>
@@ -8895,7 +8860,7 @@
                           </a:solidFill>
                           <a:latin typeface="Calibri"/>
                         </a:rPr>
-                        <a:t>329</a:t>
+                        <a:t>—</a:t>
                       </a:r>
                     </a:p>
                   </a:txBody>
@@ -8983,7 +8948,7 @@
                           </a:solidFill>
                           <a:latin typeface="Calibri"/>
                         </a:rPr>
-                        <a:t>225</a:t>
+                        <a:t>—</a:t>
                       </a:r>
                     </a:p>
                   </a:txBody>
@@ -9026,7 +8991,7 @@
                           </a:solidFill>
                           <a:latin typeface="Calibri"/>
                         </a:rPr>
-                        <a:t>237</a:t>
+                        <a:t>—</a:t>
                       </a:r>
                     </a:p>
                   </a:txBody>
@@ -9069,7 +9034,7 @@
                           </a:solidFill>
                           <a:latin typeface="Calibri"/>
                         </a:rPr>
-                        <a:t>251</a:t>
+                        <a:t>—</a:t>
                       </a:r>
                     </a:p>
                   </a:txBody>
@@ -9112,7 +9077,7 @@
                           </a:solidFill>
                           <a:latin typeface="Calibri"/>
                         </a:rPr>
-                        <a:t>267</a:t>
+                        <a:t>—</a:t>
                       </a:r>
                     </a:p>
                   </a:txBody>
@@ -9155,7 +9120,7 @@
                           </a:solidFill>
                           <a:latin typeface="Calibri"/>
                         </a:rPr>
-                        <a:t>285</a:t>
+                        <a:t>—</a:t>
                       </a:r>
                     </a:p>
                   </a:txBody>
@@ -9243,7 +9208,7 @@
                           </a:solidFill>
                           <a:latin typeface="Calibri"/>
                         </a:rPr>
-                        <a:t>203</a:t>
+                        <a:t>—</a:t>
                       </a:r>
                     </a:p>
                   </a:txBody>
@@ -9286,7 +9251,7 @@
                           </a:solidFill>
                           <a:latin typeface="Calibri"/>
                         </a:rPr>
-                        <a:t>213</a:t>
+                        <a:t>—</a:t>
                       </a:r>
                     </a:p>
                   </a:txBody>
@@ -9329,7 +9294,7 @@
                           </a:solidFill>
                           <a:latin typeface="Calibri"/>
                         </a:rPr>
-                        <a:t>225</a:t>
+                        <a:t>—</a:t>
                       </a:r>
                     </a:p>
                   </a:txBody>
@@ -9372,7 +9337,7 @@
                           </a:solidFill>
                           <a:latin typeface="Calibri"/>
                         </a:rPr>
-                        <a:t>237</a:t>
+                        <a:t>—</a:t>
                       </a:r>
                     </a:p>
                   </a:txBody>
@@ -9415,7 +9380,7 @@
                           </a:solidFill>
                           <a:latin typeface="Calibri"/>
                         </a:rPr>
-                        <a:t>251</a:t>
+                        <a:t>—</a:t>
                       </a:r>
                     </a:p>
                   </a:txBody>
@@ -9450,41 +9415,6 @@
           </a:graphicData>
         </a:graphic>
       </p:graphicFrame>
-      <p:sp>
-        <p:nvSpPr>
-          <p:cNvPr id="20" name="TextBox 19"/>
-          <p:cNvSpPr txBox="1"/>
-          <p:nvPr/>
-        </p:nvSpPr>
-        <p:spPr>
-          <a:xfrm>
-            <a:off x="367200" y="3916800"/>
-            <a:ext cx="8413200" cy="547200"/>
-          </a:xfrm>
-          <a:prstGeom prst="rect">
-            <a:avLst/>
-          </a:prstGeom>
-          <a:noFill/>
-        </p:spPr>
-        <p:txBody>
-          <a:bodyPr wrap="square">
-            <a:spAutoFit/>
-          </a:bodyPr>
-          <a:lstStyle/>
-          <a:p>
-            <a:pPr algn="l"/>
-            <a:r>
-              <a:rPr sz="850" b="0" i="0">
-                <a:solidFill>
-                  <a:srgbClr val="555555"/>
-                </a:solidFill>
-                <a:latin typeface="Calibri"/>
-              </a:rPr>
-              <a:t>Avec un WACC de 10.4% et une TGR de 3.0%, le prix implicite DCF est de 275$ (vs cours 248.8$), soit un upside de 10.5%. La prime de croissance semble partiellement intégrée, mais les catalyseurs (IA, Chine) pourraient justifier une réévaluation à la hausse si exécutés avec succès.</a:t>
-            </a:r>
-          </a:p>
-        </p:txBody>
-      </p:sp>
     </p:spTree>
   </p:cSld>
   <p:clrMapOvr>
@@ -10094,7 +10024,7 @@
         </p:nvGraphicFramePr>
         <p:xfrm>
           <a:off x="367200" y="914400"/>
-          <a:ext cx="8413200" cy="2015999"/>
+          <a:ext cx="8413200" cy="871200"/>
         </p:xfrm>
         <a:graphic>
           <a:graphicData uri="http://schemas.openxmlformats.org/drawingml/2006/table">
@@ -10112,7 +10042,7 @@
                 <a:gridCol w="1093716"/>
                 <a:gridCol w="1009584"/>
               </a:tblGrid>
-              <a:tr h="251999">
+              <a:tr h="290400">
                 <a:tc>
                   <a:txBody>
                     <a:bodyPr/>
@@ -10298,7 +10228,7 @@
                   </a:tcPr>
                 </a:tc>
               </a:tr>
-              <a:tr h="251999">
+              <a:tr h="290400">
                 <a:tc>
                   <a:txBody>
                     <a:bodyPr/>
@@ -10484,937 +10414,7 @@
                   </a:tcPr>
                 </a:tc>
               </a:tr>
-              <a:tr h="251999">
-                <a:tc>
-                  <a:txBody>
-                    <a:bodyPr/>
-                    <a:lstStyle/>
-                    <a:p>
-                      <a:pPr algn="l"/>
-                      <a:r>
-                        <a:rPr sz="800" b="0" i="0">
-                          <a:solidFill>
-                            <a:srgbClr val="0D0D0D"/>
-                          </a:solidFill>
-                          <a:latin typeface="Calibri"/>
-                        </a:rPr>
-                        <a:t>Samsung Electronics</a:t>
-                      </a:r>
-                    </a:p>
-                  </a:txBody>
-                  <a:tcPr>
-                    <a:solidFill>
-                      <a:srgbClr val="FFFFFF"/>
-                    </a:solidFill>
-                  </a:tcPr>
-                </a:tc>
-                <a:tc>
-                  <a:txBody>
-                    <a:bodyPr/>
-                    <a:lstStyle/>
-                    <a:p>
-                      <a:pPr algn="ctr"/>
-                      <a:r>
-                        <a:rPr sz="750" b="0" i="0">
-                          <a:solidFill>
-                            <a:srgbClr val="555555"/>
-                          </a:solidFill>
-                          <a:latin typeface="Calibri"/>
-                        </a:rPr>
-                        <a:t>005930.KS</a:t>
-                      </a:r>
-                    </a:p>
-                  </a:txBody>
-                  <a:tcPr>
-                    <a:solidFill>
-                      <a:srgbClr val="FFFFFF"/>
-                    </a:solidFill>
-                  </a:tcPr>
-                </a:tc>
-                <a:tc>
-                  <a:txBody>
-                    <a:bodyPr/>
-                    <a:lstStyle/>
-                    <a:p>
-                      <a:pPr algn="ctr"/>
-                      <a:r>
-                        <a:rPr sz="800" b="0" i="0">
-                          <a:solidFill>
-                            <a:srgbClr val="0D0D0D"/>
-                          </a:solidFill>
-                          <a:latin typeface="Calibri"/>
-                        </a:rPr>
-                        <a:t>450,0</a:t>
-                      </a:r>
-                    </a:p>
-                  </a:txBody>
-                  <a:tcPr>
-                    <a:solidFill>
-                      <a:srgbClr val="FFFFFF"/>
-                    </a:solidFill>
-                  </a:tcPr>
-                </a:tc>
-                <a:tc>
-                  <a:txBody>
-                    <a:bodyPr/>
-                    <a:lstStyle/>
-                    <a:p>
-                      <a:pPr algn="ctr"/>
-                      <a:r>
-                        <a:rPr sz="800" b="0" i="0">
-                          <a:solidFill>
-                            <a:srgbClr val="0D0D0D"/>
-                          </a:solidFill>
-                          <a:latin typeface="Calibri"/>
-                        </a:rPr>
-                        <a:t>6,8x</a:t>
-                      </a:r>
-                    </a:p>
-                  </a:txBody>
-                  <a:tcPr>
-                    <a:solidFill>
-                      <a:srgbClr val="FFFFFF"/>
-                    </a:solidFill>
-                  </a:tcPr>
-                </a:tc>
-                <a:tc>
-                  <a:txBody>
-                    <a:bodyPr/>
-                    <a:lstStyle/>
-                    <a:p>
-                      <a:pPr algn="ctr"/>
-                      <a:r>
-                        <a:rPr sz="800" b="0" i="0">
-                          <a:solidFill>
-                            <a:srgbClr val="0D0D0D"/>
-                          </a:solidFill>
-                          <a:latin typeface="Calibri"/>
-                        </a:rPr>
-                        <a:t>1,2x</a:t>
-                      </a:r>
-                    </a:p>
-                  </a:txBody>
-                  <a:tcPr>
-                    <a:solidFill>
-                      <a:srgbClr val="FFFFFF"/>
-                    </a:solidFill>
-                  </a:tcPr>
-                </a:tc>
-                <a:tc>
-                  <a:txBody>
-                    <a:bodyPr/>
-                    <a:lstStyle/>
-                    <a:p>
-                      <a:pPr algn="ctr"/>
-                      <a:r>
-                        <a:rPr sz="800" b="0" i="0">
-                          <a:solidFill>
-                            <a:srgbClr val="0D0D0D"/>
-                          </a:solidFill>
-                          <a:latin typeface="Calibri"/>
-                        </a:rPr>
-                        <a:t>15,2x</a:t>
-                      </a:r>
-                    </a:p>
-                  </a:txBody>
-                  <a:tcPr>
-                    <a:solidFill>
-                      <a:srgbClr val="FFFFFF"/>
-                    </a:solidFill>
-                  </a:tcPr>
-                </a:tc>
-                <a:tc>
-                  <a:txBody>
-                    <a:bodyPr/>
-                    <a:lstStyle/>
-                    <a:p>
-                      <a:pPr algn="ctr"/>
-                      <a:r>
-                        <a:rPr sz="800" b="0" i="0">
-                          <a:solidFill>
-                            <a:srgbClr val="0D0D0D"/>
-                          </a:solidFill>
-                          <a:latin typeface="Calibri"/>
-                        </a:rPr>
-                        <a:t>38,0 %</a:t>
-                      </a:r>
-                    </a:p>
-                  </a:txBody>
-                  <a:tcPr>
-                    <a:solidFill>
-                      <a:srgbClr val="FFFFFF"/>
-                    </a:solidFill>
-                  </a:tcPr>
-                </a:tc>
-                <a:tc>
-                  <a:txBody>
-                    <a:bodyPr/>
-                    <a:lstStyle/>
-                    <a:p>
-                      <a:pPr algn="ctr"/>
-                      <a:r>
-                        <a:rPr sz="800" b="0" i="0">
-                          <a:solidFill>
-                            <a:srgbClr val="0D0D0D"/>
-                          </a:solidFill>
-                          <a:latin typeface="Calibri"/>
-                        </a:rPr>
-                        <a:t>22,0 %</a:t>
-                      </a:r>
-                    </a:p>
-                  </a:txBody>
-                  <a:tcPr>
-                    <a:solidFill>
-                      <a:srgbClr val="FFFFFF"/>
-                    </a:solidFill>
-                  </a:tcPr>
-                </a:tc>
-              </a:tr>
-              <a:tr h="251999">
-                <a:tc>
-                  <a:txBody>
-                    <a:bodyPr/>
-                    <a:lstStyle/>
-                    <a:p>
-                      <a:pPr algn="l"/>
-                      <a:r>
-                        <a:rPr sz="800" b="0" i="0">
-                          <a:solidFill>
-                            <a:srgbClr val="0D0D0D"/>
-                          </a:solidFill>
-                          <a:latin typeface="Calibri"/>
-                        </a:rPr>
-                        <a:t>Microsoft</a:t>
-                      </a:r>
-                    </a:p>
-                  </a:txBody>
-                  <a:tcPr>
-                    <a:solidFill>
-                      <a:srgbClr val="F7F8FA"/>
-                    </a:solidFill>
-                  </a:tcPr>
-                </a:tc>
-                <a:tc>
-                  <a:txBody>
-                    <a:bodyPr/>
-                    <a:lstStyle/>
-                    <a:p>
-                      <a:pPr algn="ctr"/>
-                      <a:r>
-                        <a:rPr sz="750" b="0" i="0">
-                          <a:solidFill>
-                            <a:srgbClr val="555555"/>
-                          </a:solidFill>
-                          <a:latin typeface="Calibri"/>
-                        </a:rPr>
-                        <a:t>MSFT</a:t>
-                      </a:r>
-                    </a:p>
-                  </a:txBody>
-                  <a:tcPr>
-                    <a:solidFill>
-                      <a:srgbClr val="F7F8FA"/>
-                    </a:solidFill>
-                  </a:tcPr>
-                </a:tc>
-                <a:tc>
-                  <a:txBody>
-                    <a:bodyPr/>
-                    <a:lstStyle/>
-                    <a:p>
-                      <a:pPr algn="ctr"/>
-                      <a:r>
-                        <a:rPr sz="800" b="0" i="0">
-                          <a:solidFill>
-                            <a:srgbClr val="0D0D0D"/>
-                          </a:solidFill>
-                          <a:latin typeface="Calibri"/>
-                        </a:rPr>
-                        <a:t>3 100,0</a:t>
-                      </a:r>
-                    </a:p>
-                  </a:txBody>
-                  <a:tcPr>
-                    <a:solidFill>
-                      <a:srgbClr val="F7F8FA"/>
-                    </a:solidFill>
-                  </a:tcPr>
-                </a:tc>
-                <a:tc>
-                  <a:txBody>
-                    <a:bodyPr/>
-                    <a:lstStyle/>
-                    <a:p>
-                      <a:pPr algn="ctr"/>
-                      <a:r>
-                        <a:rPr sz="800" b="0" i="0">
-                          <a:solidFill>
-                            <a:srgbClr val="0D0D0D"/>
-                          </a:solidFill>
-                          <a:latin typeface="Calibri"/>
-                        </a:rPr>
-                        <a:t>22,5x</a:t>
-                      </a:r>
-                    </a:p>
-                  </a:txBody>
-                  <a:tcPr>
-                    <a:solidFill>
-                      <a:srgbClr val="F7F8FA"/>
-                    </a:solidFill>
-                  </a:tcPr>
-                </a:tc>
-                <a:tc>
-                  <a:txBody>
-                    <a:bodyPr/>
-                    <a:lstStyle/>
-                    <a:p>
-                      <a:pPr algn="ctr"/>
-                      <a:r>
-                        <a:rPr sz="800" b="0" i="0">
-                          <a:solidFill>
-                            <a:srgbClr val="0D0D0D"/>
-                          </a:solidFill>
-                          <a:latin typeface="Calibri"/>
-                        </a:rPr>
-                        <a:t>8,9x</a:t>
-                      </a:r>
-                    </a:p>
-                  </a:txBody>
-                  <a:tcPr>
-                    <a:solidFill>
-                      <a:srgbClr val="F7F8FA"/>
-                    </a:solidFill>
-                  </a:tcPr>
-                </a:tc>
-                <a:tc>
-                  <a:txBody>
-                    <a:bodyPr/>
-                    <a:lstStyle/>
-                    <a:p>
-                      <a:pPr algn="ctr"/>
-                      <a:r>
-                        <a:rPr sz="800" b="0" i="0">
-                          <a:solidFill>
-                            <a:srgbClr val="0D0D0D"/>
-                          </a:solidFill>
-                          <a:latin typeface="Calibri"/>
-                        </a:rPr>
-                        <a:t>38,1x</a:t>
-                      </a:r>
-                    </a:p>
-                  </a:txBody>
-                  <a:tcPr>
-                    <a:solidFill>
-                      <a:srgbClr val="F7F8FA"/>
-                    </a:solidFill>
-                  </a:tcPr>
-                </a:tc>
-                <a:tc>
-                  <a:txBody>
-                    <a:bodyPr/>
-                    <a:lstStyle/>
-                    <a:p>
-                      <a:pPr algn="ctr"/>
-                      <a:r>
-                        <a:rPr sz="800" b="0" i="0">
-                          <a:solidFill>
-                            <a:srgbClr val="0D0D0D"/>
-                          </a:solidFill>
-                          <a:latin typeface="Calibri"/>
-                        </a:rPr>
-                        <a:t>68,0 %</a:t>
-                      </a:r>
-                    </a:p>
-                  </a:txBody>
-                  <a:tcPr>
-                    <a:solidFill>
-                      <a:srgbClr val="F7F8FA"/>
-                    </a:solidFill>
-                  </a:tcPr>
-                </a:tc>
-                <a:tc>
-                  <a:txBody>
-                    <a:bodyPr/>
-                    <a:lstStyle/>
-                    <a:p>
-                      <a:pPr algn="ctr"/>
-                      <a:r>
-                        <a:rPr sz="800" b="0" i="0">
-                          <a:solidFill>
-                            <a:srgbClr val="0D0D0D"/>
-                          </a:solidFill>
-                          <a:latin typeface="Calibri"/>
-                        </a:rPr>
-                        <a:t>48,0 %</a:t>
-                      </a:r>
-                    </a:p>
-                  </a:txBody>
-                  <a:tcPr>
-                    <a:solidFill>
-                      <a:srgbClr val="F7F8FA"/>
-                    </a:solidFill>
-                  </a:tcPr>
-                </a:tc>
-              </a:tr>
-              <a:tr h="251999">
-                <a:tc>
-                  <a:txBody>
-                    <a:bodyPr/>
-                    <a:lstStyle/>
-                    <a:p>
-                      <a:pPr algn="l"/>
-                      <a:r>
-                        <a:rPr sz="800" b="0" i="0">
-                          <a:solidFill>
-                            <a:srgbClr val="0D0D0D"/>
-                          </a:solidFill>
-                          <a:latin typeface="Calibri"/>
-                        </a:rPr>
-                        <a:t>Alphabet</a:t>
-                      </a:r>
-                    </a:p>
-                  </a:txBody>
-                  <a:tcPr>
-                    <a:solidFill>
-                      <a:srgbClr val="FFFFFF"/>
-                    </a:solidFill>
-                  </a:tcPr>
-                </a:tc>
-                <a:tc>
-                  <a:txBody>
-                    <a:bodyPr/>
-                    <a:lstStyle/>
-                    <a:p>
-                      <a:pPr algn="ctr"/>
-                      <a:r>
-                        <a:rPr sz="750" b="0" i="0">
-                          <a:solidFill>
-                            <a:srgbClr val="555555"/>
-                          </a:solidFill>
-                          <a:latin typeface="Calibri"/>
-                        </a:rPr>
-                        <a:t>GOOGL</a:t>
-                      </a:r>
-                    </a:p>
-                  </a:txBody>
-                  <a:tcPr>
-                    <a:solidFill>
-                      <a:srgbClr val="FFFFFF"/>
-                    </a:solidFill>
-                  </a:tcPr>
-                </a:tc>
-                <a:tc>
-                  <a:txBody>
-                    <a:bodyPr/>
-                    <a:lstStyle/>
-                    <a:p>
-                      <a:pPr algn="ctr"/>
-                      <a:r>
-                        <a:rPr sz="800" b="0" i="0">
-                          <a:solidFill>
-                            <a:srgbClr val="0D0D0D"/>
-                          </a:solidFill>
-                          <a:latin typeface="Calibri"/>
-                        </a:rPr>
-                        <a:t>2 000,0</a:t>
-                      </a:r>
-                    </a:p>
-                  </a:txBody>
-                  <a:tcPr>
-                    <a:solidFill>
-                      <a:srgbClr val="FFFFFF"/>
-                    </a:solidFill>
-                  </a:tcPr>
-                </a:tc>
-                <a:tc>
-                  <a:txBody>
-                    <a:bodyPr/>
-                    <a:lstStyle/>
-                    <a:p>
-                      <a:pPr algn="ctr"/>
-                      <a:r>
-                        <a:rPr sz="800" b="0" i="0">
-                          <a:solidFill>
-                            <a:srgbClr val="0D0D0D"/>
-                          </a:solidFill>
-                          <a:latin typeface="Calibri"/>
-                        </a:rPr>
-                        <a:t>18,7x</a:t>
-                      </a:r>
-                    </a:p>
-                  </a:txBody>
-                  <a:tcPr>
-                    <a:solidFill>
-                      <a:srgbClr val="FFFFFF"/>
-                    </a:solidFill>
-                  </a:tcPr>
-                </a:tc>
-                <a:tc>
-                  <a:txBody>
-                    <a:bodyPr/>
-                    <a:lstStyle/>
-                    <a:p>
-                      <a:pPr algn="ctr"/>
-                      <a:r>
-                        <a:rPr sz="800" b="0" i="0">
-                          <a:solidFill>
-                            <a:srgbClr val="0D0D0D"/>
-                          </a:solidFill>
-                          <a:latin typeface="Calibri"/>
-                        </a:rPr>
-                        <a:t>7,2x</a:t>
-                      </a:r>
-                    </a:p>
-                  </a:txBody>
-                  <a:tcPr>
-                    <a:solidFill>
-                      <a:srgbClr val="FFFFFF"/>
-                    </a:solidFill>
-                  </a:tcPr>
-                </a:tc>
-                <a:tc>
-                  <a:txBody>
-                    <a:bodyPr/>
-                    <a:lstStyle/>
-                    <a:p>
-                      <a:pPr algn="ctr"/>
-                      <a:r>
-                        <a:rPr sz="800" b="0" i="0">
-                          <a:solidFill>
-                            <a:srgbClr val="0D0D0D"/>
-                          </a:solidFill>
-                          <a:latin typeface="Calibri"/>
-                        </a:rPr>
-                        <a:t>26,4x</a:t>
-                      </a:r>
-                    </a:p>
-                  </a:txBody>
-                  <a:tcPr>
-                    <a:solidFill>
-                      <a:srgbClr val="FFFFFF"/>
-                    </a:solidFill>
-                  </a:tcPr>
-                </a:tc>
-                <a:tc>
-                  <a:txBody>
-                    <a:bodyPr/>
-                    <a:lstStyle/>
-                    <a:p>
-                      <a:pPr algn="ctr"/>
-                      <a:r>
-                        <a:rPr sz="800" b="0" i="0">
-                          <a:solidFill>
-                            <a:srgbClr val="0D0D0D"/>
-                          </a:solidFill>
-                          <a:latin typeface="Calibri"/>
-                        </a:rPr>
-                        <a:t>56,0 %</a:t>
-                      </a:r>
-                    </a:p>
-                  </a:txBody>
-                  <a:tcPr>
-                    <a:solidFill>
-                      <a:srgbClr val="FFFFFF"/>
-                    </a:solidFill>
-                  </a:tcPr>
-                </a:tc>
-                <a:tc>
-                  <a:txBody>
-                    <a:bodyPr/>
-                    <a:lstStyle/>
-                    <a:p>
-                      <a:pPr algn="ctr"/>
-                      <a:r>
-                        <a:rPr sz="800" b="0" i="0">
-                          <a:solidFill>
-                            <a:srgbClr val="0D0D0D"/>
-                          </a:solidFill>
-                          <a:latin typeface="Calibri"/>
-                        </a:rPr>
-                        <a:t>38,0 %</a:t>
-                      </a:r>
-                    </a:p>
-                  </a:txBody>
-                  <a:tcPr>
-                    <a:solidFill>
-                      <a:srgbClr val="FFFFFF"/>
-                    </a:solidFill>
-                  </a:tcPr>
-                </a:tc>
-              </a:tr>
-              <a:tr h="251999">
-                <a:tc>
-                  <a:txBody>
-                    <a:bodyPr/>
-                    <a:lstStyle/>
-                    <a:p>
-                      <a:pPr algn="l"/>
-                      <a:r>
-                        <a:rPr sz="800" b="0" i="0">
-                          <a:solidFill>
-                            <a:srgbClr val="0D0D0D"/>
-                          </a:solidFill>
-                          <a:latin typeface="Calibri"/>
-                        </a:rPr>
-                        <a:t>Meta Platforms</a:t>
-                      </a:r>
-                    </a:p>
-                  </a:txBody>
-                  <a:tcPr>
-                    <a:solidFill>
-                      <a:srgbClr val="F7F8FA"/>
-                    </a:solidFill>
-                  </a:tcPr>
-                </a:tc>
-                <a:tc>
-                  <a:txBody>
-                    <a:bodyPr/>
-                    <a:lstStyle/>
-                    <a:p>
-                      <a:pPr algn="ctr"/>
-                      <a:r>
-                        <a:rPr sz="750" b="0" i="0">
-                          <a:solidFill>
-                            <a:srgbClr val="555555"/>
-                          </a:solidFill>
-                          <a:latin typeface="Calibri"/>
-                        </a:rPr>
-                        <a:t>META</a:t>
-                      </a:r>
-                    </a:p>
-                  </a:txBody>
-                  <a:tcPr>
-                    <a:solidFill>
-                      <a:srgbClr val="F7F8FA"/>
-                    </a:solidFill>
-                  </a:tcPr>
-                </a:tc>
-                <a:tc>
-                  <a:txBody>
-                    <a:bodyPr/>
-                    <a:lstStyle/>
-                    <a:p>
-                      <a:pPr algn="ctr"/>
-                      <a:r>
-                        <a:rPr sz="800" b="0" i="0">
-                          <a:solidFill>
-                            <a:srgbClr val="0D0D0D"/>
-                          </a:solidFill>
-                          <a:latin typeface="Calibri"/>
-                        </a:rPr>
-                        <a:t>1 500,0</a:t>
-                      </a:r>
-                    </a:p>
-                  </a:txBody>
-                  <a:tcPr>
-                    <a:solidFill>
-                      <a:srgbClr val="F7F8FA"/>
-                    </a:solidFill>
-                  </a:tcPr>
-                </a:tc>
-                <a:tc>
-                  <a:txBody>
-                    <a:bodyPr/>
-                    <a:lstStyle/>
-                    <a:p>
-                      <a:pPr algn="ctr"/>
-                      <a:r>
-                        <a:rPr sz="800" b="0" i="0">
-                          <a:solidFill>
-                            <a:srgbClr val="0D0D0D"/>
-                          </a:solidFill>
-                          <a:latin typeface="Calibri"/>
-                        </a:rPr>
-                        <a:t>14,3x</a:t>
-                      </a:r>
-                    </a:p>
-                  </a:txBody>
-                  <a:tcPr>
-                    <a:solidFill>
-                      <a:srgbClr val="F7F8FA"/>
-                    </a:solidFill>
-                  </a:tcPr>
-                </a:tc>
-                <a:tc>
-                  <a:txBody>
-                    <a:bodyPr/>
-                    <a:lstStyle/>
-                    <a:p>
-                      <a:pPr algn="ctr"/>
-                      <a:r>
-                        <a:rPr sz="800" b="0" i="0">
-                          <a:solidFill>
-                            <a:srgbClr val="0D0D0D"/>
-                          </a:solidFill>
-                          <a:latin typeface="Calibri"/>
-                        </a:rPr>
-                        <a:t>8,1x</a:t>
-                      </a:r>
-                    </a:p>
-                  </a:txBody>
-                  <a:tcPr>
-                    <a:solidFill>
-                      <a:srgbClr val="F7F8FA"/>
-                    </a:solidFill>
-                  </a:tcPr>
-                </a:tc>
-                <a:tc>
-                  <a:txBody>
-                    <a:bodyPr/>
-                    <a:lstStyle/>
-                    <a:p>
-                      <a:pPr algn="ctr"/>
-                      <a:r>
-                        <a:rPr sz="800" b="0" i="0">
-                          <a:solidFill>
-                            <a:srgbClr val="0D0D0D"/>
-                          </a:solidFill>
-                          <a:latin typeface="Calibri"/>
-                        </a:rPr>
-                        <a:t>24,8x</a:t>
-                      </a:r>
-                    </a:p>
-                  </a:txBody>
-                  <a:tcPr>
-                    <a:solidFill>
-                      <a:srgbClr val="F7F8FA"/>
-                    </a:solidFill>
-                  </a:tcPr>
-                </a:tc>
-                <a:tc>
-                  <a:txBody>
-                    <a:bodyPr/>
-                    <a:lstStyle/>
-                    <a:p>
-                      <a:pPr algn="ctr"/>
-                      <a:r>
-                        <a:rPr sz="800" b="0" i="0">
-                          <a:solidFill>
-                            <a:srgbClr val="0D0D0D"/>
-                          </a:solidFill>
-                          <a:latin typeface="Calibri"/>
-                        </a:rPr>
-                        <a:t>88,0 %</a:t>
-                      </a:r>
-                    </a:p>
-                  </a:txBody>
-                  <a:tcPr>
-                    <a:solidFill>
-                      <a:srgbClr val="F7F8FA"/>
-                    </a:solidFill>
-                  </a:tcPr>
-                </a:tc>
-                <a:tc>
-                  <a:txBody>
-                    <a:bodyPr/>
-                    <a:lstStyle/>
-                    <a:p>
-                      <a:pPr algn="ctr"/>
-                      <a:r>
-                        <a:rPr sz="800" b="0" i="0">
-                          <a:solidFill>
-                            <a:srgbClr val="0D0D0D"/>
-                          </a:solidFill>
-                          <a:latin typeface="Calibri"/>
-                        </a:rPr>
-                        <a:t>55,0 %</a:t>
-                      </a:r>
-                    </a:p>
-                  </a:txBody>
-                  <a:tcPr>
-                    <a:solidFill>
-                      <a:srgbClr val="F7F8FA"/>
-                    </a:solidFill>
-                  </a:tcPr>
-                </a:tc>
-              </a:tr>
-              <a:tr h="251999">
-                <a:tc>
-                  <a:txBody>
-                    <a:bodyPr/>
-                    <a:lstStyle/>
-                    <a:p>
-                      <a:pPr algn="l"/>
-                      <a:r>
-                        <a:rPr sz="800" b="0" i="0">
-                          <a:solidFill>
-                            <a:srgbClr val="0D0D0D"/>
-                          </a:solidFill>
-                          <a:latin typeface="Calibri"/>
-                        </a:rPr>
-                        <a:t>TSMC</a:t>
-                      </a:r>
-                    </a:p>
-                  </a:txBody>
-                  <a:tcPr>
-                    <a:solidFill>
-                      <a:srgbClr val="FFFFFF"/>
-                    </a:solidFill>
-                  </a:tcPr>
-                </a:tc>
-                <a:tc>
-                  <a:txBody>
-                    <a:bodyPr/>
-                    <a:lstStyle/>
-                    <a:p>
-                      <a:pPr algn="ctr"/>
-                      <a:r>
-                        <a:rPr sz="750" b="0" i="0">
-                          <a:solidFill>
-                            <a:srgbClr val="555555"/>
-                          </a:solidFill>
-                          <a:latin typeface="Calibri"/>
-                        </a:rPr>
-                        <a:t>TSM</a:t>
-                      </a:r>
-                    </a:p>
-                  </a:txBody>
-                  <a:tcPr>
-                    <a:solidFill>
-                      <a:srgbClr val="FFFFFF"/>
-                    </a:solidFill>
-                  </a:tcPr>
-                </a:tc>
-                <a:tc>
-                  <a:txBody>
-                    <a:bodyPr/>
-                    <a:lstStyle/>
-                    <a:p>
-                      <a:pPr algn="ctr"/>
-                      <a:r>
-                        <a:rPr sz="800" b="0" i="0">
-                          <a:solidFill>
-                            <a:srgbClr val="0D0D0D"/>
-                          </a:solidFill>
-                          <a:latin typeface="Calibri"/>
-                        </a:rPr>
-                        <a:t>500,0</a:t>
-                      </a:r>
-                    </a:p>
-                  </a:txBody>
-                  <a:tcPr>
-                    <a:solidFill>
-                      <a:srgbClr val="FFFFFF"/>
-                    </a:solidFill>
-                  </a:tcPr>
-                </a:tc>
-                <a:tc>
-                  <a:txBody>
-                    <a:bodyPr/>
-                    <a:lstStyle/>
-                    <a:p>
-                      <a:pPr algn="ctr"/>
-                      <a:r>
-                        <a:rPr sz="800" b="0" i="0">
-                          <a:solidFill>
-                            <a:srgbClr val="0D0D0D"/>
-                          </a:solidFill>
-                          <a:latin typeface="Calibri"/>
-                        </a:rPr>
-                        <a:t>12,1x</a:t>
-                      </a:r>
-                    </a:p>
-                  </a:txBody>
-                  <a:tcPr>
-                    <a:solidFill>
-                      <a:srgbClr val="FFFFFF"/>
-                    </a:solidFill>
-                  </a:tcPr>
-                </a:tc>
-                <a:tc>
-                  <a:txBody>
-                    <a:bodyPr/>
-                    <a:lstStyle/>
-                    <a:p>
-                      <a:pPr algn="ctr"/>
-                      <a:r>
-                        <a:rPr sz="800" b="0" i="0">
-                          <a:solidFill>
-                            <a:srgbClr val="0D0D0D"/>
-                          </a:solidFill>
-                          <a:latin typeface="Calibri"/>
-                        </a:rPr>
-                        <a:t>7,5x</a:t>
-                      </a:r>
-                    </a:p>
-                  </a:txBody>
-                  <a:tcPr>
-                    <a:solidFill>
-                      <a:srgbClr val="FFFFFF"/>
-                    </a:solidFill>
-                  </a:tcPr>
-                </a:tc>
-                <a:tc>
-                  <a:txBody>
-                    <a:bodyPr/>
-                    <a:lstStyle/>
-                    <a:p>
-                      <a:pPr algn="ctr"/>
-                      <a:r>
-                        <a:rPr sz="800" b="0" i="0">
-                          <a:solidFill>
-                            <a:srgbClr val="0D0D0D"/>
-                          </a:solidFill>
-                          <a:latin typeface="Calibri"/>
-                        </a:rPr>
-                        <a:t>20,5x</a:t>
-                      </a:r>
-                    </a:p>
-                  </a:txBody>
-                  <a:tcPr>
-                    <a:solidFill>
-                      <a:srgbClr val="FFFFFF"/>
-                    </a:solidFill>
-                  </a:tcPr>
-                </a:tc>
-                <a:tc>
-                  <a:txBody>
-                    <a:bodyPr/>
-                    <a:lstStyle/>
-                    <a:p>
-                      <a:pPr algn="ctr"/>
-                      <a:r>
-                        <a:rPr sz="800" b="0" i="0">
-                          <a:solidFill>
-                            <a:srgbClr val="0D0D0D"/>
-                          </a:solidFill>
-                          <a:latin typeface="Calibri"/>
-                        </a:rPr>
-                        <a:t>52,0 %</a:t>
-                      </a:r>
-                    </a:p>
-                  </a:txBody>
-                  <a:tcPr>
-                    <a:solidFill>
-                      <a:srgbClr val="FFFFFF"/>
-                    </a:solidFill>
-                  </a:tcPr>
-                </a:tc>
-                <a:tc>
-                  <a:txBody>
-                    <a:bodyPr/>
-                    <a:lstStyle/>
-                    <a:p>
-                      <a:pPr algn="ctr"/>
-                      <a:r>
-                        <a:rPr sz="800" b="0" i="0">
-                          <a:solidFill>
-                            <a:srgbClr val="0D0D0D"/>
-                          </a:solidFill>
-                          <a:latin typeface="Calibri"/>
-                        </a:rPr>
-                        <a:t>45,0 %</a:t>
-                      </a:r>
-                    </a:p>
-                  </a:txBody>
-                  <a:tcPr>
-                    <a:solidFill>
-                      <a:srgbClr val="FFFFFF"/>
-                    </a:solidFill>
-                  </a:tcPr>
-                </a:tc>
-              </a:tr>
-              <a:tr h="252006">
+              <a:tr h="290400">
                 <a:tc>
                   <a:txBody>
                     <a:bodyPr/>
@@ -11497,7 +10497,7 @@
                           </a:solidFill>
                           <a:latin typeface="Calibri"/>
                         </a:rPr>
-                        <a:t>14,3x</a:t>
+                        <a:t>—</a:t>
                       </a:r>
                     </a:p>
                   </a:txBody>
@@ -11520,7 +10520,7 @@
                           </a:solidFill>
                           <a:latin typeface="Calibri"/>
                         </a:rPr>
-                        <a:t>7,5x</a:t>
+                        <a:t>—</a:t>
                       </a:r>
                     </a:p>
                   </a:txBody>
@@ -11543,7 +10543,7 @@
                           </a:solidFill>
                           <a:latin typeface="Calibri"/>
                         </a:rPr>
-                        <a:t>24,8x</a:t>
+                        <a:t>—</a:t>
                       </a:r>
                     </a:p>
                   </a:txBody>
@@ -11566,7 +10566,7 @@
                           </a:solidFill>
                           <a:latin typeface="Calibri"/>
                         </a:rPr>
-                        <a:t>56,0 %</a:t>
+                        <a:t>—</a:t>
                       </a:r>
                     </a:p>
                   </a:txBody>
@@ -11589,7 +10589,7 @@
                           </a:solidFill>
                           <a:latin typeface="Calibri"/>
                         </a:rPr>
-                        <a:t>45,0 %</a:t>
+                        <a:t>—</a:t>
                       </a:r>
                     </a:p>
                   </a:txBody>
@@ -11604,41 +10604,6 @@
           </a:graphicData>
         </a:graphic>
       </p:graphicFrame>
-      <p:sp>
-        <p:nvSpPr>
-          <p:cNvPr id="18" name="TextBox 17"/>
-          <p:cNvSpPr txBox="1"/>
-          <p:nvPr/>
-        </p:nvSpPr>
-        <p:spPr>
-          <a:xfrm>
-            <a:off x="367200" y="3128400"/>
-            <a:ext cx="8413200" cy="1234800"/>
-          </a:xfrm>
-          <a:prstGeom prst="rect">
-            <a:avLst/>
-          </a:prstGeom>
-          <a:noFill/>
-        </p:spPr>
-        <p:txBody>
-          <a:bodyPr wrap="square">
-            <a:spAutoFit/>
-          </a:bodyPr>
-          <a:lstStyle/>
-          <a:p>
-            <a:pPr algn="l"/>
-            <a:r>
-              <a:rPr sz="850" b="0" i="0">
-                <a:solidFill>
-                  <a:srgbClr val="555555"/>
-                </a:solidFill>
-                <a:latin typeface="Calibri"/>
-              </a:rPr>
-              <a:t>Apple se traite à 32.6x P/E vs 24.8x pour la médiane peers (Samsung, Microsoft, Alphabet, Meta, TSMC). La prime de 31% est justifiée par la qualité des actifs (marges, trésorerie) et la récurrence des revenus services. Une convergence vers la médiane impliquerait un downside de 24%, mais la prime semble durable compte tenu des avantages concurrentiels.</a:t>
-            </a:r>
-          </a:p>
-        </p:txBody>
-      </p:sp>
     </p:spTree>
   </p:cSld>
   <p:clrMapOvr>
@@ -12238,65 +11203,222 @@
           </a:p>
         </p:txBody>
       </p:sp>
-      <p:pic>
-        <p:nvPicPr>
-          <p:cNvPr id="17" name="Picture 16" descr="image.png"/>
-          <p:cNvPicPr>
-            <a:picLocks noChangeAspect="1"/>
-          </p:cNvPicPr>
-          <p:nvPr/>
-        </p:nvPicPr>
-        <p:blipFill>
-          <a:blip r:embed="rId2"/>
-          <a:stretch>
-            <a:fillRect/>
-          </a:stretch>
-        </p:blipFill>
-        <p:spPr>
-          <a:xfrm>
-            <a:off x="367200" y="914400"/>
-            <a:ext cx="8413200" cy="2448000"/>
-          </a:xfrm>
-          <a:prstGeom prst="rect">
-            <a:avLst/>
-          </a:prstGeom>
-        </p:spPr>
-      </p:pic>
-      <p:sp>
-        <p:nvSpPr>
-          <p:cNvPr id="18" name="TextBox 17"/>
-          <p:cNvSpPr txBox="1"/>
-          <p:nvPr/>
-        </p:nvSpPr>
-        <p:spPr>
-          <a:xfrm>
-            <a:off x="367200" y="3488400"/>
-            <a:ext cx="8413200" cy="914400"/>
-          </a:xfrm>
-          <a:prstGeom prst="rect">
-            <a:avLst/>
-          </a:prstGeom>
-          <a:noFill/>
-        </p:spPr>
-        <p:txBody>
-          <a:bodyPr wrap="square">
-            <a:spAutoFit/>
-          </a:bodyPr>
-          <a:lstStyle/>
-          <a:p>
-            <a:pPr algn="l"/>
-            <a:r>
-              <a:rPr sz="850" b="0" i="0">
-                <a:solidFill>
-                  <a:srgbClr val="555555"/>
-                </a:solidFill>
-                <a:latin typeface="Calibri"/>
-              </a:rPr>
-              <a:t>Avec un WACC de 10.4% et une TGR de 3.0%, le prix implicite DCF est de 275$ (vs cours 248.8$), soit un upside de 10.5%. La prime de croissance semble partiellement intégrée, mais les catalyseurs (IA, Chine) pourraient justifier une réévaluation à la hausse si exécutés avec succès.</a:t>
-            </a:r>
-          </a:p>
-        </p:txBody>
-      </p:sp>
+      <p:graphicFrame>
+        <p:nvGraphicFramePr>
+          <p:cNvPr id="17" name="Table 16"/>
+          <p:cNvGraphicFramePr>
+            <a:graphicFrameLocks noGrp="1"/>
+          </p:cNvGraphicFramePr>
+          <p:nvPr/>
+        </p:nvGraphicFramePr>
+        <p:xfrm>
+          <a:off x="367200" y="914400"/>
+          <a:ext cx="8413200" cy="615600"/>
+        </p:xfrm>
+        <a:graphic>
+          <a:graphicData uri="http://schemas.openxmlformats.org/drawingml/2006/table">
+            <a:tbl>
+              <a:tblPr firstRow="1" bandRow="1">
+                <a:tableStyleId>{5C22544A-7EE6-4342-B048-85BDC9FD1C3A}</a:tableStyleId>
+              </a:tblPr>
+              <a:tblGrid>
+                <a:gridCol w="2944620"/>
+                <a:gridCol w="1682640"/>
+                <a:gridCol w="1682640"/>
+                <a:gridCol w="2103300"/>
+              </a:tblGrid>
+              <a:tr h="307800">
+                <a:tc>
+                  <a:txBody>
+                    <a:bodyPr/>
+                    <a:lstStyle/>
+                    <a:p>
+                      <a:pPr algn="l"/>
+                      <a:r>
+                        <a:rPr sz="800" b="1" i="0">
+                          <a:solidFill>
+                            <a:srgbClr val="FFFFFF"/>
+                          </a:solidFill>
+                          <a:latin typeface="Calibri"/>
+                        </a:rPr>
+                        <a:t>Methode</a:t>
+                      </a:r>
+                    </a:p>
+                  </a:txBody>
+                  <a:tcPr>
+                    <a:solidFill>
+                      <a:srgbClr val="1B3A6B"/>
+                    </a:solidFill>
+                  </a:tcPr>
+                </a:tc>
+                <a:tc>
+                  <a:txBody>
+                    <a:bodyPr/>
+                    <a:lstStyle/>
+                    <a:p>
+                      <a:pPr algn="ctr"/>
+                      <a:r>
+                        <a:rPr sz="800" b="1" i="0">
+                          <a:solidFill>
+                            <a:srgbClr val="FFFFFF"/>
+                          </a:solidFill>
+                          <a:latin typeface="Calibri"/>
+                        </a:rPr>
+                        <a:t>Fourchette basse</a:t>
+                      </a:r>
+                    </a:p>
+                  </a:txBody>
+                  <a:tcPr>
+                    <a:solidFill>
+                      <a:srgbClr val="1B3A6B"/>
+                    </a:solidFill>
+                  </a:tcPr>
+                </a:tc>
+                <a:tc>
+                  <a:txBody>
+                    <a:bodyPr/>
+                    <a:lstStyle/>
+                    <a:p>
+                      <a:pPr algn="ctr"/>
+                      <a:r>
+                        <a:rPr sz="800" b="1" i="0">
+                          <a:solidFill>
+                            <a:srgbClr val="FFFFFF"/>
+                          </a:solidFill>
+                          <a:latin typeface="Calibri"/>
+                        </a:rPr>
+                        <a:t>Fourchette haute</a:t>
+                      </a:r>
+                    </a:p>
+                  </a:txBody>
+                  <a:tcPr>
+                    <a:solidFill>
+                      <a:srgbClr val="1B3A6B"/>
+                    </a:solidFill>
+                  </a:tcPr>
+                </a:tc>
+                <a:tc>
+                  <a:txBody>
+                    <a:bodyPr/>
+                    <a:lstStyle/>
+                    <a:p>
+                      <a:pPr algn="ctr"/>
+                      <a:r>
+                        <a:rPr sz="800" b="1" i="0">
+                          <a:solidFill>
+                            <a:srgbClr val="FFFFFF"/>
+                          </a:solidFill>
+                          <a:latin typeface="Calibri"/>
+                        </a:rPr>
+                        <a:t>Point central</a:t>
+                      </a:r>
+                    </a:p>
+                  </a:txBody>
+                  <a:tcPr>
+                    <a:solidFill>
+                      <a:srgbClr val="1B3A6B"/>
+                    </a:solidFill>
+                  </a:tcPr>
+                </a:tc>
+              </a:tr>
+              <a:tr h="307800">
+                <a:tc>
+                  <a:txBody>
+                    <a:bodyPr/>
+                    <a:lstStyle/>
+                    <a:p>
+                      <a:pPr algn="l"/>
+                      <a:r>
+                        <a:rPr sz="800" b="0" i="0">
+                          <a:solidFill>
+                            <a:srgbClr val="0D0D0D"/>
+                          </a:solidFill>
+                          <a:latin typeface="Calibri"/>
+                        </a:rPr>
+                        <a:t>Cours actuel (248,80)</a:t>
+                      </a:r>
+                    </a:p>
+                  </a:txBody>
+                  <a:tcPr>
+                    <a:solidFill>
+                      <a:srgbClr val="EEF3FA"/>
+                    </a:solidFill>
+                  </a:tcPr>
+                </a:tc>
+                <a:tc>
+                  <a:txBody>
+                    <a:bodyPr/>
+                    <a:lstStyle/>
+                    <a:p>
+                      <a:pPr algn="ctr"/>
+                      <a:r>
+                        <a:rPr sz="800" b="0" i="0">
+                          <a:solidFill>
+                            <a:srgbClr val="0D0D0D"/>
+                          </a:solidFill>
+                          <a:latin typeface="Calibri"/>
+                        </a:rPr>
+                        <a:t>—</a:t>
+                      </a:r>
+                    </a:p>
+                  </a:txBody>
+                  <a:tcPr>
+                    <a:solidFill>
+                      <a:srgbClr val="EEF3FA"/>
+                    </a:solidFill>
+                  </a:tcPr>
+                </a:tc>
+                <a:tc>
+                  <a:txBody>
+                    <a:bodyPr/>
+                    <a:lstStyle/>
+                    <a:p>
+                      <a:pPr algn="ctr"/>
+                      <a:r>
+                        <a:rPr sz="800" b="0" i="0">
+                          <a:solidFill>
+                            <a:srgbClr val="0D0D0D"/>
+                          </a:solidFill>
+                          <a:latin typeface="Calibri"/>
+                        </a:rPr>
+                        <a:t>—</a:t>
+                      </a:r>
+                    </a:p>
+                  </a:txBody>
+                  <a:tcPr>
+                    <a:solidFill>
+                      <a:srgbClr val="EEF3FA"/>
+                    </a:solidFill>
+                  </a:tcPr>
+                </a:tc>
+                <a:tc>
+                  <a:txBody>
+                    <a:bodyPr/>
+                    <a:lstStyle/>
+                    <a:p>
+                      <a:pPr algn="ctr"/>
+                      <a:r>
+                        <a:rPr sz="800" b="0" i="0">
+                          <a:solidFill>
+                            <a:srgbClr val="0D0D0D"/>
+                          </a:solidFill>
+                          <a:latin typeface="Calibri"/>
+                        </a:rPr>
+                        <a:t>248,80</a:t>
+                      </a:r>
+                    </a:p>
+                  </a:txBody>
+                  <a:tcPr>
+                    <a:solidFill>
+                      <a:srgbClr val="EEF3FA"/>
+                    </a:solidFill>
+                  </a:tcPr>
+                </a:tc>
+              </a:tr>
+            </a:tbl>
+          </a:graphicData>
+        </a:graphic>
+      </p:graphicFrame>
     </p:spTree>
   </p:cSld>
   <p:clrMapOvr>
@@ -13265,7 +12387,7 @@
                 </a:solidFill>
                 <a:latin typeface="Calibri"/>
               </a:rPr>
-              <a:t>Dépendance iPhone 52% CA</a:t>
+              <a:t>Risque 1</a:t>
             </a:r>
           </a:p>
         </p:txBody>
@@ -13300,7 +12422,7 @@
                 </a:solidFill>
                 <a:latin typeface="Calibri"/>
               </a:rPr>
-              <a:t>Le P/E de 32.61x surpasse de 50% la moyenne du secteur (21.8x) et reflète une valorisation déjà intégrant 5 ans de croissance future; or les marges brutes &gt;45% reposent sur un mix produit vieillissant avec iPhone à 52% du CA en 2024, en baisse tendancielle depuis 2020.</a:t>
+              <a:t>Risque macro-economique : remontee des taux ou ralentissement de la demande mondiale.</a:t>
             </a:r>
           </a:p>
         </p:txBody>
@@ -13421,7 +12543,7 @@
                 </a:solidFill>
                 <a:latin typeface="Calibri"/>
               </a:rPr>
-              <a:t>Dette opérationnelle croissante</a:t>
+              <a:t>Risque 2</a:t>
             </a:r>
           </a:p>
         </p:txBody>
@@ -13456,7 +12578,7 @@
                 </a:solidFill>
                 <a:latin typeface="Calibri"/>
               </a:rPr>
-              <a:t>La trésorerie nette de 166Md$ masque une dette opérationnelle croissante avec 11.5Md$ de coûts de financement en 2023, soit 1.8x le résultat net de 6.3Md$ du segment services, fragilisant la rentabilité future.</a:t>
+              <a:t>Risque sectoriel : intensification de la concurrence ou disruption technologique.</a:t>
             </a:r>
           </a:p>
         </p:txBody>
@@ -13577,7 +12699,7 @@
                 </a:solidFill>
                 <a:latin typeface="Calibri"/>
               </a:rPr>
-              <a:t>Valorisation excessive P/E</a:t>
+              <a:t>Risque 3</a:t>
             </a:r>
           </a:p>
         </p:txBody>
@@ -13612,7 +12734,7 @@
                 </a:solidFill>
                 <a:latin typeface="Calibri"/>
               </a:rPr>
-              <a:t>L'Altman Z-score de 9.83, bien au-delà du seuil de 3, suggère une santé financière exceptionnelle; pourtant, ce ratio ignore les 38Md$ de rachats d'actions en 2023 qui ont artificiellement boosté le ROE à 151.9%, masquant une rentabilité économique réelle de 12.4% hors effets de levier.</a:t>
+              <a:t>Risque specifique : deterioration des marges ou execution strategique.</a:t>
             </a:r>
           </a:p>
         </p:txBody>
@@ -13826,7 +12948,7 @@
                           </a:solidFill>
                           <a:latin typeface="Calibri"/>
                         </a:rPr>
-                        <a:t>Récession mondiale réduisant la demande premium de 15%</a:t>
+                        <a:t>Remontée des taux directeurs &gt; 200bps</a:t>
                       </a:r>
                     </a:p>
                   </a:txBody>
@@ -13897,7 +13019,7 @@
                           </a:solidFill>
                           <a:latin typeface="Calibri"/>
                         </a:rPr>
-                        <a:t>Concurrence accrue dans l'IA réduisant l'avantage différenciant</a:t>
+                        <a:t>Rupture technologique remettant en cause le modèle</a:t>
                       </a:r>
                     </a:p>
                   </a:txBody>
@@ -13945,7 +13067,7 @@
                           </a:solidFill>
                           <a:latin typeface="Calibri"/>
                         </a:rPr>
-                        <a:t>Societe</a:t>
+                        <a:t>Société</a:t>
                       </a:r>
                     </a:p>
                   </a:txBody>
@@ -13968,7 +13090,7 @@
                           </a:solidFill>
                           <a:latin typeface="Calibri"/>
                         </a:rPr>
-                        <a:t>Régulation chinoise limitant l'accès au marché</a:t>
+                        <a:t>Détérioration matérielle des marges opérationnelles</a:t>
                       </a:r>
                     </a:p>
                   </a:txBody>
@@ -14974,7 +14096,7 @@
                 </a:solidFill>
                 <a:latin typeface="Calibri"/>
               </a:rPr>
-              <a:t>Positif</a:t>
+              <a:t>Negatif</a:t>
             </a:r>
           </a:p>
         </p:txBody>
@@ -15044,7 +14166,7 @@
                 </a:solidFill>
                 <a:latin typeface="Calibri"/>
               </a:rPr>
-              <a:t>Score agrege : +0,177</a:t>
+              <a:t>Score agrege : -0,012</a:t>
             </a:r>
           </a:p>
         </p:txBody>
@@ -15356,7 +14478,7 @@
                 </a:solidFill>
                 <a:latin typeface="Calibri"/>
               </a:rPr>
-              <a:t>43,3 %</a:t>
+              <a:t>40,8 %</a:t>
             </a:r>
           </a:p>
         </p:txBody>
@@ -15547,7 +14669,7 @@
                 </a:solidFill>
                 <a:latin typeface="Calibri"/>
               </a:rPr>
-              <a:t>BUY</a:t>
+              <a:t>HOLD</a:t>
             </a:r>
           </a:p>
         </p:txBody>
@@ -15812,7 +14934,7 @@
                           </a:solidFill>
                           <a:latin typeface="Calibri"/>
                         </a:rPr>
-                        <a:t>14</a:t>
+                        <a:t>13</a:t>
                       </a:r>
                     </a:p>
                   </a:txBody>
@@ -15835,7 +14957,7 @@
                           </a:solidFill>
                           <a:latin typeface="Calibri"/>
                         </a:rPr>
-                        <a:t>+0,433</a:t>
+                        <a:t>+0,396</a:t>
                       </a:r>
                     </a:p>
                   </a:txBody>
@@ -15858,7 +14980,7 @@
                           </a:solidFill>
                           <a:latin typeface="Calibri"/>
                         </a:rPr>
-                        <a:t>Lancement iPhone 16 avec IA intégrée en septembre 2026 pourrait ajouter 12-15Md$ de revenus annuels d'ici 2027 | Impact sur les services cloud et abonnements via amélioration de l'expérience utilisateur</a:t>
+                        <a:t>Catalyseurs, croissance, résultats</a:t>
                       </a:r>
                     </a:p>
                   </a:txBody>
@@ -15906,7 +15028,7 @@
                           </a:solidFill>
                           <a:latin typeface="Calibri"/>
                         </a:rPr>
-                        <a:t>9</a:t>
+                        <a:t>3</a:t>
                       </a:r>
                     </a:p>
                   </a:txBody>
@@ -15929,7 +15051,7 @@
                           </a:solidFill>
                           <a:latin typeface="Calibri"/>
                         </a:rPr>
-                        <a:t>+0,312</a:t>
+                        <a:t>+0,196</a:t>
                       </a:r>
                     </a:p>
                   </a:txBody>
@@ -16000,7 +15122,7 @@
                           </a:solidFill>
                           <a:latin typeface="Calibri"/>
                         </a:rPr>
-                        <a:t>7</a:t>
+                        <a:t>14</a:t>
                       </a:r>
                     </a:p>
                   </a:txBody>
@@ -16023,7 +15145,7 @@
                           </a:solidFill>
                           <a:latin typeface="Calibri"/>
                         </a:rPr>
-                        <a:t>+0,256</a:t>
+                        <a:t>+0,408</a:t>
                       </a:r>
                     </a:p>
                   </a:txBody>
@@ -16046,7 +15168,7 @@
                           </a:solidFill>
                           <a:latin typeface="Calibri"/>
                         </a:rPr>
-                        <a:t>Régulation chinoise accrue pourrait limiter l'accès au marché et réduire les marges de 5-8% | Impact sur les ventes iPhone estimées à 20Md$ d'ici 2027 | Horizon 12-18 mois avec risque de sanctions</a:t>
+                        <a:t>Risques macro, concurrence, dette</a:t>
                       </a:r>
                     </a:p>
                   </a:txBody>
@@ -16091,7 +15213,7 @@
                 </a:solidFill>
                 <a:latin typeface="Calibri"/>
               </a:rPr>
-              <a:t>La presse financière souligne l'optimisme autour des innovations IA et des services d'Apple, malgré un contexte de marché volatil affectant les "Magnificent 7". Les analystes anticipent une croissance future portée par les nouveaux cycles produits et l'IA, tempérée par les risques macroéconomiques.</a:t>
+              <a:t>La presse financière souligne une semaine difficile pour Apple, marquée par un recul du secteur tech et une volatilité accrue. Cependant, les initiatives en IA et la croissance des services restent des points positifs majeurs pour l'action.</a:t>
             </a:r>
           </a:p>
         </p:txBody>
@@ -16690,7 +15812,7 @@
                 </a:solidFill>
                 <a:latin typeface="Calibri"/>
               </a:rPr>
-              <a:t>Répartition de l'actionnariat  ·  Au 27 mars 2026</a:t>
+              <a:t>Répartition de l'actionnariat  ·  Au 28 mars 2026</a:t>
             </a:r>
           </a:p>
         </p:txBody>
@@ -18999,41 +18121,6 @@
           </a:graphicData>
         </a:graphic>
       </p:graphicFrame>
-      <p:sp>
-        <p:nvSpPr>
-          <p:cNvPr id="21" name="TextBox 20"/>
-          <p:cNvSpPr txBox="1"/>
-          <p:nvPr/>
-        </p:nvSpPr>
-        <p:spPr>
-          <a:xfrm>
-            <a:off x="367200" y="3326400"/>
-            <a:ext cx="8413200" cy="1004400"/>
-          </a:xfrm>
-          <a:prstGeom prst="rect">
-            <a:avLst/>
-          </a:prstGeom>
-          <a:noFill/>
-        </p:spPr>
-        <p:txBody>
-          <a:bodyPr wrap="square">
-            <a:spAutoFit/>
-          </a:bodyPr>
-          <a:lstStyle/>
-          <a:p>
-            <a:pPr algn="l"/>
-            <a:r>
-              <a:rPr sz="850" b="0" i="0">
-                <a:solidFill>
-                  <a:srgbClr val="555555"/>
-                </a:solidFill>
-                <a:latin typeface="Calibri"/>
-              </a:rPr>
-              <a:t>Apple se négocie à 25.7x EV/EBITDA vs 22.1x pour la médiane des peers technologiques. La prime de 16% est justifiée par la qualité des actifs et la récurrence des revenus services.</a:t>
-            </a:r>
-          </a:p>
-        </p:txBody>
-      </p:sp>
     </p:spTree>
   </p:cSld>
   <p:clrMapOvr>
@@ -19223,7 +18310,7 @@
             <a:avLst/>
           </a:prstGeom>
           <a:solidFill>
-            <a:srgbClr val="EAF4EF"/>
+            <a:srgbClr val="FDF6E8"/>
           </a:solidFill>
           <a:ln>
             <a:noFill/>
@@ -19266,7 +18353,7 @@
             <a:avLst/>
           </a:prstGeom>
           <a:solidFill>
-            <a:srgbClr val="1A7A4A"/>
+            <a:srgbClr val="B06000"/>
           </a:solidFill>
           <a:ln>
             <a:noFill/>
@@ -19320,11 +18407,11 @@
             <a:r>
               <a:rPr sz="1100" b="1" i="0">
                 <a:solidFill>
-                  <a:srgbClr val="1A7A4A"/>
+                  <a:srgbClr val="B06000"/>
                 </a:solidFill>
                 <a:latin typeface="Calibri"/>
               </a:rPr>
-              <a:t>● BUY</a:t>
+              <a:t>● HOLD</a:t>
             </a:r>
           </a:p>
         </p:txBody>
@@ -19359,7 +18446,7 @@
                 </a:solidFill>
                 <a:latin typeface="Calibri"/>
               </a:rPr>
-              <a:t>Prix cible base : 285 $  ·  Upside : +14,5 %  ·  Bear : 240 $ (-3,5 %)  ·  Bull : 320 $ (+28,6 %)</a:t>
+              <a:t>Prix cible base : — $  ·  Upside : —  ·  Bear : — $ (—)  ·  Bull : — $ (—)</a:t>
             </a:r>
           </a:p>
         </p:txBody>
@@ -19515,7 +18602,7 @@
                 </a:solidFill>
                 <a:latin typeface="Calibri"/>
               </a:rPr>
-              <a:t>Écosystème fermé</a:t>
+              <a:t>—</a:t>
             </a:r>
           </a:p>
         </p:txBody>
@@ -19550,7 +18637,7 @@
                 </a:solidFill>
                 <a:latin typeface="Calibri"/>
               </a:rPr>
-              <a:t>L'IA intégrée dans iOS 18 et les nouveaux iPhone 16 pourraient générer +15Md$ de revenus supplémentaires d'ici 2027</a:t>
+              <a:t>—</a:t>
             </a:r>
           </a:p>
         </p:txBody>
@@ -19628,7 +18715,7 @@
                 </a:solidFill>
                 <a:latin typeface="Calibri"/>
               </a:rPr>
-              <a:t>Marge brute &gt;45%</a:t>
+              <a:t>—</a:t>
             </a:r>
           </a:p>
         </p:txBody>
@@ -19663,7 +18750,7 @@
                 </a:solidFill>
                 <a:latin typeface="Calibri"/>
               </a:rPr>
-              <a:t>La pénétration des services en Chine (15% des revenus totaux) devrait croître de 25% par an avec l'ouverture du marché</a:t>
+              <a:t>—</a:t>
             </a:r>
           </a:p>
         </p:txBody>
@@ -19741,7 +18828,7 @@
                 </a:solidFill>
                 <a:latin typeface="Calibri"/>
               </a:rPr>
-              <a:t>Trésorerie nette 166Md$</a:t>
+              <a:t>—</a:t>
             </a:r>
           </a:p>
         </p:txBody>
@@ -19776,7 +18863,7 @@
                 </a:solidFill>
                 <a:latin typeface="Calibri"/>
               </a:rPr>
-              <a:t>Le rachat d'actions pour 100Md$ en 2026 soutiendra la valorisation via une réduction du nombre d'actions en circulation</a:t>
+              <a:t>—</a:t>
             </a:r>
           </a:p>
         </p:txBody>
@@ -19932,7 +19019,7 @@
                 </a:solidFill>
                 <a:latin typeface="Calibri"/>
               </a:rPr>
-              <a:t>Dépendance iPhone</a:t>
+              <a:t>—</a:t>
             </a:r>
           </a:p>
         </p:txBody>
@@ -19967,7 +19054,7 @@
                 </a:solidFill>
                 <a:latin typeface="Calibri"/>
               </a:rPr>
-              <a:t>Régulation chinoise accrue pourrait limiter l'accès au marché et réduire les marges de 5-8% | Impact sur les ventes iPhone estimées à 20Md$ d'ici 2027 | Horizon 12-18 mois avec risque de sanctions</a:t>
+              <a:t>Impact potentiel sur la these d'investissement — surveillance recommandee sur les 6-12 prochains mois.</a:t>
             </a:r>
           </a:p>
         </p:txBody>
@@ -20045,7 +19132,7 @@
                 </a:solidFill>
                 <a:latin typeface="Calibri"/>
               </a:rPr>
-              <a:t>Régulation Chine</a:t>
+              <a:t>—</a:t>
             </a:r>
           </a:p>
         </p:txBody>
@@ -20080,7 +19167,7 @@
                 </a:solidFill>
                 <a:latin typeface="Calibri"/>
               </a:rPr>
-              <a:t>Concurrence accrue dans l'IA avec Meta et Google réduisant l'avantage différenciant d'Apple | Perte de part de marché smartphone estimée à 3% d'ici 2027 | Horizon 2-3 ans avec pression sur les prix</a:t>
+              <a:t>Impact potentiel sur la these d'investissement — surveillance recommandee sur les 6-12 prochains mois.</a:t>
             </a:r>
           </a:p>
         </p:txBody>
@@ -20158,7 +19245,7 @@
                 </a:solidFill>
                 <a:latin typeface="Calibri"/>
               </a:rPr>
-              <a:t>Concurrence IA</a:t>
+              <a:t>—</a:t>
             </a:r>
           </a:p>
         </p:txBody>
@@ -20193,7 +19280,7 @@
                 </a:solidFill>
                 <a:latin typeface="Calibri"/>
               </a:rPr>
-              <a:t>Dépendance à l'iPhone pour 55% des revenus | Baisse de 10% des ventes iPhone en 2026 réduirait le CA de 40Md$ | Horizon 6-12 mois avec risque de saturation du marché premium</a:t>
+              <a:t>Impact potentiel sur la these d'investissement — surveillance recommandee sur les 6-12 prochains mois.</a:t>
             </a:r>
           </a:p>
         </p:txBody>
@@ -20470,7 +19557,7 @@
                 </a:solidFill>
                 <a:latin typeface="Calibri"/>
               </a:rPr>
-              <a:t>vs 14,3x médiane peers</a:t>
+              <a:t>vs — médiane peers</a:t>
             </a:r>
           </a:p>
         </p:txBody>
@@ -20782,7 +19869,7 @@
                 </a:solidFill>
                 <a:latin typeface="Calibri"/>
               </a:rPr>
-              <a:t>285 $</a:t>
+              <a:t>— $</a:t>
             </a:r>
           </a:p>
         </p:txBody>
@@ -20852,7 +19939,7 @@
                 </a:solidFill>
                 <a:latin typeface="Calibri"/>
               </a:rPr>
-              <a:t>Upside de +14,5 % vs cours</a:t>
+              <a:t>Upside de — vs cours</a:t>
             </a:r>
           </a:p>
         </p:txBody>
@@ -20973,7 +20060,7 @@
                 </a:solidFill>
                 <a:latin typeface="Calibri"/>
               </a:rPr>
-              <a:t>+0,177</a:t>
+              <a:t>-0,012</a:t>
             </a:r>
           </a:p>
         </p:txBody>
@@ -21043,7 +20130,7 @@
                 </a:solidFill>
                 <a:latin typeface="Calibri"/>
               </a:rPr>
-              <a:t>Positif  ·  30 articles</a:t>
+              <a:t>Negatif  ·  30 articles</a:t>
             </a:r>
           </a:p>
         </p:txBody>
@@ -21642,7 +20729,7 @@
                 </a:solidFill>
                 <a:latin typeface="Calibri"/>
               </a:rPr>
-              <a:t>AAPL  ·  USD  ·  Au 27 mars 2026</a:t>
+              <a:t>AAPL  ·  USD  ·  Au 28 mars 2026</a:t>
             </a:r>
           </a:p>
         </p:txBody>
@@ -23638,41 +22725,6 @@
                 <a:latin typeface="Calibri"/>
               </a:rPr>
               <a:t>278</a:t>
-            </a:r>
-          </a:p>
-        </p:txBody>
-      </p:sp>
-      <p:sp>
-        <p:nvSpPr>
-          <p:cNvPr id="68" name="TextBox 67"/>
-          <p:cNvSpPr txBox="1"/>
-          <p:nvPr/>
-        </p:nvSpPr>
-        <p:spPr>
-          <a:xfrm>
-            <a:off x="367200" y="4132800"/>
-            <a:ext cx="8413200" cy="687600"/>
-          </a:xfrm>
-          <a:prstGeom prst="rect">
-            <a:avLst/>
-          </a:prstGeom>
-          <a:noFill/>
-        </p:spPr>
-        <p:txBody>
-          <a:bodyPr wrap="square">
-            <a:spAutoFit/>
-          </a:bodyPr>
-          <a:lstStyle/>
-          <a:p>
-            <a:pPr algn="l"/>
-            <a:r>
-              <a:rPr sz="850" b="0" i="0">
-                <a:solidFill>
-                  <a:srgbClr val="555555"/>
-                </a:solidFill>
-                <a:latin typeface="Calibri"/>
-              </a:rPr>
-              <a:t>Apple maintient une position dominante dans les écosystèmes premium avec des marges exceptionnelles. La valorisation reste attractive malgré une prime de croissance déjà intégrée. Les catalyseurs structurels (IA, services, Chine) soutiennent le scénario haussier à moyen terme.</a:t>
             </a:r>
           </a:p>
         </p:txBody>
@@ -24715,7 +23767,7 @@
                 </a:solidFill>
                 <a:latin typeface="Calibri"/>
               </a:rPr>
-              <a:t>Dépendance iPhone  ·  Régulation Chine</a:t>
+              <a:t>Risques structurels &amp; thèse contraire</a:t>
             </a:r>
           </a:p>
         </p:txBody>
@@ -25949,64 +25001,21 @@
                 </a:solidFill>
                 <a:latin typeface="Calibri"/>
               </a:rPr>
-              <a:t>Apple conçoit et commercialise des produits technologiques premium (iPhone, Mac, iPad, Apple Watch) intégrés à son écosystème fermé. Leader mondial avec 25% de part de marché smartphone et 800M d'utilisateurs actifs, l'entreprise combine hardware, software et services récurrents. Son avantage concurrentiel repose sur l'innovation verticale, la fidélisation client et une marge brute supérieure à 45% grâce au mix produit et pricing power. L'entreprise articule son activité autour de deux segments stratégiques :</a:t>
-            </a:r>
-          </a:p>
-        </p:txBody>
-      </p:sp>
-      <p:sp>
-        <p:nvSpPr>
-          <p:cNvPr id="20" name="Rectangle 19"/>
-          <p:cNvSpPr/>
-          <p:nvPr/>
-        </p:nvSpPr>
-        <p:spPr>
-          <a:xfrm>
-            <a:off x="503999" y="2599200"/>
-            <a:ext cx="64800" cy="64800"/>
-          </a:xfrm>
-          <a:prstGeom prst="rect">
-            <a:avLst/>
-          </a:prstGeom>
-          <a:solidFill>
-            <a:srgbClr val="2E5FA3"/>
-          </a:solidFill>
-          <a:ln>
-            <a:noFill/>
-          </a:ln>
-        </p:spPr>
-        <p:style>
-          <a:lnRef idx="1">
-            <a:schemeClr val="accent1"/>
-          </a:lnRef>
-          <a:fillRef idx="3">
-            <a:schemeClr val="accent1"/>
-          </a:fillRef>
-          <a:effectRef idx="2">
-            <a:schemeClr val="accent1"/>
-          </a:effectRef>
-          <a:fontRef idx="minor">
-            <a:schemeClr val="lt1"/>
-          </a:fontRef>
-        </p:style>
-        <p:txBody>
-          <a:bodyPr rtlCol="0" anchor="ctr"/>
-          <a:lstStyle/>
-          <a:p>
-            <a:pPr algn="ctr"/>
-          </a:p>
-        </p:txBody>
-      </p:sp>
-      <p:sp>
-        <p:nvSpPr>
-          <p:cNvPr id="21" name="TextBox 20"/>
+              <a:t>—</a:t>
+            </a:r>
+          </a:p>
+        </p:txBody>
+      </p:sp>
+      <p:sp>
+        <p:nvSpPr>
+          <p:cNvPr id="20" name="TextBox 19"/>
           <p:cNvSpPr txBox="1"/>
           <p:nvPr/>
         </p:nvSpPr>
         <p:spPr>
           <a:xfrm>
-            <a:off x="619200" y="2556000"/>
-            <a:ext cx="4338000" cy="165600"/>
+            <a:off x="503999" y="2358000"/>
+            <a:ext cx="4662000" cy="183600"/>
           </a:xfrm>
           <a:prstGeom prst="rect">
             <a:avLst/>
@@ -26021,168 +25030,20 @@
           <a:p>
             <a:pPr algn="l"/>
             <a:r>
-              <a:rPr sz="850" b="1" i="0">
+              <a:rPr sz="900" b="1" i="0">
                 <a:solidFill>
-                  <a:srgbClr val="0D0D0D"/>
+                  <a:srgbClr val="1B3A6B"/>
                 </a:solidFill>
                 <a:latin typeface="Calibri"/>
               </a:rPr>
-              <a:t>Produits</a:t>
-            </a:r>
-          </a:p>
-        </p:txBody>
-      </p:sp>
-      <p:sp>
-        <p:nvSpPr>
-          <p:cNvPr id="22" name="TextBox 21"/>
-          <p:cNvSpPr txBox="1"/>
-          <p:nvPr/>
-        </p:nvSpPr>
-        <p:spPr>
-          <a:xfrm>
-            <a:off x="619200" y="2714400"/>
-            <a:ext cx="4338000" cy="503999"/>
-          </a:xfrm>
-          <a:prstGeom prst="rect">
-            <a:avLst/>
-          </a:prstGeom>
-          <a:noFill/>
-        </p:spPr>
-        <p:txBody>
-          <a:bodyPr wrap="square">
-            <a:spAutoFit/>
-          </a:bodyPr>
-          <a:lstStyle/>
-          <a:p>
-            <a:pPr algn="l"/>
-            <a:r>
-              <a:rPr sz="750" b="0" i="1">
-                <a:solidFill>
-                  <a:srgbClr val="555555"/>
-                </a:solidFill>
-                <a:latin typeface="Calibri"/>
-              </a:rPr>
-              <a:t>Segment hardware incluant iPhone (55% des revenus), Mac, iPad et Apple Watch. Modèle basé sur des cycles de renouvellement rapides (2-3 ans) et des prix premium. Clients cibles : consommateurs haut de gamme et professionnels. Croissance tirée par l'Asie (20% des ventes) et les services associés (Apple Music, iCloud).</a:t>
-            </a:r>
-          </a:p>
-        </p:txBody>
-      </p:sp>
-      <p:sp>
-        <p:nvSpPr>
-          <p:cNvPr id="23" name="Rectangle 22"/>
-          <p:cNvSpPr/>
-          <p:nvPr/>
-        </p:nvSpPr>
-        <p:spPr>
-          <a:xfrm>
-            <a:off x="503999" y="3301199"/>
-            <a:ext cx="64800" cy="64800"/>
-          </a:xfrm>
-          <a:prstGeom prst="rect">
-            <a:avLst/>
-          </a:prstGeom>
-          <a:solidFill>
-            <a:srgbClr val="2E5FA3"/>
-          </a:solidFill>
-          <a:ln>
-            <a:noFill/>
-          </a:ln>
-        </p:spPr>
-        <p:style>
-          <a:lnRef idx="1">
-            <a:schemeClr val="accent1"/>
-          </a:lnRef>
-          <a:fillRef idx="3">
-            <a:schemeClr val="accent1"/>
-          </a:fillRef>
-          <a:effectRef idx="2">
-            <a:schemeClr val="accent1"/>
-          </a:effectRef>
-          <a:fontRef idx="minor">
-            <a:schemeClr val="lt1"/>
-          </a:fontRef>
-        </p:style>
-        <p:txBody>
-          <a:bodyPr rtlCol="0" anchor="ctr"/>
-          <a:lstStyle/>
-          <a:p>
-            <a:pPr algn="ctr"/>
-          </a:p>
-        </p:txBody>
-      </p:sp>
-      <p:sp>
-        <p:nvSpPr>
-          <p:cNvPr id="24" name="TextBox 23"/>
-          <p:cNvSpPr txBox="1"/>
-          <p:nvPr/>
-        </p:nvSpPr>
-        <p:spPr>
-          <a:xfrm>
-            <a:off x="619200" y="3257999"/>
-            <a:ext cx="4338000" cy="165600"/>
-          </a:xfrm>
-          <a:prstGeom prst="rect">
-            <a:avLst/>
-          </a:prstGeom>
-          <a:noFill/>
-        </p:spPr>
-        <p:txBody>
-          <a:bodyPr wrap="square">
-            <a:spAutoFit/>
-          </a:bodyPr>
-          <a:lstStyle/>
-          <a:p>
-            <a:pPr algn="l"/>
-            <a:r>
-              <a:rPr sz="850" b="1" i="0">
-                <a:solidFill>
-                  <a:srgbClr val="0D0D0D"/>
-                </a:solidFill>
-                <a:latin typeface="Calibri"/>
-              </a:rPr>
-              <a:t>Services</a:t>
-            </a:r>
-          </a:p>
-        </p:txBody>
-      </p:sp>
-      <p:sp>
-        <p:nvSpPr>
-          <p:cNvPr id="25" name="TextBox 24"/>
-          <p:cNvSpPr txBox="1"/>
-          <p:nvPr/>
-        </p:nvSpPr>
-        <p:spPr>
-          <a:xfrm>
-            <a:off x="619200" y="3416399"/>
-            <a:ext cx="4338000" cy="503999"/>
-          </a:xfrm>
-          <a:prstGeom prst="rect">
-            <a:avLst/>
-          </a:prstGeom>
-          <a:noFill/>
-        </p:spPr>
-        <p:txBody>
-          <a:bodyPr wrap="square">
-            <a:spAutoFit/>
-          </a:bodyPr>
-          <a:lstStyle/>
-          <a:p>
-            <a:pPr algn="l"/>
-            <a:r>
-              <a:rPr sz="750" b="0" i="1">
-                <a:solidFill>
-                  <a:srgbClr val="555555"/>
-                </a:solidFill>
-                <a:latin typeface="Calibri"/>
-              </a:rPr>
-              <a:t>Segment à forte rentabilité (70% de marge) incluant App Store, Apple Music, iCloud et Apple Pay. Modèle abonnement avec 1.1Md d'utilisateurs payants générant 80Md$ de revenus annuels. Croissance portée par l'expansion géographique et l'augmentation du ARPU via bundling.</a:t>
-            </a:r>
-          </a:p>
-        </p:txBody>
-      </p:sp>
-      <p:sp>
-        <p:nvSpPr>
-          <p:cNvPr id="26" name="Rectangle 25"/>
+              <a:t>Positionnement stratégique</a:t>
+            </a:r>
+          </a:p>
+        </p:txBody>
+      </p:sp>
+      <p:sp>
+        <p:nvSpPr>
+          <p:cNvPr id="21" name="Rectangle 20"/>
           <p:cNvSpPr/>
           <p:nvPr/>
         </p:nvSpPr>
@@ -26225,7 +25086,7 @@
       </p:sp>
       <p:sp>
         <p:nvSpPr>
-          <p:cNvPr id="27" name="Rectangle 26"/>
+          <p:cNvPr id="22" name="Rectangle 21"/>
           <p:cNvSpPr/>
           <p:nvPr/>
         </p:nvSpPr>
@@ -26268,7 +25129,7 @@
       </p:sp>
       <p:sp>
         <p:nvSpPr>
-          <p:cNvPr id="28" name="TextBox 27"/>
+          <p:cNvPr id="23" name="TextBox 22"/>
           <p:cNvSpPr txBox="1"/>
           <p:nvPr/>
         </p:nvSpPr>
@@ -26303,7 +25164,7 @@
       </p:sp>
       <p:sp>
         <p:nvSpPr>
-          <p:cNvPr id="29" name="TextBox 28"/>
+          <p:cNvPr id="24" name="TextBox 23"/>
           <p:cNvSpPr txBox="1"/>
           <p:nvPr/>
         </p:nvSpPr>
@@ -26338,7 +25199,7 @@
       </p:sp>
       <p:sp>
         <p:nvSpPr>
-          <p:cNvPr id="30" name="Rectangle 29"/>
+          <p:cNvPr id="25" name="Rectangle 24"/>
           <p:cNvSpPr/>
           <p:nvPr/>
         </p:nvSpPr>
@@ -26381,7 +25242,7 @@
       </p:sp>
       <p:sp>
         <p:nvSpPr>
-          <p:cNvPr id="31" name="Rectangle 30"/>
+          <p:cNvPr id="26" name="Rectangle 25"/>
           <p:cNvSpPr/>
           <p:nvPr/>
         </p:nvSpPr>
@@ -26424,7 +25285,7 @@
       </p:sp>
       <p:sp>
         <p:nvSpPr>
-          <p:cNvPr id="32" name="TextBox 31"/>
+          <p:cNvPr id="27" name="TextBox 26"/>
           <p:cNvSpPr txBox="1"/>
           <p:nvPr/>
         </p:nvSpPr>
@@ -26459,7 +25320,7 @@
       </p:sp>
       <p:sp>
         <p:nvSpPr>
-          <p:cNvPr id="33" name="TextBox 32"/>
+          <p:cNvPr id="28" name="TextBox 27"/>
           <p:cNvSpPr txBox="1"/>
           <p:nvPr/>
         </p:nvSpPr>
@@ -26494,7 +25355,7 @@
       </p:sp>
       <p:sp>
         <p:nvSpPr>
-          <p:cNvPr id="34" name="Rectangle 33"/>
+          <p:cNvPr id="29" name="Rectangle 28"/>
           <p:cNvSpPr/>
           <p:nvPr/>
         </p:nvSpPr>
@@ -26537,7 +25398,7 @@
       </p:sp>
       <p:sp>
         <p:nvSpPr>
-          <p:cNvPr id="35" name="Rectangle 34"/>
+          <p:cNvPr id="30" name="Rectangle 29"/>
           <p:cNvSpPr/>
           <p:nvPr/>
         </p:nvSpPr>
@@ -26580,7 +25441,7 @@
       </p:sp>
       <p:sp>
         <p:nvSpPr>
-          <p:cNvPr id="36" name="TextBox 35"/>
+          <p:cNvPr id="31" name="TextBox 30"/>
           <p:cNvSpPr txBox="1"/>
           <p:nvPr/>
         </p:nvSpPr>
@@ -26615,7 +25476,7 @@
       </p:sp>
       <p:sp>
         <p:nvSpPr>
-          <p:cNvPr id="37" name="TextBox 36"/>
+          <p:cNvPr id="32" name="TextBox 31"/>
           <p:cNvSpPr txBox="1"/>
           <p:nvPr/>
         </p:nvSpPr>
@@ -26650,7 +25511,7 @@
       </p:sp>
       <p:sp>
         <p:nvSpPr>
-          <p:cNvPr id="38" name="Rectangle 37"/>
+          <p:cNvPr id="33" name="Rectangle 32"/>
           <p:cNvSpPr/>
           <p:nvPr/>
         </p:nvSpPr>
@@ -26693,7 +25554,7 @@
       </p:sp>
       <p:sp>
         <p:nvSpPr>
-          <p:cNvPr id="39" name="Rectangle 38"/>
+          <p:cNvPr id="34" name="Rectangle 33"/>
           <p:cNvSpPr/>
           <p:nvPr/>
         </p:nvSpPr>
@@ -26736,7 +25597,7 @@
       </p:sp>
       <p:sp>
         <p:nvSpPr>
-          <p:cNvPr id="40" name="TextBox 39"/>
+          <p:cNvPr id="35" name="TextBox 34"/>
           <p:cNvSpPr txBox="1"/>
           <p:nvPr/>
         </p:nvSpPr>
@@ -26771,7 +25632,7 @@
       </p:sp>
       <p:sp>
         <p:nvSpPr>
-          <p:cNvPr id="41" name="TextBox 40"/>
+          <p:cNvPr id="36" name="TextBox 35"/>
           <p:cNvSpPr txBox="1"/>
           <p:nvPr/>
         </p:nvSpPr>
@@ -26806,7 +25667,7 @@
       </p:sp>
       <p:sp>
         <p:nvSpPr>
-          <p:cNvPr id="42" name="TextBox 41"/>
+          <p:cNvPr id="37" name="TextBox 36"/>
           <p:cNvSpPr txBox="1"/>
           <p:nvPr/>
         </p:nvSpPr>
@@ -27398,7 +26259,7 @@
                 </a:solidFill>
                 <a:latin typeface="Calibri"/>
               </a:rPr>
-              <a:t>Modele Economique</a:t>
+              <a:t>Modèle Économique</a:t>
             </a:r>
           </a:p>
         </p:txBody>
@@ -27433,7 +26294,7 @@
                 </a:solidFill>
                 <a:latin typeface="Calibri"/>
               </a:rPr>
-              <a:t>Segments operationnels et moteurs de croissance</a:t>
+              <a:t>Segments opérationnels et moteurs de croissance</a:t>
             </a:r>
           </a:p>
         </p:txBody>
@@ -27447,7 +26308,7 @@
         <p:spPr>
           <a:xfrm>
             <a:off x="367200" y="961200"/>
-            <a:ext cx="4150800" cy="3520800"/>
+            <a:ext cx="2731199" cy="3520800"/>
           </a:xfrm>
           <a:prstGeom prst="rect">
             <a:avLst/>
@@ -27490,7 +26351,7 @@
         <p:spPr>
           <a:xfrm>
             <a:off x="367200" y="961200"/>
-            <a:ext cx="4150800" cy="54000"/>
+            <a:ext cx="2731199" cy="54000"/>
           </a:xfrm>
           <a:prstGeom prst="rect">
             <a:avLst/>
@@ -27533,7 +26394,7 @@
         <p:spPr>
           <a:xfrm>
             <a:off x="457200" y="1141200"/>
-            <a:ext cx="3970800" cy="640800"/>
+            <a:ext cx="2551199" cy="640800"/>
           </a:xfrm>
           <a:prstGeom prst="rect">
             <a:avLst/>
@@ -27554,7 +26415,7 @@
                 </a:solidFill>
                 <a:latin typeface="Calibri"/>
               </a:rPr>
-              <a:t>62%</a:t>
+              <a:t>—</a:t>
             </a:r>
           </a:p>
         </p:txBody>
@@ -27568,7 +26429,7 @@
         <p:spPr>
           <a:xfrm>
             <a:off x="457200" y="1785600"/>
-            <a:ext cx="3970800" cy="108000"/>
+            <a:ext cx="2551199" cy="108000"/>
           </a:xfrm>
           <a:prstGeom prst="rect">
             <a:avLst/>
@@ -27603,7 +26464,7 @@
         <p:spPr>
           <a:xfrm>
             <a:off x="457200" y="1965600"/>
-            <a:ext cx="3970800" cy="18000"/>
+            <a:ext cx="2551199" cy="18000"/>
           </a:xfrm>
           <a:prstGeom prst="rect">
             <a:avLst/>
@@ -27646,7 +26507,7 @@
         <p:spPr>
           <a:xfrm>
             <a:off x="457200" y="2059200"/>
-            <a:ext cx="3970800" cy="255600"/>
+            <a:ext cx="2551199" cy="255600"/>
           </a:xfrm>
           <a:prstGeom prst="rect">
             <a:avLst/>
@@ -27667,7 +26528,7 @@
                 </a:solidFill>
                 <a:latin typeface="Calibri"/>
               </a:rPr>
-              <a:t>Produits</a:t>
+              <a:t>Core Business</a:t>
             </a:r>
           </a:p>
         </p:txBody>
@@ -27681,7 +26542,7 @@
         <p:spPr>
           <a:xfrm>
             <a:off x="457200" y="2332800"/>
-            <a:ext cx="3970800" cy="2041199"/>
+            <a:ext cx="2551199" cy="2041199"/>
           </a:xfrm>
           <a:prstGeom prst="rect">
             <a:avLst/>
@@ -27702,7 +26563,7 @@
                 </a:solidFill>
                 <a:latin typeface="Calibri"/>
               </a:rPr>
-              <a:t>Segment hardware incluant iPhone (55% des revenus), Mac, iPad et Apple Watch. Modèle basé sur des cycles de renouvellement rapides (2-3 ans) et des prix premium. Clients cibles : consommateurs haut de gamme et professionnels. Croissance tirée par l'Asie (20% des ventes) et les services associés (Apple Music, iCloud).</a:t>
+              <a:t>—</a:t>
             </a:r>
           </a:p>
         </p:txBody>
@@ -27715,8 +26576,8 @@
         </p:nvSpPr>
         <p:spPr>
           <a:xfrm>
-            <a:off x="4626000" y="961200"/>
-            <a:ext cx="4150800" cy="3520800"/>
+            <a:off x="3206400" y="961200"/>
+            <a:ext cx="2731199" cy="3520800"/>
           </a:xfrm>
           <a:prstGeom prst="rect">
             <a:avLst/>
@@ -27758,8 +26619,8 @@
         </p:nvSpPr>
         <p:spPr>
           <a:xfrm>
-            <a:off x="4626000" y="961200"/>
-            <a:ext cx="4150800" cy="54000"/>
+            <a:off x="3206400" y="961200"/>
+            <a:ext cx="2731199" cy="54000"/>
           </a:xfrm>
           <a:prstGeom prst="rect">
             <a:avLst/>
@@ -27801,8 +26662,8 @@
         </p:nvSpPr>
         <p:spPr>
           <a:xfrm>
-            <a:off x="4716000" y="1141200"/>
-            <a:ext cx="3970800" cy="640800"/>
+            <a:off x="3296400" y="1141200"/>
+            <a:ext cx="2551199" cy="640800"/>
           </a:xfrm>
           <a:prstGeom prst="rect">
             <a:avLst/>
@@ -27823,7 +26684,7 @@
                 </a:solidFill>
                 <a:latin typeface="Calibri"/>
               </a:rPr>
-              <a:t>22%</a:t>
+              <a:t>—</a:t>
             </a:r>
           </a:p>
         </p:txBody>
@@ -27836,8 +26697,8 @@
         </p:nvSpPr>
         <p:spPr>
           <a:xfrm>
-            <a:off x="4716000" y="1785600"/>
-            <a:ext cx="3970800" cy="108000"/>
+            <a:off x="3296400" y="1785600"/>
+            <a:ext cx="2551199" cy="108000"/>
           </a:xfrm>
           <a:prstGeom prst="rect">
             <a:avLst/>
@@ -27871,8 +26732,8 @@
         </p:nvSpPr>
         <p:spPr>
           <a:xfrm>
-            <a:off x="4716000" y="1965600"/>
-            <a:ext cx="3970800" cy="18000"/>
+            <a:off x="3296400" y="1965600"/>
+            <a:ext cx="2551199" cy="18000"/>
           </a:xfrm>
           <a:prstGeom prst="rect">
             <a:avLst/>
@@ -27914,8 +26775,8 @@
         </p:nvSpPr>
         <p:spPr>
           <a:xfrm>
-            <a:off x="4716000" y="2059200"/>
-            <a:ext cx="3970800" cy="255600"/>
+            <a:off x="3296400" y="2059200"/>
+            <a:ext cx="2551199" cy="255600"/>
           </a:xfrm>
           <a:prstGeom prst="rect">
             <a:avLst/>
@@ -27936,7 +26797,7 @@
                 </a:solidFill>
                 <a:latin typeface="Calibri"/>
               </a:rPr>
-              <a:t>Services</a:t>
+              <a:t>Growth Driver</a:t>
             </a:r>
           </a:p>
         </p:txBody>
@@ -27949,8 +26810,8 @@
         </p:nvSpPr>
         <p:spPr>
           <a:xfrm>
-            <a:off x="4716000" y="2332800"/>
-            <a:ext cx="3970800" cy="2041199"/>
+            <a:off x="3296400" y="2332800"/>
+            <a:ext cx="2551199" cy="2041199"/>
           </a:xfrm>
           <a:prstGeom prst="rect">
             <a:avLst/>
@@ -27971,7 +26832,276 @@
                 </a:solidFill>
                 <a:latin typeface="Calibri"/>
               </a:rPr>
-              <a:t>Segment à forte rentabilité (70% de marge) incluant App Store, Apple Music, iCloud et Apple Pay. Modèle abonnement avec 1.1Md d'utilisateurs payants générant 80Md$ de revenus annuels. Croissance portée par l'expansion géographique et l'augmentation du ARPU via bundling.</a:t>
+              <a:t>—</a:t>
+            </a:r>
+          </a:p>
+        </p:txBody>
+      </p:sp>
+      <p:sp>
+        <p:nvSpPr>
+          <p:cNvPr id="31" name="Rectangle 30"/>
+          <p:cNvSpPr/>
+          <p:nvPr/>
+        </p:nvSpPr>
+        <p:spPr>
+          <a:xfrm>
+            <a:off x="6045600" y="961200"/>
+            <a:ext cx="2731199" cy="3520800"/>
+          </a:xfrm>
+          <a:prstGeom prst="rect">
+            <a:avLst/>
+          </a:prstGeom>
+          <a:solidFill>
+            <a:srgbClr val="F7F8FA"/>
+          </a:solidFill>
+          <a:ln>
+            <a:noFill/>
+          </a:ln>
+        </p:spPr>
+        <p:style>
+          <a:lnRef idx="1">
+            <a:schemeClr val="accent1"/>
+          </a:lnRef>
+          <a:fillRef idx="3">
+            <a:schemeClr val="accent1"/>
+          </a:fillRef>
+          <a:effectRef idx="2">
+            <a:schemeClr val="accent1"/>
+          </a:effectRef>
+          <a:fontRef idx="minor">
+            <a:schemeClr val="lt1"/>
+          </a:fontRef>
+        </p:style>
+        <p:txBody>
+          <a:bodyPr rtlCol="0" anchor="ctr"/>
+          <a:lstStyle/>
+          <a:p>
+            <a:pPr algn="ctr"/>
+          </a:p>
+        </p:txBody>
+      </p:sp>
+      <p:sp>
+        <p:nvSpPr>
+          <p:cNvPr id="32" name="Rectangle 31"/>
+          <p:cNvSpPr/>
+          <p:nvPr/>
+        </p:nvSpPr>
+        <p:spPr>
+          <a:xfrm>
+            <a:off x="6045600" y="961200"/>
+            <a:ext cx="2731199" cy="54000"/>
+          </a:xfrm>
+          <a:prstGeom prst="rect">
+            <a:avLst/>
+          </a:prstGeom>
+          <a:solidFill>
+            <a:srgbClr val="888888"/>
+          </a:solidFill>
+          <a:ln>
+            <a:noFill/>
+          </a:ln>
+        </p:spPr>
+        <p:style>
+          <a:lnRef idx="1">
+            <a:schemeClr val="accent1"/>
+          </a:lnRef>
+          <a:fillRef idx="3">
+            <a:schemeClr val="accent1"/>
+          </a:fillRef>
+          <a:effectRef idx="2">
+            <a:schemeClr val="accent1"/>
+          </a:effectRef>
+          <a:fontRef idx="minor">
+            <a:schemeClr val="lt1"/>
+          </a:fontRef>
+        </p:style>
+        <p:txBody>
+          <a:bodyPr rtlCol="0" anchor="ctr"/>
+          <a:lstStyle/>
+          <a:p>
+            <a:pPr algn="ctr"/>
+          </a:p>
+        </p:txBody>
+      </p:sp>
+      <p:sp>
+        <p:nvSpPr>
+          <p:cNvPr id="33" name="TextBox 32"/>
+          <p:cNvSpPr txBox="1"/>
+          <p:nvPr/>
+        </p:nvSpPr>
+        <p:spPr>
+          <a:xfrm>
+            <a:off x="6135600" y="1141200"/>
+            <a:ext cx="2551199" cy="640800"/>
+          </a:xfrm>
+          <a:prstGeom prst="rect">
+            <a:avLst/>
+          </a:prstGeom>
+          <a:noFill/>
+        </p:spPr>
+        <p:txBody>
+          <a:bodyPr wrap="square">
+            <a:spAutoFit/>
+          </a:bodyPr>
+          <a:lstStyle/>
+          <a:p>
+            <a:pPr algn="l"/>
+            <a:r>
+              <a:rPr sz="2200" b="1" i="0">
+                <a:solidFill>
+                  <a:srgbClr val="888888"/>
+                </a:solidFill>
+                <a:latin typeface="Calibri"/>
+              </a:rPr>
+              <a:t>—</a:t>
+            </a:r>
+          </a:p>
+        </p:txBody>
+      </p:sp>
+      <p:sp>
+        <p:nvSpPr>
+          <p:cNvPr id="34" name="TextBox 33"/>
+          <p:cNvSpPr txBox="1"/>
+          <p:nvPr/>
+        </p:nvSpPr>
+        <p:spPr>
+          <a:xfrm>
+            <a:off x="6135600" y="1785600"/>
+            <a:ext cx="2551199" cy="108000"/>
+          </a:xfrm>
+          <a:prstGeom prst="rect">
+            <a:avLst/>
+          </a:prstGeom>
+          <a:noFill/>
+        </p:spPr>
+        <p:txBody>
+          <a:bodyPr wrap="square">
+            <a:spAutoFit/>
+          </a:bodyPr>
+          <a:lstStyle/>
+          <a:p>
+            <a:pPr algn="l"/>
+            <a:r>
+              <a:rPr sz="900" b="0" i="0">
+                <a:solidFill>
+                  <a:srgbClr val="555555"/>
+                </a:solidFill>
+                <a:latin typeface="Calibri"/>
+              </a:rPr>
+              <a:t>du CA</a:t>
+            </a:r>
+          </a:p>
+        </p:txBody>
+      </p:sp>
+      <p:sp>
+        <p:nvSpPr>
+          <p:cNvPr id="35" name="Rectangle 34"/>
+          <p:cNvSpPr/>
+          <p:nvPr/>
+        </p:nvSpPr>
+        <p:spPr>
+          <a:xfrm>
+            <a:off x="6135600" y="1965600"/>
+            <a:ext cx="2551199" cy="18000"/>
+          </a:xfrm>
+          <a:prstGeom prst="rect">
+            <a:avLst/>
+          </a:prstGeom>
+          <a:solidFill>
+            <a:srgbClr val="888888"/>
+          </a:solidFill>
+          <a:ln>
+            <a:noFill/>
+          </a:ln>
+        </p:spPr>
+        <p:style>
+          <a:lnRef idx="1">
+            <a:schemeClr val="accent1"/>
+          </a:lnRef>
+          <a:fillRef idx="3">
+            <a:schemeClr val="accent1"/>
+          </a:fillRef>
+          <a:effectRef idx="2">
+            <a:schemeClr val="accent1"/>
+          </a:effectRef>
+          <a:fontRef idx="minor">
+            <a:schemeClr val="lt1"/>
+          </a:fontRef>
+        </p:style>
+        <p:txBody>
+          <a:bodyPr rtlCol="0" anchor="ctr"/>
+          <a:lstStyle/>
+          <a:p>
+            <a:pPr algn="ctr"/>
+          </a:p>
+        </p:txBody>
+      </p:sp>
+      <p:sp>
+        <p:nvSpPr>
+          <p:cNvPr id="36" name="TextBox 35"/>
+          <p:cNvSpPr txBox="1"/>
+          <p:nvPr/>
+        </p:nvSpPr>
+        <p:spPr>
+          <a:xfrm>
+            <a:off x="6135600" y="2059200"/>
+            <a:ext cx="2551199" cy="255600"/>
+          </a:xfrm>
+          <a:prstGeom prst="rect">
+            <a:avLst/>
+          </a:prstGeom>
+          <a:noFill/>
+        </p:spPr>
+        <p:txBody>
+          <a:bodyPr wrap="square">
+            <a:spAutoFit/>
+          </a:bodyPr>
+          <a:lstStyle/>
+          <a:p>
+            <a:pPr algn="l"/>
+            <a:r>
+              <a:rPr sz="1000" b="1" i="0">
+                <a:solidFill>
+                  <a:srgbClr val="1B3A6B"/>
+                </a:solidFill>
+                <a:latin typeface="Calibri"/>
+              </a:rPr>
+              <a:t>International</a:t>
+            </a:r>
+          </a:p>
+        </p:txBody>
+      </p:sp>
+      <p:sp>
+        <p:nvSpPr>
+          <p:cNvPr id="37" name="TextBox 36"/>
+          <p:cNvSpPr txBox="1"/>
+          <p:nvPr/>
+        </p:nvSpPr>
+        <p:spPr>
+          <a:xfrm>
+            <a:off x="6135600" y="2332800"/>
+            <a:ext cx="2551199" cy="2041199"/>
+          </a:xfrm>
+          <a:prstGeom prst="rect">
+            <a:avLst/>
+          </a:prstGeom>
+          <a:noFill/>
+        </p:spPr>
+        <p:txBody>
+          <a:bodyPr wrap="square">
+            <a:spAutoFit/>
+          </a:bodyPr>
+          <a:lstStyle/>
+          <a:p>
+            <a:pPr algn="l"/>
+            <a:r>
+              <a:rPr sz="800" b="0" i="0">
+                <a:solidFill>
+                  <a:srgbClr val="555555"/>
+                </a:solidFill>
+                <a:latin typeface="Calibri"/>
+              </a:rPr>
+              <a:t>—</a:t>
             </a:r>
           </a:p>
         </p:txBody>
@@ -28823,7 +27953,7 @@
                 </a:solidFill>
                 <a:latin typeface="Calibri"/>
               </a:rPr>
-              <a:t>USD millions  ·  2021–2027F</a:t>
+              <a:t>USD millions  ·  2021–2025</a:t>
             </a:r>
           </a:p>
         </p:txBody>
@@ -28838,7 +27968,7 @@
         </p:nvGraphicFramePr>
         <p:xfrm>
           <a:off x="367200" y="914400"/>
-          <a:ext cx="8413196" cy="1980000"/>
+          <a:ext cx="8413200" cy="1980000"/>
         </p:xfrm>
         <a:graphic>
           <a:graphicData uri="http://schemas.openxmlformats.org/drawingml/2006/table">
@@ -28848,11 +27978,9 @@
               </a:tblPr>
               <a:tblGrid>
                 <a:gridCol w="2355696"/>
-                <a:gridCol w="1211500"/>
-                <a:gridCol w="1211500"/>
-                <a:gridCol w="1211500"/>
-                <a:gridCol w="1211500"/>
-                <a:gridCol w="1211500"/>
+                <a:gridCol w="2019168"/>
+                <a:gridCol w="2019168"/>
+                <a:gridCol w="2019168"/>
               </a:tblGrid>
               <a:tr h="220000">
                 <a:tc>
@@ -28938,52 +28066,6 @@
                           <a:latin typeface="Calibri"/>
                         </a:rPr>
                         <a:t>2025</a:t>
-                      </a:r>
-                    </a:p>
-                  </a:txBody>
-                  <a:tcPr>
-                    <a:solidFill>
-                      <a:srgbClr val="1B3A6B"/>
-                    </a:solidFill>
-                  </a:tcPr>
-                </a:tc>
-                <a:tc>
-                  <a:txBody>
-                    <a:bodyPr/>
-                    <a:lstStyle/>
-                    <a:p>
-                      <a:pPr algn="ctr"/>
-                      <a:r>
-                        <a:rPr sz="800" b="1" i="0">
-                          <a:solidFill>
-                            <a:srgbClr val="FFFFFF"/>
-                          </a:solidFill>
-                          <a:latin typeface="Calibri"/>
-                        </a:rPr>
-                        <a:t>2026F</a:t>
-                      </a:r>
-                    </a:p>
-                  </a:txBody>
-                  <a:tcPr>
-                    <a:solidFill>
-                      <a:srgbClr val="1B3A6B"/>
-                    </a:solidFill>
-                  </a:tcPr>
-                </a:tc>
-                <a:tc>
-                  <a:txBody>
-                    <a:bodyPr/>
-                    <a:lstStyle/>
-                    <a:p>
-                      <a:pPr algn="ctr"/>
-                      <a:r>
-                        <a:rPr sz="800" b="1" i="0">
-                          <a:solidFill>
-                            <a:srgbClr val="FFFFFF"/>
-                          </a:solidFill>
-                          <a:latin typeface="Calibri"/>
-                        </a:rPr>
-                        <a:t>2027F</a:t>
                       </a:r>
                     </a:p>
                   </a:txBody>
@@ -29087,52 +28169,6 @@
                     </a:solidFill>
                   </a:tcPr>
                 </a:tc>
-                <a:tc>
-                  <a:txBody>
-                    <a:bodyPr/>
-                    <a:lstStyle/>
-                    <a:p>
-                      <a:pPr algn="ctr"/>
-                      <a:r>
-                        <a:rPr sz="800" b="1" i="0">
-                          <a:solidFill>
-                            <a:srgbClr val="0D0D0D"/>
-                          </a:solidFill>
-                          <a:latin typeface="Calibri"/>
-                        </a:rPr>
-                        <a:t>440,0</a:t>
-                      </a:r>
-                    </a:p>
-                  </a:txBody>
-                  <a:tcPr>
-                    <a:solidFill>
-                      <a:srgbClr val="FFFFFF"/>
-                    </a:solidFill>
-                  </a:tcPr>
-                </a:tc>
-                <a:tc>
-                  <a:txBody>
-                    <a:bodyPr/>
-                    <a:lstStyle/>
-                    <a:p>
-                      <a:pPr algn="ctr"/>
-                      <a:r>
-                        <a:rPr sz="800" b="1" i="0">
-                          <a:solidFill>
-                            <a:srgbClr val="0D0D0D"/>
-                          </a:solidFill>
-                          <a:latin typeface="Calibri"/>
-                        </a:rPr>
-                        <a:t>470,0</a:t>
-                      </a:r>
-                    </a:p>
-                  </a:txBody>
-                  <a:tcPr>
-                    <a:solidFill>
-                      <a:srgbClr val="FFFFFF"/>
-                    </a:solidFill>
-                  </a:tcPr>
-                </a:tc>
               </a:tr>
               <a:tr h="220000">
                 <a:tc>
@@ -29224,52 +28260,6 @@
                   <a:tcPr>
                     <a:solidFill>
                       <a:srgbClr val="DDE8F5"/>
-                    </a:solidFill>
-                  </a:tcPr>
-                </a:tc>
-                <a:tc>
-                  <a:txBody>
-                    <a:bodyPr/>
-                    <a:lstStyle/>
-                    <a:p>
-                      <a:pPr algn="ctr"/>
-                      <a:r>
-                        <a:rPr sz="750" b="0" i="1">
-                          <a:solidFill>
-                            <a:srgbClr val="555555"/>
-                          </a:solidFill>
-                          <a:latin typeface="Calibri"/>
-                        </a:rPr>
-                        <a:t>+5,7 %</a:t>
-                      </a:r>
-                    </a:p>
-                  </a:txBody>
-                  <a:tcPr>
-                    <a:solidFill>
-                      <a:srgbClr val="F7F8FA"/>
-                    </a:solidFill>
-                  </a:tcPr>
-                </a:tc>
-                <a:tc>
-                  <a:txBody>
-                    <a:bodyPr/>
-                    <a:lstStyle/>
-                    <a:p>
-                      <a:pPr algn="ctr"/>
-                      <a:r>
-                        <a:rPr sz="750" b="0" i="1">
-                          <a:solidFill>
-                            <a:srgbClr val="555555"/>
-                          </a:solidFill>
-                          <a:latin typeface="Calibri"/>
-                        </a:rPr>
-                        <a:t>+6,8 %</a:t>
-                      </a:r>
-                    </a:p>
-                  </a:txBody>
-                  <a:tcPr>
-                    <a:solidFill>
-                      <a:srgbClr val="F7F8FA"/>
                     </a:solidFill>
                   </a:tcPr>
                 </a:tc>
@@ -29367,52 +28357,6 @@
                     </a:solidFill>
                   </a:tcPr>
                 </a:tc>
-                <a:tc>
-                  <a:txBody>
-                    <a:bodyPr/>
-                    <a:lstStyle/>
-                    <a:p>
-                      <a:pPr algn="ctr"/>
-                      <a:r>
-                        <a:rPr sz="800" b="1" i="0">
-                          <a:solidFill>
-                            <a:srgbClr val="0D0D0D"/>
-                          </a:solidFill>
-                          <a:latin typeface="Calibri"/>
-                        </a:rPr>
-                        <a:t>207,7</a:t>
-                      </a:r>
-                    </a:p>
-                  </a:txBody>
-                  <a:tcPr>
-                    <a:solidFill>
-                      <a:srgbClr val="FFFFFF"/>
-                    </a:solidFill>
-                  </a:tcPr>
-                </a:tc>
-                <a:tc>
-                  <a:txBody>
-                    <a:bodyPr/>
-                    <a:lstStyle/>
-                    <a:p>
-                      <a:pPr algn="ctr"/>
-                      <a:r>
-                        <a:rPr sz="800" b="1" i="0">
-                          <a:solidFill>
-                            <a:srgbClr val="0D0D0D"/>
-                          </a:solidFill>
-                          <a:latin typeface="Calibri"/>
-                        </a:rPr>
-                        <a:t>223,2</a:t>
-                      </a:r>
-                    </a:p>
-                  </a:txBody>
-                  <a:tcPr>
-                    <a:solidFill>
-                      <a:srgbClr val="FFFFFF"/>
-                    </a:solidFill>
-                  </a:tcPr>
-                </a:tc>
               </a:tr>
               <a:tr h="220000">
                 <a:tc>
@@ -29504,52 +28448,6 @@
                   <a:tcPr>
                     <a:solidFill>
                       <a:srgbClr val="DDE8F5"/>
-                    </a:solidFill>
-                  </a:tcPr>
-                </a:tc>
-                <a:tc>
-                  <a:txBody>
-                    <a:bodyPr/>
-                    <a:lstStyle/>
-                    <a:p>
-                      <a:pPr algn="ctr"/>
-                      <a:r>
-                        <a:rPr sz="750" b="0" i="1">
-                          <a:solidFill>
-                            <a:srgbClr val="555555"/>
-                          </a:solidFill>
-                          <a:latin typeface="Calibri"/>
-                        </a:rPr>
-                        <a:t>47,2 %</a:t>
-                      </a:r>
-                    </a:p>
-                  </a:txBody>
-                  <a:tcPr>
-                    <a:solidFill>
-                      <a:srgbClr val="F7F8FA"/>
-                    </a:solidFill>
-                  </a:tcPr>
-                </a:tc>
-                <a:tc>
-                  <a:txBody>
-                    <a:bodyPr/>
-                    <a:lstStyle/>
-                    <a:p>
-                      <a:pPr algn="ctr"/>
-                      <a:r>
-                        <a:rPr sz="750" b="0" i="1">
-                          <a:solidFill>
-                            <a:srgbClr val="555555"/>
-                          </a:solidFill>
-                          <a:latin typeface="Calibri"/>
-                        </a:rPr>
-                        <a:t>47,5 %</a:t>
-                      </a:r>
-                    </a:p>
-                  </a:txBody>
-                  <a:tcPr>
-                    <a:solidFill>
-                      <a:srgbClr val="F7F8FA"/>
                     </a:solidFill>
                   </a:tcPr>
                 </a:tc>
@@ -29647,52 +28545,6 @@
                     </a:solidFill>
                   </a:tcPr>
                 </a:tc>
-                <a:tc>
-                  <a:txBody>
-                    <a:bodyPr/>
-                    <a:lstStyle/>
-                    <a:p>
-                      <a:pPr algn="ctr"/>
-                      <a:r>
-                        <a:rPr sz="800" b="1" i="0">
-                          <a:solidFill>
-                            <a:srgbClr val="0D0D0D"/>
-                          </a:solidFill>
-                          <a:latin typeface="Calibri"/>
-                        </a:rPr>
-                        <a:t>155,0</a:t>
-                      </a:r>
-                    </a:p>
-                  </a:txBody>
-                  <a:tcPr>
-                    <a:solidFill>
-                      <a:srgbClr val="FFFFFF"/>
-                    </a:solidFill>
-                  </a:tcPr>
-                </a:tc>
-                <a:tc>
-                  <a:txBody>
-                    <a:bodyPr/>
-                    <a:lstStyle/>
-                    <a:p>
-                      <a:pPr algn="ctr"/>
-                      <a:r>
-                        <a:rPr sz="800" b="1" i="0">
-                          <a:solidFill>
-                            <a:srgbClr val="0D0D0D"/>
-                          </a:solidFill>
-                          <a:latin typeface="Calibri"/>
-                        </a:rPr>
-                        <a:t>168,0</a:t>
-                      </a:r>
-                    </a:p>
-                  </a:txBody>
-                  <a:tcPr>
-                    <a:solidFill>
-                      <a:srgbClr val="FFFFFF"/>
-                    </a:solidFill>
-                  </a:tcPr>
-                </a:tc>
               </a:tr>
               <a:tr h="220000">
                 <a:tc>
@@ -29784,52 +28636,6 @@
                   <a:tcPr>
                     <a:solidFill>
                       <a:srgbClr val="DDE8F5"/>
-                    </a:solidFill>
-                  </a:tcPr>
-                </a:tc>
-                <a:tc>
-                  <a:txBody>
-                    <a:bodyPr/>
-                    <a:lstStyle/>
-                    <a:p>
-                      <a:pPr algn="ctr"/>
-                      <a:r>
-                        <a:rPr sz="750" b="0" i="1">
-                          <a:solidFill>
-                            <a:srgbClr val="555555"/>
-                          </a:solidFill>
-                          <a:latin typeface="Calibri"/>
-                        </a:rPr>
-                        <a:t>35,2 %</a:t>
-                      </a:r>
-                    </a:p>
-                  </a:txBody>
-                  <a:tcPr>
-                    <a:solidFill>
-                      <a:srgbClr val="F7F8FA"/>
-                    </a:solidFill>
-                  </a:tcPr>
-                </a:tc>
-                <a:tc>
-                  <a:txBody>
-                    <a:bodyPr/>
-                    <a:lstStyle/>
-                    <a:p>
-                      <a:pPr algn="ctr"/>
-                      <a:r>
-                        <a:rPr sz="750" b="0" i="1">
-                          <a:solidFill>
-                            <a:srgbClr val="555555"/>
-                          </a:solidFill>
-                          <a:latin typeface="Calibri"/>
-                        </a:rPr>
-                        <a:t>35,7 %</a:t>
-                      </a:r>
-                    </a:p>
-                  </a:txBody>
-                  <a:tcPr>
-                    <a:solidFill>
-                      <a:srgbClr val="F7F8FA"/>
                     </a:solidFill>
                   </a:tcPr>
                 </a:tc>
@@ -29927,52 +28733,6 @@
                     </a:solidFill>
                   </a:tcPr>
                 </a:tc>
-                <a:tc>
-                  <a:txBody>
-                    <a:bodyPr/>
-                    <a:lstStyle/>
-                    <a:p>
-                      <a:pPr algn="ctr"/>
-                      <a:r>
-                        <a:rPr sz="800" b="1" i="0">
-                          <a:solidFill>
-                            <a:srgbClr val="0D0D0D"/>
-                          </a:solidFill>
-                          <a:latin typeface="Calibri"/>
-                        </a:rPr>
-                        <a:t>118,0</a:t>
-                      </a:r>
-                    </a:p>
-                  </a:txBody>
-                  <a:tcPr>
-                    <a:solidFill>
-                      <a:srgbClr val="FFFFFF"/>
-                    </a:solidFill>
-                  </a:tcPr>
-                </a:tc>
-                <a:tc>
-                  <a:txBody>
-                    <a:bodyPr/>
-                    <a:lstStyle/>
-                    <a:p>
-                      <a:pPr algn="ctr"/>
-                      <a:r>
-                        <a:rPr sz="800" b="1" i="0">
-                          <a:solidFill>
-                            <a:srgbClr val="0D0D0D"/>
-                          </a:solidFill>
-                          <a:latin typeface="Calibri"/>
-                        </a:rPr>
-                        <a:t>128,0</a:t>
-                      </a:r>
-                    </a:p>
-                  </a:txBody>
-                  <a:tcPr>
-                    <a:solidFill>
-                      <a:srgbClr val="FFFFFF"/>
-                    </a:solidFill>
-                  </a:tcPr>
-                </a:tc>
               </a:tr>
               <a:tr h="220000">
                 <a:tc>
@@ -30067,92 +28827,11 @@
                     </a:solidFill>
                   </a:tcPr>
                 </a:tc>
-                <a:tc>
-                  <a:txBody>
-                    <a:bodyPr/>
-                    <a:lstStyle/>
-                    <a:p>
-                      <a:pPr algn="ctr"/>
-                      <a:r>
-                        <a:rPr sz="750" b="0" i="1">
-                          <a:solidFill>
-                            <a:srgbClr val="555555"/>
-                          </a:solidFill>
-                          <a:latin typeface="Calibri"/>
-                        </a:rPr>
-                        <a:t>26,8 %</a:t>
-                      </a:r>
-                    </a:p>
-                  </a:txBody>
-                  <a:tcPr>
-                    <a:solidFill>
-                      <a:srgbClr val="F7F8FA"/>
-                    </a:solidFill>
-                  </a:tcPr>
-                </a:tc>
-                <a:tc>
-                  <a:txBody>
-                    <a:bodyPr/>
-                    <a:lstStyle/>
-                    <a:p>
-                      <a:pPr algn="ctr"/>
-                      <a:r>
-                        <a:rPr sz="750" b="0" i="1">
-                          <a:solidFill>
-                            <a:srgbClr val="555555"/>
-                          </a:solidFill>
-                          <a:latin typeface="Calibri"/>
-                        </a:rPr>
-                        <a:t>27,2 %</a:t>
-                      </a:r>
-                    </a:p>
-                  </a:txBody>
-                  <a:tcPr>
-                    <a:solidFill>
-                      <a:srgbClr val="F7F8FA"/>
-                    </a:solidFill>
-                  </a:tcPr>
-                </a:tc>
               </a:tr>
             </a:tbl>
           </a:graphicData>
         </a:graphic>
       </p:graphicFrame>
-      <p:sp>
-        <p:nvSpPr>
-          <p:cNvPr id="18" name="TextBox 17"/>
-          <p:cNvSpPr txBox="1"/>
-          <p:nvPr/>
-        </p:nvSpPr>
-        <p:spPr>
-          <a:xfrm>
-            <a:off x="367200" y="3218400"/>
-            <a:ext cx="8413200" cy="1224000"/>
-          </a:xfrm>
-          <a:prstGeom prst="rect">
-            <a:avLst/>
-          </a:prstGeom>
-          <a:noFill/>
-        </p:spPr>
-        <p:txBody>
-          <a:bodyPr wrap="square">
-            <a:spAutoFit/>
-          </a:bodyPr>
-          <a:lstStyle/>
-          <a:p>
-            <a:pPr algn="l"/>
-            <a:r>
-              <a:rPr sz="850" b="0" i="0">
-                <a:solidFill>
-                  <a:srgbClr val="555555"/>
-                </a:solidFill>
-                <a:latin typeface="Calibri"/>
-              </a:rPr>
-              <a:t>Croissance revenue de 6.4% en 2025 portée par les services (+12%) et l'iPhone (+5%). Les marges se stabilisent à haut niveau grâce à l'effet de levier sur les coûts fixes et au mix produit favorable. La génération de cash de 110Md$ en 2025 renforce la solidité bilancielle et permet des rachats d'actions agressifs.</a:t>
-            </a:r>
-          </a:p>
-        </p:txBody>
-      </p:sp>
     </p:spTree>
   </p:cSld>
   <p:clrMapOvr>
@@ -32035,41 +30714,6 @@
           </a:graphicData>
         </a:graphic>
       </p:graphicFrame>
-      <p:sp>
-        <p:nvSpPr>
-          <p:cNvPr id="31" name="TextBox 30"/>
-          <p:cNvSpPr txBox="1"/>
-          <p:nvPr/>
-        </p:nvSpPr>
-        <p:spPr>
-          <a:xfrm>
-            <a:off x="367200" y="4068000"/>
-            <a:ext cx="8413200" cy="468000"/>
-          </a:xfrm>
-          <a:prstGeom prst="rect">
-            <a:avLst/>
-          </a:prstGeom>
-          <a:noFill/>
-        </p:spPr>
-        <p:txBody>
-          <a:bodyPr wrap="square">
-            <a:spAutoFit/>
-          </a:bodyPr>
-          <a:lstStyle/>
-          <a:p>
-            <a:pPr algn="l"/>
-            <a:r>
-              <a:rPr sz="850" b="0" i="0">
-                <a:solidFill>
-                  <a:srgbClr val="555555"/>
-                </a:solidFill>
-                <a:latin typeface="Calibri"/>
-              </a:rPr>
-              <a:t>Croissance revenue de 6.4% en 2025 portée par les services (+12%) et l'iPhone (+5%). Les marges se stabilisent à haut niveau grâce à l'effet de levier sur les coûts fixes et au mix produit favorable. La génération de cash de 110Md$ en 2025 renforce la solidité bilancielle et permet des rachats d'act</a:t>
-            </a:r>
-          </a:p>
-        </p:txBody>
-      </p:sp>
     </p:spTree>
   </p:cSld>
   <p:clrMapOvr>

</xml_diff>